<commit_message>
Clarify Colab opening instructions in Weeks 5 and 8
</commit_message>
<xml_diff>
--- a/week_05/week_05_transactions_mvcc_locks.pptx
+++ b/week_05/week_05_transactions_mvcc_locks.pptx
@@ -2,35 +2,35 @@
 <file path=ppt/presentation.xml><?xml version="1.0" encoding="utf-8"?>
 <p:presentation xmlns:p="http://schemas.openxmlformats.org/presentationml/2006/main">
   <p:sldMasterIdLst>
-    <p:sldMasterId xmlns:r="http://schemas.openxmlformats.org/officeDocument/2006/relationships" id="2147483648" r:id="R81cd0a6aba704127"/>
+    <p:sldMasterId xmlns:r="http://schemas.openxmlformats.org/officeDocument/2006/relationships" id="2147483648" r:id="R94e74b49adb6400c"/>
   </p:sldMasterIdLst>
   <p:notesMasterIdLst>
-    <p:notesMasterId xmlns:r="http://schemas.openxmlformats.org/officeDocument/2006/relationships" r:id="Rb9caf98134594345"/>
+    <p:notesMasterId xmlns:r="http://schemas.openxmlformats.org/officeDocument/2006/relationships" r:id="R6abd42e934524dd0"/>
   </p:notesMasterIdLst>
   <p:sldIdLst>
-    <p:sldId xmlns:r="http://schemas.openxmlformats.org/officeDocument/2006/relationships" id="256" r:id="R6013379c1e224b9b"/>
-    <p:sldId xmlns:r="http://schemas.openxmlformats.org/officeDocument/2006/relationships" id="257" r:id="R08a7bfe7e9da4d52"/>
-    <p:sldId xmlns:r="http://schemas.openxmlformats.org/officeDocument/2006/relationships" id="258" r:id="R447ef44b29ee4b93"/>
-    <p:sldId xmlns:r="http://schemas.openxmlformats.org/officeDocument/2006/relationships" id="259" r:id="R808c86a461ae4d26"/>
-    <p:sldId xmlns:r="http://schemas.openxmlformats.org/officeDocument/2006/relationships" id="260" r:id="Rc8d40ac95421493d"/>
-    <p:sldId xmlns:r="http://schemas.openxmlformats.org/officeDocument/2006/relationships" id="261" r:id="R78bf18c4a9754f0c"/>
-    <p:sldId xmlns:r="http://schemas.openxmlformats.org/officeDocument/2006/relationships" id="262" r:id="Rc6ed9dbc17a04e61"/>
-    <p:sldId xmlns:r="http://schemas.openxmlformats.org/officeDocument/2006/relationships" id="263" r:id="Rc5e08e1fabc4449b"/>
-    <p:sldId xmlns:r="http://schemas.openxmlformats.org/officeDocument/2006/relationships" id="264" r:id="R9a2fcef39ecf4c89"/>
-    <p:sldId xmlns:r="http://schemas.openxmlformats.org/officeDocument/2006/relationships" id="265" r:id="R7d33f2979e494ee6"/>
-    <p:sldId xmlns:r="http://schemas.openxmlformats.org/officeDocument/2006/relationships" id="266" r:id="R94ecc33507da485a"/>
-    <p:sldId xmlns:r="http://schemas.openxmlformats.org/officeDocument/2006/relationships" id="267" r:id="R06141a2abf90404e"/>
-    <p:sldId xmlns:r="http://schemas.openxmlformats.org/officeDocument/2006/relationships" id="268" r:id="R29bf4d7948ba4941"/>
-    <p:sldId xmlns:r="http://schemas.openxmlformats.org/officeDocument/2006/relationships" id="269" r:id="R9478e8d1ad774c62"/>
-    <p:sldId xmlns:r="http://schemas.openxmlformats.org/officeDocument/2006/relationships" id="270" r:id="Ra0fa594fc56b4b55"/>
-    <p:sldId xmlns:r="http://schemas.openxmlformats.org/officeDocument/2006/relationships" id="271" r:id="R51eda322f8f94865"/>
-    <p:sldId xmlns:r="http://schemas.openxmlformats.org/officeDocument/2006/relationships" id="272" r:id="Rd8ea9778a77e4499"/>
-    <p:sldId xmlns:r="http://schemas.openxmlformats.org/officeDocument/2006/relationships" id="273" r:id="Rb2f74f1425a9426c"/>
-    <p:sldId xmlns:r="http://schemas.openxmlformats.org/officeDocument/2006/relationships" id="274" r:id="R11666809922b4710"/>
-    <p:sldId xmlns:r="http://schemas.openxmlformats.org/officeDocument/2006/relationships" id="275" r:id="R3d716368eb1a46bb"/>
-    <p:sldId xmlns:r="http://schemas.openxmlformats.org/officeDocument/2006/relationships" id="276" r:id="Re315715c71ae4daf"/>
-    <p:sldId xmlns:r="http://schemas.openxmlformats.org/officeDocument/2006/relationships" id="277" r:id="Rb84b1e225e364d32"/>
-    <p:sldId xmlns:r="http://schemas.openxmlformats.org/officeDocument/2006/relationships" id="278" r:id="R2752c26f1d384fe3"/>
+    <p:sldId xmlns:r="http://schemas.openxmlformats.org/officeDocument/2006/relationships" id="256" r:id="R1ff7ea3ebf3d4246"/>
+    <p:sldId xmlns:r="http://schemas.openxmlformats.org/officeDocument/2006/relationships" id="257" r:id="R3ed5b3aa4d3c464d"/>
+    <p:sldId xmlns:r="http://schemas.openxmlformats.org/officeDocument/2006/relationships" id="258" r:id="Ra5ebf5e02f234097"/>
+    <p:sldId xmlns:r="http://schemas.openxmlformats.org/officeDocument/2006/relationships" id="259" r:id="Rb83c376d995c406c"/>
+    <p:sldId xmlns:r="http://schemas.openxmlformats.org/officeDocument/2006/relationships" id="260" r:id="Rb015ca425fff4677"/>
+    <p:sldId xmlns:r="http://schemas.openxmlformats.org/officeDocument/2006/relationships" id="261" r:id="R31f0bf4c3f254cd0"/>
+    <p:sldId xmlns:r="http://schemas.openxmlformats.org/officeDocument/2006/relationships" id="262" r:id="R5a93b76553bc4625"/>
+    <p:sldId xmlns:r="http://schemas.openxmlformats.org/officeDocument/2006/relationships" id="263" r:id="R2c8af698741c445b"/>
+    <p:sldId xmlns:r="http://schemas.openxmlformats.org/officeDocument/2006/relationships" id="264" r:id="R747a8310d4514767"/>
+    <p:sldId xmlns:r="http://schemas.openxmlformats.org/officeDocument/2006/relationships" id="265" r:id="Reaa608241ad24ce2"/>
+    <p:sldId xmlns:r="http://schemas.openxmlformats.org/officeDocument/2006/relationships" id="266" r:id="R817309a7c4ed40e7"/>
+    <p:sldId xmlns:r="http://schemas.openxmlformats.org/officeDocument/2006/relationships" id="267" r:id="Rbb808739f21d45be"/>
+    <p:sldId xmlns:r="http://schemas.openxmlformats.org/officeDocument/2006/relationships" id="268" r:id="R8357a355d7344b5b"/>
+    <p:sldId xmlns:r="http://schemas.openxmlformats.org/officeDocument/2006/relationships" id="269" r:id="R80173a5033584042"/>
+    <p:sldId xmlns:r="http://schemas.openxmlformats.org/officeDocument/2006/relationships" id="270" r:id="Rb8c7cfb365174f12"/>
+    <p:sldId xmlns:r="http://schemas.openxmlformats.org/officeDocument/2006/relationships" id="271" r:id="R13f0a3a7855f4382"/>
+    <p:sldId xmlns:r="http://schemas.openxmlformats.org/officeDocument/2006/relationships" id="272" r:id="R175530253b964be8"/>
+    <p:sldId xmlns:r="http://schemas.openxmlformats.org/officeDocument/2006/relationships" id="273" r:id="R343bd95ea1254cc0"/>
+    <p:sldId xmlns:r="http://schemas.openxmlformats.org/officeDocument/2006/relationships" id="274" r:id="Ree52ccd3b8384160"/>
+    <p:sldId xmlns:r="http://schemas.openxmlformats.org/officeDocument/2006/relationships" id="275" r:id="Rca7265d1b8bf4f12"/>
+    <p:sldId xmlns:r="http://schemas.openxmlformats.org/officeDocument/2006/relationships" id="276" r:id="R6d73f0e599e946ff"/>
+    <p:sldId xmlns:r="http://schemas.openxmlformats.org/officeDocument/2006/relationships" id="277" r:id="R2233b3af0b664c5c"/>
+    <p:sldId xmlns:r="http://schemas.openxmlformats.org/officeDocument/2006/relationships" id="278" r:id="Rceb81f7a34904ca9"/>
   </p:sldIdLst>
   <p:sldSz cx="12192000" cy="6858000"/>
   <p:notesSz cx="6858000" cy="9144000"/>
@@ -2014,7 +2014,7 @@
           </a:p>
           <a:p xmlns:a="http://schemas.openxmlformats.org/drawingml/2006/main">
             <a:r>
-              <a:t>Download Notebook 02, open Colab, and use File, then Upload notebook. In Supabase, use the Connect dialog's Session pooler connection for this exercise. Follow the notebook's SSL instructions and enter the connection URL only when the hidden prompt appears. Do not paste a password-bearing URL into a code cell or a Markdown explanation.</a:t>
+              <a:t>Open the Lab 2 page and click Open in Colab. Save a copy in Drive so you can keep your changes and results. The weekly page has the same button beside Notebook 02; downloading the file is only necessary if you prefer local Jupyter. In Supabase, use the Connect dialog's Session pooler connection for this exercise. Follow the notebook's SSL instructions and enter the connection URL only when the hidden prompt appears. Do not paste a password-bearing URL into a code cell or a Markdown explanation.</a:t>
             </a:r>
           </a:p>
           <a:p xmlns:a="http://schemas.openxmlformats.org/drawingml/2006/main">
@@ -2065,6 +2065,11 @@
           <a:p xmlns:a="http://schemas.openxmlformats.org/drawingml/2006/main">
             <a:r>
               <a:t>- https://supabase.com/docs/guides/database/connecting-to-postgres</a:t>
+            </a:r>
+          </a:p>
+          <a:p xmlns:a="http://schemas.openxmlformats.org/drawingml/2006/main">
+            <a:r>
+              <a:t>- https://research.google.com/colaboratory/faq.html</a:t>
             </a:r>
           </a:p>
         </p:txBody>
@@ -3442,7 +3447,7 @@
   </p:cSld>
   <p:clrMap bg1="lt1" tx1="dk1" bg2="lt2" tx2="dk2" accent1="accent1" accent2="accent2" accent3="accent3" accent4="accent4" accent5="accent5" accent6="accent6" hlink="hlink" folHlink="folHlink"/>
   <p:sldLayoutIdLst>
-    <p:sldLayoutId xmlns:r="http://schemas.openxmlformats.org/officeDocument/2006/relationships" id="2147483649" r:id="R953f7a2e2b174faa"/>
+    <p:sldLayoutId xmlns:r="http://schemas.openxmlformats.org/officeDocument/2006/relationships" id="2147483649" r:id="R444d135e12854908"/>
   </p:sldLayoutIdLst>
   <p:txStyles>
     <p:titleStyle>
@@ -3993,7 +3998,7 @@
           <p:cNvPr id="7" name="eyebrow">
             <a:extLst xmlns:a="http://schemas.openxmlformats.org/drawingml/2006/main">
               <a:ext uri="{FF2B5EF4-FFF2-40B4-BE49-F238E27FC236}">
-                <a16:creationId xmlns:a16="http://schemas.microsoft.com/office/drawing/2014/main" id="{D85199EE-2C54-4005-841F-35A0021B59BA}"/>
+                <a16:creationId xmlns:a16="http://schemas.microsoft.com/office/drawing/2014/main" id="{5282D8E0-BB31-43C6-A66B-FC059D999DDA}"/>
               </a:ext>
             </a:extLst>
           </p:cNvPr>
@@ -4050,7 +4055,7 @@
           <p:cNvPr id="2" name="slide-title">
             <a:extLst xmlns:a="http://schemas.openxmlformats.org/drawingml/2006/main">
               <a:ext uri="{FF2B5EF4-FFF2-40B4-BE49-F238E27FC236}">
-                <a16:creationId xmlns:a16="http://schemas.microsoft.com/office/drawing/2014/main" id="{400B5B79-52D7-4F32-A9C6-45A079FC566A}"/>
+                <a16:creationId xmlns:a16="http://schemas.microsoft.com/office/drawing/2014/main" id="{8CA4A6A4-226C-46C5-96B7-E7C4CDCBC6D5}"/>
               </a:ext>
             </a:extLst>
           </p:cNvPr>
@@ -4107,7 +4112,7 @@
           <p:cNvPr id="3" name="">
             <a:extLst xmlns:a="http://schemas.openxmlformats.org/drawingml/2006/main">
               <a:ext uri="{FF2B5EF4-FFF2-40B4-BE49-F238E27FC236}">
-                <a16:creationId xmlns:a16="http://schemas.microsoft.com/office/drawing/2014/main" id="{EED5CE30-9DFE-4976-85EA-BFC0C5A75FFD}"/>
+                <a16:creationId xmlns:a16="http://schemas.microsoft.com/office/drawing/2014/main" id="{A96C4786-75CF-48E2-8AEC-B843CA7EED86}"/>
               </a:ext>
             </a:extLst>
           </p:cNvPr>
@@ -4139,7 +4144,7 @@
           <p:cNvPr id="4" name="slide-number">
             <a:extLst xmlns:a="http://schemas.openxmlformats.org/drawingml/2006/main">
               <a:ext uri="{FF2B5EF4-FFF2-40B4-BE49-F238E27FC236}">
-                <a16:creationId xmlns:a16="http://schemas.microsoft.com/office/drawing/2014/main" id="{D7EC0B46-544E-4773-93C9-667EA364A08A}"/>
+                <a16:creationId xmlns:a16="http://schemas.microsoft.com/office/drawing/2014/main" id="{803D1117-4D9D-4B26-8490-135359584FB4}"/>
               </a:ext>
             </a:extLst>
           </p:cNvPr>
@@ -4196,7 +4201,7 @@
           <p:cNvPr id="5" name="cover-case">
             <a:extLst xmlns:a="http://schemas.openxmlformats.org/drawingml/2006/main">
               <a:ext uri="{FF2B5EF4-FFF2-40B4-BE49-F238E27FC236}">
-                <a16:creationId xmlns:a16="http://schemas.microsoft.com/office/drawing/2014/main" id="{F87B510E-5730-4B12-9CA8-54B0866634B8}"/>
+                <a16:creationId xmlns:a16="http://schemas.microsoft.com/office/drawing/2014/main" id="{F246AFB4-4AE1-4A2A-B3B0-2785287C8908}"/>
               </a:ext>
             </a:extLst>
           </p:cNvPr>
@@ -4276,7 +4281,7 @@
           <p:cNvPr id="6" name="cover-arc">
             <a:extLst xmlns:a="http://schemas.openxmlformats.org/drawingml/2006/main">
               <a:ext uri="{FF2B5EF4-FFF2-40B4-BE49-F238E27FC236}">
-                <a16:creationId xmlns:a16="http://schemas.microsoft.com/office/drawing/2014/main" id="{694AD1FF-0447-4EE9-958C-CE38C122757D}"/>
+                <a16:creationId xmlns:a16="http://schemas.microsoft.com/office/drawing/2014/main" id="{4D69AC97-E91B-4624-8889-8E8730B0AC6B}"/>
               </a:ext>
             </a:extLst>
           </p:cNvPr>
@@ -4385,7 +4390,7 @@
           <p:cNvPr id="7" name="eyebrow">
             <a:extLst xmlns:a="http://schemas.openxmlformats.org/drawingml/2006/main">
               <a:ext uri="{FF2B5EF4-FFF2-40B4-BE49-F238E27FC236}">
-                <a16:creationId xmlns:a16="http://schemas.microsoft.com/office/drawing/2014/main" id="{09B1EF38-F579-413C-88B7-BDF343EE1118}"/>
+                <a16:creationId xmlns:a16="http://schemas.microsoft.com/office/drawing/2014/main" id="{00A7FA01-ECB9-49C4-9A85-441A73E37296}"/>
               </a:ext>
             </a:extLst>
           </p:cNvPr>
@@ -4442,7 +4447,7 @@
           <p:cNvPr id="2" name="slide-title">
             <a:extLst xmlns:a="http://schemas.openxmlformats.org/drawingml/2006/main">
               <a:ext uri="{FF2B5EF4-FFF2-40B4-BE49-F238E27FC236}">
-                <a16:creationId xmlns:a16="http://schemas.microsoft.com/office/drawing/2014/main" id="{2231ED2B-96D9-468E-AF64-B6A2AA4DA1C4}"/>
+                <a16:creationId xmlns:a16="http://schemas.microsoft.com/office/drawing/2014/main" id="{6D24E76D-3265-46B9-B5BC-0BDB6A27C620}"/>
               </a:ext>
             </a:extLst>
           </p:cNvPr>
@@ -4499,7 +4504,7 @@
           <p:cNvPr id="3" name="">
             <a:extLst xmlns:a="http://schemas.openxmlformats.org/drawingml/2006/main">
               <a:ext uri="{FF2B5EF4-FFF2-40B4-BE49-F238E27FC236}">
-                <a16:creationId xmlns:a16="http://schemas.microsoft.com/office/drawing/2014/main" id="{BDF0B2A7-F77B-4041-A92E-3BF4E18A0247}"/>
+                <a16:creationId xmlns:a16="http://schemas.microsoft.com/office/drawing/2014/main" id="{C7F3219D-75F5-46E2-9FEE-B810B6F67C87}"/>
               </a:ext>
             </a:extLst>
           </p:cNvPr>
@@ -4531,7 +4536,7 @@
           <p:cNvPr id="4" name="slide-number">
             <a:extLst xmlns:a="http://schemas.openxmlformats.org/drawingml/2006/main">
               <a:ext uri="{FF2B5EF4-FFF2-40B4-BE49-F238E27FC236}">
-                <a16:creationId xmlns:a16="http://schemas.microsoft.com/office/drawing/2014/main" id="{83F394D0-7225-46A8-98CE-648D2A75124F}"/>
+                <a16:creationId xmlns:a16="http://schemas.microsoft.com/office/drawing/2014/main" id="{E01D92B5-14AB-4211-AF26-7444B057588D}"/>
               </a:ext>
             </a:extLst>
           </p:cNvPr>
@@ -4588,7 +4593,7 @@
           <p:cNvPr id="5" name="day2">
             <a:extLst xmlns:a="http://schemas.openxmlformats.org/drawingml/2006/main">
               <a:ext uri="{FF2B5EF4-FFF2-40B4-BE49-F238E27FC236}">
-                <a16:creationId xmlns:a16="http://schemas.microsoft.com/office/drawing/2014/main" id="{48CA955C-F979-46AA-BDFE-2C00314F011D}"/>
+                <a16:creationId xmlns:a16="http://schemas.microsoft.com/office/drawing/2014/main" id="{6338F753-83FB-40B5-95C2-F84473F86947}"/>
               </a:ext>
             </a:extLst>
           </p:cNvPr>
@@ -4668,7 +4673,7 @@
           <p:cNvPr id="6" name="day2-goal">
             <a:extLst xmlns:a="http://schemas.openxmlformats.org/drawingml/2006/main">
               <a:ext uri="{FF2B5EF4-FFF2-40B4-BE49-F238E27FC236}">
-                <a16:creationId xmlns:a16="http://schemas.microsoft.com/office/drawing/2014/main" id="{DAD3FA74-ED73-43FD-BC72-D479F953D39F}"/>
+                <a16:creationId xmlns:a16="http://schemas.microsoft.com/office/drawing/2014/main" id="{6DBDCCAF-0F6E-46EE-A176-D8946C99A781}"/>
               </a:ext>
             </a:extLst>
           </p:cNvPr>
@@ -4754,7 +4759,7 @@
           <p:cNvPr id="13" name="eyebrow">
             <a:extLst xmlns:a="http://schemas.openxmlformats.org/drawingml/2006/main">
               <a:ext uri="{FF2B5EF4-FFF2-40B4-BE49-F238E27FC236}">
-                <a16:creationId xmlns:a16="http://schemas.microsoft.com/office/drawing/2014/main" id="{8247F7DD-F27D-4F64-93E6-6DCA680237D2}"/>
+                <a16:creationId xmlns:a16="http://schemas.microsoft.com/office/drawing/2014/main" id="{246F00BB-85CC-4690-A155-C246331BC41B}"/>
               </a:ext>
             </a:extLst>
           </p:cNvPr>
@@ -4811,7 +4816,7 @@
           <p:cNvPr id="2" name="slide-title">
             <a:extLst xmlns:a="http://schemas.openxmlformats.org/drawingml/2006/main">
               <a:ext uri="{FF2B5EF4-FFF2-40B4-BE49-F238E27FC236}">
-                <a16:creationId xmlns:a16="http://schemas.microsoft.com/office/drawing/2014/main" id="{9FCBC62A-709B-4F37-B333-081D83413B15}"/>
+                <a16:creationId xmlns:a16="http://schemas.microsoft.com/office/drawing/2014/main" id="{473D672B-C815-4D1B-9BA1-0D25A793CB7E}"/>
               </a:ext>
             </a:extLst>
           </p:cNvPr>
@@ -4868,7 +4873,7 @@
           <p:cNvPr id="3" name="">
             <a:extLst xmlns:a="http://schemas.openxmlformats.org/drawingml/2006/main">
               <a:ext uri="{FF2B5EF4-FFF2-40B4-BE49-F238E27FC236}">
-                <a16:creationId xmlns:a16="http://schemas.microsoft.com/office/drawing/2014/main" id="{01D17EE0-DCA1-4BFD-85DF-150F20401870}"/>
+                <a16:creationId xmlns:a16="http://schemas.microsoft.com/office/drawing/2014/main" id="{359D79BB-E681-4E6E-90B3-783DBDFA0670}"/>
               </a:ext>
             </a:extLst>
           </p:cNvPr>
@@ -4900,7 +4905,7 @@
           <p:cNvPr id="4" name="slide-number">
             <a:extLst xmlns:a="http://schemas.openxmlformats.org/drawingml/2006/main">
               <a:ext uri="{FF2B5EF4-FFF2-40B4-BE49-F238E27FC236}">
-                <a16:creationId xmlns:a16="http://schemas.microsoft.com/office/drawing/2014/main" id="{F6505887-D5A5-4068-BCED-5C555AF755C6}"/>
+                <a16:creationId xmlns:a16="http://schemas.microsoft.com/office/drawing/2014/main" id="{DBF5B670-A5B6-4F99-AF0A-2F961EC63553}"/>
               </a:ext>
             </a:extLst>
           </p:cNvPr>
@@ -4957,7 +4962,7 @@
           <p:cNvPr id="5" name="">
             <a:extLst xmlns:a="http://schemas.openxmlformats.org/drawingml/2006/main">
               <a:ext uri="{FF2B5EF4-FFF2-40B4-BE49-F238E27FC236}">
-                <a16:creationId xmlns:a16="http://schemas.microsoft.com/office/drawing/2014/main" id="{5340170A-F92E-452F-BA24-92DC011E9289}"/>
+                <a16:creationId xmlns:a16="http://schemas.microsoft.com/office/drawing/2014/main" id="{F3B195BB-137D-441D-9D6A-AEACCC9312BB}"/>
               </a:ext>
             </a:extLst>
           </p:cNvPr>
@@ -4989,7 +4994,7 @@
           <p:cNvPr id="6" name="session-a">
             <a:extLst xmlns:a="http://schemas.openxmlformats.org/drawingml/2006/main">
               <a:ext uri="{FF2B5EF4-FFF2-40B4-BE49-F238E27FC236}">
-                <a16:creationId xmlns:a16="http://schemas.microsoft.com/office/drawing/2014/main" id="{CAA75E7A-F4D9-43A5-8A75-0B7F9606E8EF}"/>
+                <a16:creationId xmlns:a16="http://schemas.microsoft.com/office/drawing/2014/main" id="{56212C75-060C-438D-94AA-5EA5BE6AA48C}"/>
               </a:ext>
             </a:extLst>
           </p:cNvPr>
@@ -5092,7 +5097,7 @@
           <p:cNvPr id="7" name="">
             <a:extLst xmlns:a="http://schemas.openxmlformats.org/drawingml/2006/main">
               <a:ext uri="{FF2B5EF4-FFF2-40B4-BE49-F238E27FC236}">
-                <a16:creationId xmlns:a16="http://schemas.microsoft.com/office/drawing/2014/main" id="{C2173879-9FC3-464D-A966-4EB793BA1086}"/>
+                <a16:creationId xmlns:a16="http://schemas.microsoft.com/office/drawing/2014/main" id="{A7E88D17-5B6B-4A37-B494-3437C3561803}"/>
               </a:ext>
             </a:extLst>
           </p:cNvPr>
@@ -5124,7 +5129,7 @@
           <p:cNvPr id="8" name="session-b">
             <a:extLst xmlns:a="http://schemas.openxmlformats.org/drawingml/2006/main">
               <a:ext uri="{FF2B5EF4-FFF2-40B4-BE49-F238E27FC236}">
-                <a16:creationId xmlns:a16="http://schemas.microsoft.com/office/drawing/2014/main" id="{150FE13B-7CEF-4B5F-9519-F256C27994C1}"/>
+                <a16:creationId xmlns:a16="http://schemas.microsoft.com/office/drawing/2014/main" id="{F9BC2E7F-EF81-4F99-856B-C68AD7F78478}"/>
               </a:ext>
             </a:extLst>
           </p:cNvPr>
@@ -5227,7 +5232,7 @@
           <p:cNvPr id="9" name="">
             <a:extLst xmlns:a="http://schemas.openxmlformats.org/drawingml/2006/main">
               <a:ext uri="{FF2B5EF4-FFF2-40B4-BE49-F238E27FC236}">
-                <a16:creationId xmlns:a16="http://schemas.microsoft.com/office/drawing/2014/main" id="{26B14E14-E4EE-42F0-B3CA-76919FB5B344}"/>
+                <a16:creationId xmlns:a16="http://schemas.microsoft.com/office/drawing/2014/main" id="{EBF51CD7-E5E6-46A0-AB9F-E69CE36AF561}"/>
               </a:ext>
             </a:extLst>
           </p:cNvPr>
@@ -5259,7 +5264,7 @@
           <p:cNvPr id="10" name="diagnostic">
             <a:extLst xmlns:a="http://schemas.openxmlformats.org/drawingml/2006/main">
               <a:ext uri="{FF2B5EF4-FFF2-40B4-BE49-F238E27FC236}">
-                <a16:creationId xmlns:a16="http://schemas.microsoft.com/office/drawing/2014/main" id="{89AC502E-F95E-48A3-B582-C428F63D59F0}"/>
+                <a16:creationId xmlns:a16="http://schemas.microsoft.com/office/drawing/2014/main" id="{98C7985A-3376-412B-86D3-2A0E6D3F3ED0}"/>
               </a:ext>
             </a:extLst>
           </p:cNvPr>
@@ -5362,7 +5367,7 @@
           <p:cNvPr id="11" name="sessions-rule">
             <a:extLst xmlns:a="http://schemas.openxmlformats.org/drawingml/2006/main">
               <a:ext uri="{FF2B5EF4-FFF2-40B4-BE49-F238E27FC236}">
-                <a16:creationId xmlns:a16="http://schemas.microsoft.com/office/drawing/2014/main" id="{5F80FCFA-D0A5-4F73-8A4D-6E4F33EBD67A}"/>
+                <a16:creationId xmlns:a16="http://schemas.microsoft.com/office/drawing/2014/main" id="{E1BE2431-83CB-4149-BD2D-04D62E3DB157}"/>
               </a:ext>
             </a:extLst>
           </p:cNvPr>
@@ -5419,7 +5424,7 @@
           <p:cNvPr id="12" name="fixture">
             <a:extLst xmlns:a="http://schemas.openxmlformats.org/drawingml/2006/main">
               <a:ext uri="{FF2B5EF4-FFF2-40B4-BE49-F238E27FC236}">
-                <a16:creationId xmlns:a16="http://schemas.microsoft.com/office/drawing/2014/main" id="{4C7EC722-8976-4707-96E0-0F7F5CE3C4B5}"/>
+                <a16:creationId xmlns:a16="http://schemas.microsoft.com/office/drawing/2014/main" id="{020E450B-5B61-4E37-945D-56EC1BCB88ED}"/>
               </a:ext>
             </a:extLst>
           </p:cNvPr>
@@ -5505,7 +5510,7 @@
           <p:cNvPr id="16" name="eyebrow">
             <a:extLst xmlns:a="http://schemas.openxmlformats.org/drawingml/2006/main">
               <a:ext uri="{FF2B5EF4-FFF2-40B4-BE49-F238E27FC236}">
-                <a16:creationId xmlns:a16="http://schemas.microsoft.com/office/drawing/2014/main" id="{D2AF0723-C32B-4A90-B219-49099003A76D}"/>
+                <a16:creationId xmlns:a16="http://schemas.microsoft.com/office/drawing/2014/main" id="{F3CCCB44-A304-48BB-8899-E2C9A09BEEF6}"/>
               </a:ext>
             </a:extLst>
           </p:cNvPr>
@@ -5562,7 +5567,7 @@
           <p:cNvPr id="2" name="slide-title">
             <a:extLst xmlns:a="http://schemas.openxmlformats.org/drawingml/2006/main">
               <a:ext uri="{FF2B5EF4-FFF2-40B4-BE49-F238E27FC236}">
-                <a16:creationId xmlns:a16="http://schemas.microsoft.com/office/drawing/2014/main" id="{BED17273-327B-4D4F-9EDA-C92A6082F333}"/>
+                <a16:creationId xmlns:a16="http://schemas.microsoft.com/office/drawing/2014/main" id="{69ADF478-CF6C-4DC6-ABB1-5D0B1485E585}"/>
               </a:ext>
             </a:extLst>
           </p:cNvPr>
@@ -5619,7 +5624,7 @@
           <p:cNvPr id="3" name="">
             <a:extLst xmlns:a="http://schemas.openxmlformats.org/drawingml/2006/main">
               <a:ext uri="{FF2B5EF4-FFF2-40B4-BE49-F238E27FC236}">
-                <a16:creationId xmlns:a16="http://schemas.microsoft.com/office/drawing/2014/main" id="{9A13CA03-479F-4FB9-9A76-5E42B6D117B8}"/>
+                <a16:creationId xmlns:a16="http://schemas.microsoft.com/office/drawing/2014/main" id="{E594D198-CAF5-4FC1-B2AF-923DAAAF7597}"/>
               </a:ext>
             </a:extLst>
           </p:cNvPr>
@@ -5651,7 +5656,7 @@
           <p:cNvPr id="4" name="slide-number">
             <a:extLst xmlns:a="http://schemas.openxmlformats.org/drawingml/2006/main">
               <a:ext uri="{FF2B5EF4-FFF2-40B4-BE49-F238E27FC236}">
-                <a16:creationId xmlns:a16="http://schemas.microsoft.com/office/drawing/2014/main" id="{EF7BD055-CE6F-4F6B-A8DF-624C51683C3C}"/>
+                <a16:creationId xmlns:a16="http://schemas.microsoft.com/office/drawing/2014/main" id="{7677FE1F-5E64-4051-A2F1-90161C8ACB5B}"/>
               </a:ext>
             </a:extLst>
           </p:cNvPr>
@@ -5708,7 +5713,7 @@
           <p:cNvPr id="5" name="">
             <a:extLst xmlns:a="http://schemas.openxmlformats.org/drawingml/2006/main">
               <a:ext uri="{FF2B5EF4-FFF2-40B4-BE49-F238E27FC236}">
-                <a16:creationId xmlns:a16="http://schemas.microsoft.com/office/drawing/2014/main" id="{F31B8CC9-BEC7-499C-BD15-BD1DE229BBE0}"/>
+                <a16:creationId xmlns:a16="http://schemas.microsoft.com/office/drawing/2014/main" id="{08907E85-0B80-44F7-ACD9-708F20EF69F6}"/>
               </a:ext>
             </a:extLst>
           </p:cNvPr>
@@ -5740,7 +5745,7 @@
           <p:cNvPr id="6" name="old-version">
             <a:extLst xmlns:a="http://schemas.openxmlformats.org/drawingml/2006/main">
               <a:ext uri="{FF2B5EF4-FFF2-40B4-BE49-F238E27FC236}">
-                <a16:creationId xmlns:a16="http://schemas.microsoft.com/office/drawing/2014/main" id="{8E5E99E1-4ABC-4703-8E28-2D7FEDFFA3C2}"/>
+                <a16:creationId xmlns:a16="http://schemas.microsoft.com/office/drawing/2014/main" id="{DD28F30D-EF1D-42C7-B97E-86AD7AAE2B2F}"/>
               </a:ext>
             </a:extLst>
           </p:cNvPr>
@@ -5820,7 +5825,7 @@
           <p:cNvPr id="7" name="">
             <a:extLst xmlns:a="http://schemas.openxmlformats.org/drawingml/2006/main">
               <a:ext uri="{FF2B5EF4-FFF2-40B4-BE49-F238E27FC236}">
-                <a16:creationId xmlns:a16="http://schemas.microsoft.com/office/drawing/2014/main" id="{E0E7614D-3B26-4DF2-85F5-8CA4CAD459B2}"/>
+                <a16:creationId xmlns:a16="http://schemas.microsoft.com/office/drawing/2014/main" id="{D6986DB6-39AC-4E56-B587-FB307FDF91AD}"/>
               </a:ext>
             </a:extLst>
           </p:cNvPr>
@@ -5852,7 +5857,7 @@
           <p:cNvPr id="8" name="new-version">
             <a:extLst xmlns:a="http://schemas.openxmlformats.org/drawingml/2006/main">
               <a:ext uri="{FF2B5EF4-FFF2-40B4-BE49-F238E27FC236}">
-                <a16:creationId xmlns:a16="http://schemas.microsoft.com/office/drawing/2014/main" id="{3A91A1D5-C22C-42E7-A237-04BF8E65D823}"/>
+                <a16:creationId xmlns:a16="http://schemas.microsoft.com/office/drawing/2014/main" id="{1B535AE9-1014-499D-84A0-61FF0DAB7489}"/>
               </a:ext>
             </a:extLst>
           </p:cNvPr>
@@ -5932,7 +5937,7 @@
           <p:cNvPr id="9" name="">
             <a:extLst xmlns:a="http://schemas.openxmlformats.org/drawingml/2006/main">
               <a:ext uri="{FF2B5EF4-FFF2-40B4-BE49-F238E27FC236}">
-                <a16:creationId xmlns:a16="http://schemas.microsoft.com/office/drawing/2014/main" id="{6DC8F7D1-C87D-49CF-B060-ACABA2C70AE7}"/>
+                <a16:creationId xmlns:a16="http://schemas.microsoft.com/office/drawing/2014/main" id="{A12AD0BC-1FFE-4737-BA29-1F651E403AEF}"/>
               </a:ext>
             </a:extLst>
           </p:cNvPr>
@@ -5964,7 +5969,7 @@
           <p:cNvPr id="10" name="">
             <a:extLst xmlns:a="http://schemas.openxmlformats.org/drawingml/2006/main">
               <a:ext uri="{FF2B5EF4-FFF2-40B4-BE49-F238E27FC236}">
-                <a16:creationId xmlns:a16="http://schemas.microsoft.com/office/drawing/2014/main" id="{56174C45-232B-4CF7-854E-91AC2D21D21E}"/>
+                <a16:creationId xmlns:a16="http://schemas.microsoft.com/office/drawing/2014/main" id="{B7310EE0-0554-4EF8-BE5C-AF12301D441A}"/>
               </a:ext>
             </a:extLst>
           </p:cNvPr>
@@ -5996,7 +6001,7 @@
           <p:cNvPr id="11" name="">
             <a:extLst xmlns:a="http://schemas.openxmlformats.org/drawingml/2006/main">
               <a:ext uri="{FF2B5EF4-FFF2-40B4-BE49-F238E27FC236}">
-                <a16:creationId xmlns:a16="http://schemas.microsoft.com/office/drawing/2014/main" id="{A46E5EDC-33F7-41F5-86C7-C640B860A1FF}"/>
+                <a16:creationId xmlns:a16="http://schemas.microsoft.com/office/drawing/2014/main" id="{FCEEEC64-D624-43CE-B9F9-C1154798DD78}"/>
               </a:ext>
             </a:extLst>
           </p:cNvPr>
@@ -6028,7 +6033,7 @@
           <p:cNvPr id="12" name="reader">
             <a:extLst xmlns:a="http://schemas.openxmlformats.org/drawingml/2006/main">
               <a:ext uri="{FF2B5EF4-FFF2-40B4-BE49-F238E27FC236}">
-                <a16:creationId xmlns:a16="http://schemas.microsoft.com/office/drawing/2014/main" id="{F550D660-5DA2-4FE9-BD79-CE19DEE2B334}"/>
+                <a16:creationId xmlns:a16="http://schemas.microsoft.com/office/drawing/2014/main" id="{FEAC3AFB-66BA-494B-B008-BB9AF7178F53}"/>
               </a:ext>
             </a:extLst>
           </p:cNvPr>
@@ -6108,7 +6113,7 @@
           <p:cNvPr id="13" name="">
             <a:extLst xmlns:a="http://schemas.openxmlformats.org/drawingml/2006/main">
               <a:ext uri="{FF2B5EF4-FFF2-40B4-BE49-F238E27FC236}">
-                <a16:creationId xmlns:a16="http://schemas.microsoft.com/office/drawing/2014/main" id="{49416598-0318-4F49-8171-3A085B7CCA87}"/>
+                <a16:creationId xmlns:a16="http://schemas.microsoft.com/office/drawing/2014/main" id="{E07AC19B-449A-46B2-8203-D9650FCF8E1D}"/>
               </a:ext>
             </a:extLst>
           </p:cNvPr>
@@ -6140,7 +6145,7 @@
           <p:cNvPr id="14" name="own-writes">
             <a:extLst xmlns:a="http://schemas.openxmlformats.org/drawingml/2006/main">
               <a:ext uri="{FF2B5EF4-FFF2-40B4-BE49-F238E27FC236}">
-                <a16:creationId xmlns:a16="http://schemas.microsoft.com/office/drawing/2014/main" id="{270E04BD-5CFB-431A-AA0F-AEA35A6FC255}"/>
+                <a16:creationId xmlns:a16="http://schemas.microsoft.com/office/drawing/2014/main" id="{1689AA91-5494-46FF-9AAE-B31B9C972CEF}"/>
               </a:ext>
             </a:extLst>
           </p:cNvPr>
@@ -6220,7 +6225,7 @@
           <p:cNvPr id="15" name="mvcc">
             <a:extLst xmlns:a="http://schemas.openxmlformats.org/drawingml/2006/main">
               <a:ext uri="{FF2B5EF4-FFF2-40B4-BE49-F238E27FC236}">
-                <a16:creationId xmlns:a16="http://schemas.microsoft.com/office/drawing/2014/main" id="{8DF65418-0B18-480D-A7BA-CB0705941417}"/>
+                <a16:creationId xmlns:a16="http://schemas.microsoft.com/office/drawing/2014/main" id="{C179B911-1AA3-4B03-89E8-60BDD0DD3F2F}"/>
               </a:ext>
             </a:extLst>
           </p:cNvPr>
@@ -6306,7 +6311,7 @@
           <p:cNvPr id="8" name="eyebrow">
             <a:extLst xmlns:a="http://schemas.openxmlformats.org/drawingml/2006/main">
               <a:ext uri="{FF2B5EF4-FFF2-40B4-BE49-F238E27FC236}">
-                <a16:creationId xmlns:a16="http://schemas.microsoft.com/office/drawing/2014/main" id="{78DA4FEB-978B-479D-BE01-3357F73BFD83}"/>
+                <a16:creationId xmlns:a16="http://schemas.microsoft.com/office/drawing/2014/main" id="{BFE7D312-7445-4F86-AA8F-E16A199C32EE}"/>
               </a:ext>
             </a:extLst>
           </p:cNvPr>
@@ -6363,7 +6368,7 @@
           <p:cNvPr id="2" name="slide-title">
             <a:extLst xmlns:a="http://schemas.openxmlformats.org/drawingml/2006/main">
               <a:ext uri="{FF2B5EF4-FFF2-40B4-BE49-F238E27FC236}">
-                <a16:creationId xmlns:a16="http://schemas.microsoft.com/office/drawing/2014/main" id="{8FDB8CBC-025F-431D-A8EA-6D7401AD190C}"/>
+                <a16:creationId xmlns:a16="http://schemas.microsoft.com/office/drawing/2014/main" id="{45A251B9-3E16-48E2-9616-E4B0273A1EF9}"/>
               </a:ext>
             </a:extLst>
           </p:cNvPr>
@@ -6420,7 +6425,7 @@
           <p:cNvPr id="3" name="">
             <a:extLst xmlns:a="http://schemas.openxmlformats.org/drawingml/2006/main">
               <a:ext uri="{FF2B5EF4-FFF2-40B4-BE49-F238E27FC236}">
-                <a16:creationId xmlns:a16="http://schemas.microsoft.com/office/drawing/2014/main" id="{B2B33346-1D03-4139-8449-6AAF89554C57}"/>
+                <a16:creationId xmlns:a16="http://schemas.microsoft.com/office/drawing/2014/main" id="{44B1B77D-C4FA-4358-8C5B-9C6109A3B734}"/>
               </a:ext>
             </a:extLst>
           </p:cNvPr>
@@ -6452,7 +6457,7 @@
           <p:cNvPr id="4" name="slide-number">
             <a:extLst xmlns:a="http://schemas.openxmlformats.org/drawingml/2006/main">
               <a:ext uri="{FF2B5EF4-FFF2-40B4-BE49-F238E27FC236}">
-                <a16:creationId xmlns:a16="http://schemas.microsoft.com/office/drawing/2014/main" id="{79FCBB30-14D1-49F1-9667-907A3A0FCD34}"/>
+                <a16:creationId xmlns:a16="http://schemas.microsoft.com/office/drawing/2014/main" id="{AB61F3D1-FD38-4DA6-91F6-0A076FFD6BF2}"/>
               </a:ext>
             </a:extLst>
           </p:cNvPr>
@@ -6509,7 +6514,7 @@
           <p:cNvPr id="5" name="isolation-case">
             <a:extLst xmlns:a="http://schemas.openxmlformats.org/drawingml/2006/main">
               <a:ext uri="{FF2B5EF4-FFF2-40B4-BE49-F238E27FC236}">
-                <a16:creationId xmlns:a16="http://schemas.microsoft.com/office/drawing/2014/main" id="{AD004FA6-3F28-4981-9939-F5E2943AE086}"/>
+                <a16:creationId xmlns:a16="http://schemas.microsoft.com/office/drawing/2014/main" id="{14396E19-2B2C-494F-9024-7F0EFA39E796}"/>
               </a:ext>
             </a:extLst>
           </p:cNvPr>
@@ -6885,7 +6890,7 @@
           <p:cNvPr id="7" name="isolation-scope">
             <a:extLst xmlns:a="http://schemas.openxmlformats.org/drawingml/2006/main">
               <a:ext uri="{FF2B5EF4-FFF2-40B4-BE49-F238E27FC236}">
-                <a16:creationId xmlns:a16="http://schemas.microsoft.com/office/drawing/2014/main" id="{0CA9F872-FA79-46A2-9AB9-0084974F7E62}"/>
+                <a16:creationId xmlns:a16="http://schemas.microsoft.com/office/drawing/2014/main" id="{C005ED86-6142-4FE9-BE71-2B25491446CE}"/>
               </a:ext>
             </a:extLst>
           </p:cNvPr>
@@ -6971,7 +6976,7 @@
           <p:cNvPr id="12" name="eyebrow">
             <a:extLst xmlns:a="http://schemas.openxmlformats.org/drawingml/2006/main">
               <a:ext uri="{FF2B5EF4-FFF2-40B4-BE49-F238E27FC236}">
-                <a16:creationId xmlns:a16="http://schemas.microsoft.com/office/drawing/2014/main" id="{244EA00E-C1F9-4B97-BC11-F1C98ACEFEEB}"/>
+                <a16:creationId xmlns:a16="http://schemas.microsoft.com/office/drawing/2014/main" id="{8F03A9C0-1688-47D5-B6DE-285980026149}"/>
               </a:ext>
             </a:extLst>
           </p:cNvPr>
@@ -7028,7 +7033,7 @@
           <p:cNvPr id="2" name="slide-title">
             <a:extLst xmlns:a="http://schemas.openxmlformats.org/drawingml/2006/main">
               <a:ext uri="{FF2B5EF4-FFF2-40B4-BE49-F238E27FC236}">
-                <a16:creationId xmlns:a16="http://schemas.microsoft.com/office/drawing/2014/main" id="{B545D963-F927-4D94-820B-3AD679D21FBE}"/>
+                <a16:creationId xmlns:a16="http://schemas.microsoft.com/office/drawing/2014/main" id="{9B193C55-0254-4298-95A6-81EAEE0E45ED}"/>
               </a:ext>
             </a:extLst>
           </p:cNvPr>
@@ -7085,7 +7090,7 @@
           <p:cNvPr id="3" name="">
             <a:extLst xmlns:a="http://schemas.openxmlformats.org/drawingml/2006/main">
               <a:ext uri="{FF2B5EF4-FFF2-40B4-BE49-F238E27FC236}">
-                <a16:creationId xmlns:a16="http://schemas.microsoft.com/office/drawing/2014/main" id="{81C5A469-3280-48EE-8667-77E96ECC0B01}"/>
+                <a16:creationId xmlns:a16="http://schemas.microsoft.com/office/drawing/2014/main" id="{9EDA3007-35FC-4D4F-BFAF-112660A976F3}"/>
               </a:ext>
             </a:extLst>
           </p:cNvPr>
@@ -7117,7 +7122,7 @@
           <p:cNvPr id="4" name="slide-number">
             <a:extLst xmlns:a="http://schemas.openxmlformats.org/drawingml/2006/main">
               <a:ext uri="{FF2B5EF4-FFF2-40B4-BE49-F238E27FC236}">
-                <a16:creationId xmlns:a16="http://schemas.microsoft.com/office/drawing/2014/main" id="{66F021FE-A3A6-46BD-955A-E3826BC5F6A3}"/>
+                <a16:creationId xmlns:a16="http://schemas.microsoft.com/office/drawing/2014/main" id="{E22D5F07-D970-4213-88C7-F5C0E6EF7896}"/>
               </a:ext>
             </a:extLst>
           </p:cNvPr>
@@ -7174,7 +7179,7 @@
           <p:cNvPr id="5" name="">
             <a:extLst xmlns:a="http://schemas.openxmlformats.org/drawingml/2006/main">
               <a:ext uri="{FF2B5EF4-FFF2-40B4-BE49-F238E27FC236}">
-                <a16:creationId xmlns:a16="http://schemas.microsoft.com/office/drawing/2014/main" id="{4924F37C-7373-4570-90EA-41876D9845CD}"/>
+                <a16:creationId xmlns:a16="http://schemas.microsoft.com/office/drawing/2014/main" id="{347AF73C-59F0-46BB-8AE5-AAA2EE74F9A0}"/>
               </a:ext>
             </a:extLst>
           </p:cNvPr>
@@ -7206,7 +7211,7 @@
           <p:cNvPr id="6" name="a-sql">
             <a:extLst xmlns:a="http://schemas.openxmlformats.org/drawingml/2006/main">
               <a:ext uri="{FF2B5EF4-FFF2-40B4-BE49-F238E27FC236}">
-                <a16:creationId xmlns:a16="http://schemas.microsoft.com/office/drawing/2014/main" id="{1A8764DC-809A-468D-B489-C2E4A3D17B0E}"/>
+                <a16:creationId xmlns:a16="http://schemas.microsoft.com/office/drawing/2014/main" id="{95B88899-2269-4230-A2F1-7D8AB367F746}"/>
               </a:ext>
             </a:extLst>
           </p:cNvPr>
@@ -7332,7 +7337,7 @@
           <p:cNvPr id="7" name="">
             <a:extLst xmlns:a="http://schemas.openxmlformats.org/drawingml/2006/main">
               <a:ext uri="{FF2B5EF4-FFF2-40B4-BE49-F238E27FC236}">
-                <a16:creationId xmlns:a16="http://schemas.microsoft.com/office/drawing/2014/main" id="{BE3C5F03-1207-49DD-A2BB-8580E4FC6062}"/>
+                <a16:creationId xmlns:a16="http://schemas.microsoft.com/office/drawing/2014/main" id="{EEF4D42B-36FC-4A73-84AB-BB05001934EB}"/>
               </a:ext>
             </a:extLst>
           </p:cNvPr>
@@ -7364,7 +7369,7 @@
           <p:cNvPr id="8" name="b-sql">
             <a:extLst xmlns:a="http://schemas.openxmlformats.org/drawingml/2006/main">
               <a:ext uri="{FF2B5EF4-FFF2-40B4-BE49-F238E27FC236}">
-                <a16:creationId xmlns:a16="http://schemas.microsoft.com/office/drawing/2014/main" id="{8F13A41C-1BA1-4FA7-97F9-20DF98BE7812}"/>
+                <a16:creationId xmlns:a16="http://schemas.microsoft.com/office/drawing/2014/main" id="{8D8BAF3F-012E-496F-A8A8-F94493F08FE5}"/>
               </a:ext>
             </a:extLst>
           </p:cNvPr>
@@ -7536,7 +7541,7 @@
           <p:cNvPr id="9" name="a-label">
             <a:extLst xmlns:a="http://schemas.openxmlformats.org/drawingml/2006/main">
               <a:ext uri="{FF2B5EF4-FFF2-40B4-BE49-F238E27FC236}">
-                <a16:creationId xmlns:a16="http://schemas.microsoft.com/office/drawing/2014/main" id="{9D521826-F9A7-4F12-903E-B62BA49D2A38}"/>
+                <a16:creationId xmlns:a16="http://schemas.microsoft.com/office/drawing/2014/main" id="{26141BCD-90CE-4575-98A7-767B8BC15E55}"/>
               </a:ext>
             </a:extLst>
           </p:cNvPr>
@@ -7593,7 +7598,7 @@
           <p:cNvPr id="10" name="b-label">
             <a:extLst xmlns:a="http://schemas.openxmlformats.org/drawingml/2006/main">
               <a:ext uri="{FF2B5EF4-FFF2-40B4-BE49-F238E27FC236}">
-                <a16:creationId xmlns:a16="http://schemas.microsoft.com/office/drawing/2014/main" id="{A9CF8251-D77D-49B6-BF2C-DA1A9C8E0740}"/>
+                <a16:creationId xmlns:a16="http://schemas.microsoft.com/office/drawing/2014/main" id="{E12EB9B7-D4A1-44C8-90B1-866200DB0DE1}"/>
               </a:ext>
             </a:extLst>
           </p:cNvPr>
@@ -7650,7 +7655,7 @@
           <p:cNvPr id="11" name="bounded">
             <a:extLst xmlns:a="http://schemas.openxmlformats.org/drawingml/2006/main">
               <a:ext uri="{FF2B5EF4-FFF2-40B4-BE49-F238E27FC236}">
-                <a16:creationId xmlns:a16="http://schemas.microsoft.com/office/drawing/2014/main" id="{00E9593B-ED9E-40C5-9A52-46486206EBDF}"/>
+                <a16:creationId xmlns:a16="http://schemas.microsoft.com/office/drawing/2014/main" id="{2AE0004E-30FC-4C9D-A30E-37017A65C744}"/>
               </a:ext>
             </a:extLst>
           </p:cNvPr>
@@ -7736,7 +7741,7 @@
           <p:cNvPr id="9" name="eyebrow">
             <a:extLst xmlns:a="http://schemas.openxmlformats.org/drawingml/2006/main">
               <a:ext uri="{FF2B5EF4-FFF2-40B4-BE49-F238E27FC236}">
-                <a16:creationId xmlns:a16="http://schemas.microsoft.com/office/drawing/2014/main" id="{6AAAEE49-84C9-4C38-8B1E-722A55475502}"/>
+                <a16:creationId xmlns:a16="http://schemas.microsoft.com/office/drawing/2014/main" id="{E5D6D4C2-9DAE-4BF4-8024-6C903490BDD0}"/>
               </a:ext>
             </a:extLst>
           </p:cNvPr>
@@ -7793,7 +7798,7 @@
           <p:cNvPr id="2" name="slide-title">
             <a:extLst xmlns:a="http://schemas.openxmlformats.org/drawingml/2006/main">
               <a:ext uri="{FF2B5EF4-FFF2-40B4-BE49-F238E27FC236}">
-                <a16:creationId xmlns:a16="http://schemas.microsoft.com/office/drawing/2014/main" id="{D910D9AB-3A6C-413C-B887-6156B599B6EE}"/>
+                <a16:creationId xmlns:a16="http://schemas.microsoft.com/office/drawing/2014/main" id="{15679570-A62D-4D77-B14E-8F0998D4E59C}"/>
               </a:ext>
             </a:extLst>
           </p:cNvPr>
@@ -7850,7 +7855,7 @@
           <p:cNvPr id="3" name="">
             <a:extLst xmlns:a="http://schemas.openxmlformats.org/drawingml/2006/main">
               <a:ext uri="{FF2B5EF4-FFF2-40B4-BE49-F238E27FC236}">
-                <a16:creationId xmlns:a16="http://schemas.microsoft.com/office/drawing/2014/main" id="{8C7533B8-9442-49A9-9E96-07F2C3BD3CAB}"/>
+                <a16:creationId xmlns:a16="http://schemas.microsoft.com/office/drawing/2014/main" id="{81252111-FD48-489F-A66C-C4A9C7591D91}"/>
               </a:ext>
             </a:extLst>
           </p:cNvPr>
@@ -7882,7 +7887,7 @@
           <p:cNvPr id="4" name="slide-number">
             <a:extLst xmlns:a="http://schemas.openxmlformats.org/drawingml/2006/main">
               <a:ext uri="{FF2B5EF4-FFF2-40B4-BE49-F238E27FC236}">
-                <a16:creationId xmlns:a16="http://schemas.microsoft.com/office/drawing/2014/main" id="{22D9534C-CB77-403A-9991-1C28EA24862A}"/>
+                <a16:creationId xmlns:a16="http://schemas.microsoft.com/office/drawing/2014/main" id="{68F22210-DA15-4FB0-A5C7-F54EF754DB01}"/>
               </a:ext>
             </a:extLst>
           </p:cNvPr>
@@ -7939,7 +7944,7 @@
           <p:cNvPr id="5" name="">
             <a:extLst xmlns:a="http://schemas.openxmlformats.org/drawingml/2006/main">
               <a:ext uri="{FF2B5EF4-FFF2-40B4-BE49-F238E27FC236}">
-                <a16:creationId xmlns:a16="http://schemas.microsoft.com/office/drawing/2014/main" id="{89FB078B-A838-4F13-846C-85164A68C3AD}"/>
+                <a16:creationId xmlns:a16="http://schemas.microsoft.com/office/drawing/2014/main" id="{43C5241E-2578-48F3-8488-DB9489034B65}"/>
               </a:ext>
             </a:extLst>
           </p:cNvPr>
@@ -7971,7 +7976,7 @@
           <p:cNvPr id="6" name="diagnose-sql">
             <a:extLst xmlns:a="http://schemas.openxmlformats.org/drawingml/2006/main">
               <a:ext uri="{FF2B5EF4-FFF2-40B4-BE49-F238E27FC236}">
-                <a16:creationId xmlns:a16="http://schemas.microsoft.com/office/drawing/2014/main" id="{A244C015-5976-49BA-8049-561F7566A8BA}"/>
+                <a16:creationId xmlns:a16="http://schemas.microsoft.com/office/drawing/2014/main" id="{992AEC77-6455-4B96-880A-D45DB98BF372}"/>
               </a:ext>
             </a:extLst>
           </p:cNvPr>
@@ -8189,7 +8194,7 @@
           <p:cNvPr id="7" name="diagnose-meaning">
             <a:extLst xmlns:a="http://schemas.openxmlformats.org/drawingml/2006/main">
               <a:ext uri="{FF2B5EF4-FFF2-40B4-BE49-F238E27FC236}">
-                <a16:creationId xmlns:a16="http://schemas.microsoft.com/office/drawing/2014/main" id="{9268A2BA-1170-4EC1-A59E-5C83494F91B5}"/>
+                <a16:creationId xmlns:a16="http://schemas.microsoft.com/office/drawing/2014/main" id="{849D0ACB-0D89-482F-9A88-39CC8C109423}"/>
               </a:ext>
             </a:extLst>
           </p:cNvPr>
@@ -8246,7 +8251,7 @@
           <p:cNvPr id="8" name="diagnose-scope">
             <a:extLst xmlns:a="http://schemas.openxmlformats.org/drawingml/2006/main">
               <a:ext uri="{FF2B5EF4-FFF2-40B4-BE49-F238E27FC236}">
-                <a16:creationId xmlns:a16="http://schemas.microsoft.com/office/drawing/2014/main" id="{32A33211-EF0C-4764-9584-AD0CE0DB5619}"/>
+                <a16:creationId xmlns:a16="http://schemas.microsoft.com/office/drawing/2014/main" id="{2833A890-B37F-4804-A060-2214D31D1D99}"/>
               </a:ext>
             </a:extLst>
           </p:cNvPr>
@@ -8332,7 +8337,7 @@
           <p:cNvPr id="8" name="eyebrow">
             <a:extLst xmlns:a="http://schemas.openxmlformats.org/drawingml/2006/main">
               <a:ext uri="{FF2B5EF4-FFF2-40B4-BE49-F238E27FC236}">
-                <a16:creationId xmlns:a16="http://schemas.microsoft.com/office/drawing/2014/main" id="{E755EDB9-0450-47B0-8207-34EBA1C4BDC5}"/>
+                <a16:creationId xmlns:a16="http://schemas.microsoft.com/office/drawing/2014/main" id="{AAC1CBF8-E831-406D-BBB4-2F68EEE7B142}"/>
               </a:ext>
             </a:extLst>
           </p:cNvPr>
@@ -8389,7 +8394,7 @@
           <p:cNvPr id="2" name="slide-title">
             <a:extLst xmlns:a="http://schemas.openxmlformats.org/drawingml/2006/main">
               <a:ext uri="{FF2B5EF4-FFF2-40B4-BE49-F238E27FC236}">
-                <a16:creationId xmlns:a16="http://schemas.microsoft.com/office/drawing/2014/main" id="{B43FAB27-AB18-4A18-A852-CA0BB2127441}"/>
+                <a16:creationId xmlns:a16="http://schemas.microsoft.com/office/drawing/2014/main" id="{9E4D5AA0-7446-48CD-AC10-F358B81B807F}"/>
               </a:ext>
             </a:extLst>
           </p:cNvPr>
@@ -8446,7 +8451,7 @@
           <p:cNvPr id="3" name="">
             <a:extLst xmlns:a="http://schemas.openxmlformats.org/drawingml/2006/main">
               <a:ext uri="{FF2B5EF4-FFF2-40B4-BE49-F238E27FC236}">
-                <a16:creationId xmlns:a16="http://schemas.microsoft.com/office/drawing/2014/main" id="{EBA81930-A62E-4D2A-A8E0-CBE1AB4FB79C}"/>
+                <a16:creationId xmlns:a16="http://schemas.microsoft.com/office/drawing/2014/main" id="{620051F0-A9B2-4D54-B323-826ECED2428B}"/>
               </a:ext>
             </a:extLst>
           </p:cNvPr>
@@ -8478,7 +8483,7 @@
           <p:cNvPr id="4" name="slide-number">
             <a:extLst xmlns:a="http://schemas.openxmlformats.org/drawingml/2006/main">
               <a:ext uri="{FF2B5EF4-FFF2-40B4-BE49-F238E27FC236}">
-                <a16:creationId xmlns:a16="http://schemas.microsoft.com/office/drawing/2014/main" id="{AC322006-B8B2-4832-A3C9-7901102164C9}"/>
+                <a16:creationId xmlns:a16="http://schemas.microsoft.com/office/drawing/2014/main" id="{EC1E46A6-3C75-4E3C-86C3-1FE2B716603D}"/>
               </a:ext>
             </a:extLst>
           </p:cNvPr>
@@ -8926,7 +8931,7 @@
           <p:cNvPr id="6" name="snapshot-meaning">
             <a:extLst xmlns:a="http://schemas.openxmlformats.org/drawingml/2006/main">
               <a:ext uri="{FF2B5EF4-FFF2-40B4-BE49-F238E27FC236}">
-                <a16:creationId xmlns:a16="http://schemas.microsoft.com/office/drawing/2014/main" id="{70045764-6792-444B-8246-672B0431CDD0}"/>
+                <a16:creationId xmlns:a16="http://schemas.microsoft.com/office/drawing/2014/main" id="{A8C5D696-6EE9-4531-83D0-40894D5376A6}"/>
               </a:ext>
             </a:extLst>
           </p:cNvPr>
@@ -8983,7 +8988,7 @@
           <p:cNvPr id="7" name="snapshot-scope">
             <a:extLst xmlns:a="http://schemas.openxmlformats.org/drawingml/2006/main">
               <a:ext uri="{FF2B5EF4-FFF2-40B4-BE49-F238E27FC236}">
-                <a16:creationId xmlns:a16="http://schemas.microsoft.com/office/drawing/2014/main" id="{7647E327-DF52-4F0B-86B8-A2445A54BB4F}"/>
+                <a16:creationId xmlns:a16="http://schemas.microsoft.com/office/drawing/2014/main" id="{FA530846-BEA7-4337-9B78-692073AB235B}"/>
               </a:ext>
             </a:extLst>
           </p:cNvPr>
@@ -9069,7 +9074,7 @@
           <p:cNvPr id="9" name="eyebrow">
             <a:extLst xmlns:a="http://schemas.openxmlformats.org/drawingml/2006/main">
               <a:ext uri="{FF2B5EF4-FFF2-40B4-BE49-F238E27FC236}">
-                <a16:creationId xmlns:a16="http://schemas.microsoft.com/office/drawing/2014/main" id="{FD46654A-66B6-47D2-AF41-BFCBCC50F181}"/>
+                <a16:creationId xmlns:a16="http://schemas.microsoft.com/office/drawing/2014/main" id="{54D609E8-7F45-492B-B8AF-EDD2B743FBBC}"/>
               </a:ext>
             </a:extLst>
           </p:cNvPr>
@@ -9126,7 +9131,7 @@
           <p:cNvPr id="2" name="slide-title">
             <a:extLst xmlns:a="http://schemas.openxmlformats.org/drawingml/2006/main">
               <a:ext uri="{FF2B5EF4-FFF2-40B4-BE49-F238E27FC236}">
-                <a16:creationId xmlns:a16="http://schemas.microsoft.com/office/drawing/2014/main" id="{E6A69260-715A-47D8-867E-96FE1909692A}"/>
+                <a16:creationId xmlns:a16="http://schemas.microsoft.com/office/drawing/2014/main" id="{104FA06B-239F-4FB7-9FA5-806AB4373968}"/>
               </a:ext>
             </a:extLst>
           </p:cNvPr>
@@ -9183,7 +9188,7 @@
           <p:cNvPr id="3" name="">
             <a:extLst xmlns:a="http://schemas.openxmlformats.org/drawingml/2006/main">
               <a:ext uri="{FF2B5EF4-FFF2-40B4-BE49-F238E27FC236}">
-                <a16:creationId xmlns:a16="http://schemas.microsoft.com/office/drawing/2014/main" id="{6CC52167-E833-4FE5-908B-1E23433AC75B}"/>
+                <a16:creationId xmlns:a16="http://schemas.microsoft.com/office/drawing/2014/main" id="{447D83FD-92EC-4077-85DF-A8E02D557F7F}"/>
               </a:ext>
             </a:extLst>
           </p:cNvPr>
@@ -9215,7 +9220,7 @@
           <p:cNvPr id="4" name="slide-number">
             <a:extLst xmlns:a="http://schemas.openxmlformats.org/drawingml/2006/main">
               <a:ext uri="{FF2B5EF4-FFF2-40B4-BE49-F238E27FC236}">
-                <a16:creationId xmlns:a16="http://schemas.microsoft.com/office/drawing/2014/main" id="{05860306-933B-4177-BAB9-3747F20962B6}"/>
+                <a16:creationId xmlns:a16="http://schemas.microsoft.com/office/drawing/2014/main" id="{302069DC-E852-4038-9225-278E51FC4D77}"/>
               </a:ext>
             </a:extLst>
           </p:cNvPr>
@@ -9517,7 +9522,7 @@
           <p:cNvPr id="6" name="">
             <a:extLst xmlns:a="http://schemas.openxmlformats.org/drawingml/2006/main">
               <a:ext uri="{FF2B5EF4-FFF2-40B4-BE49-F238E27FC236}">
-                <a16:creationId xmlns:a16="http://schemas.microsoft.com/office/drawing/2014/main" id="{4A4B9CD3-0D65-4C73-8527-304C41776CD7}"/>
+                <a16:creationId xmlns:a16="http://schemas.microsoft.com/office/drawing/2014/main" id="{7D63AC62-8E58-4A98-9665-0412CFBFF95E}"/>
               </a:ext>
             </a:extLst>
           </p:cNvPr>
@@ -9549,7 +9554,7 @@
           <p:cNvPr id="7" name="lock-final">
             <a:extLst xmlns:a="http://schemas.openxmlformats.org/drawingml/2006/main">
               <a:ext uri="{FF2B5EF4-FFF2-40B4-BE49-F238E27FC236}">
-                <a16:creationId xmlns:a16="http://schemas.microsoft.com/office/drawing/2014/main" id="{60713B24-C587-440D-A087-1065F9DF662B}"/>
+                <a16:creationId xmlns:a16="http://schemas.microsoft.com/office/drawing/2014/main" id="{5032042C-A659-49D4-AC1D-E94714A03E47}"/>
               </a:ext>
             </a:extLst>
           </p:cNvPr>
@@ -9629,7 +9634,7 @@
           <p:cNvPr id="8" name="outcome-limit">
             <a:extLst xmlns:a="http://schemas.openxmlformats.org/drawingml/2006/main">
               <a:ext uri="{FF2B5EF4-FFF2-40B4-BE49-F238E27FC236}">
-                <a16:creationId xmlns:a16="http://schemas.microsoft.com/office/drawing/2014/main" id="{C305D01E-9168-4BEB-A92C-248DFE8F46D5}"/>
+                <a16:creationId xmlns:a16="http://schemas.microsoft.com/office/drawing/2014/main" id="{FE32279F-7A26-4E38-824F-1A2F2D317700}"/>
               </a:ext>
             </a:extLst>
           </p:cNvPr>
@@ -9715,7 +9720,7 @@
           <p:cNvPr id="7" name="eyebrow">
             <a:extLst xmlns:a="http://schemas.openxmlformats.org/drawingml/2006/main">
               <a:ext uri="{FF2B5EF4-FFF2-40B4-BE49-F238E27FC236}">
-                <a16:creationId xmlns:a16="http://schemas.microsoft.com/office/drawing/2014/main" id="{56B207CD-559C-4C40-A0FC-A40E87A24597}"/>
+                <a16:creationId xmlns:a16="http://schemas.microsoft.com/office/drawing/2014/main" id="{4F5884AC-B5CD-4EC4-9E47-1CDB0BE02E9A}"/>
               </a:ext>
             </a:extLst>
           </p:cNvPr>
@@ -9772,7 +9777,7 @@
           <p:cNvPr id="2" name="slide-title">
             <a:extLst xmlns:a="http://schemas.openxmlformats.org/drawingml/2006/main">
               <a:ext uri="{FF2B5EF4-FFF2-40B4-BE49-F238E27FC236}">
-                <a16:creationId xmlns:a16="http://schemas.microsoft.com/office/drawing/2014/main" id="{F104BD01-85A6-4811-926D-AC3FC9C5C153}"/>
+                <a16:creationId xmlns:a16="http://schemas.microsoft.com/office/drawing/2014/main" id="{AA947065-12C8-404F-9F45-EDD65D1733A2}"/>
               </a:ext>
             </a:extLst>
           </p:cNvPr>
@@ -9829,7 +9834,7 @@
           <p:cNvPr id="3" name="">
             <a:extLst xmlns:a="http://schemas.openxmlformats.org/drawingml/2006/main">
               <a:ext uri="{FF2B5EF4-FFF2-40B4-BE49-F238E27FC236}">
-                <a16:creationId xmlns:a16="http://schemas.microsoft.com/office/drawing/2014/main" id="{88FDA524-782E-46CC-88B3-20195088CA64}"/>
+                <a16:creationId xmlns:a16="http://schemas.microsoft.com/office/drawing/2014/main" id="{0DF9DA51-A344-4F0A-9C23-20423A9D07C8}"/>
               </a:ext>
             </a:extLst>
           </p:cNvPr>
@@ -9861,7 +9866,7 @@
           <p:cNvPr id="4" name="slide-number">
             <a:extLst xmlns:a="http://schemas.openxmlformats.org/drawingml/2006/main">
               <a:ext uri="{FF2B5EF4-FFF2-40B4-BE49-F238E27FC236}">
-                <a16:creationId xmlns:a16="http://schemas.microsoft.com/office/drawing/2014/main" id="{9B449957-41A4-4DFA-B92E-CE6F0685DA1F}"/>
+                <a16:creationId xmlns:a16="http://schemas.microsoft.com/office/drawing/2014/main" id="{58280F4F-ED06-49E6-9700-004E2B2C4D92}"/>
               </a:ext>
             </a:extLst>
           </p:cNvPr>
@@ -10163,7 +10168,7 @@
           <p:cNvPr id="6" name="slow">
             <a:extLst xmlns:a="http://schemas.openxmlformats.org/drawingml/2006/main">
               <a:ext uri="{FF2B5EF4-FFF2-40B4-BE49-F238E27FC236}">
-                <a16:creationId xmlns:a16="http://schemas.microsoft.com/office/drawing/2014/main" id="{BE9AA80F-438C-4288-BC01-2017C4DB0047}"/>
+                <a16:creationId xmlns:a16="http://schemas.microsoft.com/office/drawing/2014/main" id="{08BF162D-07F3-493F-89FB-77FF945C5794}"/>
               </a:ext>
             </a:extLst>
           </p:cNvPr>
@@ -10249,7 +10254,7 @@
           <p:cNvPr id="17" name="eyebrow">
             <a:extLst xmlns:a="http://schemas.openxmlformats.org/drawingml/2006/main">
               <a:ext uri="{FF2B5EF4-FFF2-40B4-BE49-F238E27FC236}">
-                <a16:creationId xmlns:a16="http://schemas.microsoft.com/office/drawing/2014/main" id="{1A46527A-5835-4630-85D9-2E1F10918988}"/>
+                <a16:creationId xmlns:a16="http://schemas.microsoft.com/office/drawing/2014/main" id="{8EAF7DB9-A4F1-45BC-9E4F-49FF69BD1916}"/>
               </a:ext>
             </a:extLst>
           </p:cNvPr>
@@ -10306,7 +10311,7 @@
           <p:cNvPr id="2" name="slide-title">
             <a:extLst xmlns:a="http://schemas.openxmlformats.org/drawingml/2006/main">
               <a:ext uri="{FF2B5EF4-FFF2-40B4-BE49-F238E27FC236}">
-                <a16:creationId xmlns:a16="http://schemas.microsoft.com/office/drawing/2014/main" id="{04F8A094-09C4-4CEC-9F04-C59CEB3E0388}"/>
+                <a16:creationId xmlns:a16="http://schemas.microsoft.com/office/drawing/2014/main" id="{B3810B85-679D-4C39-B04E-C958D4667404}"/>
               </a:ext>
             </a:extLst>
           </p:cNvPr>
@@ -10363,7 +10368,7 @@
           <p:cNvPr id="3" name="">
             <a:extLst xmlns:a="http://schemas.openxmlformats.org/drawingml/2006/main">
               <a:ext uri="{FF2B5EF4-FFF2-40B4-BE49-F238E27FC236}">
-                <a16:creationId xmlns:a16="http://schemas.microsoft.com/office/drawing/2014/main" id="{2044577C-1E63-431F-BEA4-7E607FE13F28}"/>
+                <a16:creationId xmlns:a16="http://schemas.microsoft.com/office/drawing/2014/main" id="{B4A0B3D9-972B-4170-AC84-19B5CDAC3297}"/>
               </a:ext>
             </a:extLst>
           </p:cNvPr>
@@ -10395,7 +10400,7 @@
           <p:cNvPr id="4" name="slide-number">
             <a:extLst xmlns:a="http://schemas.openxmlformats.org/drawingml/2006/main">
               <a:ext uri="{FF2B5EF4-FFF2-40B4-BE49-F238E27FC236}">
-                <a16:creationId xmlns:a16="http://schemas.microsoft.com/office/drawing/2014/main" id="{B00AB3F5-14A9-4C45-BF76-D3873B37BDB4}"/>
+                <a16:creationId xmlns:a16="http://schemas.microsoft.com/office/drawing/2014/main" id="{6526CDF9-80AB-499F-A548-66CD51D314EE}"/>
               </a:ext>
             </a:extLst>
           </p:cNvPr>
@@ -10452,7 +10457,7 @@
           <p:cNvPr id="5" name="">
             <a:extLst xmlns:a="http://schemas.openxmlformats.org/drawingml/2006/main">
               <a:ext uri="{FF2B5EF4-FFF2-40B4-BE49-F238E27FC236}">
-                <a16:creationId xmlns:a16="http://schemas.microsoft.com/office/drawing/2014/main" id="{C4EC4FB2-2BFB-4B06-B1ED-48DCF71611C1}"/>
+                <a16:creationId xmlns:a16="http://schemas.microsoft.com/office/drawing/2014/main" id="{BE622F63-298D-4BCC-BB26-9BFDB9C12CBA}"/>
               </a:ext>
             </a:extLst>
           </p:cNvPr>
@@ -10484,7 +10489,7 @@
           <p:cNvPr id="6" name="deadlock-a">
             <a:extLst xmlns:a="http://schemas.openxmlformats.org/drawingml/2006/main">
               <a:ext uri="{FF2B5EF4-FFF2-40B4-BE49-F238E27FC236}">
-                <a16:creationId xmlns:a16="http://schemas.microsoft.com/office/drawing/2014/main" id="{76BCC726-2DA0-41AC-9FFB-E38A0BBF7B2B}"/>
+                <a16:creationId xmlns:a16="http://schemas.microsoft.com/office/drawing/2014/main" id="{11F50A90-8A2C-401E-B644-C75A605142C1}"/>
               </a:ext>
             </a:extLst>
           </p:cNvPr>
@@ -10564,7 +10569,7 @@
           <p:cNvPr id="7" name="">
             <a:extLst xmlns:a="http://schemas.openxmlformats.org/drawingml/2006/main">
               <a:ext uri="{FF2B5EF4-FFF2-40B4-BE49-F238E27FC236}">
-                <a16:creationId xmlns:a16="http://schemas.microsoft.com/office/drawing/2014/main" id="{649766EA-CC5C-47B9-A4AE-E30A40885905}"/>
+                <a16:creationId xmlns:a16="http://schemas.microsoft.com/office/drawing/2014/main" id="{AAE53842-4443-4583-8FF3-1A333B3B046D}"/>
               </a:ext>
             </a:extLst>
           </p:cNvPr>
@@ -10596,7 +10601,7 @@
           <p:cNvPr id="8" name="deadlock-b">
             <a:extLst xmlns:a="http://schemas.openxmlformats.org/drawingml/2006/main">
               <a:ext uri="{FF2B5EF4-FFF2-40B4-BE49-F238E27FC236}">
-                <a16:creationId xmlns:a16="http://schemas.microsoft.com/office/drawing/2014/main" id="{51339023-0CF4-4B41-AEB9-F525D183C98A}"/>
+                <a16:creationId xmlns:a16="http://schemas.microsoft.com/office/drawing/2014/main" id="{3315906E-E8F7-4717-8BBB-3F348BDAF7BC}"/>
               </a:ext>
             </a:extLst>
           </p:cNvPr>
@@ -10676,7 +10681,7 @@
           <p:cNvPr id="9" name="">
             <a:extLst xmlns:a="http://schemas.openxmlformats.org/drawingml/2006/main">
               <a:ext uri="{FF2B5EF4-FFF2-40B4-BE49-F238E27FC236}">
-                <a16:creationId xmlns:a16="http://schemas.microsoft.com/office/drawing/2014/main" id="{1B148520-5860-4182-94CA-0DB2A37F8076}"/>
+                <a16:creationId xmlns:a16="http://schemas.microsoft.com/office/drawing/2014/main" id="{BC8DE987-1239-40B7-82BA-856FF0E674BF}"/>
               </a:ext>
             </a:extLst>
           </p:cNvPr>
@@ -10708,7 +10713,7 @@
           <p:cNvPr id="10" name="a-waits">
             <a:extLst xmlns:a="http://schemas.openxmlformats.org/drawingml/2006/main">
               <a:ext uri="{FF2B5EF4-FFF2-40B4-BE49-F238E27FC236}">
-                <a16:creationId xmlns:a16="http://schemas.microsoft.com/office/drawing/2014/main" id="{61E051B8-0BA4-4B00-9390-97F40C8740CB}"/>
+                <a16:creationId xmlns:a16="http://schemas.microsoft.com/office/drawing/2014/main" id="{6034E111-CFA9-42A8-8126-BE73BD2B7948}"/>
               </a:ext>
             </a:extLst>
           </p:cNvPr>
@@ -10765,7 +10770,7 @@
           <p:cNvPr id="11" name="">
             <a:extLst xmlns:a="http://schemas.openxmlformats.org/drawingml/2006/main">
               <a:ext uri="{FF2B5EF4-FFF2-40B4-BE49-F238E27FC236}">
-                <a16:creationId xmlns:a16="http://schemas.microsoft.com/office/drawing/2014/main" id="{70FBABEB-F8DE-42C9-98AE-CC51204498F3}"/>
+                <a16:creationId xmlns:a16="http://schemas.microsoft.com/office/drawing/2014/main" id="{79EA599E-D4AA-4D1A-8EC6-F044CF16101F}"/>
               </a:ext>
             </a:extLst>
           </p:cNvPr>
@@ -10797,7 +10802,7 @@
           <p:cNvPr id="12" name="">
             <a:extLst xmlns:a="http://schemas.openxmlformats.org/drawingml/2006/main">
               <a:ext uri="{FF2B5EF4-FFF2-40B4-BE49-F238E27FC236}">
-                <a16:creationId xmlns:a16="http://schemas.microsoft.com/office/drawing/2014/main" id="{DEB81FC1-15EF-4396-BCC1-3B1B89070BD6}"/>
+                <a16:creationId xmlns:a16="http://schemas.microsoft.com/office/drawing/2014/main" id="{15376F10-2886-4C71-907C-337357DAD89D}"/>
               </a:ext>
             </a:extLst>
           </p:cNvPr>
@@ -10829,7 +10834,7 @@
           <p:cNvPr id="13" name="">
             <a:extLst xmlns:a="http://schemas.openxmlformats.org/drawingml/2006/main">
               <a:ext uri="{FF2B5EF4-FFF2-40B4-BE49-F238E27FC236}">
-                <a16:creationId xmlns:a16="http://schemas.microsoft.com/office/drawing/2014/main" id="{43CBE24D-ECEC-4C9E-A249-82C5410CA26A}"/>
+                <a16:creationId xmlns:a16="http://schemas.microsoft.com/office/drawing/2014/main" id="{AB3EF428-5F42-480F-8B92-E2E55E749288}"/>
               </a:ext>
             </a:extLst>
           </p:cNvPr>
@@ -10861,7 +10866,7 @@
           <p:cNvPr id="14" name="b-waits">
             <a:extLst xmlns:a="http://schemas.openxmlformats.org/drawingml/2006/main">
               <a:ext uri="{FF2B5EF4-FFF2-40B4-BE49-F238E27FC236}">
-                <a16:creationId xmlns:a16="http://schemas.microsoft.com/office/drawing/2014/main" id="{E03F434C-BDC2-44C1-9879-0FB2C3E7E0A9}"/>
+                <a16:creationId xmlns:a16="http://schemas.microsoft.com/office/drawing/2014/main" id="{52DE5CE3-6484-4649-897D-BF1DCCA85144}"/>
               </a:ext>
             </a:extLst>
           </p:cNvPr>
@@ -10918,7 +10923,7 @@
           <p:cNvPr id="15" name="cycle">
             <a:extLst xmlns:a="http://schemas.openxmlformats.org/drawingml/2006/main">
               <a:ext uri="{FF2B5EF4-FFF2-40B4-BE49-F238E27FC236}">
-                <a16:creationId xmlns:a16="http://schemas.microsoft.com/office/drawing/2014/main" id="{06B47E5C-476C-412C-B645-AAFFD3A9C7E9}"/>
+                <a16:creationId xmlns:a16="http://schemas.microsoft.com/office/drawing/2014/main" id="{B448BC30-A7DB-4C20-81DA-1B40CE10AD9F}"/>
               </a:ext>
             </a:extLst>
           </p:cNvPr>
@@ -10975,7 +10980,7 @@
           <p:cNvPr id="16" name="deadlock-rule">
             <a:extLst xmlns:a="http://schemas.openxmlformats.org/drawingml/2006/main">
               <a:ext uri="{FF2B5EF4-FFF2-40B4-BE49-F238E27FC236}">
-                <a16:creationId xmlns:a16="http://schemas.microsoft.com/office/drawing/2014/main" id="{B0FA103D-4C2A-4451-B024-7AB6CFCE0C11}"/>
+                <a16:creationId xmlns:a16="http://schemas.microsoft.com/office/drawing/2014/main" id="{FA25FD7A-ABB1-4C44-BB4D-B52A3C02CD5B}"/>
               </a:ext>
             </a:extLst>
           </p:cNvPr>
@@ -11061,7 +11066,7 @@
           <p:cNvPr id="7" name="eyebrow">
             <a:extLst xmlns:a="http://schemas.openxmlformats.org/drawingml/2006/main">
               <a:ext uri="{FF2B5EF4-FFF2-40B4-BE49-F238E27FC236}">
-                <a16:creationId xmlns:a16="http://schemas.microsoft.com/office/drawing/2014/main" id="{8D3B149B-0A46-4D48-8C8C-8B39D8AE7894}"/>
+                <a16:creationId xmlns:a16="http://schemas.microsoft.com/office/drawing/2014/main" id="{FC582DAB-6ADF-4B65-AD4A-FB9EEFE93E24}"/>
               </a:ext>
             </a:extLst>
           </p:cNvPr>
@@ -11118,7 +11123,7 @@
           <p:cNvPr id="2" name="slide-title">
             <a:extLst xmlns:a="http://schemas.openxmlformats.org/drawingml/2006/main">
               <a:ext uri="{FF2B5EF4-FFF2-40B4-BE49-F238E27FC236}">
-                <a16:creationId xmlns:a16="http://schemas.microsoft.com/office/drawing/2014/main" id="{701F602D-FDCE-49E8-BC53-9FE5010A32D1}"/>
+                <a16:creationId xmlns:a16="http://schemas.microsoft.com/office/drawing/2014/main" id="{7C8DF21C-AD43-459D-9A70-A4425797C575}"/>
               </a:ext>
             </a:extLst>
           </p:cNvPr>
@@ -11175,7 +11180,7 @@
           <p:cNvPr id="3" name="">
             <a:extLst xmlns:a="http://schemas.openxmlformats.org/drawingml/2006/main">
               <a:ext uri="{FF2B5EF4-FFF2-40B4-BE49-F238E27FC236}">
-                <a16:creationId xmlns:a16="http://schemas.microsoft.com/office/drawing/2014/main" id="{B1F560DC-B390-4A74-B70C-BF41607FB9F3}"/>
+                <a16:creationId xmlns:a16="http://schemas.microsoft.com/office/drawing/2014/main" id="{E9E31118-B50B-4BC2-8A35-3E8EDA3E866F}"/>
               </a:ext>
             </a:extLst>
           </p:cNvPr>
@@ -11207,7 +11212,7 @@
           <p:cNvPr id="4" name="slide-number">
             <a:extLst xmlns:a="http://schemas.openxmlformats.org/drawingml/2006/main">
               <a:ext uri="{FF2B5EF4-FFF2-40B4-BE49-F238E27FC236}">
-                <a16:creationId xmlns:a16="http://schemas.microsoft.com/office/drawing/2014/main" id="{4C872290-EA43-40BD-A4B0-56006F64E6B8}"/>
+                <a16:creationId xmlns:a16="http://schemas.microsoft.com/office/drawing/2014/main" id="{7C8CB1A9-E5E1-4688-BCDA-619F0FD83683}"/>
               </a:ext>
             </a:extLst>
           </p:cNvPr>
@@ -11509,7 +11514,7 @@
           <p:cNvPr id="6" name="pair-meaning">
             <a:extLst xmlns:a="http://schemas.openxmlformats.org/drawingml/2006/main">
               <a:ext uri="{FF2B5EF4-FFF2-40B4-BE49-F238E27FC236}">
-                <a16:creationId xmlns:a16="http://schemas.microsoft.com/office/drawing/2014/main" id="{FADF6F30-CAC0-4439-A392-89DDD5206819}"/>
+                <a16:creationId xmlns:a16="http://schemas.microsoft.com/office/drawing/2014/main" id="{D2DB94B0-8086-47BF-9DBA-19454DE98D66}"/>
               </a:ext>
             </a:extLst>
           </p:cNvPr>
@@ -11595,7 +11600,7 @@
           <p:cNvPr id="9" name="eyebrow">
             <a:extLst xmlns:a="http://schemas.openxmlformats.org/drawingml/2006/main">
               <a:ext uri="{FF2B5EF4-FFF2-40B4-BE49-F238E27FC236}">
-                <a16:creationId xmlns:a16="http://schemas.microsoft.com/office/drawing/2014/main" id="{319D169E-7BC1-491E-8B6E-AED992CD3797}"/>
+                <a16:creationId xmlns:a16="http://schemas.microsoft.com/office/drawing/2014/main" id="{E0FE72EB-A4F3-4821-B178-920B2AE39B8B}"/>
               </a:ext>
             </a:extLst>
           </p:cNvPr>
@@ -11652,7 +11657,7 @@
           <p:cNvPr id="2" name="slide-title">
             <a:extLst xmlns:a="http://schemas.openxmlformats.org/drawingml/2006/main">
               <a:ext uri="{FF2B5EF4-FFF2-40B4-BE49-F238E27FC236}">
-                <a16:creationId xmlns:a16="http://schemas.microsoft.com/office/drawing/2014/main" id="{3E687EEF-CFF8-4453-BDBC-24AADAFCEA32}"/>
+                <a16:creationId xmlns:a16="http://schemas.microsoft.com/office/drawing/2014/main" id="{88B7B094-76E2-4B1E-85F0-81CA1CBAAE3A}"/>
               </a:ext>
             </a:extLst>
           </p:cNvPr>
@@ -11709,7 +11714,7 @@
           <p:cNvPr id="3" name="">
             <a:extLst xmlns:a="http://schemas.openxmlformats.org/drawingml/2006/main">
               <a:ext uri="{FF2B5EF4-FFF2-40B4-BE49-F238E27FC236}">
-                <a16:creationId xmlns:a16="http://schemas.microsoft.com/office/drawing/2014/main" id="{A022F300-3B34-436A-A8DA-41AD4493EF30}"/>
+                <a16:creationId xmlns:a16="http://schemas.microsoft.com/office/drawing/2014/main" id="{80F01157-9FDD-4436-8050-97034B7C1B93}"/>
               </a:ext>
             </a:extLst>
           </p:cNvPr>
@@ -11741,7 +11746,7 @@
           <p:cNvPr id="4" name="slide-number">
             <a:extLst xmlns:a="http://schemas.openxmlformats.org/drawingml/2006/main">
               <a:ext uri="{FF2B5EF4-FFF2-40B4-BE49-F238E27FC236}">
-                <a16:creationId xmlns:a16="http://schemas.microsoft.com/office/drawing/2014/main" id="{85F281FF-AC43-4B73-8F98-1D4806F56573}"/>
+                <a16:creationId xmlns:a16="http://schemas.microsoft.com/office/drawing/2014/main" id="{E2791B53-8CDD-427C-B5D0-9B0F5F299196}"/>
               </a:ext>
             </a:extLst>
           </p:cNvPr>
@@ -11798,7 +11803,7 @@
           <p:cNvPr id="5" name="">
             <a:extLst xmlns:a="http://schemas.openxmlformats.org/drawingml/2006/main">
               <a:ext uri="{FF2B5EF4-FFF2-40B4-BE49-F238E27FC236}">
-                <a16:creationId xmlns:a16="http://schemas.microsoft.com/office/drawing/2014/main" id="{5FD7B446-6A2B-468E-881D-3F54321839E2}"/>
+                <a16:creationId xmlns:a16="http://schemas.microsoft.com/office/drawing/2014/main" id="{3CED0C05-807D-4E60-ADF9-58FB87DE3A33}"/>
               </a:ext>
             </a:extLst>
           </p:cNvPr>
@@ -11830,7 +11835,7 @@
           <p:cNvPr id="6" name="flags">
             <a:extLst xmlns:a="http://schemas.openxmlformats.org/drawingml/2006/main">
               <a:ext uri="{FF2B5EF4-FFF2-40B4-BE49-F238E27FC236}">
-                <a16:creationId xmlns:a16="http://schemas.microsoft.com/office/drawing/2014/main" id="{B9B6C68E-12DD-4ECA-B411-6C25FB729B46}"/>
+                <a16:creationId xmlns:a16="http://schemas.microsoft.com/office/drawing/2014/main" id="{0929DF84-FFF1-47C7-8521-C44F96DD77C2}"/>
               </a:ext>
             </a:extLst>
           </p:cNvPr>
@@ -11933,7 +11938,7 @@
           <p:cNvPr id="7" name="connect">
             <a:extLst xmlns:a="http://schemas.openxmlformats.org/drawingml/2006/main">
               <a:ext uri="{FF2B5EF4-FFF2-40B4-BE49-F238E27FC236}">
-                <a16:creationId xmlns:a16="http://schemas.microsoft.com/office/drawing/2014/main" id="{E891F3B5-92A3-439E-88FA-4898D12F2143}"/>
+                <a16:creationId xmlns:a16="http://schemas.microsoft.com/office/drawing/2014/main" id="{4E7D0C2B-6E28-4B96-BBE7-45A0A97885FE}"/>
               </a:ext>
             </a:extLst>
           </p:cNvPr>
@@ -11980,7 +11985,7 @@
                 <a:ea typeface="Helvetica Neue"/>
                 <a:cs typeface="Helvetica Neue"/>
               </a:rPr>
-              <a:t>Colab: File &gt; Upload notebook.</a:t>
+              <a:t>Lab page: Open in Colab, then save a copy in Drive.</a:t>
             </a:r>
           </a:p>
           <a:p xmlns:a="http://schemas.openxmlformats.org/drawingml/2006/main">
@@ -12036,7 +12041,7 @@
           <p:cNvPr id="8" name="mechanics">
             <a:extLst xmlns:a="http://schemas.openxmlformats.org/drawingml/2006/main">
               <a:ext uri="{FF2B5EF4-FFF2-40B4-BE49-F238E27FC236}">
-                <a16:creationId xmlns:a16="http://schemas.microsoft.com/office/drawing/2014/main" id="{CB32E514-2234-4F6F-AB0D-AAB837D52E3E}"/>
+                <a16:creationId xmlns:a16="http://schemas.microsoft.com/office/drawing/2014/main" id="{7D79320F-4B6D-4443-B971-761108CF2AA4}"/>
               </a:ext>
             </a:extLst>
           </p:cNvPr>
@@ -12122,7 +12127,7 @@
           <p:cNvPr id="9" name="eyebrow">
             <a:extLst xmlns:a="http://schemas.openxmlformats.org/drawingml/2006/main">
               <a:ext uri="{FF2B5EF4-FFF2-40B4-BE49-F238E27FC236}">
-                <a16:creationId xmlns:a16="http://schemas.microsoft.com/office/drawing/2014/main" id="{1A962B80-708E-4C10-A774-4360CE8CE941}"/>
+                <a16:creationId xmlns:a16="http://schemas.microsoft.com/office/drawing/2014/main" id="{57BAC73E-D2A7-4D4A-9349-68DB9CFB10DD}"/>
               </a:ext>
             </a:extLst>
           </p:cNvPr>
@@ -12179,7 +12184,7 @@
           <p:cNvPr id="2" name="slide-title">
             <a:extLst xmlns:a="http://schemas.openxmlformats.org/drawingml/2006/main">
               <a:ext uri="{FF2B5EF4-FFF2-40B4-BE49-F238E27FC236}">
-                <a16:creationId xmlns:a16="http://schemas.microsoft.com/office/drawing/2014/main" id="{1045BB52-860F-47B7-ABAA-9DFAB8A0DC65}"/>
+                <a16:creationId xmlns:a16="http://schemas.microsoft.com/office/drawing/2014/main" id="{9E49A496-ADB7-44D5-A8FE-A3202E53D6E8}"/>
               </a:ext>
             </a:extLst>
           </p:cNvPr>
@@ -12236,7 +12241,7 @@
           <p:cNvPr id="3" name="">
             <a:extLst xmlns:a="http://schemas.openxmlformats.org/drawingml/2006/main">
               <a:ext uri="{FF2B5EF4-FFF2-40B4-BE49-F238E27FC236}">
-                <a16:creationId xmlns:a16="http://schemas.microsoft.com/office/drawing/2014/main" id="{32029B46-C706-4B1B-869C-6CB6A1F2AD0A}"/>
+                <a16:creationId xmlns:a16="http://schemas.microsoft.com/office/drawing/2014/main" id="{7EEB1497-A607-436A-AE81-FCFD58057B31}"/>
               </a:ext>
             </a:extLst>
           </p:cNvPr>
@@ -12268,7 +12273,7 @@
           <p:cNvPr id="4" name="slide-number">
             <a:extLst xmlns:a="http://schemas.openxmlformats.org/drawingml/2006/main">
               <a:ext uri="{FF2B5EF4-FFF2-40B4-BE49-F238E27FC236}">
-                <a16:creationId xmlns:a16="http://schemas.microsoft.com/office/drawing/2014/main" id="{A0DA0A48-43D9-4008-A4A6-50D99AC0FB5A}"/>
+                <a16:creationId xmlns:a16="http://schemas.microsoft.com/office/drawing/2014/main" id="{7AA75051-BBE8-43C6-8A02-1A3B18F38B94}"/>
               </a:ext>
             </a:extLst>
           </p:cNvPr>
@@ -12325,7 +12330,7 @@
           <p:cNvPr id="5" name="lab2">
             <a:extLst xmlns:a="http://schemas.openxmlformats.org/drawingml/2006/main">
               <a:ext uri="{FF2B5EF4-FFF2-40B4-BE49-F238E27FC236}">
-                <a16:creationId xmlns:a16="http://schemas.microsoft.com/office/drawing/2014/main" id="{B4DA36AE-83B1-4910-9B79-73F97A19EA39}"/>
+                <a16:creationId xmlns:a16="http://schemas.microsoft.com/office/drawing/2014/main" id="{A88B9639-336B-4EEF-BD8D-47F887441713}"/>
               </a:ext>
             </a:extLst>
           </p:cNvPr>
@@ -12382,7 +12387,7 @@
           <p:cNvPr id="6" name="lab2-action">
             <a:extLst xmlns:a="http://schemas.openxmlformats.org/drawingml/2006/main">
               <a:ext uri="{FF2B5EF4-FFF2-40B4-BE49-F238E27FC236}">
-                <a16:creationId xmlns:a16="http://schemas.microsoft.com/office/drawing/2014/main" id="{F634E064-7D49-4A5E-852A-1758481F00C4}"/>
+                <a16:creationId xmlns:a16="http://schemas.microsoft.com/office/drawing/2014/main" id="{102DE16F-6586-49F0-AD06-8CCD0E2CE17B}"/>
               </a:ext>
             </a:extLst>
           </p:cNvPr>
@@ -12462,7 +12467,7 @@
           <p:cNvPr id="7" name="lab2-explain">
             <a:extLst xmlns:a="http://schemas.openxmlformats.org/drawingml/2006/main">
               <a:ext uri="{FF2B5EF4-FFF2-40B4-BE49-F238E27FC236}">
-                <a16:creationId xmlns:a16="http://schemas.microsoft.com/office/drawing/2014/main" id="{E2A8F183-E516-4485-B888-CCD50326F074}"/>
+                <a16:creationId xmlns:a16="http://schemas.microsoft.com/office/drawing/2014/main" id="{22F32B02-4C01-4F71-90E9-AE8C988647BA}"/>
               </a:ext>
             </a:extLst>
           </p:cNvPr>
@@ -12519,7 +12524,7 @@
           <p:cNvPr id="8" name="lab2-submit">
             <a:extLst xmlns:a="http://schemas.openxmlformats.org/drawingml/2006/main">
               <a:ext uri="{FF2B5EF4-FFF2-40B4-BE49-F238E27FC236}">
-                <a16:creationId xmlns:a16="http://schemas.microsoft.com/office/drawing/2014/main" id="{C759F4FF-904F-4597-B0DD-A5F937B63FB8}"/>
+                <a16:creationId xmlns:a16="http://schemas.microsoft.com/office/drawing/2014/main" id="{C2D7D17B-AFB8-4ABD-BBEF-BB8D707EDF53}"/>
               </a:ext>
             </a:extLst>
           </p:cNvPr>
@@ -12605,7 +12610,7 @@
           <p:cNvPr id="9" name="eyebrow">
             <a:extLst xmlns:a="http://schemas.openxmlformats.org/drawingml/2006/main">
               <a:ext uri="{FF2B5EF4-FFF2-40B4-BE49-F238E27FC236}">
-                <a16:creationId xmlns:a16="http://schemas.microsoft.com/office/drawing/2014/main" id="{1EE3FEFA-64D3-46D5-8688-BB6AE55692ED}"/>
+                <a16:creationId xmlns:a16="http://schemas.microsoft.com/office/drawing/2014/main" id="{DE53486C-4EA6-415F-A6E7-1708019FDAC6}"/>
               </a:ext>
             </a:extLst>
           </p:cNvPr>
@@ -12662,7 +12667,7 @@
           <p:cNvPr id="2" name="slide-title">
             <a:extLst xmlns:a="http://schemas.openxmlformats.org/drawingml/2006/main">
               <a:ext uri="{FF2B5EF4-FFF2-40B4-BE49-F238E27FC236}">
-                <a16:creationId xmlns:a16="http://schemas.microsoft.com/office/drawing/2014/main" id="{6A4AE4BB-A14E-4F2F-9D7B-7508928C8B25}"/>
+                <a16:creationId xmlns:a16="http://schemas.microsoft.com/office/drawing/2014/main" id="{60B33121-F811-4889-A35E-5F3558856DE6}"/>
               </a:ext>
             </a:extLst>
           </p:cNvPr>
@@ -12719,7 +12724,7 @@
           <p:cNvPr id="3" name="">
             <a:extLst xmlns:a="http://schemas.openxmlformats.org/drawingml/2006/main">
               <a:ext uri="{FF2B5EF4-FFF2-40B4-BE49-F238E27FC236}">
-                <a16:creationId xmlns:a16="http://schemas.microsoft.com/office/drawing/2014/main" id="{279DA3DB-9288-41CB-94FB-3056B89AD41D}"/>
+                <a16:creationId xmlns:a16="http://schemas.microsoft.com/office/drawing/2014/main" id="{72F8F3A2-A947-4061-B718-7A0948BDC0F5}"/>
               </a:ext>
             </a:extLst>
           </p:cNvPr>
@@ -12751,7 +12756,7 @@
           <p:cNvPr id="4" name="slide-number">
             <a:extLst xmlns:a="http://schemas.openxmlformats.org/drawingml/2006/main">
               <a:ext uri="{FF2B5EF4-FFF2-40B4-BE49-F238E27FC236}">
-                <a16:creationId xmlns:a16="http://schemas.microsoft.com/office/drawing/2014/main" id="{87F23C0D-20BD-4611-8352-3D636759D9B8}"/>
+                <a16:creationId xmlns:a16="http://schemas.microsoft.com/office/drawing/2014/main" id="{16D69F16-E9A2-45D4-941D-14AB623F4770}"/>
               </a:ext>
             </a:extLst>
           </p:cNvPr>
@@ -12808,7 +12813,7 @@
           <p:cNvPr id="5" name="">
             <a:extLst xmlns:a="http://schemas.openxmlformats.org/drawingml/2006/main">
               <a:ext uri="{FF2B5EF4-FFF2-40B4-BE49-F238E27FC236}">
-                <a16:creationId xmlns:a16="http://schemas.microsoft.com/office/drawing/2014/main" id="{B727B00B-1CD4-45DA-88CF-B4AAF7193BBD}"/>
+                <a16:creationId xmlns:a16="http://schemas.microsoft.com/office/drawing/2014/main" id="{9028C468-EF8C-4409-A630-9A06AF0720BE}"/>
               </a:ext>
             </a:extLst>
           </p:cNvPr>
@@ -12840,7 +12845,7 @@
           <p:cNvPr id="6" name="sample-update">
             <a:extLst xmlns:a="http://schemas.openxmlformats.org/drawingml/2006/main">
               <a:ext uri="{FF2B5EF4-FFF2-40B4-BE49-F238E27FC236}">
-                <a16:creationId xmlns:a16="http://schemas.microsoft.com/office/drawing/2014/main" id="{CE050448-EE61-4DA4-BD4B-81021A48D809}"/>
+                <a16:creationId xmlns:a16="http://schemas.microsoft.com/office/drawing/2014/main" id="{D0EC1275-453F-49DA-9397-73FC45D91B16}"/>
               </a:ext>
             </a:extLst>
           </p:cNvPr>
@@ -12897,7 +12902,7 @@
           <p:cNvPr id="7" name="interpret">
             <a:extLst xmlns:a="http://schemas.openxmlformats.org/drawingml/2006/main">
               <a:ext uri="{FF2B5EF4-FFF2-40B4-BE49-F238E27FC236}">
-                <a16:creationId xmlns:a16="http://schemas.microsoft.com/office/drawing/2014/main" id="{51C3B041-2228-4BD5-98D3-3A3D8E2C55A6}"/>
+                <a16:creationId xmlns:a16="http://schemas.microsoft.com/office/drawing/2014/main" id="{EFA5FBA4-90D1-4845-91F7-3A398C5D2FD1}"/>
               </a:ext>
             </a:extLst>
           </p:cNvPr>
@@ -12954,7 +12959,7 @@
           <p:cNvPr id="8" name="source-kind">
             <a:extLst xmlns:a="http://schemas.openxmlformats.org/drawingml/2006/main">
               <a:ext uri="{FF2B5EF4-FFF2-40B4-BE49-F238E27FC236}">
-                <a16:creationId xmlns:a16="http://schemas.microsoft.com/office/drawing/2014/main" id="{8F8912EB-AB28-45F1-B456-DA358F4D796E}"/>
+                <a16:creationId xmlns:a16="http://schemas.microsoft.com/office/drawing/2014/main" id="{FBADCC9D-03D5-4FFE-BF3C-CCD91297EF77}"/>
               </a:ext>
             </a:extLst>
           </p:cNvPr>
@@ -13040,7 +13045,7 @@
           <p:cNvPr id="8" name="eyebrow">
             <a:extLst xmlns:a="http://schemas.openxmlformats.org/drawingml/2006/main">
               <a:ext uri="{FF2B5EF4-FFF2-40B4-BE49-F238E27FC236}">
-                <a16:creationId xmlns:a16="http://schemas.microsoft.com/office/drawing/2014/main" id="{8AEACEBF-BEFE-4B42-B9DC-81A4B580A825}"/>
+                <a16:creationId xmlns:a16="http://schemas.microsoft.com/office/drawing/2014/main" id="{9DEA49AC-BADE-4E93-A69E-31619EA29B56}"/>
               </a:ext>
             </a:extLst>
           </p:cNvPr>
@@ -13097,7 +13102,7 @@
           <p:cNvPr id="2" name="slide-title">
             <a:extLst xmlns:a="http://schemas.openxmlformats.org/drawingml/2006/main">
               <a:ext uri="{FF2B5EF4-FFF2-40B4-BE49-F238E27FC236}">
-                <a16:creationId xmlns:a16="http://schemas.microsoft.com/office/drawing/2014/main" id="{766826DD-2BB0-4BB5-AF69-640212833DC4}"/>
+                <a16:creationId xmlns:a16="http://schemas.microsoft.com/office/drawing/2014/main" id="{19511CC4-E3E8-4F62-86C9-517E9AEF36B2}"/>
               </a:ext>
             </a:extLst>
           </p:cNvPr>
@@ -13154,7 +13159,7 @@
           <p:cNvPr id="3" name="">
             <a:extLst xmlns:a="http://schemas.openxmlformats.org/drawingml/2006/main">
               <a:ext uri="{FF2B5EF4-FFF2-40B4-BE49-F238E27FC236}">
-                <a16:creationId xmlns:a16="http://schemas.microsoft.com/office/drawing/2014/main" id="{38722D92-77B5-4621-9E3B-BF6BE022E5FF}"/>
+                <a16:creationId xmlns:a16="http://schemas.microsoft.com/office/drawing/2014/main" id="{676CBED8-1A5F-4DEF-867A-60A24D1B3494}"/>
               </a:ext>
             </a:extLst>
           </p:cNvPr>
@@ -13186,7 +13191,7 @@
           <p:cNvPr id="4" name="slide-number">
             <a:extLst xmlns:a="http://schemas.openxmlformats.org/drawingml/2006/main">
               <a:ext uri="{FF2B5EF4-FFF2-40B4-BE49-F238E27FC236}">
-                <a16:creationId xmlns:a16="http://schemas.microsoft.com/office/drawing/2014/main" id="{9BBC669D-DE1F-4577-B033-ADDA625EE914}"/>
+                <a16:creationId xmlns:a16="http://schemas.microsoft.com/office/drawing/2014/main" id="{13B035D3-FBFE-423F-A0CB-587E912A2F6B}"/>
               </a:ext>
             </a:extLst>
           </p:cNvPr>
@@ -13243,7 +13248,7 @@
           <p:cNvPr id="5" name="summary">
             <a:extLst xmlns:a="http://schemas.openxmlformats.org/drawingml/2006/main">
               <a:ext uri="{FF2B5EF4-FFF2-40B4-BE49-F238E27FC236}">
-                <a16:creationId xmlns:a16="http://schemas.microsoft.com/office/drawing/2014/main" id="{D5783BB6-0CB7-4124-826D-E4E693D343D7}"/>
+                <a16:creationId xmlns:a16="http://schemas.microsoft.com/office/drawing/2014/main" id="{32268515-DCA8-46E8-88DC-904942007FD7}"/>
               </a:ext>
             </a:extLst>
           </p:cNvPr>
@@ -13346,7 +13351,7 @@
           <p:cNvPr id="6" name="synthesis">
             <a:extLst xmlns:a="http://schemas.openxmlformats.org/drawingml/2006/main">
               <a:ext uri="{FF2B5EF4-FFF2-40B4-BE49-F238E27FC236}">
-                <a16:creationId xmlns:a16="http://schemas.microsoft.com/office/drawing/2014/main" id="{6B2FA9C8-412D-403E-A630-73DB37DFAC4F}"/>
+                <a16:creationId xmlns:a16="http://schemas.microsoft.com/office/drawing/2014/main" id="{B604F771-994E-4C2B-8957-F08FD9D20E87}"/>
               </a:ext>
             </a:extLst>
           </p:cNvPr>
@@ -13403,7 +13408,7 @@
           <p:cNvPr id="7" name="next">
             <a:extLst xmlns:a="http://schemas.openxmlformats.org/drawingml/2006/main">
               <a:ext uri="{FF2B5EF4-FFF2-40B4-BE49-F238E27FC236}">
-                <a16:creationId xmlns:a16="http://schemas.microsoft.com/office/drawing/2014/main" id="{D79E6EFA-AFD1-493B-AA35-71C4EF9D7BCF}"/>
+                <a16:creationId xmlns:a16="http://schemas.microsoft.com/office/drawing/2014/main" id="{DB58AFA3-93D5-487E-A420-C135D4BBA5C4}"/>
               </a:ext>
             </a:extLst>
           </p:cNvPr>
@@ -13489,7 +13494,7 @@
           <p:cNvPr id="17" name="eyebrow">
             <a:extLst xmlns:a="http://schemas.openxmlformats.org/drawingml/2006/main">
               <a:ext uri="{FF2B5EF4-FFF2-40B4-BE49-F238E27FC236}">
-                <a16:creationId xmlns:a16="http://schemas.microsoft.com/office/drawing/2014/main" id="{6D70F9A8-586B-4B8A-9E72-D97E3368F4FD}"/>
+                <a16:creationId xmlns:a16="http://schemas.microsoft.com/office/drawing/2014/main" id="{EDE0ABD4-33BE-4ABA-BFE4-22CF7190DC1C}"/>
               </a:ext>
             </a:extLst>
           </p:cNvPr>
@@ -13546,7 +13551,7 @@
           <p:cNvPr id="2" name="slide-title">
             <a:extLst xmlns:a="http://schemas.openxmlformats.org/drawingml/2006/main">
               <a:ext uri="{FF2B5EF4-FFF2-40B4-BE49-F238E27FC236}">
-                <a16:creationId xmlns:a16="http://schemas.microsoft.com/office/drawing/2014/main" id="{59C072F4-580F-4867-8BD8-33269AB18A09}"/>
+                <a16:creationId xmlns:a16="http://schemas.microsoft.com/office/drawing/2014/main" id="{826F38BB-555E-4675-B3D9-CD62B925B3FD}"/>
               </a:ext>
             </a:extLst>
           </p:cNvPr>
@@ -13603,7 +13608,7 @@
           <p:cNvPr id="3" name="">
             <a:extLst xmlns:a="http://schemas.openxmlformats.org/drawingml/2006/main">
               <a:ext uri="{FF2B5EF4-FFF2-40B4-BE49-F238E27FC236}">
-                <a16:creationId xmlns:a16="http://schemas.microsoft.com/office/drawing/2014/main" id="{E57FAABF-C826-46D1-89D4-5C04ED038BCC}"/>
+                <a16:creationId xmlns:a16="http://schemas.microsoft.com/office/drawing/2014/main" id="{BC813853-F604-4450-97E0-8AFB695B0BCB}"/>
               </a:ext>
             </a:extLst>
           </p:cNvPr>
@@ -13635,7 +13640,7 @@
           <p:cNvPr id="4" name="slide-number">
             <a:extLst xmlns:a="http://schemas.openxmlformats.org/drawingml/2006/main">
               <a:ext uri="{FF2B5EF4-FFF2-40B4-BE49-F238E27FC236}">
-                <a16:creationId xmlns:a16="http://schemas.microsoft.com/office/drawing/2014/main" id="{D22E2CED-70AF-4EE9-A003-0609FAF38A6F}"/>
+                <a16:creationId xmlns:a16="http://schemas.microsoft.com/office/drawing/2014/main" id="{B221BDB5-DBAC-4675-A5DB-9A2A72359F5F}"/>
               </a:ext>
             </a:extLst>
           </p:cNvPr>
@@ -13692,7 +13697,7 @@
           <p:cNvPr id="5" name="">
             <a:extLst xmlns:a="http://schemas.openxmlformats.org/drawingml/2006/main">
               <a:ext uri="{FF2B5EF4-FFF2-40B4-BE49-F238E27FC236}">
-                <a16:creationId xmlns:a16="http://schemas.microsoft.com/office/drawing/2014/main" id="{315077C0-A7FD-4836-8A88-9DD2289987B9}"/>
+                <a16:creationId xmlns:a16="http://schemas.microsoft.com/office/drawing/2014/main" id="{A774F2CD-1500-4FDB-AD0D-A1101B2248BC}"/>
               </a:ext>
             </a:extLst>
           </p:cNvPr>
@@ -13724,7 +13729,7 @@
           <p:cNvPr id="6" name="begin">
             <a:extLst xmlns:a="http://schemas.openxmlformats.org/drawingml/2006/main">
               <a:ext uri="{FF2B5EF4-FFF2-40B4-BE49-F238E27FC236}">
-                <a16:creationId xmlns:a16="http://schemas.microsoft.com/office/drawing/2014/main" id="{B5CC25D4-9719-4924-83F8-5F97205A2350}"/>
+                <a16:creationId xmlns:a16="http://schemas.microsoft.com/office/drawing/2014/main" id="{F292FD1D-A734-4DEF-983E-770D4BA534EB}"/>
               </a:ext>
             </a:extLst>
           </p:cNvPr>
@@ -13804,7 +13809,7 @@
           <p:cNvPr id="7" name="">
             <a:extLst xmlns:a="http://schemas.openxmlformats.org/drawingml/2006/main">
               <a:ext uri="{FF2B5EF4-FFF2-40B4-BE49-F238E27FC236}">
-                <a16:creationId xmlns:a16="http://schemas.microsoft.com/office/drawing/2014/main" id="{B6F1FE45-D7CB-4840-91E7-9E59B0C139C0}"/>
+                <a16:creationId xmlns:a16="http://schemas.microsoft.com/office/drawing/2014/main" id="{E4412517-F5C6-4576-80C7-F05C0795C1EA}"/>
               </a:ext>
             </a:extLst>
           </p:cNvPr>
@@ -13836,7 +13841,7 @@
           <p:cNvPr id="8" name="">
             <a:extLst xmlns:a="http://schemas.openxmlformats.org/drawingml/2006/main">
               <a:ext uri="{FF2B5EF4-FFF2-40B4-BE49-F238E27FC236}">
-                <a16:creationId xmlns:a16="http://schemas.microsoft.com/office/drawing/2014/main" id="{52F2FDB2-7480-4BDE-B354-C7F57A0BBBC9}"/>
+                <a16:creationId xmlns:a16="http://schemas.microsoft.com/office/drawing/2014/main" id="{C848783E-B1A3-496A-A83C-9B6CF35BBC18}"/>
               </a:ext>
             </a:extLst>
           </p:cNvPr>
@@ -13868,7 +13873,7 @@
           <p:cNvPr id="9" name="work">
             <a:extLst xmlns:a="http://schemas.openxmlformats.org/drawingml/2006/main">
               <a:ext uri="{FF2B5EF4-FFF2-40B4-BE49-F238E27FC236}">
-                <a16:creationId xmlns:a16="http://schemas.microsoft.com/office/drawing/2014/main" id="{05A5CDE8-82E0-48E7-AF00-F94DC5ED661B}"/>
+                <a16:creationId xmlns:a16="http://schemas.microsoft.com/office/drawing/2014/main" id="{6720F450-36E2-4F52-B016-F483BCF333E2}"/>
               </a:ext>
             </a:extLst>
           </p:cNvPr>
@@ -13948,7 +13953,7 @@
           <p:cNvPr id="10" name="">
             <a:extLst xmlns:a="http://schemas.openxmlformats.org/drawingml/2006/main">
               <a:ext uri="{FF2B5EF4-FFF2-40B4-BE49-F238E27FC236}">
-                <a16:creationId xmlns:a16="http://schemas.microsoft.com/office/drawing/2014/main" id="{4F834228-A982-4FDC-9D2F-45F6BC99E78B}"/>
+                <a16:creationId xmlns:a16="http://schemas.microsoft.com/office/drawing/2014/main" id="{D9003930-2912-4A25-8CD9-6503FF03281A}"/>
               </a:ext>
             </a:extLst>
           </p:cNvPr>
@@ -13980,7 +13985,7 @@
           <p:cNvPr id="11" name="">
             <a:extLst xmlns:a="http://schemas.openxmlformats.org/drawingml/2006/main">
               <a:ext uri="{FF2B5EF4-FFF2-40B4-BE49-F238E27FC236}">
-                <a16:creationId xmlns:a16="http://schemas.microsoft.com/office/drawing/2014/main" id="{4AD19E55-4256-46F8-B382-50C8F452A2F9}"/>
+                <a16:creationId xmlns:a16="http://schemas.microsoft.com/office/drawing/2014/main" id="{B47FC5F0-C09C-455E-9F2D-E565EF7E5841}"/>
               </a:ext>
             </a:extLst>
           </p:cNvPr>
@@ -14012,7 +14017,7 @@
           <p:cNvPr id="12" name="">
             <a:extLst xmlns:a="http://schemas.openxmlformats.org/drawingml/2006/main">
               <a:ext uri="{FF2B5EF4-FFF2-40B4-BE49-F238E27FC236}">
-                <a16:creationId xmlns:a16="http://schemas.microsoft.com/office/drawing/2014/main" id="{6EF9E3E8-2702-43A0-9E36-60CA0403F797}"/>
+                <a16:creationId xmlns:a16="http://schemas.microsoft.com/office/drawing/2014/main" id="{E2030B7B-9902-4601-835C-326335D8B7E0}"/>
               </a:ext>
             </a:extLst>
           </p:cNvPr>
@@ -14044,7 +14049,7 @@
           <p:cNvPr id="13" name="commit">
             <a:extLst xmlns:a="http://schemas.openxmlformats.org/drawingml/2006/main">
               <a:ext uri="{FF2B5EF4-FFF2-40B4-BE49-F238E27FC236}">
-                <a16:creationId xmlns:a16="http://schemas.microsoft.com/office/drawing/2014/main" id="{720BC556-401D-467D-8DB2-E98D41F6F66F}"/>
+                <a16:creationId xmlns:a16="http://schemas.microsoft.com/office/drawing/2014/main" id="{7875C11B-5D3A-4F06-8D9E-F99B6671A9D6}"/>
               </a:ext>
             </a:extLst>
           </p:cNvPr>
@@ -14124,7 +14129,7 @@
           <p:cNvPr id="14" name="">
             <a:extLst xmlns:a="http://schemas.openxmlformats.org/drawingml/2006/main">
               <a:ext uri="{FF2B5EF4-FFF2-40B4-BE49-F238E27FC236}">
-                <a16:creationId xmlns:a16="http://schemas.microsoft.com/office/drawing/2014/main" id="{0D2722FE-47F6-4572-B3A5-34E34937102A}"/>
+                <a16:creationId xmlns:a16="http://schemas.microsoft.com/office/drawing/2014/main" id="{60051C8D-FCC5-4011-BE3F-B779F9EF28AC}"/>
               </a:ext>
             </a:extLst>
           </p:cNvPr>
@@ -14156,7 +14161,7 @@
           <p:cNvPr id="15" name="rollback">
             <a:extLst xmlns:a="http://schemas.openxmlformats.org/drawingml/2006/main">
               <a:ext uri="{FF2B5EF4-FFF2-40B4-BE49-F238E27FC236}">
-                <a16:creationId xmlns:a16="http://schemas.microsoft.com/office/drawing/2014/main" id="{D6B72790-25F4-4D82-8D4E-D1E2D3BDFF55}"/>
+                <a16:creationId xmlns:a16="http://schemas.microsoft.com/office/drawing/2014/main" id="{EF4CC15A-BF5A-4A75-8814-AF987064EE3B}"/>
               </a:ext>
             </a:extLst>
           </p:cNvPr>
@@ -14236,7 +14241,7 @@
           <p:cNvPr id="16" name="boundary">
             <a:extLst xmlns:a="http://schemas.openxmlformats.org/drawingml/2006/main">
               <a:ext uri="{FF2B5EF4-FFF2-40B4-BE49-F238E27FC236}">
-                <a16:creationId xmlns:a16="http://schemas.microsoft.com/office/drawing/2014/main" id="{48829002-3C46-4471-A45B-F28DA348A73F}"/>
+                <a16:creationId xmlns:a16="http://schemas.microsoft.com/office/drawing/2014/main" id="{E3D7A150-E1EB-466C-903A-2B7F72D0DF3A}"/>
               </a:ext>
             </a:extLst>
           </p:cNvPr>
@@ -14322,7 +14327,7 @@
           <p:cNvPr id="8" name="eyebrow">
             <a:extLst xmlns:a="http://schemas.openxmlformats.org/drawingml/2006/main">
               <a:ext uri="{FF2B5EF4-FFF2-40B4-BE49-F238E27FC236}">
-                <a16:creationId xmlns:a16="http://schemas.microsoft.com/office/drawing/2014/main" id="{E51BF43C-2586-4BF0-AEA7-41B2C39849C7}"/>
+                <a16:creationId xmlns:a16="http://schemas.microsoft.com/office/drawing/2014/main" id="{06DA6D27-0E2C-421B-8467-EAEC4ABA0886}"/>
               </a:ext>
             </a:extLst>
           </p:cNvPr>
@@ -14379,7 +14384,7 @@
           <p:cNvPr id="2" name="slide-title">
             <a:extLst xmlns:a="http://schemas.openxmlformats.org/drawingml/2006/main">
               <a:ext uri="{FF2B5EF4-FFF2-40B4-BE49-F238E27FC236}">
-                <a16:creationId xmlns:a16="http://schemas.microsoft.com/office/drawing/2014/main" id="{10942BC1-94BC-445D-90BB-A38954B45DE1}"/>
+                <a16:creationId xmlns:a16="http://schemas.microsoft.com/office/drawing/2014/main" id="{A1D8C996-F885-4C60-9186-F76999DA9A26}"/>
               </a:ext>
             </a:extLst>
           </p:cNvPr>
@@ -14436,7 +14441,7 @@
           <p:cNvPr id="3" name="">
             <a:extLst xmlns:a="http://schemas.openxmlformats.org/drawingml/2006/main">
               <a:ext uri="{FF2B5EF4-FFF2-40B4-BE49-F238E27FC236}">
-                <a16:creationId xmlns:a16="http://schemas.microsoft.com/office/drawing/2014/main" id="{BA203D03-C2D9-4A3D-BB27-E1EDA266E72F}"/>
+                <a16:creationId xmlns:a16="http://schemas.microsoft.com/office/drawing/2014/main" id="{FE021676-EE78-4438-AA7E-B9AE577B63E5}"/>
               </a:ext>
             </a:extLst>
           </p:cNvPr>
@@ -14468,7 +14473,7 @@
           <p:cNvPr id="4" name="slide-number">
             <a:extLst xmlns:a="http://schemas.openxmlformats.org/drawingml/2006/main">
               <a:ext uri="{FF2B5EF4-FFF2-40B4-BE49-F238E27FC236}">
-                <a16:creationId xmlns:a16="http://schemas.microsoft.com/office/drawing/2014/main" id="{E39D197A-6200-4870-A913-3CC2F8D2D69A}"/>
+                <a16:creationId xmlns:a16="http://schemas.microsoft.com/office/drawing/2014/main" id="{FBFB5B3E-B5EB-4A70-BD1E-3554161F4DCA}"/>
               </a:ext>
             </a:extLst>
           </p:cNvPr>
@@ -14525,7 +14530,7 @@
           <p:cNvPr id="5" name="">
             <a:extLst xmlns:a="http://schemas.openxmlformats.org/drawingml/2006/main">
               <a:ext uri="{FF2B5EF4-FFF2-40B4-BE49-F238E27FC236}">
-                <a16:creationId xmlns:a16="http://schemas.microsoft.com/office/drawing/2014/main" id="{34AE6E59-D9C0-4AD7-B9AF-D8B20C8F4FEF}"/>
+                <a16:creationId xmlns:a16="http://schemas.microsoft.com/office/drawing/2014/main" id="{B3912175-4F6A-4C04-9C3F-91B880622377}"/>
               </a:ext>
             </a:extLst>
           </p:cNvPr>
@@ -14557,7 +14562,7 @@
           <p:cNvPr id="6" name="pair-sql">
             <a:extLst xmlns:a="http://schemas.openxmlformats.org/drawingml/2006/main">
               <a:ext uri="{FF2B5EF4-FFF2-40B4-BE49-F238E27FC236}">
-                <a16:creationId xmlns:a16="http://schemas.microsoft.com/office/drawing/2014/main" id="{D17BB4FB-8220-455F-BA64-BE16D8DAED27}"/>
+                <a16:creationId xmlns:a16="http://schemas.microsoft.com/office/drawing/2014/main" id="{E727CEC1-A70C-4584-9910-C0EC21706EBF}"/>
               </a:ext>
             </a:extLst>
           </p:cNvPr>
@@ -14854,7 +14859,7 @@
           <p:cNvPr id="7" name="whole-block">
             <a:extLst xmlns:a="http://schemas.openxmlformats.org/drawingml/2006/main">
               <a:ext uri="{FF2B5EF4-FFF2-40B4-BE49-F238E27FC236}">
-                <a16:creationId xmlns:a16="http://schemas.microsoft.com/office/drawing/2014/main" id="{2904A377-05CE-45D5-8AC9-AB554C46AF7A}"/>
+                <a16:creationId xmlns:a16="http://schemas.microsoft.com/office/drawing/2014/main" id="{5BFE7905-7489-46B5-985A-3E3DBABF3F25}"/>
               </a:ext>
             </a:extLst>
           </p:cNvPr>
@@ -14940,7 +14945,7 @@
           <p:cNvPr id="8" name="eyebrow">
             <a:extLst xmlns:a="http://schemas.openxmlformats.org/drawingml/2006/main">
               <a:ext uri="{FF2B5EF4-FFF2-40B4-BE49-F238E27FC236}">
-                <a16:creationId xmlns:a16="http://schemas.microsoft.com/office/drawing/2014/main" id="{BB94E950-DC38-4EAC-B429-2659B7EDEC6D}"/>
+                <a16:creationId xmlns:a16="http://schemas.microsoft.com/office/drawing/2014/main" id="{F5103186-F296-4C98-BCB7-9127FA2D529D}"/>
               </a:ext>
             </a:extLst>
           </p:cNvPr>
@@ -14997,7 +15002,7 @@
           <p:cNvPr id="2" name="slide-title">
             <a:extLst xmlns:a="http://schemas.openxmlformats.org/drawingml/2006/main">
               <a:ext uri="{FF2B5EF4-FFF2-40B4-BE49-F238E27FC236}">
-                <a16:creationId xmlns:a16="http://schemas.microsoft.com/office/drawing/2014/main" id="{6925D154-1D21-41CA-87CB-78DDCFF1A1CA}"/>
+                <a16:creationId xmlns:a16="http://schemas.microsoft.com/office/drawing/2014/main" id="{A2068DE1-858C-4ABB-A009-1418F5A9C73C}"/>
               </a:ext>
             </a:extLst>
           </p:cNvPr>
@@ -15054,7 +15059,7 @@
           <p:cNvPr id="3" name="">
             <a:extLst xmlns:a="http://schemas.openxmlformats.org/drawingml/2006/main">
               <a:ext uri="{FF2B5EF4-FFF2-40B4-BE49-F238E27FC236}">
-                <a16:creationId xmlns:a16="http://schemas.microsoft.com/office/drawing/2014/main" id="{169A143E-B2A9-4AEC-BBA3-45FCC72C3A72}"/>
+                <a16:creationId xmlns:a16="http://schemas.microsoft.com/office/drawing/2014/main" id="{B4A7F4E2-3370-45B1-8731-EA51030D03AE}"/>
               </a:ext>
             </a:extLst>
           </p:cNvPr>
@@ -15086,7 +15091,7 @@
           <p:cNvPr id="4" name="slide-number">
             <a:extLst xmlns:a="http://schemas.openxmlformats.org/drawingml/2006/main">
               <a:ext uri="{FF2B5EF4-FFF2-40B4-BE49-F238E27FC236}">
-                <a16:creationId xmlns:a16="http://schemas.microsoft.com/office/drawing/2014/main" id="{6CB5AE75-7591-4299-8CDC-4636258CAED0}"/>
+                <a16:creationId xmlns:a16="http://schemas.microsoft.com/office/drawing/2014/main" id="{6394A3D0-32B0-4FD9-AB5C-93D4E284D6D9}"/>
               </a:ext>
             </a:extLst>
           </p:cNvPr>
@@ -15462,7 +15467,7 @@
           <p:cNvPr id="6" name="">
             <a:extLst xmlns:a="http://schemas.openxmlformats.org/drawingml/2006/main">
               <a:ext uri="{FF2B5EF4-FFF2-40B4-BE49-F238E27FC236}">
-                <a16:creationId xmlns:a16="http://schemas.microsoft.com/office/drawing/2014/main" id="{BC997844-815B-4F8E-9627-DE97256B85AA}"/>
+                <a16:creationId xmlns:a16="http://schemas.microsoft.com/office/drawing/2014/main" id="{ABBFCE14-E8D2-4AD1-8D6A-45F132AEA114}"/>
               </a:ext>
             </a:extLst>
           </p:cNvPr>
@@ -15494,7 +15499,7 @@
           <p:cNvPr id="7" name="postcheck">
             <a:extLst xmlns:a="http://schemas.openxmlformats.org/drawingml/2006/main">
               <a:ext uri="{FF2B5EF4-FFF2-40B4-BE49-F238E27FC236}">
-                <a16:creationId xmlns:a16="http://schemas.microsoft.com/office/drawing/2014/main" id="{793F26DC-8834-41C5-BCEA-83327FC79E06}"/>
+                <a16:creationId xmlns:a16="http://schemas.microsoft.com/office/drawing/2014/main" id="{3D13179B-055F-436C-A5C0-9C1DA6F52407}"/>
               </a:ext>
             </a:extLst>
           </p:cNvPr>
@@ -15626,7 +15631,7 @@
           <p:cNvPr id="11" name="eyebrow">
             <a:extLst xmlns:a="http://schemas.openxmlformats.org/drawingml/2006/main">
               <a:ext uri="{FF2B5EF4-FFF2-40B4-BE49-F238E27FC236}">
-                <a16:creationId xmlns:a16="http://schemas.microsoft.com/office/drawing/2014/main" id="{20EAF61D-B1F4-450C-B9C4-198DC5B350D6}"/>
+                <a16:creationId xmlns:a16="http://schemas.microsoft.com/office/drawing/2014/main" id="{5FB0CB77-A11B-4C3F-93F5-E79B25F68EB8}"/>
               </a:ext>
             </a:extLst>
           </p:cNvPr>
@@ -15683,7 +15688,7 @@
           <p:cNvPr id="2" name="slide-title">
             <a:extLst xmlns:a="http://schemas.openxmlformats.org/drawingml/2006/main">
               <a:ext uri="{FF2B5EF4-FFF2-40B4-BE49-F238E27FC236}">
-                <a16:creationId xmlns:a16="http://schemas.microsoft.com/office/drawing/2014/main" id="{B585E3A0-4398-45A9-9CD2-DCCF2725D75D}"/>
+                <a16:creationId xmlns:a16="http://schemas.microsoft.com/office/drawing/2014/main" id="{A416EB9A-855B-48A0-831B-7FE43682C286}"/>
               </a:ext>
             </a:extLst>
           </p:cNvPr>
@@ -15740,7 +15745,7 @@
           <p:cNvPr id="3" name="">
             <a:extLst xmlns:a="http://schemas.openxmlformats.org/drawingml/2006/main">
               <a:ext uri="{FF2B5EF4-FFF2-40B4-BE49-F238E27FC236}">
-                <a16:creationId xmlns:a16="http://schemas.microsoft.com/office/drawing/2014/main" id="{03D319A0-83A6-4935-9D2A-608D69B00EF9}"/>
+                <a16:creationId xmlns:a16="http://schemas.microsoft.com/office/drawing/2014/main" id="{B9BEC49D-E5E2-4662-8037-DBDA54308C7F}"/>
               </a:ext>
             </a:extLst>
           </p:cNvPr>
@@ -15772,7 +15777,7 @@
           <p:cNvPr id="4" name="slide-number">
             <a:extLst xmlns:a="http://schemas.openxmlformats.org/drawingml/2006/main">
               <a:ext uri="{FF2B5EF4-FFF2-40B4-BE49-F238E27FC236}">
-                <a16:creationId xmlns:a16="http://schemas.microsoft.com/office/drawing/2014/main" id="{9E6E8067-DF25-4C72-83C7-F00D7F11132A}"/>
+                <a16:creationId xmlns:a16="http://schemas.microsoft.com/office/drawing/2014/main" id="{58935236-4B61-4553-8BE6-4689558F79B2}"/>
               </a:ext>
             </a:extLst>
           </p:cNvPr>
@@ -15829,7 +15834,7 @@
           <p:cNvPr id="5" name="">
             <a:extLst xmlns:a="http://schemas.openxmlformats.org/drawingml/2006/main">
               <a:ext uri="{FF2B5EF4-FFF2-40B4-BE49-F238E27FC236}">
-                <a16:creationId xmlns:a16="http://schemas.microsoft.com/office/drawing/2014/main" id="{9D2CB602-C813-4712-BA2B-B046A9A1F06C}"/>
+                <a16:creationId xmlns:a16="http://schemas.microsoft.com/office/drawing/2014/main" id="{F343CB03-C42A-4B12-A7FE-FB3D13506DF6}"/>
               </a:ext>
             </a:extLst>
           </p:cNvPr>
@@ -15861,7 +15866,7 @@
           <p:cNvPr id="6" name="failure-sql">
             <a:extLst xmlns:a="http://schemas.openxmlformats.org/drawingml/2006/main">
               <a:ext uri="{FF2B5EF4-FFF2-40B4-BE49-F238E27FC236}">
-                <a16:creationId xmlns:a16="http://schemas.microsoft.com/office/drawing/2014/main" id="{A693C951-90D6-4C74-BB45-3156A7525303}"/>
+                <a16:creationId xmlns:a16="http://schemas.microsoft.com/office/drawing/2014/main" id="{16BA1DEC-3455-42E5-9417-F616FC04B5BA}"/>
               </a:ext>
             </a:extLst>
           </p:cNvPr>
@@ -16010,7 +16015,7 @@
           <p:cNvPr id="7" name="failure-result">
             <a:extLst xmlns:a="http://schemas.openxmlformats.org/drawingml/2006/main">
               <a:ext uri="{FF2B5EF4-FFF2-40B4-BE49-F238E27FC236}">
-                <a16:creationId xmlns:a16="http://schemas.microsoft.com/office/drawing/2014/main" id="{8F44D6B6-DA06-4A6E-B82B-DEBE9E1F9F4E}"/>
+                <a16:creationId xmlns:a16="http://schemas.microsoft.com/office/drawing/2014/main" id="{2177C360-5F79-49E1-90B8-EBF65EEAA136}"/>
               </a:ext>
             </a:extLst>
           </p:cNvPr>
@@ -16090,7 +16095,7 @@
           <p:cNvPr id="8" name="">
             <a:extLst xmlns:a="http://schemas.openxmlformats.org/drawingml/2006/main">
               <a:ext uri="{FF2B5EF4-FFF2-40B4-BE49-F238E27FC236}">
-                <a16:creationId xmlns:a16="http://schemas.microsoft.com/office/drawing/2014/main" id="{429C6493-6426-408D-937A-E724C82601B1}"/>
+                <a16:creationId xmlns:a16="http://schemas.microsoft.com/office/drawing/2014/main" id="{560996C1-CC85-4970-8A2D-6C7C6D17B347}"/>
               </a:ext>
             </a:extLst>
           </p:cNvPr>
@@ -16122,7 +16127,7 @@
           <p:cNvPr id="9" name="failure-cleanup">
             <a:extLst xmlns:a="http://schemas.openxmlformats.org/drawingml/2006/main">
               <a:ext uri="{FF2B5EF4-FFF2-40B4-BE49-F238E27FC236}">
-                <a16:creationId xmlns:a16="http://schemas.microsoft.com/office/drawing/2014/main" id="{E98BBFE4-DECD-443D-AA12-30A5625B47AD}"/>
+                <a16:creationId xmlns:a16="http://schemas.microsoft.com/office/drawing/2014/main" id="{2F20C1D2-81A5-4432-B9FF-32E9CA9E0EEE}"/>
               </a:ext>
             </a:extLst>
           </p:cNvPr>
@@ -16202,7 +16207,7 @@
           <p:cNvPr id="10" name="failure-run">
             <a:extLst xmlns:a="http://schemas.openxmlformats.org/drawingml/2006/main">
               <a:ext uri="{FF2B5EF4-FFF2-40B4-BE49-F238E27FC236}">
-                <a16:creationId xmlns:a16="http://schemas.microsoft.com/office/drawing/2014/main" id="{B588EA1D-F95B-4FD1-AC26-A246E37C58F5}"/>
+                <a16:creationId xmlns:a16="http://schemas.microsoft.com/office/drawing/2014/main" id="{2AB73AAD-28AC-4306-9072-EA6FA26F794C}"/>
               </a:ext>
             </a:extLst>
           </p:cNvPr>
@@ -16288,7 +16293,7 @@
           <p:cNvPr id="9" name="eyebrow">
             <a:extLst xmlns:a="http://schemas.openxmlformats.org/drawingml/2006/main">
               <a:ext uri="{FF2B5EF4-FFF2-40B4-BE49-F238E27FC236}">
-                <a16:creationId xmlns:a16="http://schemas.microsoft.com/office/drawing/2014/main" id="{D45E170D-2033-49BB-A1EA-FDC746DAC3E8}"/>
+                <a16:creationId xmlns:a16="http://schemas.microsoft.com/office/drawing/2014/main" id="{FD15A125-832E-4E9B-97AC-7BAA6EF11FC8}"/>
               </a:ext>
             </a:extLst>
           </p:cNvPr>
@@ -16345,7 +16350,7 @@
           <p:cNvPr id="2" name="slide-title">
             <a:extLst xmlns:a="http://schemas.openxmlformats.org/drawingml/2006/main">
               <a:ext uri="{FF2B5EF4-FFF2-40B4-BE49-F238E27FC236}">
-                <a16:creationId xmlns:a16="http://schemas.microsoft.com/office/drawing/2014/main" id="{7B685771-64A2-436D-9A8B-D92BE35285F5}"/>
+                <a16:creationId xmlns:a16="http://schemas.microsoft.com/office/drawing/2014/main" id="{E35C31FA-D981-4F02-ADED-5FA54229E0B9}"/>
               </a:ext>
             </a:extLst>
           </p:cNvPr>
@@ -16402,7 +16407,7 @@
           <p:cNvPr id="3" name="">
             <a:extLst xmlns:a="http://schemas.openxmlformats.org/drawingml/2006/main">
               <a:ext uri="{FF2B5EF4-FFF2-40B4-BE49-F238E27FC236}">
-                <a16:creationId xmlns:a16="http://schemas.microsoft.com/office/drawing/2014/main" id="{3592071D-8AEF-4122-A310-838705C4EDB6}"/>
+                <a16:creationId xmlns:a16="http://schemas.microsoft.com/office/drawing/2014/main" id="{86935EFE-8338-490F-9BB1-5B17257219D9}"/>
               </a:ext>
             </a:extLst>
           </p:cNvPr>
@@ -16434,7 +16439,7 @@
           <p:cNvPr id="4" name="slide-number">
             <a:extLst xmlns:a="http://schemas.openxmlformats.org/drawingml/2006/main">
               <a:ext uri="{FF2B5EF4-FFF2-40B4-BE49-F238E27FC236}">
-                <a16:creationId xmlns:a16="http://schemas.microsoft.com/office/drawing/2014/main" id="{42380205-F7FA-4A93-8FF9-A63B2D49142D}"/>
+                <a16:creationId xmlns:a16="http://schemas.microsoft.com/office/drawing/2014/main" id="{2B00323B-4012-4200-B18C-0BF71ADDC5D7}"/>
               </a:ext>
             </a:extLst>
           </p:cNvPr>
@@ -16491,7 +16496,7 @@
           <p:cNvPr id="5" name="">
             <a:extLst xmlns:a="http://schemas.openxmlformats.org/drawingml/2006/main">
               <a:ext uri="{FF2B5EF4-FFF2-40B4-BE49-F238E27FC236}">
-                <a16:creationId xmlns:a16="http://schemas.microsoft.com/office/drawing/2014/main" id="{DE81E2E2-2B70-490A-A802-EBED4BAF289C}"/>
+                <a16:creationId xmlns:a16="http://schemas.microsoft.com/office/drawing/2014/main" id="{0A9F8DE3-5E58-47F8-9F57-C78786155363}"/>
               </a:ext>
             </a:extLst>
           </p:cNvPr>
@@ -16523,7 +16528,7 @@
           <p:cNvPr id="6" name="zero-sql">
             <a:extLst xmlns:a="http://schemas.openxmlformats.org/drawingml/2006/main">
               <a:ext uri="{FF2B5EF4-FFF2-40B4-BE49-F238E27FC236}">
-                <a16:creationId xmlns:a16="http://schemas.microsoft.com/office/drawing/2014/main" id="{C34A62C3-212E-4C2F-AAE3-C338227BD75C}"/>
+                <a16:creationId xmlns:a16="http://schemas.microsoft.com/office/drawing/2014/main" id="{DF4FD002-9971-45CE-B91B-54019E39FC33}"/>
               </a:ext>
             </a:extLst>
           </p:cNvPr>
@@ -16672,7 +16677,7 @@
           <p:cNvPr id="7" name="zero-outcome">
             <a:extLst xmlns:a="http://schemas.openxmlformats.org/drawingml/2006/main">
               <a:ext uri="{FF2B5EF4-FFF2-40B4-BE49-F238E27FC236}">
-                <a16:creationId xmlns:a16="http://schemas.microsoft.com/office/drawing/2014/main" id="{4D46235D-0EE0-4CCC-BB3B-C11E1C98DAE9}"/>
+                <a16:creationId xmlns:a16="http://schemas.microsoft.com/office/drawing/2014/main" id="{54139A78-306E-46DF-BA00-E88ED9B4DF18}"/>
               </a:ext>
             </a:extLst>
           </p:cNvPr>
@@ -16729,7 +16734,7 @@
           <p:cNvPr id="8" name="zero-action">
             <a:extLst xmlns:a="http://schemas.openxmlformats.org/drawingml/2006/main">
               <a:ext uri="{FF2B5EF4-FFF2-40B4-BE49-F238E27FC236}">
-                <a16:creationId xmlns:a16="http://schemas.microsoft.com/office/drawing/2014/main" id="{A90F22E2-5356-4632-A512-B8790DE108AC}"/>
+                <a16:creationId xmlns:a16="http://schemas.microsoft.com/office/drawing/2014/main" id="{BA877CBD-532A-42CF-8478-ECE6601E1BD2}"/>
               </a:ext>
             </a:extLst>
           </p:cNvPr>
@@ -16815,7 +16820,7 @@
           <p:cNvPr id="7" name="eyebrow">
             <a:extLst xmlns:a="http://schemas.openxmlformats.org/drawingml/2006/main">
               <a:ext uri="{FF2B5EF4-FFF2-40B4-BE49-F238E27FC236}">
-                <a16:creationId xmlns:a16="http://schemas.microsoft.com/office/drawing/2014/main" id="{8C92D022-ECC8-417D-B40C-D1FB20D60B64}"/>
+                <a16:creationId xmlns:a16="http://schemas.microsoft.com/office/drawing/2014/main" id="{99A11F11-3218-4766-A4CE-CA316E2EA45F}"/>
               </a:ext>
             </a:extLst>
           </p:cNvPr>
@@ -16872,7 +16877,7 @@
           <p:cNvPr id="2" name="slide-title">
             <a:extLst xmlns:a="http://schemas.openxmlformats.org/drawingml/2006/main">
               <a:ext uri="{FF2B5EF4-FFF2-40B4-BE49-F238E27FC236}">
-                <a16:creationId xmlns:a16="http://schemas.microsoft.com/office/drawing/2014/main" id="{4CAA9922-B381-4782-A19C-B71B96A7600E}"/>
+                <a16:creationId xmlns:a16="http://schemas.microsoft.com/office/drawing/2014/main" id="{C3140584-4701-4462-921B-1B780D0DF556}"/>
               </a:ext>
             </a:extLst>
           </p:cNvPr>
@@ -16929,7 +16934,7 @@
           <p:cNvPr id="3" name="">
             <a:extLst xmlns:a="http://schemas.openxmlformats.org/drawingml/2006/main">
               <a:ext uri="{FF2B5EF4-FFF2-40B4-BE49-F238E27FC236}">
-                <a16:creationId xmlns:a16="http://schemas.microsoft.com/office/drawing/2014/main" id="{993D0AB5-664B-4D31-8351-303D320CC663}"/>
+                <a16:creationId xmlns:a16="http://schemas.microsoft.com/office/drawing/2014/main" id="{C07F8ADB-C7F8-4A97-882A-9E3FEC470B17}"/>
               </a:ext>
             </a:extLst>
           </p:cNvPr>
@@ -16961,7 +16966,7 @@
           <p:cNvPr id="4" name="slide-number">
             <a:extLst xmlns:a="http://schemas.openxmlformats.org/drawingml/2006/main">
               <a:ext uri="{FF2B5EF4-FFF2-40B4-BE49-F238E27FC236}">
-                <a16:creationId xmlns:a16="http://schemas.microsoft.com/office/drawing/2014/main" id="{CFFCA34A-8E0B-4712-8C96-1CFF5C05DC47}"/>
+                <a16:creationId xmlns:a16="http://schemas.microsoft.com/office/drawing/2014/main" id="{52743D68-0E56-423E-B08C-EE625269B78A}"/>
               </a:ext>
             </a:extLst>
           </p:cNvPr>
@@ -17290,7 +17295,7 @@
           <p:cNvPr id="6" name="acid-limits">
             <a:extLst xmlns:a="http://schemas.openxmlformats.org/drawingml/2006/main">
               <a:ext uri="{FF2B5EF4-FFF2-40B4-BE49-F238E27FC236}">
-                <a16:creationId xmlns:a16="http://schemas.microsoft.com/office/drawing/2014/main" id="{E403134D-9012-4CC0-B685-6439A7EFB900}"/>
+                <a16:creationId xmlns:a16="http://schemas.microsoft.com/office/drawing/2014/main" id="{D4C30E08-3AB9-4DD8-9377-8629134CE8AE}"/>
               </a:ext>
             </a:extLst>
           </p:cNvPr>
@@ -17376,7 +17381,7 @@
           <p:cNvPr id="9" name="eyebrow">
             <a:extLst xmlns:a="http://schemas.openxmlformats.org/drawingml/2006/main">
               <a:ext uri="{FF2B5EF4-FFF2-40B4-BE49-F238E27FC236}">
-                <a16:creationId xmlns:a16="http://schemas.microsoft.com/office/drawing/2014/main" id="{42153290-4451-4369-AF81-9D19361C6D87}"/>
+                <a16:creationId xmlns:a16="http://schemas.microsoft.com/office/drawing/2014/main" id="{38A5FB20-C46B-486D-A3FA-D4837C4D510F}"/>
               </a:ext>
             </a:extLst>
           </p:cNvPr>
@@ -17433,7 +17438,7 @@
           <p:cNvPr id="2" name="slide-title">
             <a:extLst xmlns:a="http://schemas.openxmlformats.org/drawingml/2006/main">
               <a:ext uri="{FF2B5EF4-FFF2-40B4-BE49-F238E27FC236}">
-                <a16:creationId xmlns:a16="http://schemas.microsoft.com/office/drawing/2014/main" id="{28C3C0C1-5539-49C6-9501-2BCE6A4B2828}"/>
+                <a16:creationId xmlns:a16="http://schemas.microsoft.com/office/drawing/2014/main" id="{14E505A2-0B40-4C04-B027-4722E8FC18C2}"/>
               </a:ext>
             </a:extLst>
           </p:cNvPr>
@@ -17490,7 +17495,7 @@
           <p:cNvPr id="3" name="">
             <a:extLst xmlns:a="http://schemas.openxmlformats.org/drawingml/2006/main">
               <a:ext uri="{FF2B5EF4-FFF2-40B4-BE49-F238E27FC236}">
-                <a16:creationId xmlns:a16="http://schemas.microsoft.com/office/drawing/2014/main" id="{C789C122-B1BC-4801-9DD5-74641E3485B4}"/>
+                <a16:creationId xmlns:a16="http://schemas.microsoft.com/office/drawing/2014/main" id="{9A5253C8-538B-4E37-89F7-573DB4105B54}"/>
               </a:ext>
             </a:extLst>
           </p:cNvPr>
@@ -17522,7 +17527,7 @@
           <p:cNvPr id="4" name="slide-number">
             <a:extLst xmlns:a="http://schemas.openxmlformats.org/drawingml/2006/main">
               <a:ext uri="{FF2B5EF4-FFF2-40B4-BE49-F238E27FC236}">
-                <a16:creationId xmlns:a16="http://schemas.microsoft.com/office/drawing/2014/main" id="{3C762EAD-6B81-4FBB-A5AD-6375F751E97D}"/>
+                <a16:creationId xmlns:a16="http://schemas.microsoft.com/office/drawing/2014/main" id="{21E8F151-B18E-4E39-8DC0-4305B574C61D}"/>
               </a:ext>
             </a:extLst>
           </p:cNvPr>
@@ -17579,7 +17584,7 @@
           <p:cNvPr id="5" name="lab1">
             <a:extLst xmlns:a="http://schemas.openxmlformats.org/drawingml/2006/main">
               <a:ext uri="{FF2B5EF4-FFF2-40B4-BE49-F238E27FC236}">
-                <a16:creationId xmlns:a16="http://schemas.microsoft.com/office/drawing/2014/main" id="{418E68FF-A0E9-4EEB-A506-86F2D49A1A46}"/>
+                <a16:creationId xmlns:a16="http://schemas.microsoft.com/office/drawing/2014/main" id="{DCC5646F-FDCE-444A-8F59-9601D80FC493}"/>
               </a:ext>
             </a:extLst>
           </p:cNvPr>
@@ -17636,7 +17641,7 @@
           <p:cNvPr id="6" name="lab1-actions">
             <a:extLst xmlns:a="http://schemas.openxmlformats.org/drawingml/2006/main">
               <a:ext uri="{FF2B5EF4-FFF2-40B4-BE49-F238E27FC236}">
-                <a16:creationId xmlns:a16="http://schemas.microsoft.com/office/drawing/2014/main" id="{2915478C-623B-4461-AACF-E4DCFCA5BBA4}"/>
+                <a16:creationId xmlns:a16="http://schemas.microsoft.com/office/drawing/2014/main" id="{6B34128E-D0B2-49EC-BC11-2CCE06610FC8}"/>
               </a:ext>
             </a:extLst>
           </p:cNvPr>
@@ -17716,7 +17721,7 @@
           <p:cNvPr id="7" name="lab1-write">
             <a:extLst xmlns:a="http://schemas.openxmlformats.org/drawingml/2006/main">
               <a:ext uri="{FF2B5EF4-FFF2-40B4-BE49-F238E27FC236}">
-                <a16:creationId xmlns:a16="http://schemas.microsoft.com/office/drawing/2014/main" id="{5B182457-9079-4712-A116-CD322B511D18}"/>
+                <a16:creationId xmlns:a16="http://schemas.microsoft.com/office/drawing/2014/main" id="{03D57A15-3D8C-4170-94F9-0D7092531BDA}"/>
               </a:ext>
             </a:extLst>
           </p:cNvPr>
@@ -17773,7 +17778,7 @@
           <p:cNvPr id="8" name="lab1-submit">
             <a:extLst xmlns:a="http://schemas.openxmlformats.org/drawingml/2006/main">
               <a:ext uri="{FF2B5EF4-FFF2-40B4-BE49-F238E27FC236}">
-                <a16:creationId xmlns:a16="http://schemas.microsoft.com/office/drawing/2014/main" id="{667359F3-AD1C-4364-9E12-3EE8E5F35422}"/>
+                <a16:creationId xmlns:a16="http://schemas.microsoft.com/office/drawing/2014/main" id="{5C6DFDEA-880E-4E21-9929-EFD07425A420}"/>
               </a:ext>
             </a:extLst>
           </p:cNvPr>

</xml_diff>

<commit_message>
Teach Week 5 Colab and Supabase connection setup
</commit_message>
<xml_diff>
--- a/week_05/week_05_transactions_mvcc_locks.pptx
+++ b/week_05/week_05_transactions_mvcc_locks.pptx
@@ -2,35 +2,37 @@
 <file path=ppt/presentation.xml><?xml version="1.0" encoding="utf-8"?>
 <p:presentation xmlns:p="http://schemas.openxmlformats.org/presentationml/2006/main">
   <p:sldMasterIdLst>
-    <p:sldMasterId xmlns:r="http://schemas.openxmlformats.org/officeDocument/2006/relationships" id="2147483648" r:id="R94e74b49adb6400c"/>
+    <p:sldMasterId xmlns:r="http://schemas.openxmlformats.org/officeDocument/2006/relationships" id="2147483648" r:id="R867424f1cf2646af"/>
   </p:sldMasterIdLst>
   <p:notesMasterIdLst>
-    <p:notesMasterId xmlns:r="http://schemas.openxmlformats.org/officeDocument/2006/relationships" r:id="R6abd42e934524dd0"/>
+    <p:notesMasterId xmlns:r="http://schemas.openxmlformats.org/officeDocument/2006/relationships" r:id="R134b639ffe774386"/>
   </p:notesMasterIdLst>
   <p:sldIdLst>
-    <p:sldId xmlns:r="http://schemas.openxmlformats.org/officeDocument/2006/relationships" id="256" r:id="R1ff7ea3ebf3d4246"/>
-    <p:sldId xmlns:r="http://schemas.openxmlformats.org/officeDocument/2006/relationships" id="257" r:id="R3ed5b3aa4d3c464d"/>
-    <p:sldId xmlns:r="http://schemas.openxmlformats.org/officeDocument/2006/relationships" id="258" r:id="Ra5ebf5e02f234097"/>
-    <p:sldId xmlns:r="http://schemas.openxmlformats.org/officeDocument/2006/relationships" id="259" r:id="Rb83c376d995c406c"/>
-    <p:sldId xmlns:r="http://schemas.openxmlformats.org/officeDocument/2006/relationships" id="260" r:id="Rb015ca425fff4677"/>
-    <p:sldId xmlns:r="http://schemas.openxmlformats.org/officeDocument/2006/relationships" id="261" r:id="R31f0bf4c3f254cd0"/>
-    <p:sldId xmlns:r="http://schemas.openxmlformats.org/officeDocument/2006/relationships" id="262" r:id="R5a93b76553bc4625"/>
-    <p:sldId xmlns:r="http://schemas.openxmlformats.org/officeDocument/2006/relationships" id="263" r:id="R2c8af698741c445b"/>
-    <p:sldId xmlns:r="http://schemas.openxmlformats.org/officeDocument/2006/relationships" id="264" r:id="R747a8310d4514767"/>
-    <p:sldId xmlns:r="http://schemas.openxmlformats.org/officeDocument/2006/relationships" id="265" r:id="Reaa608241ad24ce2"/>
-    <p:sldId xmlns:r="http://schemas.openxmlformats.org/officeDocument/2006/relationships" id="266" r:id="R817309a7c4ed40e7"/>
-    <p:sldId xmlns:r="http://schemas.openxmlformats.org/officeDocument/2006/relationships" id="267" r:id="Rbb808739f21d45be"/>
-    <p:sldId xmlns:r="http://schemas.openxmlformats.org/officeDocument/2006/relationships" id="268" r:id="R8357a355d7344b5b"/>
-    <p:sldId xmlns:r="http://schemas.openxmlformats.org/officeDocument/2006/relationships" id="269" r:id="R80173a5033584042"/>
-    <p:sldId xmlns:r="http://schemas.openxmlformats.org/officeDocument/2006/relationships" id="270" r:id="Rb8c7cfb365174f12"/>
-    <p:sldId xmlns:r="http://schemas.openxmlformats.org/officeDocument/2006/relationships" id="271" r:id="R13f0a3a7855f4382"/>
-    <p:sldId xmlns:r="http://schemas.openxmlformats.org/officeDocument/2006/relationships" id="272" r:id="R175530253b964be8"/>
-    <p:sldId xmlns:r="http://schemas.openxmlformats.org/officeDocument/2006/relationships" id="273" r:id="R343bd95ea1254cc0"/>
-    <p:sldId xmlns:r="http://schemas.openxmlformats.org/officeDocument/2006/relationships" id="274" r:id="Ree52ccd3b8384160"/>
-    <p:sldId xmlns:r="http://schemas.openxmlformats.org/officeDocument/2006/relationships" id="275" r:id="Rca7265d1b8bf4f12"/>
-    <p:sldId xmlns:r="http://schemas.openxmlformats.org/officeDocument/2006/relationships" id="276" r:id="R6d73f0e599e946ff"/>
-    <p:sldId xmlns:r="http://schemas.openxmlformats.org/officeDocument/2006/relationships" id="277" r:id="R2233b3af0b664c5c"/>
-    <p:sldId xmlns:r="http://schemas.openxmlformats.org/officeDocument/2006/relationships" id="278" r:id="Rceb81f7a34904ca9"/>
+    <p:sldId xmlns:r="http://schemas.openxmlformats.org/officeDocument/2006/relationships" id="256" r:id="Rd1b854ca7ddc49c8"/>
+    <p:sldId xmlns:r="http://schemas.openxmlformats.org/officeDocument/2006/relationships" id="257" r:id="R8c015960ee8c48a1"/>
+    <p:sldId xmlns:r="http://schemas.openxmlformats.org/officeDocument/2006/relationships" id="258" r:id="R1113958d9e0e465a"/>
+    <p:sldId xmlns:r="http://schemas.openxmlformats.org/officeDocument/2006/relationships" id="259" r:id="Rd162c189708d4ee3"/>
+    <p:sldId xmlns:r="http://schemas.openxmlformats.org/officeDocument/2006/relationships" id="260" r:id="Rd528896cc2d4484f"/>
+    <p:sldId xmlns:r="http://schemas.openxmlformats.org/officeDocument/2006/relationships" id="261" r:id="Rb854ca3a90ce4ff1"/>
+    <p:sldId xmlns:r="http://schemas.openxmlformats.org/officeDocument/2006/relationships" id="262" r:id="R99cae55cdca2454c"/>
+    <p:sldId xmlns:r="http://schemas.openxmlformats.org/officeDocument/2006/relationships" id="263" r:id="R104486fc5fc14000"/>
+    <p:sldId xmlns:r="http://schemas.openxmlformats.org/officeDocument/2006/relationships" id="264" r:id="R0b9b308af85244b8"/>
+    <p:sldId xmlns:r="http://schemas.openxmlformats.org/officeDocument/2006/relationships" id="265" r:id="R4769a970f04e4231"/>
+    <p:sldId xmlns:r="http://schemas.openxmlformats.org/officeDocument/2006/relationships" id="266" r:id="Ra36ccf3a5fe841a9"/>
+    <p:sldId xmlns:r="http://schemas.openxmlformats.org/officeDocument/2006/relationships" id="267" r:id="Rff001b088278417e"/>
+    <p:sldId xmlns:r="http://schemas.openxmlformats.org/officeDocument/2006/relationships" id="268" r:id="Rcb014e5956bd491b"/>
+    <p:sldId xmlns:r="http://schemas.openxmlformats.org/officeDocument/2006/relationships" id="269" r:id="Reb2c37c7794d4b97"/>
+    <p:sldId xmlns:r="http://schemas.openxmlformats.org/officeDocument/2006/relationships" id="270" r:id="R340e2199843e4902"/>
+    <p:sldId xmlns:r="http://schemas.openxmlformats.org/officeDocument/2006/relationships" id="271" r:id="Rc93029cb906843b4"/>
+    <p:sldId xmlns:r="http://schemas.openxmlformats.org/officeDocument/2006/relationships" id="272" r:id="R688a36fb88384842"/>
+    <p:sldId xmlns:r="http://schemas.openxmlformats.org/officeDocument/2006/relationships" id="273" r:id="R1e0cd74821484fe5"/>
+    <p:sldId xmlns:r="http://schemas.openxmlformats.org/officeDocument/2006/relationships" id="274" r:id="R29905c1512294c83"/>
+    <p:sldId xmlns:r="http://schemas.openxmlformats.org/officeDocument/2006/relationships" id="275" r:id="R4201b74423364d3a"/>
+    <p:sldId xmlns:r="http://schemas.openxmlformats.org/officeDocument/2006/relationships" id="276" r:id="R295746f805b54998"/>
+    <p:sldId xmlns:r="http://schemas.openxmlformats.org/officeDocument/2006/relationships" id="277" r:id="Rc2def0f82a9f4422"/>
+    <p:sldId xmlns:r="http://schemas.openxmlformats.org/officeDocument/2006/relationships" id="278" r:id="R7bde8793c3244a18"/>
+    <p:sldId xmlns:r="http://schemas.openxmlformats.org/officeDocument/2006/relationships" id="279" r:id="R61b7639c675d459f"/>
+    <p:sldId xmlns:r="http://schemas.openxmlformats.org/officeDocument/2006/relationships" id="280" r:id="R3aa9341b89614e3a"/>
   </p:sldIdLst>
   <p:sldSz cx="12192000" cy="6858000"/>
   <p:notesSz cx="6858000" cy="9144000"/>
@@ -1884,7 +1886,7 @@
           <a:lstStyle xmlns:a="http://schemas.openxmlformats.org/drawingml/2006/main"/>
           <a:p xmlns:a="http://schemas.openxmlformats.org/drawingml/2006/main">
             <a:r>
-              <a:t>Here is the assignment we will use in the demonstration. Ticket 1004 starts without an assignee, and its status is new. We want to assign it to Noah, whose user identifier is 202, and change the status to in progress. Those are changes to the current ticket row.</a:t>
+              <a:t>Here is the assignment we will use in the demonstration. Ticket 1004 starts without an assignee, and its status is new. We want to assign it to Agent 202, whose user identifier is 202, and change the status to in progress. Those are changes to the current ticket row.</a:t>
             </a:r>
           </a:p>
           <a:p xmlns:a="http://schemas.openxmlformats.org/drawingml/2006/main">
@@ -1904,7 +1906,7 @@
           </a:p>
           <a:p xmlns:a="http://schemas.openxmlformats.org/drawingml/2006/main">
             <a:r>
-              <a:t>Imagine that we update the ticket successfully and then lose the connection before inserting the event. A staff member might see Noah as the assignee, while someone reviewing the history finds no corresponding assignment. Each table could still contain individually valid rows. The application action would nevertheless be incomplete.</a:t>
+              <a:t>Imagine that we update the ticket successfully and then lose the connection before inserting the event. A staff member might see Agent 202 as the assignee, while someone reviewing the history finds no corresponding assignment. Each table could still contain individually valid rows. The application action would nevertheless be incomplete.</a:t>
             </a:r>
           </a:p>
           <a:p xmlns:a="http://schemas.openxmlformats.org/drawingml/2006/main">
@@ -2004,7 +2006,7 @@
           <a:lstStyle xmlns:a="http://schemas.openxmlformats.org/drawingml/2006/main"/>
           <a:p xmlns:a="http://schemas.openxmlformats.org/drawingml/2006/main">
             <a:r>
-              <a:t>This is the setting you will change in the notebook. Use cloud must be true for the connection experiment to run. Keep A change is initially false, meaning A rolls back. For your second run, change only that second setting to true. The table setup and B's SQL should remain unchanged so that the comparison isolates A's decision.</a:t>
+              <a:t>Pause here to connect the assignment to the tools students will use. Lab 2 is the assignment. Notebook 02 is the file containing its code and writing space. Colab runs that file in a hosted Python runtime. Supabase hosts the PostgreSQL database. The notebook sends SQL to that database through three separate connections.</a:t>
             </a:r>
           </a:p>
           <a:p xmlns:a="http://schemas.openxmlformats.org/drawingml/2006/main">
@@ -2014,7 +2016,7 @@
           </a:p>
           <a:p xmlns:a="http://schemas.openxmlformats.org/drawingml/2006/main">
             <a:r>
-              <a:t>Open the Lab 2 page and click Open in Colab. Save a copy in Drive so you can keep your changes and results. The weekly page has the same button beside Notebook 02; downloading the file is only necessary if you prefer local Jupyter. In Supabase, use the Connect dialog's Session pooler connection for this exercise. Follow the notebook's SSL instructions and enter the connection URL only when the hidden prompt appears. Do not paste a password-bearing URL into a code cell or a Markdown explanation.</a:t>
+              <a:t>Open the Lab 2 page from the Week 5 README and click Open in Colab. Choose File, then Save a copy in Drive. Work in that copy so the two results and your comparison remain available. Keep the existing personal course project open in a separate Supabase tab. You do not need a new database project or another copy of the Metro Support dataset for this exercise.</a:t>
             </a:r>
           </a:p>
           <a:p xmlns:a="http://schemas.openxmlformats.org/drawingml/2006/main">
@@ -2024,7 +2026,7 @@
           </a:p>
           <a:p xmlns:a="http://schemas.openxmlformats.org/drawingml/2006/main">
             <a:r>
-              <a:t>The notebook contains more mechanics than you need to write yourself. It opens labeled connections, starts B's work in a background worker, observes the actual blocking relationship, and ends A before waiting for B to finish. Its cleanup path is designed to avoid leaving a row blocked while you study the output.</a:t>
+              <a:t>When we used Supabase's SQL editor, it already had access to the project's database. Colab runs elsewhere and needs connection details. Today's code runs in the Colab cells. Do not paste Python into the SQL editor, and do not treat two browser tabs as two controlled PostgreSQL sessions. The notebook creates and labels the actual connections.</a:t>
             </a:r>
           </a:p>
           <a:p xmlns:a="http://schemas.openxmlformats.org/drawingml/2006/main">
@@ -2034,7 +2036,7 @@
           </a:p>
           <a:p xmlns:a="http://schemas.openxmlformats.org/drawingml/2006/main">
             <a:r>
-              <a:t>Read the SQL and the explicit commit-or-rollback decision carefully. The concurrency scaffolding is supplied so you can investigate database behavior without first building a concurrent client application. That is different from ignoring what the notebook does. You should still be able to identify which connection writes, which one observes, and where each transaction ends.</a:t>
+              <a:t>The connection walkthrough is also near the top of the notebook, before any credentials are requested. Students can follow it while you demonstrate. The notebook creates its own disposable lock_lab row, beginning with medium priority and open status. The earlier transaction_lab event IDs do not control this experiment.</a:t>
             </a:r>
           </a:p>
           <a:p xmlns:a="http://schemas.openxmlformats.org/drawingml/2006/main">
@@ -2044,27 +2046,12 @@
           </a:p>
           <a:p xmlns:a="http://schemas.openxmlformats.org/drawingml/2006/main">
             <a:r>
-              <a:t>Keep your first result in the final Markdown cell before rerunning. Notebook output is replaced as cells execute again, while the Markdown comparison can preserve both observations. Run cleanup after each experiment.</a:t>
-            </a:r>
-          </a:p>
-          <a:p xmlns:a="http://schemas.openxmlformats.org/drawingml/2006/main">
-            <a:r>
-              <a:t/>
-            </a:r>
-          </a:p>
-          <a:p xmlns:a="http://schemas.openxmlformats.org/drawingml/2006/main">
-            <a:r>
               <a:t>[Sources]</a:t>
             </a:r>
           </a:p>
           <a:p xmlns:a="http://schemas.openxmlformats.org/drawingml/2006/main">
             <a:r>
-              <a:t>- Notebook 02 configuration and controlled experiment.</a:t>
-            </a:r>
-          </a:p>
-          <a:p xmlns:a="http://schemas.openxmlformats.org/drawingml/2006/main">
-            <a:r>
-              <a:t>- https://supabase.com/docs/guides/database/connecting-to-postgres</a:t>
+              <a:t>- Week 5, Lab 2 and Notebook 02 introduction.</a:t>
             </a:r>
           </a:p>
           <a:p xmlns:a="http://schemas.openxmlformats.org/drawingml/2006/main">
@@ -2139,7 +2126,7 @@
           <a:lstStyle xmlns:a="http://schemas.openxmlformats.org/drawingml/2006/main"/>
           <a:p xmlns:a="http://schemas.openxmlformats.org/drawingml/2006/main">
             <a:r>
-              <a:t>Your individual lab compares two resolutions of the same controlled wait. Start with the rollback case, follow the captured relationship from B's PID to A's PID, and keep the final priority and status in the comparison cell. The order of rows in the output is not the definition of which session blocks another; the blocking-PID result establishes that relationship.</a:t>
+              <a:t>In the existing Supabase course project, click Connect and choose Session pooler. Copy the PostgreSQL URI shown for that method. It begins with postgresql://. The project's HTTPS API URL and its API keys serve a different interface. This notebook uses a PostgreSQL connection string.</a:t>
             </a:r>
           </a:p>
           <a:p xmlns:a="http://schemas.openxmlformats.org/drawingml/2006/main">
@@ -2149,7 +2136,7 @@
           </a:p>
           <a:p xmlns:a="http://schemas.openxmlformats.org/drawingml/2006/main">
             <a:r>
-              <a:t>Before the second run, predict what will remain when A commits. Then change the setting, rerun the experiment from configuration through cleanup, and compare the actual row with your prediction. B's statement stays the same. Explain why the final priority differs even though B completes in both cases.</a:t>
+              <a:t>Keep the actual host, port, and username from the copied string. Replace the literal [YOUR-PASSWORD] placeholder with the database password chosen for that project. It is not the password used to sign into the Supabase website. If you do not know the database password, stop and resolve that access before continuing. Do not guess a hostname or paste a credential into a shared slide, chat, or saved notebook cell.</a:t>
             </a:r>
           </a:p>
           <a:p xmlns:a="http://schemas.openxmlformats.org/drawingml/2006/main">
@@ -2159,7 +2146,7 @@
           </a:p>
           <a:p xmlns:a="http://schemas.openxmlformats.org/drawingml/2006/main">
             <a:r>
-              <a:t>Your short writing addresses the developer whose status update appeared stuck. Use one run's observed relationship to explain the wait and use the comparison to explain the consequence of the transaction choice. You do not need to fill out a separate incident form or provide a collection of screenshots.</a:t>
+              <a:t>Reserved characters inside a password need percent encoding in a URI. For example, an at sign becomes %40, a hash becomes %23, and a percent sign becomes %25. Encode the password component only, once. The notebook explains this next to the connection steps. A malformed URI can fail before PostgreSQL even checks the password.</a:t>
             </a:r>
           </a:p>
           <a:p xmlns:a="http://schemas.openxmlformats.org/drawingml/2006/main">
@@ -2169,7 +2156,7 @@
           </a:p>
           <a:p xmlns:a="http://schemas.openxmlformats.org/drawingml/2006/main">
             <a:r>
-              <a:t>If a connection is unavailable, the supplied trace supports a different kind of practice. Label the rollback observation as a supplied trace and the commit result as an unexecuted prediction. Tell me that you used that path so we can arrange a connection demonstration. Interpreting a trace is useful, but it is not proof that you opened or administered a live session.</a:t>
+              <a:t>The notebook requires an encrypted connection. If the copied URL ends in /postgres and has no query parameters, append ?sslmode=require. If it already has other query parameters, use &amp;sslmode=require. If sslmode is already present, set that existing value to require or keep verify-ca or verify-full. Do not add two conflicting sslmode parameters. The require mode encrypts this classroom connection but does not verify the server hostname. A production configuration uses verify-full and an appropriate CA certificate.</a:t>
             </a:r>
           </a:p>
           <a:p xmlns:a="http://schemas.openxmlformats.org/drawingml/2006/main">
@@ -2179,7 +2166,7 @@
           </a:p>
           <a:p xmlns:a="http://schemas.openxmlformats.org/drawingml/2006/main">
             <a:r>
-              <a:t>Submit the completed notebook with the comparison and explanation in its final Markdown cell. Confirm cleanup ran and remove any accidentally saved credential. The database result and your reasoning belong together in this one artifact.</a:t>
+              <a:t>Prepare the URL privately, then paste it only into the hidden prompt in Colab. The next slide shows exactly which cells to run and what success looks like. The notebook clears its URL variable after opening the connections and does not intentionally save the prompt input in the file.</a:t>
             </a:r>
           </a:p>
           <a:p xmlns:a="http://schemas.openxmlformats.org/drawingml/2006/main">
@@ -2194,7 +2181,22 @@
           </a:p>
           <a:p xmlns:a="http://schemas.openxmlformats.org/drawingml/2006/main">
             <a:r>
-              <a:t>- Week 5, Lab 2: The Query Finished, but Which Change Survived?</a:t>
+              <a:t>- Notebook 02 connection validation.</a:t>
+            </a:r>
+          </a:p>
+          <a:p xmlns:a="http://schemas.openxmlformats.org/drawingml/2006/main">
+            <a:r>
+              <a:t>- https://supabase.com/docs/guides/database/connecting-to-postgres</a:t>
+            </a:r>
+          </a:p>
+          <a:p xmlns:a="http://schemas.openxmlformats.org/drawingml/2006/main">
+            <a:r>
+              <a:t>- https://www.postgresql.org/docs/current/libpq-connect.html#LIBPQ-CONNSTRING-URIS</a:t>
+            </a:r>
+          </a:p>
+          <a:p xmlns:a="http://schemas.openxmlformats.org/drawingml/2006/main">
+            <a:r>
+              <a:t>- https://www.postgresql.org/docs/current/libpq-ssl.html</a:t>
             </a:r>
           </a:p>
         </p:txBody>
@@ -2264,7 +2266,7 @@
           <a:lstStyle xmlns:a="http://schemas.openxmlformats.org/drawingml/2006/main"/>
           <a:p xmlns:a="http://schemas.openxmlformats.org/drawingml/2006/main">
             <a:r>
-              <a:t>This short update explains the rollback case in ordinary technical language. It identifies the status update as the waiting operation, ties the wait to A's uncommitted change of the same row, and points to the captured PID relationship. Then it states what happened to the actual data after A rolled back and B committed.</a:t>
+              <a:t>Return to the Colab copy and find the configuration cell near the top. Set USE_CLOUD to True and leave KEEP_A_CHANGE False for the first run. A downloaded notebook defaults to USE_CLOUD False, which skips all database connections and offers an interpretation trace. Seeing that trace does not mean a cloud connection worked.</a:t>
             </a:r>
           </a:p>
           <a:p xmlns:a="http://schemas.openxmlformats.org/drawingml/2006/main">
@@ -2274,7 +2276,7 @@
           </a:p>
           <a:p xmlns:a="http://schemas.openxmlformats.org/drawingml/2006/main">
             <a:r>
-              <a:t>The placeholders for A's and B's PIDs are not numbers to invent. Use values from your executed run, or identify the supplied teaching trace. We want the explanation to reflect how the conclusion was obtained rather than imitate the appearance of an incident report.</a:t>
+              <a:t>Run the code cells from the top in order, beginning with the psycopg installation cell, then the configuration cell. In Section 1, run the connection cell. It displays Paste the temporary PostgreSQL connection URL. Paste the prepared URL into that hidden input and press Enter. It is normal for the cell to wait while it needs your input.</a:t>
             </a:r>
           </a:p>
           <a:p xmlns:a="http://schemas.openxmlformats.org/drawingml/2006/main">
@@ -2284,7 +2286,7 @@
           </a:p>
           <a:p xmlns:a="http://schemas.openxmlformats.org/drawingml/2006/main">
             <a:r>
-              <a:t>Your comparison adds the consequence of committing A. B still completes its status update, but the high priority remains. That is the important addition: choosing an action to restore progress also chooses what happens to somebody else's proposed data change.</a:t>
+              <a:t>Proceed when the output says Opened Session A, Session B, and the diagnostic session. Then run Section 2. It creates the disposable schema and prints Starting row: (1004, 'medium', 'open'). These are two separate checkpoints from two cells. If a connection fails, stop before setup and inspect the selected connection method, database password, URL syntax, SSL setting, and whether the project is running. A skipped cloud path means USE_CLOUD is still False or its configuration cell was not rerun.</a:t>
             </a:r>
           </a:p>
           <a:p xmlns:a="http://schemas.openxmlformats.org/drawingml/2006/main">
@@ -2294,7 +2296,7 @@
           </a:p>
           <a:p xmlns:a="http://schemas.openxmlformats.org/drawingml/2006/main">
             <a:r>
-              <a:t>In a real application, we would need to know whether that priority change was valid, who owned the transaction, and whether other work belonged to the same operation. We might contact the owner or follow an established operational procedure rather than decide from a process list alone. You can state that limitation without pretending our classroom experiment caused or measured an actual production outage.</a:t>
+              <a:t>Section 3 defines and displays A's SQL. Section 4 runs the actual concurrent experiment. It captures B waiting, rolls A back, and waits for B to finish before returning. Section 5 prints that captured activity. Under B, the blocking_pids list should contain A's PID. Section 6 prints A's decision and the final row, which should be (1004, 'medium', 'in_progress') for this rollback case. By the time those results display, the controlled wait has ended.</a:t>
             </a:r>
           </a:p>
           <a:p xmlns:a="http://schemas.openxmlformats.org/drawingml/2006/main">
@@ -2304,7 +2306,7 @@
           </a:p>
           <a:p xmlns:a="http://schemas.openxmlformats.org/drawingml/2006/main">
             <a:r>
-              <a:t>This kind of writing is useful in interviews as well. Instead of saying only that you know PostgreSQL locks, you can describe a controlled test, the diagnostic function you used, the different outcomes you verified, and the limit of your conclusion. That gives someone a concrete basis for asking about your understanding.</a:t>
+              <a:t>Run Section 7 cleanup and record the first result in the final Markdown comparison. Change only KEEP_A_CHANGE to True and rerun from configuration through cleanup. Keep USE_CLOUD True. The new setup restores the same starting row, and the second final row should be (1004, 'high', 'in_progress'). Both runs should finish successfully. Students do not need to produce a duplicate-key error in this lab.</a:t>
             </a:r>
           </a:p>
           <a:p xmlns:a="http://schemas.openxmlformats.org/drawingml/2006/main">
@@ -2319,12 +2321,7 @@
           </a:p>
           <a:p xmlns:a="http://schemas.openxmlformats.org/drawingml/2006/main">
             <a:r>
-              <a:t>- Course writing guide, Write an Incident Update.</a:t>
-            </a:r>
-          </a:p>
-          <a:p xmlns:a="http://schemas.openxmlformats.org/drawingml/2006/main">
-            <a:r>
-              <a:t>- Notebook 02 lab comparison.</a:t>
+              <a:t>- Notebook 02 configuration, connection, setup, experiment, diagnostic output, final state, and cleanup cells.</a:t>
             </a:r>
           </a:p>
         </p:txBody>
@@ -2394,6 +2391,261 @@
           <a:lstStyle xmlns:a="http://schemas.openxmlformats.org/drawingml/2006/main"/>
           <a:p xmlns:a="http://schemas.openxmlformats.org/drawingml/2006/main">
             <a:r>
+              <a:t>Your individual lab compares two resolutions of the same controlled wait. Start with the rollback case, follow the captured relationship from B's PID to A's PID, and keep the final priority and status in the comparison cell. The order of rows in the output is not the definition of which session blocks another; the blocking-PID result establishes that relationship.</a:t>
+            </a:r>
+          </a:p>
+          <a:p xmlns:a="http://schemas.openxmlformats.org/drawingml/2006/main">
+            <a:r>
+              <a:t/>
+            </a:r>
+          </a:p>
+          <a:p xmlns:a="http://schemas.openxmlformats.org/drawingml/2006/main">
+            <a:r>
+              <a:t>Before the second run, predict what will remain when A commits. Then change the setting, rerun the experiment from configuration through cleanup, and compare the actual row with your prediction. B's statement stays the same. Explain why the final priority differs even though B completes in both cases.</a:t>
+            </a:r>
+          </a:p>
+          <a:p xmlns:a="http://schemas.openxmlformats.org/drawingml/2006/main">
+            <a:r>
+              <a:t/>
+            </a:r>
+          </a:p>
+          <a:p xmlns:a="http://schemas.openxmlformats.org/drawingml/2006/main">
+            <a:r>
+              <a:t>Your short writing addresses the developer whose status update appeared stuck. Use one run's observed relationship to explain the wait and use the comparison to explain the consequence of the transaction choice. You do not need to fill out a separate incident form or provide a collection of screenshots.</a:t>
+            </a:r>
+          </a:p>
+          <a:p xmlns:a="http://schemas.openxmlformats.org/drawingml/2006/main">
+            <a:r>
+              <a:t/>
+            </a:r>
+          </a:p>
+          <a:p xmlns:a="http://schemas.openxmlformats.org/drawingml/2006/main">
+            <a:r>
+              <a:t>If a connection is unavailable, the supplied trace supports a different kind of practice. Label the rollback observation as a supplied trace and the commit result as an unexecuted prediction. Tell me that you used that path so we can arrange a connection demonstration. Interpreting a trace is useful, but it is not proof that you opened or administered a live session.</a:t>
+            </a:r>
+          </a:p>
+          <a:p xmlns:a="http://schemas.openxmlformats.org/drawingml/2006/main">
+            <a:r>
+              <a:t/>
+            </a:r>
+          </a:p>
+          <a:p xmlns:a="http://schemas.openxmlformats.org/drawingml/2006/main">
+            <a:r>
+              <a:t>Submit the completed notebook with the comparison and explanation in its final Markdown cell. Confirm cleanup ran and remove any accidentally saved credential. The database result and your reasoning belong together in this one artifact.</a:t>
+            </a:r>
+          </a:p>
+          <a:p xmlns:a="http://schemas.openxmlformats.org/drawingml/2006/main">
+            <a:r>
+              <a:t/>
+            </a:r>
+          </a:p>
+          <a:p xmlns:a="http://schemas.openxmlformats.org/drawingml/2006/main">
+            <a:r>
+              <a:t>[Sources]</a:t>
+            </a:r>
+          </a:p>
+          <a:p xmlns:a="http://schemas.openxmlformats.org/drawingml/2006/main">
+            <a:r>
+              <a:t>- Week 5, Lab 2: The Query Finished, but Which Change Survived?</a:t>
+            </a:r>
+          </a:p>
+        </p:txBody>
+      </p:sp>
+      <p:sp>
+        <p:nvSpPr>
+          <p:cNvPr id="4" name="Slide Number Placeholder 3"/>
+          <p:cNvSpPr>
+            <a:spLocks xmlns:a="http://schemas.openxmlformats.org/drawingml/2006/main" noGrp="1"/>
+          </p:cNvSpPr>
+          <p:nvPr>
+            <p:ph type="sldNum" idx="5"/>
+          </p:nvPr>
+        </p:nvSpPr>
+        <p:spPr/>
+        <p:txBody>
+          <a:bodyPr xmlns:a="http://schemas.openxmlformats.org/drawingml/2006/main"/>
+          <a:lstStyle xmlns:a="http://schemas.openxmlformats.org/drawingml/2006/main"/>
+          <a:p xmlns:a="http://schemas.openxmlformats.org/drawingml/2006/main"/>
+        </p:txBody>
+      </p:sp>
+    </p:spTree>
+  </p:cSld>
+  <p:clrMapOvr>
+    <a:masterClrMapping xmlns:a="http://schemas.openxmlformats.org/drawingml/2006/main"/>
+  </p:clrMapOvr>
+</p:notes>
+</file>
+
+<file path=ppt/notesSlides/notesSlide24.xml><?xml version="1.0" encoding="utf-8"?>
+<p:notes xmlns:p="http://schemas.openxmlformats.org/presentationml/2006/main">
+  <p:cSld>
+    <p:spTree>
+      <p:nvGrpSpPr>
+        <p:cNvPr id="1" name=""/>
+        <p:cNvGrpSpPr/>
+        <p:nvPr/>
+      </p:nvGrpSpPr>
+      <p:grpSpPr>
+        <a:xfrm xmlns:a="http://schemas.openxmlformats.org/drawingml/2006/main"/>
+      </p:grpSpPr>
+      <p:sp>
+        <p:nvSpPr>
+          <p:cNvPr id="2" name="Slide Image Placeholder 1"/>
+          <p:cNvSpPr>
+            <a:spLocks xmlns:a="http://schemas.openxmlformats.org/drawingml/2006/main" noGrp="1"/>
+          </p:cNvSpPr>
+          <p:nvPr>
+            <p:ph type="sldImg" idx="0"/>
+          </p:nvPr>
+        </p:nvSpPr>
+        <p:spPr/>
+      </p:sp>
+      <p:sp>
+        <p:nvSpPr>
+          <p:cNvPr id="3" name="Notes Placeholder 2"/>
+          <p:cNvSpPr>
+            <a:spLocks xmlns:a="http://schemas.openxmlformats.org/drawingml/2006/main" noGrp="1"/>
+          </p:cNvSpPr>
+          <p:nvPr>
+            <p:ph type="body" idx="1"/>
+          </p:nvPr>
+        </p:nvSpPr>
+        <p:spPr/>
+        <p:txBody>
+          <a:bodyPr xmlns:a="http://schemas.openxmlformats.org/drawingml/2006/main"/>
+          <a:lstStyle xmlns:a="http://schemas.openxmlformats.org/drawingml/2006/main"/>
+          <a:p xmlns:a="http://schemas.openxmlformats.org/drawingml/2006/main">
+            <a:r>
+              <a:t>This short update explains the rollback case in ordinary technical language. It identifies the status update as the waiting operation, ties the wait to A's uncommitted change of the same row, and points to the captured PID relationship. Then it states what happened to the actual data after A rolled back and B committed.</a:t>
+            </a:r>
+          </a:p>
+          <a:p xmlns:a="http://schemas.openxmlformats.org/drawingml/2006/main">
+            <a:r>
+              <a:t/>
+            </a:r>
+          </a:p>
+          <a:p xmlns:a="http://schemas.openxmlformats.org/drawingml/2006/main">
+            <a:r>
+              <a:t>The placeholders for A's and B's PIDs are not numbers to invent. Use values from your executed run, or identify the supplied teaching trace. We want the explanation to reflect how the conclusion was obtained rather than imitate the appearance of an incident report.</a:t>
+            </a:r>
+          </a:p>
+          <a:p xmlns:a="http://schemas.openxmlformats.org/drawingml/2006/main">
+            <a:r>
+              <a:t/>
+            </a:r>
+          </a:p>
+          <a:p xmlns:a="http://schemas.openxmlformats.org/drawingml/2006/main">
+            <a:r>
+              <a:t>Your comparison adds the consequence of committing A. B still completes its status update, but the high priority remains. That is the important addition: choosing an action to restore progress also chooses what happens to somebody else's proposed data change.</a:t>
+            </a:r>
+          </a:p>
+          <a:p xmlns:a="http://schemas.openxmlformats.org/drawingml/2006/main">
+            <a:r>
+              <a:t/>
+            </a:r>
+          </a:p>
+          <a:p xmlns:a="http://schemas.openxmlformats.org/drawingml/2006/main">
+            <a:r>
+              <a:t>In a real application, we would need to know whether that priority change was valid, who owned the transaction, and whether other work belonged to the same operation. We might contact the owner or follow an established operational procedure rather than decide from a process list alone. You can state that limitation without pretending our classroom experiment caused or measured an actual production outage.</a:t>
+            </a:r>
+          </a:p>
+          <a:p xmlns:a="http://schemas.openxmlformats.org/drawingml/2006/main">
+            <a:r>
+              <a:t/>
+            </a:r>
+          </a:p>
+          <a:p xmlns:a="http://schemas.openxmlformats.org/drawingml/2006/main">
+            <a:r>
+              <a:t>This kind of writing is useful in interviews as well. Instead of saying only that you know PostgreSQL locks, you can describe a controlled test, the diagnostic function you used, the different outcomes you verified, and the limit of your conclusion. That gives someone a concrete basis for asking about your understanding.</a:t>
+            </a:r>
+          </a:p>
+          <a:p xmlns:a="http://schemas.openxmlformats.org/drawingml/2006/main">
+            <a:r>
+              <a:t/>
+            </a:r>
+          </a:p>
+          <a:p xmlns:a="http://schemas.openxmlformats.org/drawingml/2006/main">
+            <a:r>
+              <a:t>[Sources]</a:t>
+            </a:r>
+          </a:p>
+          <a:p xmlns:a="http://schemas.openxmlformats.org/drawingml/2006/main">
+            <a:r>
+              <a:t>- Course writing guide, Write an Incident Update.</a:t>
+            </a:r>
+          </a:p>
+          <a:p xmlns:a="http://schemas.openxmlformats.org/drawingml/2006/main">
+            <a:r>
+              <a:t>- Notebook 02 lab comparison.</a:t>
+            </a:r>
+          </a:p>
+        </p:txBody>
+      </p:sp>
+      <p:sp>
+        <p:nvSpPr>
+          <p:cNvPr id="4" name="Slide Number Placeholder 3"/>
+          <p:cNvSpPr>
+            <a:spLocks xmlns:a="http://schemas.openxmlformats.org/drawingml/2006/main" noGrp="1"/>
+          </p:cNvSpPr>
+          <p:nvPr>
+            <p:ph type="sldNum" idx="5"/>
+          </p:nvPr>
+        </p:nvSpPr>
+        <p:spPr/>
+        <p:txBody>
+          <a:bodyPr xmlns:a="http://schemas.openxmlformats.org/drawingml/2006/main"/>
+          <a:lstStyle xmlns:a="http://schemas.openxmlformats.org/drawingml/2006/main"/>
+          <a:p xmlns:a="http://schemas.openxmlformats.org/drawingml/2006/main"/>
+        </p:txBody>
+      </p:sp>
+    </p:spTree>
+  </p:cSld>
+  <p:clrMapOvr>
+    <a:masterClrMapping xmlns:a="http://schemas.openxmlformats.org/drawingml/2006/main"/>
+  </p:clrMapOvr>
+</p:notes>
+</file>
+
+<file path=ppt/notesSlides/notesSlide25.xml><?xml version="1.0" encoding="utf-8"?>
+<p:notes xmlns:p="http://schemas.openxmlformats.org/presentationml/2006/main">
+  <p:cSld>
+    <p:spTree>
+      <p:nvGrpSpPr>
+        <p:cNvPr id="1" name=""/>
+        <p:cNvGrpSpPr/>
+        <p:nvPr/>
+      </p:nvGrpSpPr>
+      <p:grpSpPr>
+        <a:xfrm xmlns:a="http://schemas.openxmlformats.org/drawingml/2006/main"/>
+      </p:grpSpPr>
+      <p:sp>
+        <p:nvSpPr>
+          <p:cNvPr id="2" name="Slide Image Placeholder 1"/>
+          <p:cNvSpPr>
+            <a:spLocks xmlns:a="http://schemas.openxmlformats.org/drawingml/2006/main" noGrp="1"/>
+          </p:cNvSpPr>
+          <p:nvPr>
+            <p:ph type="sldImg" idx="0"/>
+          </p:nvPr>
+        </p:nvSpPr>
+        <p:spPr/>
+      </p:sp>
+      <p:sp>
+        <p:nvSpPr>
+          <p:cNvPr id="3" name="Notes Placeholder 2"/>
+          <p:cNvSpPr>
+            <a:spLocks xmlns:a="http://schemas.openxmlformats.org/drawingml/2006/main" noGrp="1"/>
+          </p:cNvSpPr>
+          <p:nvPr>
+            <p:ph type="body" idx="1"/>
+          </p:nvPr>
+        </p:nvSpPr>
+        <p:spPr/>
+        <p:txBody>
+          <a:bodyPr xmlns:a="http://schemas.openxmlformats.org/drawingml/2006/main"/>
+          <a:lstStyle xmlns:a="http://schemas.openxmlformats.org/drawingml/2006/main"/>
+          <a:p xmlns:a="http://schemas.openxmlformats.org/drawingml/2006/main">
+            <a:r>
               <a:t>We can now describe several claims that initially sound similar but require different checks. A statement succeeded. A transaction committed. A waiting query finished. The application retained the intended state. Those are not interchangeable statements.</a:t>
             </a:r>
           </a:p>
@@ -2659,7 +2911,7 @@
           </a:p>
           <a:p xmlns:a="http://schemas.openxmlformats.org/drawingml/2006/main">
             <a:r>
-              <a:t>The set clause changes the assignee to Noah and the status to in progress. Returning asks PostgreSQL to send back the affected ticket identifier, assignee, and status. For this fixture, that result is 1004, 202, and in progress. It lets us inspect the row changed by this statement.</a:t>
+              <a:t>The set clause changes the assignee to Agent 202 and the status to in progress. Returning asks PostgreSQL to send back the affected ticket identifier, assignee, and status. For this fixture, that result is 1004, 202, and in progress. It lets us inspect the row changed by this statement.</a:t>
             </a:r>
           </a:p>
           <a:p xmlns:a="http://schemas.openxmlformats.org/drawingml/2006/main">
@@ -2769,7 +3021,7 @@
           <a:lstStyle xmlns:a="http://schemas.openxmlformats.org/drawingml/2006/main"/>
           <a:p xmlns:a="http://schemas.openxmlformats.org/drawingml/2006/main">
             <a:r>
-              <a:t>The table separates three observation points. Inside the transaction, our connection sees Noah's assignment and, after the insert, the new event. Those changes are available to our own transaction even though we have not committed them.</a:t>
+              <a:t>The table separates three observation points. Inside the transaction, our connection sees Agent 202's assignment and, after the insert, the new event. Those changes are available to our own transaction even though we have not committed them.</a:t>
             </a:r>
           </a:p>
           <a:p xmlns:a="http://schemas.openxmlformats.org/drawingml/2006/main">
@@ -3304,7 +3556,7 @@
           </a:p>
           <a:p xmlns:a="http://schemas.openxmlformats.org/drawingml/2006/main">
             <a:r>
-              <a:t>The proposed assignment in your lab is to Priya, user 201, and the new event is 5999. Start by checking ticket 1004's actual initial state. Run the rehearsal ending in rollback, then query the ticket and event afterward. Next, keep the approved pair by replacing that ending with commit and check the stored result again.</a:t>
+              <a:t>The proposed assignment in your lab is to Agent 201, user 201, and the new event is 5999. Start by checking ticket 1004's actual initial state. Run the rehearsal ending in rollback, then query the ticket and event afterward. Next, run the separate committed-transaction block supplied in the lab and check the stored result again.</a:t>
             </a:r>
           </a:p>
           <a:p xmlns:a="http://schemas.openxmlformats.org/drawingml/2006/main">
@@ -3314,7 +3566,7 @@
           </a:p>
           <a:p xmlns:a="http://schemas.openxmlformats.org/drawingml/2006/main">
             <a:r>
-              <a:t>The next experiment starts a new transaction, changes priority, and deliberately attempts to insert the already approved event key. Run rollback separately after the expected error. Your checks should distinguish the discarded new priority from the earlier committed assignment and event, which remain.</a:t>
+              <a:t>The next experiment starts a new transaction, changes priority, and deliberately copies the seeded event 5001 into the same table. Its primary key already exists after setup, so the insert raises a duplicate-key error even if you have not committed event 5999. A rolled-back insertion of 5999 does not leave a duplicate key behind. Run rollback separately after the expected error. Your checks should distinguish the discarded new priority from the earlier committed assignment and event, which remain.</a:t>
             </a:r>
           </a:p>
           <a:p xmlns:a="http://schemas.openxmlformats.org/drawingml/2006/main">
@@ -3324,7 +3576,7 @@
           </a:p>
           <a:p xmlns:a="http://schemas.openxmlformats.org/drawingml/2006/main">
             <a:r>
-              <a:t>Then compare that failure with the outdated assignment request. Imagine another screen still labels this ticket new and submits an assignment to Noah, user 202. The supplied UPDATE includes the condition that status must be new. Because your earlier assignment already moved the ticket to in_progress, this UPDATE returns no rows. There is no SQL exception. The following SELECT still shows Priya, user 201. We have not inserted a history event for this attempt because there was no assignment to record.</a:t>
+              <a:t>Then compare that failure with the outdated assignment request. Imagine another screen still labels this ticket new and submits an assignment to Agent 202, user 202. The supplied UPDATE includes the condition that status must be new. Because your earlier assignment already moved the ticket to in_progress, this UPDATE returns no rows. There is no SQL exception. The following SELECT still shows Agent 201, user 201. We have not inserted a history event for this attempt because there was no assignment to record.</a:t>
             </a:r>
           </a:p>
           <a:p xmlns:a="http://schemas.openxmlformats.org/drawingml/2006/main">
@@ -3344,7 +3596,7 @@
           </a:p>
           <a:p xmlns:a="http://schemas.openxmlformats.org/drawingml/2006/main">
             <a:r>
-              <a:t>Add one sentence for the application developer: check the returned ticket before writing history or announcing success. If no row was returned, inspect the current record rather than telling the caller that Noah now has the ticket. An outdated status and a missing ticket can both produce an empty result, so the count tells us that our requested change did not happen, but does not by itself diagnose every cause.</a:t>
+              <a:t>Add one sentence for the application developer: check the returned ticket before writing history or announcing success. If no row was returned, inspect the current record rather than telling the caller that Agent 202 now has the ticket. An outdated status and a missing ticket can both produce an empty result, so the count tells us that our requested change did not happen, but does not by itself diagnose every cause.</a:t>
             </a:r>
           </a:p>
           <a:p xmlns:a="http://schemas.openxmlformats.org/drawingml/2006/main">
@@ -3447,7 +3699,7 @@
   </p:cSld>
   <p:clrMap bg1="lt1" tx1="dk1" bg2="lt2" tx2="dk2" accent1="accent1" accent2="accent2" accent3="accent3" accent4="accent4" accent5="accent5" accent6="accent6" hlink="hlink" folHlink="folHlink"/>
   <p:sldLayoutIdLst>
-    <p:sldLayoutId xmlns:r="http://schemas.openxmlformats.org/officeDocument/2006/relationships" id="2147483649" r:id="R444d135e12854908"/>
+    <p:sldLayoutId xmlns:r="http://schemas.openxmlformats.org/officeDocument/2006/relationships" id="2147483649" r:id="Rc9bb5a303b424efc"/>
   </p:sldLayoutIdLst>
   <p:txStyles>
     <p:titleStyle>
@@ -3998,7 +4250,7 @@
           <p:cNvPr id="7" name="eyebrow">
             <a:extLst xmlns:a="http://schemas.openxmlformats.org/drawingml/2006/main">
               <a:ext uri="{FF2B5EF4-FFF2-40B4-BE49-F238E27FC236}">
-                <a16:creationId xmlns:a16="http://schemas.microsoft.com/office/drawing/2014/main" id="{5282D8E0-BB31-43C6-A66B-FC059D999DDA}"/>
+                <a16:creationId xmlns:a16="http://schemas.microsoft.com/office/drawing/2014/main" id="{4E4B999E-ABC8-4B0C-BB79-322A13CB8D68}"/>
               </a:ext>
             </a:extLst>
           </p:cNvPr>
@@ -4055,7 +4307,7 @@
           <p:cNvPr id="2" name="slide-title">
             <a:extLst xmlns:a="http://schemas.openxmlformats.org/drawingml/2006/main">
               <a:ext uri="{FF2B5EF4-FFF2-40B4-BE49-F238E27FC236}">
-                <a16:creationId xmlns:a16="http://schemas.microsoft.com/office/drawing/2014/main" id="{8CA4A6A4-226C-46C5-96B7-E7C4CDCBC6D5}"/>
+                <a16:creationId xmlns:a16="http://schemas.microsoft.com/office/drawing/2014/main" id="{2344C49B-8FF4-4409-B99B-EA0453B21E01}"/>
               </a:ext>
             </a:extLst>
           </p:cNvPr>
@@ -4112,7 +4364,7 @@
           <p:cNvPr id="3" name="">
             <a:extLst xmlns:a="http://schemas.openxmlformats.org/drawingml/2006/main">
               <a:ext uri="{FF2B5EF4-FFF2-40B4-BE49-F238E27FC236}">
-                <a16:creationId xmlns:a16="http://schemas.microsoft.com/office/drawing/2014/main" id="{A96C4786-75CF-48E2-8AEC-B843CA7EED86}"/>
+                <a16:creationId xmlns:a16="http://schemas.microsoft.com/office/drawing/2014/main" id="{0BDAF6B3-C481-4330-B56B-0F679058152E}"/>
               </a:ext>
             </a:extLst>
           </p:cNvPr>
@@ -4144,7 +4396,7 @@
           <p:cNvPr id="4" name="slide-number">
             <a:extLst xmlns:a="http://schemas.openxmlformats.org/drawingml/2006/main">
               <a:ext uri="{FF2B5EF4-FFF2-40B4-BE49-F238E27FC236}">
-                <a16:creationId xmlns:a16="http://schemas.microsoft.com/office/drawing/2014/main" id="{803D1117-4D9D-4B26-8490-135359584FB4}"/>
+                <a16:creationId xmlns:a16="http://schemas.microsoft.com/office/drawing/2014/main" id="{D5794E8E-5806-4A65-8055-61E3FACC10B9}"/>
               </a:ext>
             </a:extLst>
           </p:cNvPr>
@@ -4201,7 +4453,7 @@
           <p:cNvPr id="5" name="cover-case">
             <a:extLst xmlns:a="http://schemas.openxmlformats.org/drawingml/2006/main">
               <a:ext uri="{FF2B5EF4-FFF2-40B4-BE49-F238E27FC236}">
-                <a16:creationId xmlns:a16="http://schemas.microsoft.com/office/drawing/2014/main" id="{F246AFB4-4AE1-4A2A-B3B0-2785287C8908}"/>
+                <a16:creationId xmlns:a16="http://schemas.microsoft.com/office/drawing/2014/main" id="{5B5B9AC5-AAC5-4177-90EF-094E128AA563}"/>
               </a:ext>
             </a:extLst>
           </p:cNvPr>
@@ -4281,7 +4533,7 @@
           <p:cNvPr id="6" name="cover-arc">
             <a:extLst xmlns:a="http://schemas.openxmlformats.org/drawingml/2006/main">
               <a:ext uri="{FF2B5EF4-FFF2-40B4-BE49-F238E27FC236}">
-                <a16:creationId xmlns:a16="http://schemas.microsoft.com/office/drawing/2014/main" id="{4D69AC97-E91B-4624-8889-8E8730B0AC6B}"/>
+                <a16:creationId xmlns:a16="http://schemas.microsoft.com/office/drawing/2014/main" id="{759E49CB-7173-4860-8979-9AA49C7620AD}"/>
               </a:ext>
             </a:extLst>
           </p:cNvPr>
@@ -4390,7 +4642,7 @@
           <p:cNvPr id="7" name="eyebrow">
             <a:extLst xmlns:a="http://schemas.openxmlformats.org/drawingml/2006/main">
               <a:ext uri="{FF2B5EF4-FFF2-40B4-BE49-F238E27FC236}">
-                <a16:creationId xmlns:a16="http://schemas.microsoft.com/office/drawing/2014/main" id="{00A7FA01-ECB9-49C4-9A85-441A73E37296}"/>
+                <a16:creationId xmlns:a16="http://schemas.microsoft.com/office/drawing/2014/main" id="{E9EA7003-6391-4900-8C10-8CA8EB05F741}"/>
               </a:ext>
             </a:extLst>
           </p:cNvPr>
@@ -4447,7 +4699,7 @@
           <p:cNvPr id="2" name="slide-title">
             <a:extLst xmlns:a="http://schemas.openxmlformats.org/drawingml/2006/main">
               <a:ext uri="{FF2B5EF4-FFF2-40B4-BE49-F238E27FC236}">
-                <a16:creationId xmlns:a16="http://schemas.microsoft.com/office/drawing/2014/main" id="{6D24E76D-3265-46B9-B5BC-0BDB6A27C620}"/>
+                <a16:creationId xmlns:a16="http://schemas.microsoft.com/office/drawing/2014/main" id="{EA806F2A-2180-40E0-B5E7-C699B0978531}"/>
               </a:ext>
             </a:extLst>
           </p:cNvPr>
@@ -4504,7 +4756,7 @@
           <p:cNvPr id="3" name="">
             <a:extLst xmlns:a="http://schemas.openxmlformats.org/drawingml/2006/main">
               <a:ext uri="{FF2B5EF4-FFF2-40B4-BE49-F238E27FC236}">
-                <a16:creationId xmlns:a16="http://schemas.microsoft.com/office/drawing/2014/main" id="{C7F3219D-75F5-46E2-9FEE-B810B6F67C87}"/>
+                <a16:creationId xmlns:a16="http://schemas.microsoft.com/office/drawing/2014/main" id="{2591C408-A0BC-4A24-B67B-774F96EA0C14}"/>
               </a:ext>
             </a:extLst>
           </p:cNvPr>
@@ -4536,7 +4788,7 @@
           <p:cNvPr id="4" name="slide-number">
             <a:extLst xmlns:a="http://schemas.openxmlformats.org/drawingml/2006/main">
               <a:ext uri="{FF2B5EF4-FFF2-40B4-BE49-F238E27FC236}">
-                <a16:creationId xmlns:a16="http://schemas.microsoft.com/office/drawing/2014/main" id="{E01D92B5-14AB-4211-AF26-7444B057588D}"/>
+                <a16:creationId xmlns:a16="http://schemas.microsoft.com/office/drawing/2014/main" id="{04CDF471-C92B-4737-98A6-E6D3B6D263FD}"/>
               </a:ext>
             </a:extLst>
           </p:cNvPr>
@@ -4593,7 +4845,7 @@
           <p:cNvPr id="5" name="day2">
             <a:extLst xmlns:a="http://schemas.openxmlformats.org/drawingml/2006/main">
               <a:ext uri="{FF2B5EF4-FFF2-40B4-BE49-F238E27FC236}">
-                <a16:creationId xmlns:a16="http://schemas.microsoft.com/office/drawing/2014/main" id="{6338F753-83FB-40B5-95C2-F84473F86947}"/>
+                <a16:creationId xmlns:a16="http://schemas.microsoft.com/office/drawing/2014/main" id="{4772F116-D4C1-47B7-9777-DE62C10D9D93}"/>
               </a:ext>
             </a:extLst>
           </p:cNvPr>
@@ -4673,7 +4925,7 @@
           <p:cNvPr id="6" name="day2-goal">
             <a:extLst xmlns:a="http://schemas.openxmlformats.org/drawingml/2006/main">
               <a:ext uri="{FF2B5EF4-FFF2-40B4-BE49-F238E27FC236}">
-                <a16:creationId xmlns:a16="http://schemas.microsoft.com/office/drawing/2014/main" id="{6DBDCCAF-0F6E-46EE-A176-D8946C99A781}"/>
+                <a16:creationId xmlns:a16="http://schemas.microsoft.com/office/drawing/2014/main" id="{349036A8-5F3B-4A9A-B6A8-5FC83A216233}"/>
               </a:ext>
             </a:extLst>
           </p:cNvPr>
@@ -4759,7 +5011,7 @@
           <p:cNvPr id="13" name="eyebrow">
             <a:extLst xmlns:a="http://schemas.openxmlformats.org/drawingml/2006/main">
               <a:ext uri="{FF2B5EF4-FFF2-40B4-BE49-F238E27FC236}">
-                <a16:creationId xmlns:a16="http://schemas.microsoft.com/office/drawing/2014/main" id="{246F00BB-85CC-4690-A155-C246331BC41B}"/>
+                <a16:creationId xmlns:a16="http://schemas.microsoft.com/office/drawing/2014/main" id="{D0E8A8DA-B229-4EF6-A392-3A31CEFFC837}"/>
               </a:ext>
             </a:extLst>
           </p:cNvPr>
@@ -4816,7 +5068,7 @@
           <p:cNvPr id="2" name="slide-title">
             <a:extLst xmlns:a="http://schemas.openxmlformats.org/drawingml/2006/main">
               <a:ext uri="{FF2B5EF4-FFF2-40B4-BE49-F238E27FC236}">
-                <a16:creationId xmlns:a16="http://schemas.microsoft.com/office/drawing/2014/main" id="{473D672B-C815-4D1B-9BA1-0D25A793CB7E}"/>
+                <a16:creationId xmlns:a16="http://schemas.microsoft.com/office/drawing/2014/main" id="{ABBFED6C-17BB-4C79-BF8F-2DCD17CF234F}"/>
               </a:ext>
             </a:extLst>
           </p:cNvPr>
@@ -4873,7 +5125,7 @@
           <p:cNvPr id="3" name="">
             <a:extLst xmlns:a="http://schemas.openxmlformats.org/drawingml/2006/main">
               <a:ext uri="{FF2B5EF4-FFF2-40B4-BE49-F238E27FC236}">
-                <a16:creationId xmlns:a16="http://schemas.microsoft.com/office/drawing/2014/main" id="{359D79BB-E681-4E6E-90B3-783DBDFA0670}"/>
+                <a16:creationId xmlns:a16="http://schemas.microsoft.com/office/drawing/2014/main" id="{8F0E60E4-9D51-4F36-8CAC-58C631E1166C}"/>
               </a:ext>
             </a:extLst>
           </p:cNvPr>
@@ -4905,7 +5157,7 @@
           <p:cNvPr id="4" name="slide-number">
             <a:extLst xmlns:a="http://schemas.openxmlformats.org/drawingml/2006/main">
               <a:ext uri="{FF2B5EF4-FFF2-40B4-BE49-F238E27FC236}">
-                <a16:creationId xmlns:a16="http://schemas.microsoft.com/office/drawing/2014/main" id="{DBF5B670-A5B6-4F99-AF0A-2F961EC63553}"/>
+                <a16:creationId xmlns:a16="http://schemas.microsoft.com/office/drawing/2014/main" id="{C402B882-F798-4EED-80F6-EA30F6F18613}"/>
               </a:ext>
             </a:extLst>
           </p:cNvPr>
@@ -4962,7 +5214,7 @@
           <p:cNvPr id="5" name="">
             <a:extLst xmlns:a="http://schemas.openxmlformats.org/drawingml/2006/main">
               <a:ext uri="{FF2B5EF4-FFF2-40B4-BE49-F238E27FC236}">
-                <a16:creationId xmlns:a16="http://schemas.microsoft.com/office/drawing/2014/main" id="{F3B195BB-137D-441D-9D6A-AEACCC9312BB}"/>
+                <a16:creationId xmlns:a16="http://schemas.microsoft.com/office/drawing/2014/main" id="{E50E8343-7483-48CC-80FC-99B5F6B23134}"/>
               </a:ext>
             </a:extLst>
           </p:cNvPr>
@@ -4994,7 +5246,7 @@
           <p:cNvPr id="6" name="session-a">
             <a:extLst xmlns:a="http://schemas.openxmlformats.org/drawingml/2006/main">
               <a:ext uri="{FF2B5EF4-FFF2-40B4-BE49-F238E27FC236}">
-                <a16:creationId xmlns:a16="http://schemas.microsoft.com/office/drawing/2014/main" id="{56212C75-060C-438D-94AA-5EA5BE6AA48C}"/>
+                <a16:creationId xmlns:a16="http://schemas.microsoft.com/office/drawing/2014/main" id="{811ADF84-5FC6-4013-AB1C-F80D7E7D4DE1}"/>
               </a:ext>
             </a:extLst>
           </p:cNvPr>
@@ -5097,7 +5349,7 @@
           <p:cNvPr id="7" name="">
             <a:extLst xmlns:a="http://schemas.openxmlformats.org/drawingml/2006/main">
               <a:ext uri="{FF2B5EF4-FFF2-40B4-BE49-F238E27FC236}">
-                <a16:creationId xmlns:a16="http://schemas.microsoft.com/office/drawing/2014/main" id="{A7E88D17-5B6B-4A37-B494-3437C3561803}"/>
+                <a16:creationId xmlns:a16="http://schemas.microsoft.com/office/drawing/2014/main" id="{0EBCE533-E4AF-4C08-B747-08822E367256}"/>
               </a:ext>
             </a:extLst>
           </p:cNvPr>
@@ -5129,7 +5381,7 @@
           <p:cNvPr id="8" name="session-b">
             <a:extLst xmlns:a="http://schemas.openxmlformats.org/drawingml/2006/main">
               <a:ext uri="{FF2B5EF4-FFF2-40B4-BE49-F238E27FC236}">
-                <a16:creationId xmlns:a16="http://schemas.microsoft.com/office/drawing/2014/main" id="{F9BC2E7F-EF81-4F99-856B-C68AD7F78478}"/>
+                <a16:creationId xmlns:a16="http://schemas.microsoft.com/office/drawing/2014/main" id="{A080E0AD-7216-4A1A-B3EE-32FAA743EFE8}"/>
               </a:ext>
             </a:extLst>
           </p:cNvPr>
@@ -5232,7 +5484,7 @@
           <p:cNvPr id="9" name="">
             <a:extLst xmlns:a="http://schemas.openxmlformats.org/drawingml/2006/main">
               <a:ext uri="{FF2B5EF4-FFF2-40B4-BE49-F238E27FC236}">
-                <a16:creationId xmlns:a16="http://schemas.microsoft.com/office/drawing/2014/main" id="{EBF51CD7-E5E6-46A0-AB9F-E69CE36AF561}"/>
+                <a16:creationId xmlns:a16="http://schemas.microsoft.com/office/drawing/2014/main" id="{C336B63D-687F-4F67-AE7C-75F41810BA2C}"/>
               </a:ext>
             </a:extLst>
           </p:cNvPr>
@@ -5264,7 +5516,7 @@
           <p:cNvPr id="10" name="diagnostic">
             <a:extLst xmlns:a="http://schemas.openxmlformats.org/drawingml/2006/main">
               <a:ext uri="{FF2B5EF4-FFF2-40B4-BE49-F238E27FC236}">
-                <a16:creationId xmlns:a16="http://schemas.microsoft.com/office/drawing/2014/main" id="{98C7985A-3376-412B-86D3-2A0E6D3F3ED0}"/>
+                <a16:creationId xmlns:a16="http://schemas.microsoft.com/office/drawing/2014/main" id="{E013E402-4FEB-46FB-B904-48ABDBFE8DCE}"/>
               </a:ext>
             </a:extLst>
           </p:cNvPr>
@@ -5367,7 +5619,7 @@
           <p:cNvPr id="11" name="sessions-rule">
             <a:extLst xmlns:a="http://schemas.openxmlformats.org/drawingml/2006/main">
               <a:ext uri="{FF2B5EF4-FFF2-40B4-BE49-F238E27FC236}">
-                <a16:creationId xmlns:a16="http://schemas.microsoft.com/office/drawing/2014/main" id="{E1BE2431-83CB-4149-BD2D-04D62E3DB157}"/>
+                <a16:creationId xmlns:a16="http://schemas.microsoft.com/office/drawing/2014/main" id="{08091AF2-F217-42F4-800B-6AD45FAD683F}"/>
               </a:ext>
             </a:extLst>
           </p:cNvPr>
@@ -5424,7 +5676,7 @@
           <p:cNvPr id="12" name="fixture">
             <a:extLst xmlns:a="http://schemas.openxmlformats.org/drawingml/2006/main">
               <a:ext uri="{FF2B5EF4-FFF2-40B4-BE49-F238E27FC236}">
-                <a16:creationId xmlns:a16="http://schemas.microsoft.com/office/drawing/2014/main" id="{020E450B-5B61-4E37-945D-56EC1BCB88ED}"/>
+                <a16:creationId xmlns:a16="http://schemas.microsoft.com/office/drawing/2014/main" id="{4779402A-DCE8-4777-AE94-69A00AAEAFB8}"/>
               </a:ext>
             </a:extLst>
           </p:cNvPr>
@@ -5510,7 +5762,7 @@
           <p:cNvPr id="16" name="eyebrow">
             <a:extLst xmlns:a="http://schemas.openxmlformats.org/drawingml/2006/main">
               <a:ext uri="{FF2B5EF4-FFF2-40B4-BE49-F238E27FC236}">
-                <a16:creationId xmlns:a16="http://schemas.microsoft.com/office/drawing/2014/main" id="{F3CCCB44-A304-48BB-8899-E2C9A09BEEF6}"/>
+                <a16:creationId xmlns:a16="http://schemas.microsoft.com/office/drawing/2014/main" id="{B7277A58-6A2D-4F03-B353-D129E13471F3}"/>
               </a:ext>
             </a:extLst>
           </p:cNvPr>
@@ -5567,7 +5819,7 @@
           <p:cNvPr id="2" name="slide-title">
             <a:extLst xmlns:a="http://schemas.openxmlformats.org/drawingml/2006/main">
               <a:ext uri="{FF2B5EF4-FFF2-40B4-BE49-F238E27FC236}">
-                <a16:creationId xmlns:a16="http://schemas.microsoft.com/office/drawing/2014/main" id="{69ADF478-CF6C-4DC6-ABB1-5D0B1485E585}"/>
+                <a16:creationId xmlns:a16="http://schemas.microsoft.com/office/drawing/2014/main" id="{4C38ABD8-E876-4280-93DA-0C9104D483C2}"/>
               </a:ext>
             </a:extLst>
           </p:cNvPr>
@@ -5624,7 +5876,7 @@
           <p:cNvPr id="3" name="">
             <a:extLst xmlns:a="http://schemas.openxmlformats.org/drawingml/2006/main">
               <a:ext uri="{FF2B5EF4-FFF2-40B4-BE49-F238E27FC236}">
-                <a16:creationId xmlns:a16="http://schemas.microsoft.com/office/drawing/2014/main" id="{E594D198-CAF5-4FC1-B2AF-923DAAAF7597}"/>
+                <a16:creationId xmlns:a16="http://schemas.microsoft.com/office/drawing/2014/main" id="{24CA749B-DDFA-4722-8F46-77F88A5F9ED1}"/>
               </a:ext>
             </a:extLst>
           </p:cNvPr>
@@ -5656,7 +5908,7 @@
           <p:cNvPr id="4" name="slide-number">
             <a:extLst xmlns:a="http://schemas.openxmlformats.org/drawingml/2006/main">
               <a:ext uri="{FF2B5EF4-FFF2-40B4-BE49-F238E27FC236}">
-                <a16:creationId xmlns:a16="http://schemas.microsoft.com/office/drawing/2014/main" id="{7677FE1F-5E64-4051-A2F1-90161C8ACB5B}"/>
+                <a16:creationId xmlns:a16="http://schemas.microsoft.com/office/drawing/2014/main" id="{65D0DDFF-6D26-4A63-AD9B-4F028B1A397F}"/>
               </a:ext>
             </a:extLst>
           </p:cNvPr>
@@ -5713,7 +5965,7 @@
           <p:cNvPr id="5" name="">
             <a:extLst xmlns:a="http://schemas.openxmlformats.org/drawingml/2006/main">
               <a:ext uri="{FF2B5EF4-FFF2-40B4-BE49-F238E27FC236}">
-                <a16:creationId xmlns:a16="http://schemas.microsoft.com/office/drawing/2014/main" id="{08907E85-0B80-44F7-ACD9-708F20EF69F6}"/>
+                <a16:creationId xmlns:a16="http://schemas.microsoft.com/office/drawing/2014/main" id="{C1581D99-249E-45C0-AFB1-CEB6E653DB71}"/>
               </a:ext>
             </a:extLst>
           </p:cNvPr>
@@ -5745,7 +5997,7 @@
           <p:cNvPr id="6" name="old-version">
             <a:extLst xmlns:a="http://schemas.openxmlformats.org/drawingml/2006/main">
               <a:ext uri="{FF2B5EF4-FFF2-40B4-BE49-F238E27FC236}">
-                <a16:creationId xmlns:a16="http://schemas.microsoft.com/office/drawing/2014/main" id="{DD28F30D-EF1D-42C7-B97E-86AD7AAE2B2F}"/>
+                <a16:creationId xmlns:a16="http://schemas.microsoft.com/office/drawing/2014/main" id="{2985EE86-9A12-48B9-8F01-B86DB53E9B64}"/>
               </a:ext>
             </a:extLst>
           </p:cNvPr>
@@ -5825,7 +6077,7 @@
           <p:cNvPr id="7" name="">
             <a:extLst xmlns:a="http://schemas.openxmlformats.org/drawingml/2006/main">
               <a:ext uri="{FF2B5EF4-FFF2-40B4-BE49-F238E27FC236}">
-                <a16:creationId xmlns:a16="http://schemas.microsoft.com/office/drawing/2014/main" id="{D6986DB6-39AC-4E56-B587-FB307FDF91AD}"/>
+                <a16:creationId xmlns:a16="http://schemas.microsoft.com/office/drawing/2014/main" id="{1567D0B8-B2B3-4F7D-B229-FA67D2679413}"/>
               </a:ext>
             </a:extLst>
           </p:cNvPr>
@@ -5857,7 +6109,7 @@
           <p:cNvPr id="8" name="new-version">
             <a:extLst xmlns:a="http://schemas.openxmlformats.org/drawingml/2006/main">
               <a:ext uri="{FF2B5EF4-FFF2-40B4-BE49-F238E27FC236}">
-                <a16:creationId xmlns:a16="http://schemas.microsoft.com/office/drawing/2014/main" id="{1B535AE9-1014-499D-84A0-61FF0DAB7489}"/>
+                <a16:creationId xmlns:a16="http://schemas.microsoft.com/office/drawing/2014/main" id="{5B51CFC3-D392-46EC-A7A6-AF361E8C235D}"/>
               </a:ext>
             </a:extLst>
           </p:cNvPr>
@@ -5937,7 +6189,7 @@
           <p:cNvPr id="9" name="">
             <a:extLst xmlns:a="http://schemas.openxmlformats.org/drawingml/2006/main">
               <a:ext uri="{FF2B5EF4-FFF2-40B4-BE49-F238E27FC236}">
-                <a16:creationId xmlns:a16="http://schemas.microsoft.com/office/drawing/2014/main" id="{A12AD0BC-1FFE-4737-BA29-1F651E403AEF}"/>
+                <a16:creationId xmlns:a16="http://schemas.microsoft.com/office/drawing/2014/main" id="{68934075-A905-4E96-A306-5676202BA0CF}"/>
               </a:ext>
             </a:extLst>
           </p:cNvPr>
@@ -5969,7 +6221,7 @@
           <p:cNvPr id="10" name="">
             <a:extLst xmlns:a="http://schemas.openxmlformats.org/drawingml/2006/main">
               <a:ext uri="{FF2B5EF4-FFF2-40B4-BE49-F238E27FC236}">
-                <a16:creationId xmlns:a16="http://schemas.microsoft.com/office/drawing/2014/main" id="{B7310EE0-0554-4EF8-BE5C-AF12301D441A}"/>
+                <a16:creationId xmlns:a16="http://schemas.microsoft.com/office/drawing/2014/main" id="{F26D7CD5-2686-495E-ACD9-68AECE15CD19}"/>
               </a:ext>
             </a:extLst>
           </p:cNvPr>
@@ -6001,7 +6253,7 @@
           <p:cNvPr id="11" name="">
             <a:extLst xmlns:a="http://schemas.openxmlformats.org/drawingml/2006/main">
               <a:ext uri="{FF2B5EF4-FFF2-40B4-BE49-F238E27FC236}">
-                <a16:creationId xmlns:a16="http://schemas.microsoft.com/office/drawing/2014/main" id="{FCEEEC64-D624-43CE-B9F9-C1154798DD78}"/>
+                <a16:creationId xmlns:a16="http://schemas.microsoft.com/office/drawing/2014/main" id="{4B681D30-9949-4403-A394-B17CDB0A54EF}"/>
               </a:ext>
             </a:extLst>
           </p:cNvPr>
@@ -6033,7 +6285,7 @@
           <p:cNvPr id="12" name="reader">
             <a:extLst xmlns:a="http://schemas.openxmlformats.org/drawingml/2006/main">
               <a:ext uri="{FF2B5EF4-FFF2-40B4-BE49-F238E27FC236}">
-                <a16:creationId xmlns:a16="http://schemas.microsoft.com/office/drawing/2014/main" id="{FEAC3AFB-66BA-494B-B008-BB9AF7178F53}"/>
+                <a16:creationId xmlns:a16="http://schemas.microsoft.com/office/drawing/2014/main" id="{007158E4-D424-4432-B276-D954E540582B}"/>
               </a:ext>
             </a:extLst>
           </p:cNvPr>
@@ -6113,7 +6365,7 @@
           <p:cNvPr id="13" name="">
             <a:extLst xmlns:a="http://schemas.openxmlformats.org/drawingml/2006/main">
               <a:ext uri="{FF2B5EF4-FFF2-40B4-BE49-F238E27FC236}">
-                <a16:creationId xmlns:a16="http://schemas.microsoft.com/office/drawing/2014/main" id="{E07AC19B-449A-46B2-8203-D9650FCF8E1D}"/>
+                <a16:creationId xmlns:a16="http://schemas.microsoft.com/office/drawing/2014/main" id="{2A75C9DF-AC3D-4856-94AE-D34AE5A1D118}"/>
               </a:ext>
             </a:extLst>
           </p:cNvPr>
@@ -6145,7 +6397,7 @@
           <p:cNvPr id="14" name="own-writes">
             <a:extLst xmlns:a="http://schemas.openxmlformats.org/drawingml/2006/main">
               <a:ext uri="{FF2B5EF4-FFF2-40B4-BE49-F238E27FC236}">
-                <a16:creationId xmlns:a16="http://schemas.microsoft.com/office/drawing/2014/main" id="{1689AA91-5494-46FF-9AAE-B31B9C972CEF}"/>
+                <a16:creationId xmlns:a16="http://schemas.microsoft.com/office/drawing/2014/main" id="{A18C300B-0CA0-4267-B5D9-FF028A49B398}"/>
               </a:ext>
             </a:extLst>
           </p:cNvPr>
@@ -6225,7 +6477,7 @@
           <p:cNvPr id="15" name="mvcc">
             <a:extLst xmlns:a="http://schemas.openxmlformats.org/drawingml/2006/main">
               <a:ext uri="{FF2B5EF4-FFF2-40B4-BE49-F238E27FC236}">
-                <a16:creationId xmlns:a16="http://schemas.microsoft.com/office/drawing/2014/main" id="{C179B911-1AA3-4B03-89E8-60BDD0DD3F2F}"/>
+                <a16:creationId xmlns:a16="http://schemas.microsoft.com/office/drawing/2014/main" id="{ADBE0648-F732-494A-B717-012D7B8D2326}"/>
               </a:ext>
             </a:extLst>
           </p:cNvPr>
@@ -6311,7 +6563,7 @@
           <p:cNvPr id="8" name="eyebrow">
             <a:extLst xmlns:a="http://schemas.openxmlformats.org/drawingml/2006/main">
               <a:ext uri="{FF2B5EF4-FFF2-40B4-BE49-F238E27FC236}">
-                <a16:creationId xmlns:a16="http://schemas.microsoft.com/office/drawing/2014/main" id="{BFE7D312-7445-4F86-AA8F-E16A199C32EE}"/>
+                <a16:creationId xmlns:a16="http://schemas.microsoft.com/office/drawing/2014/main" id="{29FBF59B-755A-4AE5-AE19-F84B96EB1B63}"/>
               </a:ext>
             </a:extLst>
           </p:cNvPr>
@@ -6368,7 +6620,7 @@
           <p:cNvPr id="2" name="slide-title">
             <a:extLst xmlns:a="http://schemas.openxmlformats.org/drawingml/2006/main">
               <a:ext uri="{FF2B5EF4-FFF2-40B4-BE49-F238E27FC236}">
-                <a16:creationId xmlns:a16="http://schemas.microsoft.com/office/drawing/2014/main" id="{45A251B9-3E16-48E2-9616-E4B0273A1EF9}"/>
+                <a16:creationId xmlns:a16="http://schemas.microsoft.com/office/drawing/2014/main" id="{4D78257F-E885-4C63-8E1F-1D2E10D8D5CD}"/>
               </a:ext>
             </a:extLst>
           </p:cNvPr>
@@ -6425,7 +6677,7 @@
           <p:cNvPr id="3" name="">
             <a:extLst xmlns:a="http://schemas.openxmlformats.org/drawingml/2006/main">
               <a:ext uri="{FF2B5EF4-FFF2-40B4-BE49-F238E27FC236}">
-                <a16:creationId xmlns:a16="http://schemas.microsoft.com/office/drawing/2014/main" id="{44B1B77D-C4FA-4358-8C5B-9C6109A3B734}"/>
+                <a16:creationId xmlns:a16="http://schemas.microsoft.com/office/drawing/2014/main" id="{FEE83A9E-3028-4F4C-92AC-46385ED7FEFA}"/>
               </a:ext>
             </a:extLst>
           </p:cNvPr>
@@ -6457,7 +6709,7 @@
           <p:cNvPr id="4" name="slide-number">
             <a:extLst xmlns:a="http://schemas.openxmlformats.org/drawingml/2006/main">
               <a:ext uri="{FF2B5EF4-FFF2-40B4-BE49-F238E27FC236}">
-                <a16:creationId xmlns:a16="http://schemas.microsoft.com/office/drawing/2014/main" id="{AB61F3D1-FD38-4DA6-91F6-0A076FFD6BF2}"/>
+                <a16:creationId xmlns:a16="http://schemas.microsoft.com/office/drawing/2014/main" id="{4035E493-80DB-4CAE-BABB-B45FD28ECD07}"/>
               </a:ext>
             </a:extLst>
           </p:cNvPr>
@@ -6514,7 +6766,7 @@
           <p:cNvPr id="5" name="isolation-case">
             <a:extLst xmlns:a="http://schemas.openxmlformats.org/drawingml/2006/main">
               <a:ext uri="{FF2B5EF4-FFF2-40B4-BE49-F238E27FC236}">
-                <a16:creationId xmlns:a16="http://schemas.microsoft.com/office/drawing/2014/main" id="{14396E19-2B2C-494F-9024-7F0EFA39E796}"/>
+                <a16:creationId xmlns:a16="http://schemas.microsoft.com/office/drawing/2014/main" id="{A9A72873-0997-45C3-8643-CE5220B38432}"/>
               </a:ext>
             </a:extLst>
           </p:cNvPr>
@@ -6890,7 +7142,7 @@
           <p:cNvPr id="7" name="isolation-scope">
             <a:extLst xmlns:a="http://schemas.openxmlformats.org/drawingml/2006/main">
               <a:ext uri="{FF2B5EF4-FFF2-40B4-BE49-F238E27FC236}">
-                <a16:creationId xmlns:a16="http://schemas.microsoft.com/office/drawing/2014/main" id="{C005ED86-6142-4FE9-BE71-2B25491446CE}"/>
+                <a16:creationId xmlns:a16="http://schemas.microsoft.com/office/drawing/2014/main" id="{EA0D13B1-302A-4117-B61D-0DAB93930425}"/>
               </a:ext>
             </a:extLst>
           </p:cNvPr>
@@ -6976,7 +7228,7 @@
           <p:cNvPr id="12" name="eyebrow">
             <a:extLst xmlns:a="http://schemas.openxmlformats.org/drawingml/2006/main">
               <a:ext uri="{FF2B5EF4-FFF2-40B4-BE49-F238E27FC236}">
-                <a16:creationId xmlns:a16="http://schemas.microsoft.com/office/drawing/2014/main" id="{8F03A9C0-1688-47D5-B6DE-285980026149}"/>
+                <a16:creationId xmlns:a16="http://schemas.microsoft.com/office/drawing/2014/main" id="{6A23F8AC-0527-4D45-9F45-158DBF9E4CF7}"/>
               </a:ext>
             </a:extLst>
           </p:cNvPr>
@@ -7033,7 +7285,7 @@
           <p:cNvPr id="2" name="slide-title">
             <a:extLst xmlns:a="http://schemas.openxmlformats.org/drawingml/2006/main">
               <a:ext uri="{FF2B5EF4-FFF2-40B4-BE49-F238E27FC236}">
-                <a16:creationId xmlns:a16="http://schemas.microsoft.com/office/drawing/2014/main" id="{9B193C55-0254-4298-95A6-81EAEE0E45ED}"/>
+                <a16:creationId xmlns:a16="http://schemas.microsoft.com/office/drawing/2014/main" id="{085BE5A0-A7B5-487B-8BE7-456AC779A3CD}"/>
               </a:ext>
             </a:extLst>
           </p:cNvPr>
@@ -7090,7 +7342,7 @@
           <p:cNvPr id="3" name="">
             <a:extLst xmlns:a="http://schemas.openxmlformats.org/drawingml/2006/main">
               <a:ext uri="{FF2B5EF4-FFF2-40B4-BE49-F238E27FC236}">
-                <a16:creationId xmlns:a16="http://schemas.microsoft.com/office/drawing/2014/main" id="{9EDA3007-35FC-4D4F-BFAF-112660A976F3}"/>
+                <a16:creationId xmlns:a16="http://schemas.microsoft.com/office/drawing/2014/main" id="{5845D84B-738E-4226-A457-A7C077E7BB8C}"/>
               </a:ext>
             </a:extLst>
           </p:cNvPr>
@@ -7122,7 +7374,7 @@
           <p:cNvPr id="4" name="slide-number">
             <a:extLst xmlns:a="http://schemas.openxmlformats.org/drawingml/2006/main">
               <a:ext uri="{FF2B5EF4-FFF2-40B4-BE49-F238E27FC236}">
-                <a16:creationId xmlns:a16="http://schemas.microsoft.com/office/drawing/2014/main" id="{E22D5F07-D970-4213-88C7-F5C0E6EF7896}"/>
+                <a16:creationId xmlns:a16="http://schemas.microsoft.com/office/drawing/2014/main" id="{52BA0633-AD6D-4CE2-8BB8-58220AD6F7F2}"/>
               </a:ext>
             </a:extLst>
           </p:cNvPr>
@@ -7179,7 +7431,7 @@
           <p:cNvPr id="5" name="">
             <a:extLst xmlns:a="http://schemas.openxmlformats.org/drawingml/2006/main">
               <a:ext uri="{FF2B5EF4-FFF2-40B4-BE49-F238E27FC236}">
-                <a16:creationId xmlns:a16="http://schemas.microsoft.com/office/drawing/2014/main" id="{347AF73C-59F0-46BB-8AE5-AAA2EE74F9A0}"/>
+                <a16:creationId xmlns:a16="http://schemas.microsoft.com/office/drawing/2014/main" id="{5909EC42-3F36-4392-AC26-E531C4C66085}"/>
               </a:ext>
             </a:extLst>
           </p:cNvPr>
@@ -7211,7 +7463,7 @@
           <p:cNvPr id="6" name="a-sql">
             <a:extLst xmlns:a="http://schemas.openxmlformats.org/drawingml/2006/main">
               <a:ext uri="{FF2B5EF4-FFF2-40B4-BE49-F238E27FC236}">
-                <a16:creationId xmlns:a16="http://schemas.microsoft.com/office/drawing/2014/main" id="{95B88899-2269-4230-A2F1-7D8AB367F746}"/>
+                <a16:creationId xmlns:a16="http://schemas.microsoft.com/office/drawing/2014/main" id="{83CEA01E-0848-46CA-B259-946C05F0AE3B}"/>
               </a:ext>
             </a:extLst>
           </p:cNvPr>
@@ -7337,7 +7589,7 @@
           <p:cNvPr id="7" name="">
             <a:extLst xmlns:a="http://schemas.openxmlformats.org/drawingml/2006/main">
               <a:ext uri="{FF2B5EF4-FFF2-40B4-BE49-F238E27FC236}">
-                <a16:creationId xmlns:a16="http://schemas.microsoft.com/office/drawing/2014/main" id="{EEF4D42B-36FC-4A73-84AB-BB05001934EB}"/>
+                <a16:creationId xmlns:a16="http://schemas.microsoft.com/office/drawing/2014/main" id="{0F644D8E-A88F-4DA3-9C84-107543DECC67}"/>
               </a:ext>
             </a:extLst>
           </p:cNvPr>
@@ -7369,7 +7621,7 @@
           <p:cNvPr id="8" name="b-sql">
             <a:extLst xmlns:a="http://schemas.openxmlformats.org/drawingml/2006/main">
               <a:ext uri="{FF2B5EF4-FFF2-40B4-BE49-F238E27FC236}">
-                <a16:creationId xmlns:a16="http://schemas.microsoft.com/office/drawing/2014/main" id="{8D8BAF3F-012E-496F-A8A8-F94493F08FE5}"/>
+                <a16:creationId xmlns:a16="http://schemas.microsoft.com/office/drawing/2014/main" id="{DDDFB694-2518-4DD9-856D-C2891E6D96E2}"/>
               </a:ext>
             </a:extLst>
           </p:cNvPr>
@@ -7541,7 +7793,7 @@
           <p:cNvPr id="9" name="a-label">
             <a:extLst xmlns:a="http://schemas.openxmlformats.org/drawingml/2006/main">
               <a:ext uri="{FF2B5EF4-FFF2-40B4-BE49-F238E27FC236}">
-                <a16:creationId xmlns:a16="http://schemas.microsoft.com/office/drawing/2014/main" id="{26141BCD-90CE-4575-98A7-767B8BC15E55}"/>
+                <a16:creationId xmlns:a16="http://schemas.microsoft.com/office/drawing/2014/main" id="{9BA463FA-9082-4755-9909-A1BF05E3CBF7}"/>
               </a:ext>
             </a:extLst>
           </p:cNvPr>
@@ -7598,7 +7850,7 @@
           <p:cNvPr id="10" name="b-label">
             <a:extLst xmlns:a="http://schemas.openxmlformats.org/drawingml/2006/main">
               <a:ext uri="{FF2B5EF4-FFF2-40B4-BE49-F238E27FC236}">
-                <a16:creationId xmlns:a16="http://schemas.microsoft.com/office/drawing/2014/main" id="{E12EB9B7-D4A1-44C8-90B1-866200DB0DE1}"/>
+                <a16:creationId xmlns:a16="http://schemas.microsoft.com/office/drawing/2014/main" id="{1A44E2CD-F84F-4B65-8059-47791A147CA6}"/>
               </a:ext>
             </a:extLst>
           </p:cNvPr>
@@ -7655,7 +7907,7 @@
           <p:cNvPr id="11" name="bounded">
             <a:extLst xmlns:a="http://schemas.openxmlformats.org/drawingml/2006/main">
               <a:ext uri="{FF2B5EF4-FFF2-40B4-BE49-F238E27FC236}">
-                <a16:creationId xmlns:a16="http://schemas.microsoft.com/office/drawing/2014/main" id="{2AE0004E-30FC-4C9D-A30E-37017A65C744}"/>
+                <a16:creationId xmlns:a16="http://schemas.microsoft.com/office/drawing/2014/main" id="{96594563-FA20-445B-AE0E-653525B76CB6}"/>
               </a:ext>
             </a:extLst>
           </p:cNvPr>
@@ -7741,7 +7993,7 @@
           <p:cNvPr id="9" name="eyebrow">
             <a:extLst xmlns:a="http://schemas.openxmlformats.org/drawingml/2006/main">
               <a:ext uri="{FF2B5EF4-FFF2-40B4-BE49-F238E27FC236}">
-                <a16:creationId xmlns:a16="http://schemas.microsoft.com/office/drawing/2014/main" id="{E5D6D4C2-9DAE-4BF4-8024-6C903490BDD0}"/>
+                <a16:creationId xmlns:a16="http://schemas.microsoft.com/office/drawing/2014/main" id="{433C225F-10A7-4435-BAF0-29C3B95E2F90}"/>
               </a:ext>
             </a:extLst>
           </p:cNvPr>
@@ -7798,7 +8050,7 @@
           <p:cNvPr id="2" name="slide-title">
             <a:extLst xmlns:a="http://schemas.openxmlformats.org/drawingml/2006/main">
               <a:ext uri="{FF2B5EF4-FFF2-40B4-BE49-F238E27FC236}">
-                <a16:creationId xmlns:a16="http://schemas.microsoft.com/office/drawing/2014/main" id="{15679570-A62D-4D77-B14E-8F0998D4E59C}"/>
+                <a16:creationId xmlns:a16="http://schemas.microsoft.com/office/drawing/2014/main" id="{D7835625-94B0-4EE3-97A3-0EFCCC52691C}"/>
               </a:ext>
             </a:extLst>
           </p:cNvPr>
@@ -7855,7 +8107,7 @@
           <p:cNvPr id="3" name="">
             <a:extLst xmlns:a="http://schemas.openxmlformats.org/drawingml/2006/main">
               <a:ext uri="{FF2B5EF4-FFF2-40B4-BE49-F238E27FC236}">
-                <a16:creationId xmlns:a16="http://schemas.microsoft.com/office/drawing/2014/main" id="{81252111-FD48-489F-A66C-C4A9C7591D91}"/>
+                <a16:creationId xmlns:a16="http://schemas.microsoft.com/office/drawing/2014/main" id="{06DA46B3-6320-4E31-A509-8A1A1D25ED0D}"/>
               </a:ext>
             </a:extLst>
           </p:cNvPr>
@@ -7887,7 +8139,7 @@
           <p:cNvPr id="4" name="slide-number">
             <a:extLst xmlns:a="http://schemas.openxmlformats.org/drawingml/2006/main">
               <a:ext uri="{FF2B5EF4-FFF2-40B4-BE49-F238E27FC236}">
-                <a16:creationId xmlns:a16="http://schemas.microsoft.com/office/drawing/2014/main" id="{68F22210-DA15-4FB0-A5C7-F54EF754DB01}"/>
+                <a16:creationId xmlns:a16="http://schemas.microsoft.com/office/drawing/2014/main" id="{DF9D0CB6-D595-45B7-A8C2-53931FA4C01D}"/>
               </a:ext>
             </a:extLst>
           </p:cNvPr>
@@ -7944,7 +8196,7 @@
           <p:cNvPr id="5" name="">
             <a:extLst xmlns:a="http://schemas.openxmlformats.org/drawingml/2006/main">
               <a:ext uri="{FF2B5EF4-FFF2-40B4-BE49-F238E27FC236}">
-                <a16:creationId xmlns:a16="http://schemas.microsoft.com/office/drawing/2014/main" id="{43C5241E-2578-48F3-8488-DB9489034B65}"/>
+                <a16:creationId xmlns:a16="http://schemas.microsoft.com/office/drawing/2014/main" id="{C7F2E7B5-7A37-4736-B1AC-970A8A5B56F9}"/>
               </a:ext>
             </a:extLst>
           </p:cNvPr>
@@ -7976,7 +8228,7 @@
           <p:cNvPr id="6" name="diagnose-sql">
             <a:extLst xmlns:a="http://schemas.openxmlformats.org/drawingml/2006/main">
               <a:ext uri="{FF2B5EF4-FFF2-40B4-BE49-F238E27FC236}">
-                <a16:creationId xmlns:a16="http://schemas.microsoft.com/office/drawing/2014/main" id="{992AEC77-6455-4B96-880A-D45DB98BF372}"/>
+                <a16:creationId xmlns:a16="http://schemas.microsoft.com/office/drawing/2014/main" id="{AF73E3C9-94E2-426B-80BC-25D6732C5514}"/>
               </a:ext>
             </a:extLst>
           </p:cNvPr>
@@ -8194,7 +8446,7 @@
           <p:cNvPr id="7" name="diagnose-meaning">
             <a:extLst xmlns:a="http://schemas.openxmlformats.org/drawingml/2006/main">
               <a:ext uri="{FF2B5EF4-FFF2-40B4-BE49-F238E27FC236}">
-                <a16:creationId xmlns:a16="http://schemas.microsoft.com/office/drawing/2014/main" id="{849D0ACB-0D89-482F-9A88-39CC8C109423}"/>
+                <a16:creationId xmlns:a16="http://schemas.microsoft.com/office/drawing/2014/main" id="{F3F90BB2-AEEE-49CF-9431-BB33D8FE5EC4}"/>
               </a:ext>
             </a:extLst>
           </p:cNvPr>
@@ -8251,7 +8503,7 @@
           <p:cNvPr id="8" name="diagnose-scope">
             <a:extLst xmlns:a="http://schemas.openxmlformats.org/drawingml/2006/main">
               <a:ext uri="{FF2B5EF4-FFF2-40B4-BE49-F238E27FC236}">
-                <a16:creationId xmlns:a16="http://schemas.microsoft.com/office/drawing/2014/main" id="{2833A890-B37F-4804-A060-2214D31D1D99}"/>
+                <a16:creationId xmlns:a16="http://schemas.microsoft.com/office/drawing/2014/main" id="{208A222A-859B-4124-BA1F-D6139B3800BF}"/>
               </a:ext>
             </a:extLst>
           </p:cNvPr>
@@ -8337,7 +8589,7 @@
           <p:cNvPr id="8" name="eyebrow">
             <a:extLst xmlns:a="http://schemas.openxmlformats.org/drawingml/2006/main">
               <a:ext uri="{FF2B5EF4-FFF2-40B4-BE49-F238E27FC236}">
-                <a16:creationId xmlns:a16="http://schemas.microsoft.com/office/drawing/2014/main" id="{AAC1CBF8-E831-406D-BBB4-2F68EEE7B142}"/>
+                <a16:creationId xmlns:a16="http://schemas.microsoft.com/office/drawing/2014/main" id="{352BF291-FAAB-4659-8544-B8098B8FE45A}"/>
               </a:ext>
             </a:extLst>
           </p:cNvPr>
@@ -8394,7 +8646,7 @@
           <p:cNvPr id="2" name="slide-title">
             <a:extLst xmlns:a="http://schemas.openxmlformats.org/drawingml/2006/main">
               <a:ext uri="{FF2B5EF4-FFF2-40B4-BE49-F238E27FC236}">
-                <a16:creationId xmlns:a16="http://schemas.microsoft.com/office/drawing/2014/main" id="{9E4D5AA0-7446-48CD-AC10-F358B81B807F}"/>
+                <a16:creationId xmlns:a16="http://schemas.microsoft.com/office/drawing/2014/main" id="{C8FDF406-C793-4EFF-ACFF-754752ADD99C}"/>
               </a:ext>
             </a:extLst>
           </p:cNvPr>
@@ -8451,7 +8703,7 @@
           <p:cNvPr id="3" name="">
             <a:extLst xmlns:a="http://schemas.openxmlformats.org/drawingml/2006/main">
               <a:ext uri="{FF2B5EF4-FFF2-40B4-BE49-F238E27FC236}">
-                <a16:creationId xmlns:a16="http://schemas.microsoft.com/office/drawing/2014/main" id="{620051F0-A9B2-4D54-B323-826ECED2428B}"/>
+                <a16:creationId xmlns:a16="http://schemas.microsoft.com/office/drawing/2014/main" id="{D7697199-B869-4BFC-A396-FCCFFD778A16}"/>
               </a:ext>
             </a:extLst>
           </p:cNvPr>
@@ -8483,7 +8735,7 @@
           <p:cNvPr id="4" name="slide-number">
             <a:extLst xmlns:a="http://schemas.openxmlformats.org/drawingml/2006/main">
               <a:ext uri="{FF2B5EF4-FFF2-40B4-BE49-F238E27FC236}">
-                <a16:creationId xmlns:a16="http://schemas.microsoft.com/office/drawing/2014/main" id="{EC1E46A6-3C75-4E3C-86C3-1FE2B716603D}"/>
+                <a16:creationId xmlns:a16="http://schemas.microsoft.com/office/drawing/2014/main" id="{C521A031-3286-4853-9569-11F66538A9F7}"/>
               </a:ext>
             </a:extLst>
           </p:cNvPr>
@@ -8931,7 +9183,7 @@
           <p:cNvPr id="6" name="snapshot-meaning">
             <a:extLst xmlns:a="http://schemas.openxmlformats.org/drawingml/2006/main">
               <a:ext uri="{FF2B5EF4-FFF2-40B4-BE49-F238E27FC236}">
-                <a16:creationId xmlns:a16="http://schemas.microsoft.com/office/drawing/2014/main" id="{A8C5D696-6EE9-4531-83D0-40894D5376A6}"/>
+                <a16:creationId xmlns:a16="http://schemas.microsoft.com/office/drawing/2014/main" id="{25751C11-767C-4ECD-8261-EF537BB8C376}"/>
               </a:ext>
             </a:extLst>
           </p:cNvPr>
@@ -8988,7 +9240,7 @@
           <p:cNvPr id="7" name="snapshot-scope">
             <a:extLst xmlns:a="http://schemas.openxmlformats.org/drawingml/2006/main">
               <a:ext uri="{FF2B5EF4-FFF2-40B4-BE49-F238E27FC236}">
-                <a16:creationId xmlns:a16="http://schemas.microsoft.com/office/drawing/2014/main" id="{FA530846-BEA7-4337-9B78-692073AB235B}"/>
+                <a16:creationId xmlns:a16="http://schemas.microsoft.com/office/drawing/2014/main" id="{1EA04B08-3760-44D2-A895-96C6DC892A7A}"/>
               </a:ext>
             </a:extLst>
           </p:cNvPr>
@@ -9074,7 +9326,7 @@
           <p:cNvPr id="9" name="eyebrow">
             <a:extLst xmlns:a="http://schemas.openxmlformats.org/drawingml/2006/main">
               <a:ext uri="{FF2B5EF4-FFF2-40B4-BE49-F238E27FC236}">
-                <a16:creationId xmlns:a16="http://schemas.microsoft.com/office/drawing/2014/main" id="{54D609E8-7F45-492B-B8AF-EDD2B743FBBC}"/>
+                <a16:creationId xmlns:a16="http://schemas.microsoft.com/office/drawing/2014/main" id="{EA6300E6-5616-48E1-8565-5764439DA071}"/>
               </a:ext>
             </a:extLst>
           </p:cNvPr>
@@ -9131,7 +9383,7 @@
           <p:cNvPr id="2" name="slide-title">
             <a:extLst xmlns:a="http://schemas.openxmlformats.org/drawingml/2006/main">
               <a:ext uri="{FF2B5EF4-FFF2-40B4-BE49-F238E27FC236}">
-                <a16:creationId xmlns:a16="http://schemas.microsoft.com/office/drawing/2014/main" id="{104FA06B-239F-4FB7-9FA5-806AB4373968}"/>
+                <a16:creationId xmlns:a16="http://schemas.microsoft.com/office/drawing/2014/main" id="{FA479ABE-1825-4D44-A357-EAB094A5CA12}"/>
               </a:ext>
             </a:extLst>
           </p:cNvPr>
@@ -9188,7 +9440,7 @@
           <p:cNvPr id="3" name="">
             <a:extLst xmlns:a="http://schemas.openxmlformats.org/drawingml/2006/main">
               <a:ext uri="{FF2B5EF4-FFF2-40B4-BE49-F238E27FC236}">
-                <a16:creationId xmlns:a16="http://schemas.microsoft.com/office/drawing/2014/main" id="{447D83FD-92EC-4077-85DF-A8E02D557F7F}"/>
+                <a16:creationId xmlns:a16="http://schemas.microsoft.com/office/drawing/2014/main" id="{A6E6697A-2E06-4977-A756-33A16EE01885}"/>
               </a:ext>
             </a:extLst>
           </p:cNvPr>
@@ -9220,7 +9472,7 @@
           <p:cNvPr id="4" name="slide-number">
             <a:extLst xmlns:a="http://schemas.openxmlformats.org/drawingml/2006/main">
               <a:ext uri="{FF2B5EF4-FFF2-40B4-BE49-F238E27FC236}">
-                <a16:creationId xmlns:a16="http://schemas.microsoft.com/office/drawing/2014/main" id="{302069DC-E852-4038-9225-278E51FC4D77}"/>
+                <a16:creationId xmlns:a16="http://schemas.microsoft.com/office/drawing/2014/main" id="{ADCF1AA5-D790-4980-99E8-3D9BB3D09B3F}"/>
               </a:ext>
             </a:extLst>
           </p:cNvPr>
@@ -9522,7 +9774,7 @@
           <p:cNvPr id="6" name="">
             <a:extLst xmlns:a="http://schemas.openxmlformats.org/drawingml/2006/main">
               <a:ext uri="{FF2B5EF4-FFF2-40B4-BE49-F238E27FC236}">
-                <a16:creationId xmlns:a16="http://schemas.microsoft.com/office/drawing/2014/main" id="{7D63AC62-8E58-4A98-9665-0412CFBFF95E}"/>
+                <a16:creationId xmlns:a16="http://schemas.microsoft.com/office/drawing/2014/main" id="{A74E164A-8820-43DC-B8FB-35382C806A80}"/>
               </a:ext>
             </a:extLst>
           </p:cNvPr>
@@ -9554,7 +9806,7 @@
           <p:cNvPr id="7" name="lock-final">
             <a:extLst xmlns:a="http://schemas.openxmlformats.org/drawingml/2006/main">
               <a:ext uri="{FF2B5EF4-FFF2-40B4-BE49-F238E27FC236}">
-                <a16:creationId xmlns:a16="http://schemas.microsoft.com/office/drawing/2014/main" id="{5032042C-A659-49D4-AC1D-E94714A03E47}"/>
+                <a16:creationId xmlns:a16="http://schemas.microsoft.com/office/drawing/2014/main" id="{E1800117-7126-4617-80D2-6A8633F08863}"/>
               </a:ext>
             </a:extLst>
           </p:cNvPr>
@@ -9634,7 +9886,7 @@
           <p:cNvPr id="8" name="outcome-limit">
             <a:extLst xmlns:a="http://schemas.openxmlformats.org/drawingml/2006/main">
               <a:ext uri="{FF2B5EF4-FFF2-40B4-BE49-F238E27FC236}">
-                <a16:creationId xmlns:a16="http://schemas.microsoft.com/office/drawing/2014/main" id="{FE32279F-7A26-4E38-824F-1A2F2D317700}"/>
+                <a16:creationId xmlns:a16="http://schemas.microsoft.com/office/drawing/2014/main" id="{04D253C3-00D6-4676-9C50-B0B8B0E9C209}"/>
               </a:ext>
             </a:extLst>
           </p:cNvPr>
@@ -9720,7 +9972,7 @@
           <p:cNvPr id="7" name="eyebrow">
             <a:extLst xmlns:a="http://schemas.openxmlformats.org/drawingml/2006/main">
               <a:ext uri="{FF2B5EF4-FFF2-40B4-BE49-F238E27FC236}">
-                <a16:creationId xmlns:a16="http://schemas.microsoft.com/office/drawing/2014/main" id="{4F5884AC-B5CD-4EC4-9E47-1CDB0BE02E9A}"/>
+                <a16:creationId xmlns:a16="http://schemas.microsoft.com/office/drawing/2014/main" id="{D5ED2245-6FB1-4A13-BA21-B3CEC374F14C}"/>
               </a:ext>
             </a:extLst>
           </p:cNvPr>
@@ -9777,7 +10029,7 @@
           <p:cNvPr id="2" name="slide-title">
             <a:extLst xmlns:a="http://schemas.openxmlformats.org/drawingml/2006/main">
               <a:ext uri="{FF2B5EF4-FFF2-40B4-BE49-F238E27FC236}">
-                <a16:creationId xmlns:a16="http://schemas.microsoft.com/office/drawing/2014/main" id="{AA947065-12C8-404F-9F45-EDD65D1733A2}"/>
+                <a16:creationId xmlns:a16="http://schemas.microsoft.com/office/drawing/2014/main" id="{D1591AD2-7C0B-460C-A18C-8402B474E3B7}"/>
               </a:ext>
             </a:extLst>
           </p:cNvPr>
@@ -9834,7 +10086,7 @@
           <p:cNvPr id="3" name="">
             <a:extLst xmlns:a="http://schemas.openxmlformats.org/drawingml/2006/main">
               <a:ext uri="{FF2B5EF4-FFF2-40B4-BE49-F238E27FC236}">
-                <a16:creationId xmlns:a16="http://schemas.microsoft.com/office/drawing/2014/main" id="{0DF9DA51-A344-4F0A-9C23-20423A9D07C8}"/>
+                <a16:creationId xmlns:a16="http://schemas.microsoft.com/office/drawing/2014/main" id="{6BACC31F-06F2-445C-BC01-EC2D3FF470F3}"/>
               </a:ext>
             </a:extLst>
           </p:cNvPr>
@@ -9866,7 +10118,7 @@
           <p:cNvPr id="4" name="slide-number">
             <a:extLst xmlns:a="http://schemas.openxmlformats.org/drawingml/2006/main">
               <a:ext uri="{FF2B5EF4-FFF2-40B4-BE49-F238E27FC236}">
-                <a16:creationId xmlns:a16="http://schemas.microsoft.com/office/drawing/2014/main" id="{58280F4F-ED06-49E6-9700-004E2B2C4D92}"/>
+                <a16:creationId xmlns:a16="http://schemas.microsoft.com/office/drawing/2014/main" id="{3FE3884C-73B8-44A6-B24F-6FF7CFC85667}"/>
               </a:ext>
             </a:extLst>
           </p:cNvPr>
@@ -10168,7 +10420,7 @@
           <p:cNvPr id="6" name="slow">
             <a:extLst xmlns:a="http://schemas.openxmlformats.org/drawingml/2006/main">
               <a:ext uri="{FF2B5EF4-FFF2-40B4-BE49-F238E27FC236}">
-                <a16:creationId xmlns:a16="http://schemas.microsoft.com/office/drawing/2014/main" id="{08BF162D-07F3-493F-89FB-77FF945C5794}"/>
+                <a16:creationId xmlns:a16="http://schemas.microsoft.com/office/drawing/2014/main" id="{8D6F0161-35A7-40E6-B9E6-5438D845D8AB}"/>
               </a:ext>
             </a:extLst>
           </p:cNvPr>
@@ -10254,7 +10506,7 @@
           <p:cNvPr id="17" name="eyebrow">
             <a:extLst xmlns:a="http://schemas.openxmlformats.org/drawingml/2006/main">
               <a:ext uri="{FF2B5EF4-FFF2-40B4-BE49-F238E27FC236}">
-                <a16:creationId xmlns:a16="http://schemas.microsoft.com/office/drawing/2014/main" id="{8EAF7DB9-A4F1-45BC-9E4F-49FF69BD1916}"/>
+                <a16:creationId xmlns:a16="http://schemas.microsoft.com/office/drawing/2014/main" id="{DB7393F2-91F1-44F8-AED5-2C88320940B8}"/>
               </a:ext>
             </a:extLst>
           </p:cNvPr>
@@ -10311,7 +10563,7 @@
           <p:cNvPr id="2" name="slide-title">
             <a:extLst xmlns:a="http://schemas.openxmlformats.org/drawingml/2006/main">
               <a:ext uri="{FF2B5EF4-FFF2-40B4-BE49-F238E27FC236}">
-                <a16:creationId xmlns:a16="http://schemas.microsoft.com/office/drawing/2014/main" id="{B3810B85-679D-4C39-B04E-C958D4667404}"/>
+                <a16:creationId xmlns:a16="http://schemas.microsoft.com/office/drawing/2014/main" id="{6239A3C0-B4D1-447A-87DA-AEEECC2E2BD1}"/>
               </a:ext>
             </a:extLst>
           </p:cNvPr>
@@ -10368,7 +10620,7 @@
           <p:cNvPr id="3" name="">
             <a:extLst xmlns:a="http://schemas.openxmlformats.org/drawingml/2006/main">
               <a:ext uri="{FF2B5EF4-FFF2-40B4-BE49-F238E27FC236}">
-                <a16:creationId xmlns:a16="http://schemas.microsoft.com/office/drawing/2014/main" id="{B4A0B3D9-972B-4170-AC84-19B5CDAC3297}"/>
+                <a16:creationId xmlns:a16="http://schemas.microsoft.com/office/drawing/2014/main" id="{FAC8CF08-7976-497B-9854-C8BFBDF74473}"/>
               </a:ext>
             </a:extLst>
           </p:cNvPr>
@@ -10400,7 +10652,7 @@
           <p:cNvPr id="4" name="slide-number">
             <a:extLst xmlns:a="http://schemas.openxmlformats.org/drawingml/2006/main">
               <a:ext uri="{FF2B5EF4-FFF2-40B4-BE49-F238E27FC236}">
-                <a16:creationId xmlns:a16="http://schemas.microsoft.com/office/drawing/2014/main" id="{6526CDF9-80AB-499F-A548-66CD51D314EE}"/>
+                <a16:creationId xmlns:a16="http://schemas.microsoft.com/office/drawing/2014/main" id="{EA1EF921-804E-4002-9DEF-E754A1C87E18}"/>
               </a:ext>
             </a:extLst>
           </p:cNvPr>
@@ -10457,7 +10709,7 @@
           <p:cNvPr id="5" name="">
             <a:extLst xmlns:a="http://schemas.openxmlformats.org/drawingml/2006/main">
               <a:ext uri="{FF2B5EF4-FFF2-40B4-BE49-F238E27FC236}">
-                <a16:creationId xmlns:a16="http://schemas.microsoft.com/office/drawing/2014/main" id="{BE622F63-298D-4BCC-BB26-9BFDB9C12CBA}"/>
+                <a16:creationId xmlns:a16="http://schemas.microsoft.com/office/drawing/2014/main" id="{2A777655-96D6-471E-9A85-A2406392A278}"/>
               </a:ext>
             </a:extLst>
           </p:cNvPr>
@@ -10489,7 +10741,7 @@
           <p:cNvPr id="6" name="deadlock-a">
             <a:extLst xmlns:a="http://schemas.openxmlformats.org/drawingml/2006/main">
               <a:ext uri="{FF2B5EF4-FFF2-40B4-BE49-F238E27FC236}">
-                <a16:creationId xmlns:a16="http://schemas.microsoft.com/office/drawing/2014/main" id="{11F50A90-8A2C-401E-B644-C75A605142C1}"/>
+                <a16:creationId xmlns:a16="http://schemas.microsoft.com/office/drawing/2014/main" id="{7AAC7149-D3A6-4630-A30A-D670EAB37BEE}"/>
               </a:ext>
             </a:extLst>
           </p:cNvPr>
@@ -10569,7 +10821,7 @@
           <p:cNvPr id="7" name="">
             <a:extLst xmlns:a="http://schemas.openxmlformats.org/drawingml/2006/main">
               <a:ext uri="{FF2B5EF4-FFF2-40B4-BE49-F238E27FC236}">
-                <a16:creationId xmlns:a16="http://schemas.microsoft.com/office/drawing/2014/main" id="{AAE53842-4443-4583-8FF3-1A333B3B046D}"/>
+                <a16:creationId xmlns:a16="http://schemas.microsoft.com/office/drawing/2014/main" id="{52380E93-1771-4416-8848-8BE5A30850D3}"/>
               </a:ext>
             </a:extLst>
           </p:cNvPr>
@@ -10601,7 +10853,7 @@
           <p:cNvPr id="8" name="deadlock-b">
             <a:extLst xmlns:a="http://schemas.openxmlformats.org/drawingml/2006/main">
               <a:ext uri="{FF2B5EF4-FFF2-40B4-BE49-F238E27FC236}">
-                <a16:creationId xmlns:a16="http://schemas.microsoft.com/office/drawing/2014/main" id="{3315906E-E8F7-4717-8BBB-3F348BDAF7BC}"/>
+                <a16:creationId xmlns:a16="http://schemas.microsoft.com/office/drawing/2014/main" id="{41F7BAFF-6DAA-438A-B65E-28FF2DD8D4D2}"/>
               </a:ext>
             </a:extLst>
           </p:cNvPr>
@@ -10681,7 +10933,7 @@
           <p:cNvPr id="9" name="">
             <a:extLst xmlns:a="http://schemas.openxmlformats.org/drawingml/2006/main">
               <a:ext uri="{FF2B5EF4-FFF2-40B4-BE49-F238E27FC236}">
-                <a16:creationId xmlns:a16="http://schemas.microsoft.com/office/drawing/2014/main" id="{BC8DE987-1239-40B7-82BA-856FF0E674BF}"/>
+                <a16:creationId xmlns:a16="http://schemas.microsoft.com/office/drawing/2014/main" id="{48839125-B468-4012-B82A-BDF93BD9B491}"/>
               </a:ext>
             </a:extLst>
           </p:cNvPr>
@@ -10713,7 +10965,7 @@
           <p:cNvPr id="10" name="a-waits">
             <a:extLst xmlns:a="http://schemas.openxmlformats.org/drawingml/2006/main">
               <a:ext uri="{FF2B5EF4-FFF2-40B4-BE49-F238E27FC236}">
-                <a16:creationId xmlns:a16="http://schemas.microsoft.com/office/drawing/2014/main" id="{6034E111-CFA9-42A8-8126-BE73BD2B7948}"/>
+                <a16:creationId xmlns:a16="http://schemas.microsoft.com/office/drawing/2014/main" id="{082A502B-CC13-4617-86CE-5E91C9E01DEA}"/>
               </a:ext>
             </a:extLst>
           </p:cNvPr>
@@ -10770,7 +11022,7 @@
           <p:cNvPr id="11" name="">
             <a:extLst xmlns:a="http://schemas.openxmlformats.org/drawingml/2006/main">
               <a:ext uri="{FF2B5EF4-FFF2-40B4-BE49-F238E27FC236}">
-                <a16:creationId xmlns:a16="http://schemas.microsoft.com/office/drawing/2014/main" id="{79EA599E-D4AA-4D1A-8EC6-F044CF16101F}"/>
+                <a16:creationId xmlns:a16="http://schemas.microsoft.com/office/drawing/2014/main" id="{43464F78-DB4D-4A6C-9A30-4B4945309631}"/>
               </a:ext>
             </a:extLst>
           </p:cNvPr>
@@ -10802,7 +11054,7 @@
           <p:cNvPr id="12" name="">
             <a:extLst xmlns:a="http://schemas.openxmlformats.org/drawingml/2006/main">
               <a:ext uri="{FF2B5EF4-FFF2-40B4-BE49-F238E27FC236}">
-                <a16:creationId xmlns:a16="http://schemas.microsoft.com/office/drawing/2014/main" id="{15376F10-2886-4C71-907C-337357DAD89D}"/>
+                <a16:creationId xmlns:a16="http://schemas.microsoft.com/office/drawing/2014/main" id="{5D8C901D-8568-49F4-9C03-3BD75A104EEB}"/>
               </a:ext>
             </a:extLst>
           </p:cNvPr>
@@ -10834,7 +11086,7 @@
           <p:cNvPr id="13" name="">
             <a:extLst xmlns:a="http://schemas.openxmlformats.org/drawingml/2006/main">
               <a:ext uri="{FF2B5EF4-FFF2-40B4-BE49-F238E27FC236}">
-                <a16:creationId xmlns:a16="http://schemas.microsoft.com/office/drawing/2014/main" id="{AB3EF428-5F42-480F-8B92-E2E55E749288}"/>
+                <a16:creationId xmlns:a16="http://schemas.microsoft.com/office/drawing/2014/main" id="{9EC61AE2-C4B2-469A-9E64-431F5EA7F74D}"/>
               </a:ext>
             </a:extLst>
           </p:cNvPr>
@@ -10866,7 +11118,7 @@
           <p:cNvPr id="14" name="b-waits">
             <a:extLst xmlns:a="http://schemas.openxmlformats.org/drawingml/2006/main">
               <a:ext uri="{FF2B5EF4-FFF2-40B4-BE49-F238E27FC236}">
-                <a16:creationId xmlns:a16="http://schemas.microsoft.com/office/drawing/2014/main" id="{52DE5CE3-6484-4649-897D-BF1DCCA85144}"/>
+                <a16:creationId xmlns:a16="http://schemas.microsoft.com/office/drawing/2014/main" id="{E4848BC1-B3B5-4564-8DA7-AB66B7A4B82A}"/>
               </a:ext>
             </a:extLst>
           </p:cNvPr>
@@ -10923,7 +11175,7 @@
           <p:cNvPr id="15" name="cycle">
             <a:extLst xmlns:a="http://schemas.openxmlformats.org/drawingml/2006/main">
               <a:ext uri="{FF2B5EF4-FFF2-40B4-BE49-F238E27FC236}">
-                <a16:creationId xmlns:a16="http://schemas.microsoft.com/office/drawing/2014/main" id="{B448BC30-A7DB-4C20-81DA-1B40CE10AD9F}"/>
+                <a16:creationId xmlns:a16="http://schemas.microsoft.com/office/drawing/2014/main" id="{DD5440A7-04AB-43F6-A6EC-73495C8EDAEB}"/>
               </a:ext>
             </a:extLst>
           </p:cNvPr>
@@ -10980,7 +11232,7 @@
           <p:cNvPr id="16" name="deadlock-rule">
             <a:extLst xmlns:a="http://schemas.openxmlformats.org/drawingml/2006/main">
               <a:ext uri="{FF2B5EF4-FFF2-40B4-BE49-F238E27FC236}">
-                <a16:creationId xmlns:a16="http://schemas.microsoft.com/office/drawing/2014/main" id="{FA25FD7A-ABB1-4C44-BB4D-B52A3C02CD5B}"/>
+                <a16:creationId xmlns:a16="http://schemas.microsoft.com/office/drawing/2014/main" id="{7FCE482B-EF9D-4A82-BB1E-A7FDE4DA2652}"/>
               </a:ext>
             </a:extLst>
           </p:cNvPr>
@@ -11066,7 +11318,7 @@
           <p:cNvPr id="7" name="eyebrow">
             <a:extLst xmlns:a="http://schemas.openxmlformats.org/drawingml/2006/main">
               <a:ext uri="{FF2B5EF4-FFF2-40B4-BE49-F238E27FC236}">
-                <a16:creationId xmlns:a16="http://schemas.microsoft.com/office/drawing/2014/main" id="{FC582DAB-6ADF-4B65-AD4A-FB9EEFE93E24}"/>
+                <a16:creationId xmlns:a16="http://schemas.microsoft.com/office/drawing/2014/main" id="{A23065BA-4749-4821-849E-27610A65A0D7}"/>
               </a:ext>
             </a:extLst>
           </p:cNvPr>
@@ -11123,7 +11375,7 @@
           <p:cNvPr id="2" name="slide-title">
             <a:extLst xmlns:a="http://schemas.openxmlformats.org/drawingml/2006/main">
               <a:ext uri="{FF2B5EF4-FFF2-40B4-BE49-F238E27FC236}">
-                <a16:creationId xmlns:a16="http://schemas.microsoft.com/office/drawing/2014/main" id="{7C8DF21C-AD43-459D-9A70-A4425797C575}"/>
+                <a16:creationId xmlns:a16="http://schemas.microsoft.com/office/drawing/2014/main" id="{5C3163E4-3039-4E35-AC1A-E834009DB67B}"/>
               </a:ext>
             </a:extLst>
           </p:cNvPr>
@@ -11180,7 +11432,7 @@
           <p:cNvPr id="3" name="">
             <a:extLst xmlns:a="http://schemas.openxmlformats.org/drawingml/2006/main">
               <a:ext uri="{FF2B5EF4-FFF2-40B4-BE49-F238E27FC236}">
-                <a16:creationId xmlns:a16="http://schemas.microsoft.com/office/drawing/2014/main" id="{E9E31118-B50B-4BC2-8A35-3E8EDA3E866F}"/>
+                <a16:creationId xmlns:a16="http://schemas.microsoft.com/office/drawing/2014/main" id="{E65B5796-FA3C-4F3F-A0AC-158E50C9C562}"/>
               </a:ext>
             </a:extLst>
           </p:cNvPr>
@@ -11212,7 +11464,7 @@
           <p:cNvPr id="4" name="slide-number">
             <a:extLst xmlns:a="http://schemas.openxmlformats.org/drawingml/2006/main">
               <a:ext uri="{FF2B5EF4-FFF2-40B4-BE49-F238E27FC236}">
-                <a16:creationId xmlns:a16="http://schemas.microsoft.com/office/drawing/2014/main" id="{7C8CB1A9-E5E1-4688-BCDA-619F0FD83683}"/>
+                <a16:creationId xmlns:a16="http://schemas.microsoft.com/office/drawing/2014/main" id="{04F2DF21-CD69-47AD-9368-09D7C418A0E7}"/>
               </a:ext>
             </a:extLst>
           </p:cNvPr>
@@ -11420,7 +11672,7 @@
                           <a:ea typeface="Helvetica Neue"/>
                           <a:cs typeface="Helvetica Neue"/>
                         </a:rPr>
-                        <a:t>Noah (202), in_progress</a:t>
+                        <a:t>Agent 202 (202), in_progress</a:t>
                       </a:r>
                     </a:p>
                   </a:txBody>
@@ -11514,7 +11766,7 @@
           <p:cNvPr id="6" name="pair-meaning">
             <a:extLst xmlns:a="http://schemas.openxmlformats.org/drawingml/2006/main">
               <a:ext uri="{FF2B5EF4-FFF2-40B4-BE49-F238E27FC236}">
-                <a16:creationId xmlns:a16="http://schemas.microsoft.com/office/drawing/2014/main" id="{D2DB94B0-8086-47BF-9DBA-19454DE98D66}"/>
+                <a16:creationId xmlns:a16="http://schemas.microsoft.com/office/drawing/2014/main" id="{1DB845FB-8A60-4761-BD19-19FAB950251F}"/>
               </a:ext>
             </a:extLst>
           </p:cNvPr>
@@ -11597,10 +11849,10 @@
       </p:grpSpPr>
       <p:sp>
         <p:nvSpPr>
-          <p:cNvPr id="9" name="eyebrow">
-            <a:extLst xmlns:a="http://schemas.openxmlformats.org/drawingml/2006/main">
-              <a:ext uri="{FF2B5EF4-FFF2-40B4-BE49-F238E27FC236}">
-                <a16:creationId xmlns:a16="http://schemas.microsoft.com/office/drawing/2014/main" id="{E0FE72EB-A4F3-4821-B178-920B2AE39B8B}"/>
+          <p:cNvPr id="8" name="eyebrow">
+            <a:extLst xmlns:a="http://schemas.openxmlformats.org/drawingml/2006/main">
+              <a:ext uri="{FF2B5EF4-FFF2-40B4-BE49-F238E27FC236}">
+                <a16:creationId xmlns:a16="http://schemas.microsoft.com/office/drawing/2014/main" id="{182AB24C-6DA8-44B9-A725-E4E1928D986B}"/>
               </a:ext>
             </a:extLst>
           </p:cNvPr>
@@ -11657,7 +11909,7 @@
           <p:cNvPr id="2" name="slide-title">
             <a:extLst xmlns:a="http://schemas.openxmlformats.org/drawingml/2006/main">
               <a:ext uri="{FF2B5EF4-FFF2-40B4-BE49-F238E27FC236}">
-                <a16:creationId xmlns:a16="http://schemas.microsoft.com/office/drawing/2014/main" id="{88B7B094-76E2-4B1E-85F0-81CA1CBAAE3A}"/>
+                <a16:creationId xmlns:a16="http://schemas.microsoft.com/office/drawing/2014/main" id="{247ABCB1-66D1-4222-98CE-C358B2DFEA5F}"/>
               </a:ext>
             </a:extLst>
           </p:cNvPr>
@@ -11704,7 +11956,7 @@
                 <a:ea typeface="Helvetica Neue"/>
                 <a:cs typeface="Helvetica Neue"/>
               </a:rPr>
-              <a:t>One notebook setting changes A's decision</a:t>
+              <a:t>Lab 2 runs in Colab and connects to Supabase</a:t>
             </a:r>
           </a:p>
         </p:txBody>
@@ -11714,7 +11966,7 @@
           <p:cNvPr id="3" name="">
             <a:extLst xmlns:a="http://schemas.openxmlformats.org/drawingml/2006/main">
               <a:ext uri="{FF2B5EF4-FFF2-40B4-BE49-F238E27FC236}">
-                <a16:creationId xmlns:a16="http://schemas.microsoft.com/office/drawing/2014/main" id="{80F01157-9FDD-4436-8050-97034B7C1B93}"/>
+                <a16:creationId xmlns:a16="http://schemas.microsoft.com/office/drawing/2014/main" id="{06F8EB80-E071-4F1E-A601-CFC9DAF98DE8}"/>
               </a:ext>
             </a:extLst>
           </p:cNvPr>
@@ -11746,7 +11998,7 @@
           <p:cNvPr id="4" name="slide-number">
             <a:extLst xmlns:a="http://schemas.openxmlformats.org/drawingml/2006/main">
               <a:ext uri="{FF2B5EF4-FFF2-40B4-BE49-F238E27FC236}">
-                <a16:creationId xmlns:a16="http://schemas.microsoft.com/office/drawing/2014/main" id="{E2791B53-8CDD-427C-B5D0-9B0F5F299196}"/>
+                <a16:creationId xmlns:a16="http://schemas.microsoft.com/office/drawing/2014/main" id="{0AF840A6-92FC-4A6D-AB72-7848B825C00F}"/>
               </a:ext>
             </a:extLst>
           </p:cNvPr>
@@ -11798,56 +12050,246 @@
           </a:p>
         </p:txBody>
       </p:sp>
-      <p:sp>
-        <p:nvSpPr>
-          <p:cNvPr id="5" name="">
-            <a:extLst xmlns:a="http://schemas.openxmlformats.org/drawingml/2006/main">
-              <a:ext uri="{FF2B5EF4-FFF2-40B4-BE49-F238E27FC236}">
-                <a16:creationId xmlns:a16="http://schemas.microsoft.com/office/drawing/2014/main" id="{3CED0C05-807D-4E60-ADF9-58FB87DE3A33}"/>
-              </a:ext>
-            </a:extLst>
-          </p:cNvPr>
-          <p:cNvSpPr>
-            <a:spLocks xmlns:a="http://schemas.openxmlformats.org/drawingml/2006/main" noGrp="1"/>
-          </p:cNvSpPr>
-          <p:nvPr/>
-        </p:nvSpPr>
-        <p:spPr>
-          <a:xfrm xmlns:a="http://schemas.openxmlformats.org/drawingml/2006/main">
-            <a:off x="685800" y="1857375"/>
-            <a:ext cx="10820400" cy="1438275"/>
-          </a:xfrm>
-          <a:prstGeom xmlns:a="http://schemas.openxmlformats.org/drawingml/2006/main" prst="rect">
-            <a:avLst/>
-          </a:prstGeom>
-          <a:solidFill xmlns:a="http://schemas.openxmlformats.org/drawingml/2006/main">
-            <a:srgbClr val="101728"/>
-          </a:solidFill>
-          <a:ln xmlns:a="http://schemas.openxmlformats.org/drawingml/2006/main" w="0">
-            <a:solidFill>
-              <a:srgbClr val="101728"/>
-            </a:solidFill>
-          </a:ln>
-        </p:spPr>
-      </p:sp>
-      <p:sp>
-        <p:nvSpPr>
-          <p:cNvPr id="6" name="flags">
-            <a:extLst xmlns:a="http://schemas.openxmlformats.org/drawingml/2006/main">
-              <a:ext uri="{FF2B5EF4-FFF2-40B4-BE49-F238E27FC236}">
-                <a16:creationId xmlns:a16="http://schemas.microsoft.com/office/drawing/2014/main" id="{0929DF84-FFF1-47C7-8521-C44F96DD77C2}"/>
-              </a:ext>
-            </a:extLst>
-          </p:cNvPr>
-          <p:cNvSpPr>
-            <a:spLocks xmlns:a="http://schemas.openxmlformats.org/drawingml/2006/main" noGrp="1"/>
-          </p:cNvSpPr>
-          <p:nvPr/>
-        </p:nvSpPr>
-        <p:spPr>
-          <a:xfrm xmlns:a="http://schemas.openxmlformats.org/drawingml/2006/main">
-            <a:off x="876300" y="2028825"/>
-            <a:ext cx="10439400" cy="1095375"/>
+      <p:graphicFrame>
+        <p:nvGraphicFramePr>
+          <p:cNvPr id="12" name=""/>
+          <p:cNvGraphicFramePr/>
+          <p:nvPr/>
+        </p:nvGraphicFramePr>
+        <p:xfrm>
+          <a:off xmlns:a="http://schemas.openxmlformats.org/drawingml/2006/main" x="685800" y="1752600"/>
+          <a:ext xmlns:a="http://schemas.openxmlformats.org/drawingml/2006/main" cx="10820400" cy="2609850"/>
+        </p:xfrm>
+        <a:graphic xmlns:a="http://schemas.openxmlformats.org/drawingml/2006/main">
+          <a:graphicData uri="http://schemas.openxmlformats.org/drawingml/2006/table">
+            <a:tbl>
+              <a:tblPr/>
+              <a:tblGrid>
+                <a:gridCol w="2876550"/>
+                <a:gridCol w="7943850"/>
+              </a:tblGrid>
+              <a:tr h="652463">
+                <a:tc>
+                  <a:txBody>
+                    <a:bodyPr lIns="114300" tIns="76200" rIns="114300" bIns="76200"/>
+                    <a:lstStyle/>
+                    <a:p>
+                      <a:r>
+                        <a:rPr sz="1875" b="1">
+                          <a:solidFill>
+                            <a:srgbClr val="FFFFFF"/>
+                          </a:solidFill>
+                          <a:latin typeface="Helvetica Neue"/>
+                          <a:ea typeface="Helvetica Neue"/>
+                          <a:cs typeface="Helvetica Neue"/>
+                        </a:rPr>
+                        <a:t>Part</a:t>
+                      </a:r>
+                    </a:p>
+                  </a:txBody>
+                  <a:tcPr marL="91440" marR="91440" marT="45720" marB="45720" anchor="ctr">
+                    <a:solidFill>
+                      <a:srgbClr val="BF3E05"/>
+                    </a:solidFill>
+                  </a:tcPr>
+                </a:tc>
+                <a:tc>
+                  <a:txBody>
+                    <a:bodyPr lIns="114300" tIns="76200" rIns="114300" bIns="76200"/>
+                    <a:lstStyle/>
+                    <a:p>
+                      <a:r>
+                        <a:rPr sz="1875" b="1">
+                          <a:solidFill>
+                            <a:srgbClr val="FFFFFF"/>
+                          </a:solidFill>
+                          <a:latin typeface="Helvetica Neue"/>
+                          <a:ea typeface="Helvetica Neue"/>
+                          <a:cs typeface="Helvetica Neue"/>
+                        </a:rPr>
+                        <a:t>What you use it for</a:t>
+                      </a:r>
+                    </a:p>
+                  </a:txBody>
+                  <a:tcPr marL="91440" marR="91440" marT="45720" marB="45720" anchor="ctr">
+                    <a:solidFill>
+                      <a:srgbClr val="BF3E05"/>
+                    </a:solidFill>
+                  </a:tcPr>
+                </a:tc>
+              </a:tr>
+              <a:tr h="652463">
+                <a:tc>
+                  <a:txBody>
+                    <a:bodyPr lIns="114300" tIns="76200" rIns="114300" bIns="76200"/>
+                    <a:lstStyle/>
+                    <a:p>
+                      <a:r>
+                        <a:rPr sz="1875" b="0">
+                          <a:solidFill>
+                            <a:srgbClr val="111827"/>
+                          </a:solidFill>
+                          <a:latin typeface="Helvetica Neue"/>
+                          <a:ea typeface="Helvetica Neue"/>
+                          <a:cs typeface="Helvetica Neue"/>
+                        </a:rPr>
+                        <a:t>Lab 2</a:t>
+                      </a:r>
+                    </a:p>
+                  </a:txBody>
+                  <a:tcPr marL="91440" marR="91440" marT="45720" marB="45720" anchor="ctr">
+                    <a:solidFill>
+                      <a:srgbClr val="FFFFFF"/>
+                    </a:solidFill>
+                  </a:tcPr>
+                </a:tc>
+                <a:tc>
+                  <a:txBody>
+                    <a:bodyPr lIns="114300" tIns="76200" rIns="114300" bIns="76200"/>
+                    <a:lstStyle/>
+                    <a:p>
+                      <a:r>
+                        <a:rPr sz="1875" b="0">
+                          <a:solidFill>
+                            <a:srgbClr val="111827"/>
+                          </a:solidFill>
+                          <a:latin typeface="Helvetica Neue"/>
+                          <a:ea typeface="Helvetica Neue"/>
+                          <a:cs typeface="Helvetica Neue"/>
+                        </a:rPr>
+                        <a:t>The assignment: compare rollback and commit.</a:t>
+                      </a:r>
+                    </a:p>
+                  </a:txBody>
+                  <a:tcPr marL="91440" marR="91440" marT="45720" marB="45720" anchor="ctr">
+                    <a:solidFill>
+                      <a:srgbClr val="FFFFFF"/>
+                    </a:solidFill>
+                  </a:tcPr>
+                </a:tc>
+              </a:tr>
+              <a:tr h="652463">
+                <a:tc>
+                  <a:txBody>
+                    <a:bodyPr lIns="114300" tIns="76200" rIns="114300" bIns="76200"/>
+                    <a:lstStyle/>
+                    <a:p>
+                      <a:r>
+                        <a:rPr sz="1875" b="0">
+                          <a:solidFill>
+                            <a:srgbClr val="111827"/>
+                          </a:solidFill>
+                          <a:latin typeface="Helvetica Neue"/>
+                          <a:ea typeface="Helvetica Neue"/>
+                          <a:cs typeface="Helvetica Neue"/>
+                        </a:rPr>
+                        <a:t>Colab notebook</a:t>
+                      </a:r>
+                    </a:p>
+                  </a:txBody>
+                  <a:tcPr marL="91440" marR="91440" marT="45720" marB="45720" anchor="ctr">
+                    <a:solidFill>
+                      <a:srgbClr val="F1F5F9"/>
+                    </a:solidFill>
+                  </a:tcPr>
+                </a:tc>
+                <a:tc>
+                  <a:txBody>
+                    <a:bodyPr lIns="114300" tIns="76200" rIns="114300" bIns="76200"/>
+                    <a:lstStyle/>
+                    <a:p>
+                      <a:r>
+                        <a:rPr sz="1875" b="0">
+                          <a:solidFill>
+                            <a:srgbClr val="111827"/>
+                          </a:solidFill>
+                          <a:latin typeface="Helvetica Neue"/>
+                          <a:ea typeface="Helvetica Neue"/>
+                          <a:cs typeface="Helvetica Neue"/>
+                        </a:rPr>
+                        <a:t>Runs the supplied Python and SQL cells.</a:t>
+                      </a:r>
+                    </a:p>
+                  </a:txBody>
+                  <a:tcPr marL="91440" marR="91440" marT="45720" marB="45720" anchor="ctr">
+                    <a:solidFill>
+                      <a:srgbClr val="F1F5F9"/>
+                    </a:solidFill>
+                  </a:tcPr>
+                </a:tc>
+              </a:tr>
+              <a:tr h="652463">
+                <a:tc>
+                  <a:txBody>
+                    <a:bodyPr lIns="114300" tIns="76200" rIns="114300" bIns="76200"/>
+                    <a:lstStyle/>
+                    <a:p>
+                      <a:r>
+                        <a:rPr sz="1875" b="0">
+                          <a:solidFill>
+                            <a:srgbClr val="111827"/>
+                          </a:solidFill>
+                          <a:latin typeface="Helvetica Neue"/>
+                          <a:ea typeface="Helvetica Neue"/>
+                          <a:cs typeface="Helvetica Neue"/>
+                        </a:rPr>
+                        <a:t>Supabase project</a:t>
+                      </a:r>
+                    </a:p>
+                  </a:txBody>
+                  <a:tcPr marL="91440" marR="91440" marT="45720" marB="45720" anchor="ctr">
+                    <a:solidFill>
+                      <a:srgbClr val="FFFFFF"/>
+                    </a:solidFill>
+                  </a:tcPr>
+                </a:tc>
+                <a:tc>
+                  <a:txBody>
+                    <a:bodyPr lIns="114300" tIns="76200" rIns="114300" bIns="76200"/>
+                    <a:lstStyle/>
+                    <a:p>
+                      <a:r>
+                        <a:rPr sz="1875" b="0">
+                          <a:solidFill>
+                            <a:srgbClr val="111827"/>
+                          </a:solidFill>
+                          <a:latin typeface="Helvetica Neue"/>
+                          <a:ea typeface="Helvetica Neue"/>
+                          <a:cs typeface="Helvetica Neue"/>
+                        </a:rPr>
+                        <a:t>Hosts the PostgreSQL database the cells connect to.</a:t>
+                      </a:r>
+                    </a:p>
+                  </a:txBody>
+                  <a:tcPr marL="91440" marR="91440" marT="45720" marB="45720" anchor="ctr">
+                    <a:solidFill>
+                      <a:srgbClr val="FFFFFF"/>
+                    </a:solidFill>
+                  </a:tcPr>
+                </a:tc>
+              </a:tr>
+            </a:tbl>
+          </a:graphicData>
+        </a:graphic>
+      </p:graphicFrame>
+      <p:sp>
+        <p:nvSpPr>
+          <p:cNvPr id="6" name="open-colab">
+            <a:extLst xmlns:a="http://schemas.openxmlformats.org/drawingml/2006/main">
+              <a:ext uri="{FF2B5EF4-FFF2-40B4-BE49-F238E27FC236}">
+                <a16:creationId xmlns:a16="http://schemas.microsoft.com/office/drawing/2014/main" id="{E4191470-923F-421C-BF9A-DEDE41BE92A2}"/>
+              </a:ext>
+            </a:extLst>
+          </p:cNvPr>
+          <p:cNvSpPr>
+            <a:spLocks xmlns:a="http://schemas.openxmlformats.org/drawingml/2006/main" noGrp="1"/>
+          </p:cNvSpPr>
+          <p:nvPr/>
+        </p:nvSpPr>
+        <p:spPr>
+          <a:xfrm xmlns:a="http://schemas.openxmlformats.org/drawingml/2006/main">
+            <a:off x="723900" y="4667250"/>
+            <a:ext cx="10668000" cy="1304925"/>
           </a:xfrm>
           <a:prstGeom xmlns:a="http://schemas.openxmlformats.org/drawingml/2006/main" prst="rect">
             <a:avLst/>
@@ -11864,93 +12306,93 @@
           <a:lstStyle xmlns:a="http://schemas.openxmlformats.org/drawingml/2006/main"/>
           <a:p xmlns:a="http://schemas.openxmlformats.org/drawingml/2006/main">
             <a:pPr>
-              <a:defRPr sz="1875" b="0">
-                <a:solidFill>
-                  <a:srgbClr val="E2E8F0"/>
-                </a:solidFill>
-                <a:latin typeface="Menlo"/>
-                <a:ea typeface="Menlo"/>
-                <a:cs typeface="Menlo"/>
-              </a:defRPr>
-            </a:pPr>
-            <a:r>
-              <a:rPr sz="1875" b="0">
-                <a:solidFill>
-                  <a:srgbClr val="E2E8F0"/>
-                </a:solidFill>
-                <a:latin typeface="Menlo"/>
-                <a:ea typeface="Menlo"/>
-                <a:cs typeface="Menlo"/>
-              </a:rPr>
-              <a:t>USE_CLOUD = True</a:t>
-            </a:r>
-          </a:p>
-          <a:p xmlns:a="http://schemas.openxmlformats.org/drawingml/2006/main">
-            <a:pPr>
-              <a:defRPr sz="1875" b="0">
-                <a:solidFill>
-                  <a:srgbClr val="E2E8F0"/>
-                </a:solidFill>
-                <a:latin typeface="Menlo"/>
-                <a:ea typeface="Menlo"/>
-                <a:cs typeface="Menlo"/>
-              </a:defRPr>
-            </a:pPr>
-            <a:r>
-              <a:rPr sz="1875" b="0">
-                <a:solidFill>
-                  <a:srgbClr val="E2E8F0"/>
-                </a:solidFill>
-                <a:latin typeface="Menlo"/>
-                <a:ea typeface="Menlo"/>
-                <a:cs typeface="Menlo"/>
-              </a:rPr>
-              <a:t>KEEP_A_CHANGE = False  # first run: rollback A</a:t>
-            </a:r>
-          </a:p>
-          <a:p xmlns:a="http://schemas.openxmlformats.org/drawingml/2006/main">
-            <a:pPr>
-              <a:defRPr sz="1875" b="0">
-                <a:solidFill>
-                  <a:srgbClr val="E2E8F0"/>
-                </a:solidFill>
-                <a:latin typeface="Menlo"/>
-                <a:ea typeface="Menlo"/>
-                <a:cs typeface="Menlo"/>
-              </a:defRPr>
-            </a:pPr>
-            <a:r>
-              <a:rPr sz="1875" b="0">
-                <a:solidFill>
-                  <a:srgbClr val="E2E8F0"/>
-                </a:solidFill>
-                <a:latin typeface="Menlo"/>
-                <a:ea typeface="Menlo"/>
-                <a:cs typeface="Menlo"/>
-              </a:rPr>
-              <a:t># Second run: change only KEEP_A_CHANGE to True.</a:t>
-            </a:r>
-          </a:p>
-        </p:txBody>
-      </p:sp>
-      <p:sp>
-        <p:nvSpPr>
-          <p:cNvPr id="7" name="connect">
-            <a:extLst xmlns:a="http://schemas.openxmlformats.org/drawingml/2006/main">
-              <a:ext uri="{FF2B5EF4-FFF2-40B4-BE49-F238E27FC236}">
-                <a16:creationId xmlns:a16="http://schemas.microsoft.com/office/drawing/2014/main" id="{4E7D0C2B-6E28-4B96-BBE7-45A0A97885FE}"/>
-              </a:ext>
-            </a:extLst>
-          </p:cNvPr>
-          <p:cNvSpPr>
-            <a:spLocks xmlns:a="http://schemas.openxmlformats.org/drawingml/2006/main" noGrp="1"/>
-          </p:cNvSpPr>
-          <p:nvPr/>
-        </p:nvSpPr>
-        <p:spPr>
-          <a:xfrm xmlns:a="http://schemas.openxmlformats.org/drawingml/2006/main">
-            <a:off x="723900" y="3848100"/>
-            <a:ext cx="10668000" cy="1504950"/>
+              <a:defRPr sz="2100" b="0">
+                <a:solidFill>
+                  <a:srgbClr val="111827"/>
+                </a:solidFill>
+                <a:latin typeface="Helvetica Neue"/>
+                <a:ea typeface="Helvetica Neue"/>
+                <a:cs typeface="Helvetica Neue"/>
+              </a:defRPr>
+            </a:pPr>
+            <a:r>
+              <a:rPr sz="2100" b="0">
+                <a:solidFill>
+                  <a:srgbClr val="111827"/>
+                </a:solidFill>
+                <a:latin typeface="Helvetica Neue"/>
+                <a:ea typeface="Helvetica Neue"/>
+                <a:cs typeface="Helvetica Neue"/>
+              </a:rPr>
+              <a:t>1. Open Lab 2 and click Open in Colab.</a:t>
+            </a:r>
+          </a:p>
+          <a:p xmlns:a="http://schemas.openxmlformats.org/drawingml/2006/main">
+            <a:pPr>
+              <a:defRPr sz="2100" b="0">
+                <a:solidFill>
+                  <a:srgbClr val="111827"/>
+                </a:solidFill>
+                <a:latin typeface="Helvetica Neue"/>
+                <a:ea typeface="Helvetica Neue"/>
+                <a:cs typeface="Helvetica Neue"/>
+              </a:defRPr>
+            </a:pPr>
+            <a:r>
+              <a:rPr sz="2100" b="0">
+                <a:solidFill>
+                  <a:srgbClr val="111827"/>
+                </a:solidFill>
+                <a:latin typeface="Helvetica Neue"/>
+                <a:ea typeface="Helvetica Neue"/>
+                <a:cs typeface="Helvetica Neue"/>
+              </a:rPr>
+              <a:t>2. Choose File &gt; Save a copy in Drive.</a:t>
+            </a:r>
+          </a:p>
+          <a:p xmlns:a="http://schemas.openxmlformats.org/drawingml/2006/main">
+            <a:pPr>
+              <a:defRPr sz="2100" b="0">
+                <a:solidFill>
+                  <a:srgbClr val="111827"/>
+                </a:solidFill>
+                <a:latin typeface="Helvetica Neue"/>
+                <a:ea typeface="Helvetica Neue"/>
+                <a:cs typeface="Helvetica Neue"/>
+              </a:defRPr>
+            </a:pPr>
+            <a:r>
+              <a:rPr sz="2100" b="0">
+                <a:solidFill>
+                  <a:srgbClr val="111827"/>
+                </a:solidFill>
+                <a:latin typeface="Helvetica Neue"/>
+                <a:ea typeface="Helvetica Neue"/>
+                <a:cs typeface="Helvetica Neue"/>
+              </a:rPr>
+              <a:t>3. Keep your existing course project open in Supabase.</a:t>
+            </a:r>
+          </a:p>
+        </p:txBody>
+      </p:sp>
+      <p:sp>
+        <p:nvSpPr>
+          <p:cNvPr id="7" name="where-code-runs">
+            <a:extLst xmlns:a="http://schemas.openxmlformats.org/drawingml/2006/main">
+              <a:ext uri="{FF2B5EF4-FFF2-40B4-BE49-F238E27FC236}">
+                <a16:creationId xmlns:a16="http://schemas.microsoft.com/office/drawing/2014/main" id="{0D0E2E11-0332-4C81-B46F-555013B78E79}"/>
+              </a:ext>
+            </a:extLst>
+          </p:cNvPr>
+          <p:cNvSpPr>
+            <a:spLocks xmlns:a="http://schemas.openxmlformats.org/drawingml/2006/main" noGrp="1"/>
+          </p:cNvSpPr>
+          <p:nvPr/>
+        </p:nvSpPr>
+        <p:spPr>
+          <a:xfrm xmlns:a="http://schemas.openxmlformats.org/drawingml/2006/main">
+            <a:off x="723900" y="6067425"/>
+            <a:ext cx="10668000" cy="381000"/>
           </a:xfrm>
           <a:prstGeom xmlns:a="http://schemas.openxmlformats.org/drawingml/2006/main" prst="rect">
             <a:avLst/>
@@ -11967,128 +12409,25 @@
           <a:lstStyle xmlns:a="http://schemas.openxmlformats.org/drawingml/2006/main"/>
           <a:p xmlns:a="http://schemas.openxmlformats.org/drawingml/2006/main">
             <a:pPr>
-              <a:defRPr sz="2325" b="0">
-                <a:solidFill>
-                  <a:srgbClr val="111827"/>
-                </a:solidFill>
-                <a:latin typeface="Helvetica Neue"/>
-                <a:ea typeface="Helvetica Neue"/>
-                <a:cs typeface="Helvetica Neue"/>
-              </a:defRPr>
-            </a:pPr>
-            <a:r>
-              <a:rPr sz="2325" b="0">
-                <a:solidFill>
-                  <a:srgbClr val="111827"/>
-                </a:solidFill>
-                <a:latin typeface="Helvetica Neue"/>
-                <a:ea typeface="Helvetica Neue"/>
-                <a:cs typeface="Helvetica Neue"/>
-              </a:rPr>
-              <a:t>Lab page: Open in Colab, then save a copy in Drive.</a:t>
-            </a:r>
-          </a:p>
-          <a:p xmlns:a="http://schemas.openxmlformats.org/drawingml/2006/main">
-            <a:pPr>
-              <a:defRPr sz="2325" b="0">
-                <a:solidFill>
-                  <a:srgbClr val="111827"/>
-                </a:solidFill>
-                <a:latin typeface="Helvetica Neue"/>
-                <a:ea typeface="Helvetica Neue"/>
-                <a:cs typeface="Helvetica Neue"/>
-              </a:defRPr>
-            </a:pPr>
-            <a:r>
-              <a:rPr sz="2325" b="0">
-                <a:solidFill>
-                  <a:srgbClr val="111827"/>
-                </a:solidFill>
-                <a:latin typeface="Helvetica Neue"/>
-                <a:ea typeface="Helvetica Neue"/>
-                <a:cs typeface="Helvetica Neue"/>
-              </a:rPr>
-              <a:t>Supabase: Connect &gt; Session pooler.</a:t>
-            </a:r>
-          </a:p>
-          <a:p xmlns:a="http://schemas.openxmlformats.org/drawingml/2006/main">
-            <a:pPr>
-              <a:defRPr sz="2325" b="0">
-                <a:solidFill>
-                  <a:srgbClr val="111827"/>
-                </a:solidFill>
-                <a:latin typeface="Helvetica Neue"/>
-                <a:ea typeface="Helvetica Neue"/>
-                <a:cs typeface="Helvetica Neue"/>
-              </a:defRPr>
-            </a:pPr>
-            <a:r>
-              <a:rPr sz="2325" b="0">
-                <a:solidFill>
-                  <a:srgbClr val="111827"/>
-                </a:solidFill>
-                <a:latin typeface="Helvetica Neue"/>
-                <a:ea typeface="Helvetica Neue"/>
-                <a:cs typeface="Helvetica Neue"/>
-              </a:rPr>
-              <a:t>Enter the URL only at the hidden prompt.</a:t>
-            </a:r>
-          </a:p>
-        </p:txBody>
-      </p:sp>
-      <p:sp>
-        <p:nvSpPr>
-          <p:cNvPr id="8" name="mechanics">
-            <a:extLst xmlns:a="http://schemas.openxmlformats.org/drawingml/2006/main">
-              <a:ext uri="{FF2B5EF4-FFF2-40B4-BE49-F238E27FC236}">
-                <a16:creationId xmlns:a16="http://schemas.microsoft.com/office/drawing/2014/main" id="{7D79320F-4B6D-4443-B971-761108CF2AA4}"/>
-              </a:ext>
-            </a:extLst>
-          </p:cNvPr>
-          <p:cNvSpPr>
-            <a:spLocks xmlns:a="http://schemas.openxmlformats.org/drawingml/2006/main" noGrp="1"/>
-          </p:cNvSpPr>
-          <p:nvPr/>
-        </p:nvSpPr>
-        <p:spPr>
-          <a:xfrm xmlns:a="http://schemas.openxmlformats.org/drawingml/2006/main">
-            <a:off x="723900" y="5657850"/>
-            <a:ext cx="10668000" cy="781050"/>
-          </a:xfrm>
-          <a:prstGeom xmlns:a="http://schemas.openxmlformats.org/drawingml/2006/main" prst="rect">
-            <a:avLst/>
-          </a:prstGeom>
-          <a:noFill xmlns:a="http://schemas.openxmlformats.org/drawingml/2006/main"/>
-          <a:ln xmlns:a="http://schemas.openxmlformats.org/drawingml/2006/main" w="0">
-            <a:noFill/>
-          </a:ln>
-        </p:spPr>
-        <p:txBody>
-          <a:bodyPr xmlns:a="http://schemas.openxmlformats.org/drawingml/2006/main" wrap="square" lIns="0" tIns="0" rIns="0" bIns="0" anchor="t">
-            <a:noAutofit/>
-          </a:bodyPr>
-          <a:lstStyle xmlns:a="http://schemas.openxmlformats.org/drawingml/2006/main"/>
-          <a:p xmlns:a="http://schemas.openxmlformats.org/drawingml/2006/main">
-            <a:pPr>
-              <a:defRPr sz="1875" b="0">
-                <a:solidFill>
-                  <a:srgbClr val="111827"/>
-                </a:solidFill>
-                <a:latin typeface="Helvetica Neue"/>
-                <a:ea typeface="Helvetica Neue"/>
-                <a:cs typeface="Helvetica Neue"/>
-              </a:defRPr>
-            </a:pPr>
-            <a:r>
-              <a:rPr sz="1875" b="0">
-                <a:solidFill>
-                  <a:srgbClr val="111827"/>
-                </a:solidFill>
-                <a:latin typeface="Helvetica Neue"/>
-                <a:ea typeface="Helvetica Neue"/>
-                <a:cs typeface="Helvetica Neue"/>
-              </a:rPr>
-              <a:t>The experiment captures the wait, ends A, and joins B before returning. It does not leave you reading while a row stays blocked.</a:t>
+              <a:defRPr sz="1725" b="0">
+                <a:solidFill>
+                  <a:srgbClr val="111827"/>
+                </a:solidFill>
+                <a:latin typeface="Helvetica Neue"/>
+                <a:ea typeface="Helvetica Neue"/>
+                <a:cs typeface="Helvetica Neue"/>
+              </a:defRPr>
+            </a:pPr>
+            <a:r>
+              <a:rPr sz="1725" b="0">
+                <a:solidFill>
+                  <a:srgbClr val="111827"/>
+                </a:solidFill>
+                <a:latin typeface="Helvetica Neue"/>
+                <a:ea typeface="Helvetica Neue"/>
+                <a:cs typeface="Helvetica Neue"/>
+              </a:rPr>
+              <a:t>Run today's code in Colab. The notebook opens three database connections.</a:t>
             </a:r>
           </a:p>
         </p:txBody>
@@ -12124,10 +12463,10 @@
       </p:grpSpPr>
       <p:sp>
         <p:nvSpPr>
-          <p:cNvPr id="9" name="eyebrow">
-            <a:extLst xmlns:a="http://schemas.openxmlformats.org/drawingml/2006/main">
-              <a:ext uri="{FF2B5EF4-FFF2-40B4-BE49-F238E27FC236}">
-                <a16:creationId xmlns:a16="http://schemas.microsoft.com/office/drawing/2014/main" id="{57BAC73E-D2A7-4D4A-9349-68DB9CFB10DD}"/>
+          <p:cNvPr id="11" name="eyebrow">
+            <a:extLst xmlns:a="http://schemas.openxmlformats.org/drawingml/2006/main">
+              <a:ext uri="{FF2B5EF4-FFF2-40B4-BE49-F238E27FC236}">
+                <a16:creationId xmlns:a16="http://schemas.microsoft.com/office/drawing/2014/main" id="{70955F5E-BD6B-4C28-8BF5-C0DD89D19D90}"/>
               </a:ext>
             </a:extLst>
           </p:cNvPr>
@@ -12184,7 +12523,7 @@
           <p:cNvPr id="2" name="slide-title">
             <a:extLst xmlns:a="http://schemas.openxmlformats.org/drawingml/2006/main">
               <a:ext uri="{FF2B5EF4-FFF2-40B4-BE49-F238E27FC236}">
-                <a16:creationId xmlns:a16="http://schemas.microsoft.com/office/drawing/2014/main" id="{9E49A496-ADB7-44D5-A8FE-A3202E53D6E8}"/>
+                <a16:creationId xmlns:a16="http://schemas.microsoft.com/office/drawing/2014/main" id="{BFCB8B29-72B2-4C8B-A230-039C0C68762C}"/>
               </a:ext>
             </a:extLst>
           </p:cNvPr>
@@ -12231,7 +12570,7 @@
                 <a:ea typeface="Helvetica Neue"/>
                 <a:cs typeface="Helvetica Neue"/>
               </a:rPr>
-              <a:t>Lab 2: Compare two resolutions of the same wait</a:t>
+              <a:t>The Session pooler URL supplies the connection</a:t>
             </a:r>
           </a:p>
         </p:txBody>
@@ -12241,7 +12580,7 @@
           <p:cNvPr id="3" name="">
             <a:extLst xmlns:a="http://schemas.openxmlformats.org/drawingml/2006/main">
               <a:ext uri="{FF2B5EF4-FFF2-40B4-BE49-F238E27FC236}">
-                <a16:creationId xmlns:a16="http://schemas.microsoft.com/office/drawing/2014/main" id="{7EEB1497-A607-436A-AE81-FCFD58057B31}"/>
+                <a16:creationId xmlns:a16="http://schemas.microsoft.com/office/drawing/2014/main" id="{B96D74BB-DC09-40D2-9D9E-F0F201799A91}"/>
               </a:ext>
             </a:extLst>
           </p:cNvPr>
@@ -12273,7 +12612,7 @@
           <p:cNvPr id="4" name="slide-number">
             <a:extLst xmlns:a="http://schemas.openxmlformats.org/drawingml/2006/main">
               <a:ext uri="{FF2B5EF4-FFF2-40B4-BE49-F238E27FC236}">
-                <a16:creationId xmlns:a16="http://schemas.microsoft.com/office/drawing/2014/main" id="{7AA75051-BBE8-43C6-8A02-1A3B18F38B94}"/>
+                <a16:creationId xmlns:a16="http://schemas.microsoft.com/office/drawing/2014/main" id="{F8E08BF5-7C04-4011-926F-083D73F87BB8}"/>
               </a:ext>
             </a:extLst>
           </p:cNvPr>
@@ -12327,10 +12666,10 @@
       </p:sp>
       <p:sp>
         <p:nvSpPr>
-          <p:cNvPr id="5" name="lab2">
-            <a:extLst xmlns:a="http://schemas.openxmlformats.org/drawingml/2006/main">
-              <a:ext uri="{FF2B5EF4-FFF2-40B4-BE49-F238E27FC236}">
-                <a16:creationId xmlns:a16="http://schemas.microsoft.com/office/drawing/2014/main" id="{A88B9639-336B-4EEF-BD8D-47F887441713}"/>
+          <p:cNvPr id="5" name="copy-url">
+            <a:extLst xmlns:a="http://schemas.openxmlformats.org/drawingml/2006/main">
+              <a:ext uri="{FF2B5EF4-FFF2-40B4-BE49-F238E27FC236}">
+                <a16:creationId xmlns:a16="http://schemas.microsoft.com/office/drawing/2014/main" id="{97D465DF-648F-4C06-A1C2-22AABAB93830}"/>
               </a:ext>
             </a:extLst>
           </p:cNvPr>
@@ -12342,7 +12681,7 @@
         <p:spPr>
           <a:xfrm xmlns:a="http://schemas.openxmlformats.org/drawingml/2006/main">
             <a:off x="723900" y="1743075"/>
-            <a:ext cx="10668000" cy="590550"/>
+            <a:ext cx="10668000" cy="1390650"/>
           </a:xfrm>
           <a:prstGeom xmlns:a="http://schemas.openxmlformats.org/drawingml/2006/main" prst="rect">
             <a:avLst/>
@@ -12359,47 +12698,93 @@
           <a:lstStyle xmlns:a="http://schemas.openxmlformats.org/drawingml/2006/main"/>
           <a:p xmlns:a="http://schemas.openxmlformats.org/drawingml/2006/main">
             <a:pPr>
-              <a:defRPr sz="2400" b="1">
-                <a:solidFill>
-                  <a:srgbClr val="BF3E05"/>
-                </a:solidFill>
-                <a:latin typeface="Helvetica Neue"/>
-                <a:ea typeface="Helvetica Neue"/>
-                <a:cs typeface="Helvetica Neue"/>
-              </a:defRPr>
-            </a:pPr>
-            <a:r>
-              <a:rPr sz="2400" b="1">
-                <a:solidFill>
-                  <a:srgbClr val="BF3E05"/>
-                </a:solidFill>
-                <a:latin typeface="Helvetica Neue"/>
-                <a:ea typeface="Helvetica Neue"/>
-                <a:cs typeface="Helvetica Neue"/>
-              </a:rPr>
-              <a:t>Individual work in Notebook 02</a:t>
-            </a:r>
-          </a:p>
-        </p:txBody>
-      </p:sp>
-      <p:sp>
-        <p:nvSpPr>
-          <p:cNvPr id="6" name="lab2-action">
-            <a:extLst xmlns:a="http://schemas.openxmlformats.org/drawingml/2006/main">
-              <a:ext uri="{FF2B5EF4-FFF2-40B4-BE49-F238E27FC236}">
-                <a16:creationId xmlns:a16="http://schemas.microsoft.com/office/drawing/2014/main" id="{102DE16F-6586-49F0-AD06-8CCD0E2CE17B}"/>
-              </a:ext>
-            </a:extLst>
-          </p:cNvPr>
-          <p:cNvSpPr>
-            <a:spLocks xmlns:a="http://schemas.openxmlformats.org/drawingml/2006/main" noGrp="1"/>
-          </p:cNvSpPr>
-          <p:nvPr/>
-        </p:nvSpPr>
-        <p:spPr>
-          <a:xfrm xmlns:a="http://schemas.openxmlformats.org/drawingml/2006/main">
-            <a:off x="723900" y="2752725"/>
-            <a:ext cx="10668000" cy="1285875"/>
+              <a:defRPr sz="2100" b="0">
+                <a:solidFill>
+                  <a:srgbClr val="111827"/>
+                </a:solidFill>
+                <a:latin typeface="Helvetica Neue"/>
+                <a:ea typeface="Helvetica Neue"/>
+                <a:cs typeface="Helvetica Neue"/>
+              </a:defRPr>
+            </a:pPr>
+            <a:r>
+              <a:rPr sz="2100" b="0">
+                <a:solidFill>
+                  <a:srgbClr val="111827"/>
+                </a:solidFill>
+                <a:latin typeface="Helvetica Neue"/>
+                <a:ea typeface="Helvetica Neue"/>
+                <a:cs typeface="Helvetica Neue"/>
+              </a:rPr>
+              <a:t>1. In your Supabase project, click Connect.</a:t>
+            </a:r>
+          </a:p>
+          <a:p xmlns:a="http://schemas.openxmlformats.org/drawingml/2006/main">
+            <a:pPr>
+              <a:defRPr sz="2100" b="0">
+                <a:solidFill>
+                  <a:srgbClr val="111827"/>
+                </a:solidFill>
+                <a:latin typeface="Helvetica Neue"/>
+                <a:ea typeface="Helvetica Neue"/>
+                <a:cs typeface="Helvetica Neue"/>
+              </a:defRPr>
+            </a:pPr>
+            <a:r>
+              <a:rPr sz="2100" b="0">
+                <a:solidFill>
+                  <a:srgbClr val="111827"/>
+                </a:solidFill>
+                <a:latin typeface="Helvetica Neue"/>
+                <a:ea typeface="Helvetica Neue"/>
+                <a:cs typeface="Helvetica Neue"/>
+              </a:rPr>
+              <a:t>2. Choose Session pooler and copy the PostgreSQL URI.</a:t>
+            </a:r>
+          </a:p>
+          <a:p xmlns:a="http://schemas.openxmlformats.org/drawingml/2006/main">
+            <a:pPr>
+              <a:defRPr sz="2100" b="0">
+                <a:solidFill>
+                  <a:srgbClr val="111827"/>
+                </a:solidFill>
+                <a:latin typeface="Helvetica Neue"/>
+                <a:ea typeface="Helvetica Neue"/>
+                <a:cs typeface="Helvetica Neue"/>
+              </a:defRPr>
+            </a:pPr>
+            <a:r>
+              <a:rPr sz="2100" b="0">
+                <a:solidFill>
+                  <a:srgbClr val="111827"/>
+                </a:solidFill>
+                <a:latin typeface="Helvetica Neue"/>
+                <a:ea typeface="Helvetica Neue"/>
+                <a:cs typeface="Helvetica Neue"/>
+              </a:rPr>
+              <a:t>3. Replace [YOUR-PASSWORD] with your database password.</a:t>
+            </a:r>
+          </a:p>
+        </p:txBody>
+      </p:sp>
+      <p:sp>
+        <p:nvSpPr>
+          <p:cNvPr id="6" name="url-details">
+            <a:extLst xmlns:a="http://schemas.openxmlformats.org/drawingml/2006/main">
+              <a:ext uri="{FF2B5EF4-FFF2-40B4-BE49-F238E27FC236}">
+                <a16:creationId xmlns:a16="http://schemas.microsoft.com/office/drawing/2014/main" id="{6ABB462E-A76C-42CA-BC67-FBB8FA785400}"/>
+              </a:ext>
+            </a:extLst>
+          </p:cNvPr>
+          <p:cNvSpPr>
+            <a:spLocks xmlns:a="http://schemas.openxmlformats.org/drawingml/2006/main" noGrp="1"/>
+          </p:cNvSpPr>
+          <p:nvPr/>
+        </p:nvSpPr>
+        <p:spPr>
+          <a:xfrm xmlns:a="http://schemas.openxmlformats.org/drawingml/2006/main">
+            <a:off x="723900" y="3248025"/>
+            <a:ext cx="10668000" cy="742950"/>
           </a:xfrm>
           <a:prstGeom xmlns:a="http://schemas.openxmlformats.org/drawingml/2006/main" prst="rect">
             <a:avLst/>
@@ -12416,70 +12801,102 @@
           <a:lstStyle xmlns:a="http://schemas.openxmlformats.org/drawingml/2006/main"/>
           <a:p xmlns:a="http://schemas.openxmlformats.org/drawingml/2006/main">
             <a:pPr>
-              <a:defRPr sz="2325" b="0">
-                <a:solidFill>
-                  <a:srgbClr val="111827"/>
-                </a:solidFill>
-                <a:latin typeface="Helvetica Neue"/>
-                <a:ea typeface="Helvetica Neue"/>
-                <a:cs typeface="Helvetica Neue"/>
-              </a:defRPr>
-            </a:pPr>
-            <a:r>
-              <a:rPr sz="2325" b="0">
-                <a:solidFill>
-                  <a:srgbClr val="111827"/>
-                </a:solidFill>
-                <a:latin typeface="Helvetica Neue"/>
-                <a:ea typeface="Helvetica Neue"/>
-                <a:cs typeface="Helvetica Neue"/>
-              </a:rPr>
-              <a:t>Run the rollback case and keep its final row.</a:t>
-            </a:r>
-          </a:p>
-          <a:p xmlns:a="http://schemas.openxmlformats.org/drawingml/2006/main">
-            <a:pPr>
-              <a:defRPr sz="2325" b="0">
-                <a:solidFill>
-                  <a:srgbClr val="111827"/>
-                </a:solidFill>
-                <a:latin typeface="Helvetica Neue"/>
-                <a:ea typeface="Helvetica Neue"/>
-                <a:cs typeface="Helvetica Neue"/>
-              </a:defRPr>
-            </a:pPr>
-            <a:r>
-              <a:rPr sz="2325" b="0">
-                <a:solidFill>
-                  <a:srgbClr val="111827"/>
-                </a:solidFill>
-                <a:latin typeface="Helvetica Neue"/>
-                <a:ea typeface="Helvetica Neue"/>
-                <a:cs typeface="Helvetica Neue"/>
-              </a:rPr>
-              <a:t>Predict the commit case, then change the setting and rerun.</a:t>
-            </a:r>
-          </a:p>
-        </p:txBody>
-      </p:sp>
-      <p:sp>
-        <p:nvSpPr>
-          <p:cNvPr id="7" name="lab2-explain">
-            <a:extLst xmlns:a="http://schemas.openxmlformats.org/drawingml/2006/main">
-              <a:ext uri="{FF2B5EF4-FFF2-40B4-BE49-F238E27FC236}">
-                <a16:creationId xmlns:a16="http://schemas.microsoft.com/office/drawing/2014/main" id="{22F32B02-4C01-4F71-90E9-AE8C988647BA}"/>
-              </a:ext>
-            </a:extLst>
-          </p:cNvPr>
-          <p:cNvSpPr>
-            <a:spLocks xmlns:a="http://schemas.openxmlformats.org/drawingml/2006/main" noGrp="1"/>
-          </p:cNvSpPr>
-          <p:nvPr/>
-        </p:nvSpPr>
-        <p:spPr>
-          <a:xfrm xmlns:a="http://schemas.openxmlformats.org/drawingml/2006/main">
-            <a:off x="723900" y="4629150"/>
-            <a:ext cx="10668000" cy="942975"/>
+              <a:defRPr sz="1875" b="0">
+                <a:solidFill>
+                  <a:srgbClr val="111827"/>
+                </a:solidFill>
+                <a:latin typeface="Helvetica Neue"/>
+                <a:ea typeface="Helvetica Neue"/>
+                <a:cs typeface="Helvetica Neue"/>
+              </a:defRPr>
+            </a:pPr>
+            <a:r>
+              <a:rPr sz="1875" b="0">
+                <a:solidFill>
+                  <a:srgbClr val="111827"/>
+                </a:solidFill>
+                <a:latin typeface="Helvetica Neue"/>
+                <a:ea typeface="Helvetica Neue"/>
+                <a:cs typeface="Helvetica Neue"/>
+              </a:rPr>
+              <a:t>Keep the copied host and username. Use the database password.</a:t>
+            </a:r>
+          </a:p>
+          <a:p xmlns:a="http://schemas.openxmlformats.org/drawingml/2006/main">
+            <a:pPr>
+              <a:defRPr sz="1875" b="0">
+                <a:solidFill>
+                  <a:srgbClr val="111827"/>
+                </a:solidFill>
+                <a:latin typeface="Helvetica Neue"/>
+                <a:ea typeface="Helvetica Neue"/>
+                <a:cs typeface="Helvetica Neue"/>
+              </a:defRPr>
+            </a:pPr>
+            <a:r>
+              <a:rPr sz="1875" b="0">
+                <a:solidFill>
+                  <a:srgbClr val="111827"/>
+                </a:solidFill>
+                <a:latin typeface="Helvetica Neue"/>
+                <a:ea typeface="Helvetica Neue"/>
+                <a:cs typeface="Helvetica Neue"/>
+              </a:rPr>
+              <a:t>An API key or Supabase website password will not work here.</a:t>
+            </a:r>
+          </a:p>
+        </p:txBody>
+      </p:sp>
+      <p:sp>
+        <p:nvSpPr>
+          <p:cNvPr id="7" name="">
+            <a:extLst xmlns:a="http://schemas.openxmlformats.org/drawingml/2006/main">
+              <a:ext uri="{FF2B5EF4-FFF2-40B4-BE49-F238E27FC236}">
+                <a16:creationId xmlns:a16="http://schemas.microsoft.com/office/drawing/2014/main" id="{596D7860-04FB-4D74-8938-A66EF08BBD52}"/>
+              </a:ext>
+            </a:extLst>
+          </p:cNvPr>
+          <p:cNvSpPr>
+            <a:spLocks xmlns:a="http://schemas.openxmlformats.org/drawingml/2006/main" noGrp="1"/>
+          </p:cNvSpPr>
+          <p:nvPr/>
+        </p:nvSpPr>
+        <p:spPr>
+          <a:xfrm xmlns:a="http://schemas.openxmlformats.org/drawingml/2006/main">
+            <a:off x="685800" y="4171950"/>
+            <a:ext cx="10820400" cy="1009650"/>
+          </a:xfrm>
+          <a:prstGeom xmlns:a="http://schemas.openxmlformats.org/drawingml/2006/main" prst="rect">
+            <a:avLst/>
+          </a:prstGeom>
+          <a:solidFill xmlns:a="http://schemas.openxmlformats.org/drawingml/2006/main">
+            <a:srgbClr val="101728"/>
+          </a:solidFill>
+          <a:ln xmlns:a="http://schemas.openxmlformats.org/drawingml/2006/main" w="0">
+            <a:solidFill>
+              <a:srgbClr val="101728"/>
+            </a:solidFill>
+          </a:ln>
+        </p:spPr>
+      </p:sp>
+      <p:sp>
+        <p:nvSpPr>
+          <p:cNvPr id="8" name="ssl-ending">
+            <a:extLst xmlns:a="http://schemas.openxmlformats.org/drawingml/2006/main">
+              <a:ext uri="{FF2B5EF4-FFF2-40B4-BE49-F238E27FC236}">
+                <a16:creationId xmlns:a16="http://schemas.microsoft.com/office/drawing/2014/main" id="{2C428F84-9BC9-4C98-B3F3-40D1138CB713}"/>
+              </a:ext>
+            </a:extLst>
+          </p:cNvPr>
+          <p:cNvSpPr>
+            <a:spLocks xmlns:a="http://schemas.openxmlformats.org/drawingml/2006/main" noGrp="1"/>
+          </p:cNvSpPr>
+          <p:nvPr/>
+        </p:nvSpPr>
+        <p:spPr>
+          <a:xfrm xmlns:a="http://schemas.openxmlformats.org/drawingml/2006/main">
+            <a:off x="876300" y="4343400"/>
+            <a:ext cx="10439400" cy="666750"/>
           </a:xfrm>
           <a:prstGeom xmlns:a="http://schemas.openxmlformats.org/drawingml/2006/main" prst="rect">
             <a:avLst/>
@@ -12496,47 +12913,70 @@
           <a:lstStyle xmlns:a="http://schemas.openxmlformats.org/drawingml/2006/main"/>
           <a:p xmlns:a="http://schemas.openxmlformats.org/drawingml/2006/main">
             <a:pPr>
-              <a:defRPr sz="2250" b="0">
-                <a:solidFill>
-                  <a:srgbClr val="111827"/>
-                </a:solidFill>
-                <a:latin typeface="Helvetica Neue"/>
-                <a:ea typeface="Helvetica Neue"/>
-                <a:cs typeface="Helvetica Neue"/>
-              </a:defRPr>
-            </a:pPr>
-            <a:r>
-              <a:rPr sz="2250" b="0">
-                <a:solidFill>
-                  <a:srgbClr val="111827"/>
-                </a:solidFill>
-                <a:latin typeface="Helvetica Neue"/>
-                <a:ea typeface="Helvetica Neue"/>
-                <a:cs typeface="Helvetica Neue"/>
-              </a:rPr>
-              <a:t>In the final Markdown cell: complete the comparison and explain the wait to the developer.</a:t>
-            </a:r>
-          </a:p>
-        </p:txBody>
-      </p:sp>
-      <p:sp>
-        <p:nvSpPr>
-          <p:cNvPr id="8" name="lab2-submit">
-            <a:extLst xmlns:a="http://schemas.openxmlformats.org/drawingml/2006/main">
-              <a:ext uri="{FF2B5EF4-FFF2-40B4-BE49-F238E27FC236}">
-                <a16:creationId xmlns:a16="http://schemas.microsoft.com/office/drawing/2014/main" id="{C2D7D17B-AFB8-4ABD-BBEF-BB8D707EDF53}"/>
-              </a:ext>
-            </a:extLst>
-          </p:cNvPr>
-          <p:cNvSpPr>
-            <a:spLocks xmlns:a="http://schemas.openxmlformats.org/drawingml/2006/main" noGrp="1"/>
-          </p:cNvSpPr>
-          <p:nvPr/>
-        </p:nvSpPr>
-        <p:spPr>
-          <a:xfrm xmlns:a="http://schemas.openxmlformats.org/drawingml/2006/main">
-            <a:off x="723900" y="6029325"/>
-            <a:ext cx="10668000" cy="409575"/>
+              <a:defRPr sz="1875" b="0">
+                <a:solidFill>
+                  <a:srgbClr val="E2E8F0"/>
+                </a:solidFill>
+                <a:latin typeface="Menlo"/>
+                <a:ea typeface="Menlo"/>
+                <a:cs typeface="Menlo"/>
+              </a:defRPr>
+            </a:pPr>
+            <a:r>
+              <a:rPr sz="1875" b="0">
+                <a:solidFill>
+                  <a:srgbClr val="E2E8F0"/>
+                </a:solidFill>
+                <a:latin typeface="Menlo"/>
+                <a:ea typeface="Menlo"/>
+                <a:cs typeface="Menlo"/>
+              </a:rPr>
+              <a:t>URL ending before:  /postgres</a:t>
+            </a:r>
+          </a:p>
+          <a:p xmlns:a="http://schemas.openxmlformats.org/drawingml/2006/main">
+            <a:pPr>
+              <a:defRPr sz="1875" b="0">
+                <a:solidFill>
+                  <a:srgbClr val="E2E8F0"/>
+                </a:solidFill>
+                <a:latin typeface="Menlo"/>
+                <a:ea typeface="Menlo"/>
+                <a:cs typeface="Menlo"/>
+              </a:defRPr>
+            </a:pPr>
+            <a:r>
+              <a:rPr sz="1875" b="0">
+                <a:solidFill>
+                  <a:srgbClr val="E2E8F0"/>
+                </a:solidFill>
+                <a:latin typeface="Menlo"/>
+                <a:ea typeface="Menlo"/>
+                <a:cs typeface="Menlo"/>
+              </a:rPr>
+              <a:t>URL ending after:   /postgres?sslmode=require</a:t>
+            </a:r>
+          </a:p>
+        </p:txBody>
+      </p:sp>
+      <p:sp>
+        <p:nvSpPr>
+          <p:cNvPr id="9" name="url-encoding">
+            <a:extLst xmlns:a="http://schemas.openxmlformats.org/drawingml/2006/main">
+              <a:ext uri="{FF2B5EF4-FFF2-40B4-BE49-F238E27FC236}">
+                <a16:creationId xmlns:a16="http://schemas.microsoft.com/office/drawing/2014/main" id="{68DE416A-168F-406E-90E8-8AAC3139C119}"/>
+              </a:ext>
+            </a:extLst>
+          </p:cNvPr>
+          <p:cNvSpPr>
+            <a:spLocks xmlns:a="http://schemas.openxmlformats.org/drawingml/2006/main" noGrp="1"/>
+          </p:cNvSpPr>
+          <p:nvPr/>
+        </p:nvSpPr>
+        <p:spPr>
+          <a:xfrm xmlns:a="http://schemas.openxmlformats.org/drawingml/2006/main">
+            <a:off x="723900" y="5400675"/>
+            <a:ext cx="10668000" cy="657225"/>
           </a:xfrm>
           <a:prstGeom xmlns:a="http://schemas.openxmlformats.org/drawingml/2006/main" prst="rect">
             <a:avLst/>
@@ -12571,7 +13011,87 @@
                 <a:ea typeface="Helvetica Neue"/>
                 <a:cs typeface="Helvetica Neue"/>
               </a:rPr>
-              <a:t>Brightspace: the completed notebook. Run cleanup after each experiment.</a:t>
+              <a:t>Password symbols need URL encoding: @ becomes %40 and # becomes %23.</a:t>
+            </a:r>
+          </a:p>
+          <a:p xmlns:a="http://schemas.openxmlformats.org/drawingml/2006/main">
+            <a:pPr>
+              <a:defRPr sz="1725" b="0">
+                <a:solidFill>
+                  <a:srgbClr val="111827"/>
+                </a:solidFill>
+                <a:latin typeface="Helvetica Neue"/>
+                <a:ea typeface="Helvetica Neue"/>
+                <a:cs typeface="Helvetica Neue"/>
+              </a:defRPr>
+            </a:pPr>
+            <a:r>
+              <a:rPr sz="1725" b="0">
+                <a:solidFill>
+                  <a:srgbClr val="111827"/>
+                </a:solidFill>
+                <a:latin typeface="Helvetica Neue"/>
+                <a:ea typeface="Helvetica Neue"/>
+                <a:cs typeface="Helvetica Neue"/>
+              </a:rPr>
+              <a:t>If the URL already has a query, add &amp;sslmode=require instead.</a:t>
+            </a:r>
+          </a:p>
+        </p:txBody>
+      </p:sp>
+      <p:sp>
+        <p:nvSpPr>
+          <p:cNvPr id="10" name="credential-place">
+            <a:extLst xmlns:a="http://schemas.openxmlformats.org/drawingml/2006/main">
+              <a:ext uri="{FF2B5EF4-FFF2-40B4-BE49-F238E27FC236}">
+                <a16:creationId xmlns:a16="http://schemas.microsoft.com/office/drawing/2014/main" id="{8EFF1769-5EA7-4ADA-AAFE-EE6A37E91E97}"/>
+              </a:ext>
+            </a:extLst>
+          </p:cNvPr>
+          <p:cNvSpPr>
+            <a:spLocks xmlns:a="http://schemas.openxmlformats.org/drawingml/2006/main" noGrp="1"/>
+          </p:cNvSpPr>
+          <p:nvPr/>
+        </p:nvSpPr>
+        <p:spPr>
+          <a:xfrm xmlns:a="http://schemas.openxmlformats.org/drawingml/2006/main">
+            <a:off x="723900" y="6153150"/>
+            <a:ext cx="10668000" cy="304800"/>
+          </a:xfrm>
+          <a:prstGeom xmlns:a="http://schemas.openxmlformats.org/drawingml/2006/main" prst="rect">
+            <a:avLst/>
+          </a:prstGeom>
+          <a:noFill xmlns:a="http://schemas.openxmlformats.org/drawingml/2006/main"/>
+          <a:ln xmlns:a="http://schemas.openxmlformats.org/drawingml/2006/main" w="0">
+            <a:noFill/>
+          </a:ln>
+        </p:spPr>
+        <p:txBody>
+          <a:bodyPr xmlns:a="http://schemas.openxmlformats.org/drawingml/2006/main" wrap="square" lIns="0" tIns="0" rIns="0" bIns="0" anchor="t">
+            <a:noAutofit/>
+          </a:bodyPr>
+          <a:lstStyle xmlns:a="http://schemas.openxmlformats.org/drawingml/2006/main"/>
+          <a:p xmlns:a="http://schemas.openxmlformats.org/drawingml/2006/main">
+            <a:pPr>
+              <a:defRPr sz="1725" b="1">
+                <a:solidFill>
+                  <a:srgbClr val="BF3E05"/>
+                </a:solidFill>
+                <a:latin typeface="Helvetica Neue"/>
+                <a:ea typeface="Helvetica Neue"/>
+                <a:cs typeface="Helvetica Neue"/>
+              </a:defRPr>
+            </a:pPr>
+            <a:r>
+              <a:rPr sz="1725" b="1">
+                <a:solidFill>
+                  <a:srgbClr val="BF3E05"/>
+                </a:solidFill>
+                <a:latin typeface="Helvetica Neue"/>
+                <a:ea typeface="Helvetica Neue"/>
+                <a:cs typeface="Helvetica Neue"/>
+              </a:rPr>
+              <a:t>Paste the finished URL only into Colab's hidden connection prompt.</a:t>
             </a:r>
           </a:p>
         </p:txBody>
@@ -12607,10 +13127,10 @@
       </p:grpSpPr>
       <p:sp>
         <p:nvSpPr>
-          <p:cNvPr id="9" name="eyebrow">
-            <a:extLst xmlns:a="http://schemas.openxmlformats.org/drawingml/2006/main">
-              <a:ext uri="{FF2B5EF4-FFF2-40B4-BE49-F238E27FC236}">
-                <a16:creationId xmlns:a16="http://schemas.microsoft.com/office/drawing/2014/main" id="{DE53486C-4EA6-415F-A6E7-1708019FDAC6}"/>
+          <p:cNvPr id="12" name="eyebrow">
+            <a:extLst xmlns:a="http://schemas.openxmlformats.org/drawingml/2006/main">
+              <a:ext uri="{FF2B5EF4-FFF2-40B4-BE49-F238E27FC236}">
+                <a16:creationId xmlns:a16="http://schemas.microsoft.com/office/drawing/2014/main" id="{A4FF8C7F-5A10-421D-A582-78DD829A9FE1}"/>
               </a:ext>
             </a:extLst>
           </p:cNvPr>
@@ -12667,7 +13187,7 @@
           <p:cNvPr id="2" name="slide-title">
             <a:extLst xmlns:a="http://schemas.openxmlformats.org/drawingml/2006/main">
               <a:ext uri="{FF2B5EF4-FFF2-40B4-BE49-F238E27FC236}">
-                <a16:creationId xmlns:a16="http://schemas.microsoft.com/office/drawing/2014/main" id="{60B33121-F811-4889-A35E-5F3558856DE6}"/>
+                <a16:creationId xmlns:a16="http://schemas.microsoft.com/office/drawing/2014/main" id="{50BF8793-5F69-46F4-8632-07CE130C0EFA}"/>
               </a:ext>
             </a:extLst>
           </p:cNvPr>
@@ -12714,7 +13234,7 @@
                 <a:ea typeface="Helvetica Neue"/>
                 <a:cs typeface="Helvetica Neue"/>
               </a:rPr>
-              <a:t>A useful incident update explains the data too</a:t>
+              <a:t>The first run starts with a connection check</a:t>
             </a:r>
           </a:p>
         </p:txBody>
@@ -12724,7 +13244,7 @@
           <p:cNvPr id="3" name="">
             <a:extLst xmlns:a="http://schemas.openxmlformats.org/drawingml/2006/main">
               <a:ext uri="{FF2B5EF4-FFF2-40B4-BE49-F238E27FC236}">
-                <a16:creationId xmlns:a16="http://schemas.microsoft.com/office/drawing/2014/main" id="{72F8F3A2-A947-4061-B718-7A0948BDC0F5}"/>
+                <a16:creationId xmlns:a16="http://schemas.microsoft.com/office/drawing/2014/main" id="{C472E52F-009B-45B6-BED8-463B35A8C217}"/>
               </a:ext>
             </a:extLst>
           </p:cNvPr>
@@ -12756,7 +13276,7 @@
           <p:cNvPr id="4" name="slide-number">
             <a:extLst xmlns:a="http://schemas.openxmlformats.org/drawingml/2006/main">
               <a:ext uri="{FF2B5EF4-FFF2-40B4-BE49-F238E27FC236}">
-                <a16:creationId xmlns:a16="http://schemas.microsoft.com/office/drawing/2014/main" id="{16D69F16-E9A2-45D4-941D-14AB623F4770}"/>
+                <a16:creationId xmlns:a16="http://schemas.microsoft.com/office/drawing/2014/main" id="{6F840B43-4277-41D9-B665-54CEC529C1AB}"/>
               </a:ext>
             </a:extLst>
           </p:cNvPr>
@@ -12813,51 +13333,51 @@
           <p:cNvPr id="5" name="">
             <a:extLst xmlns:a="http://schemas.openxmlformats.org/drawingml/2006/main">
               <a:ext uri="{FF2B5EF4-FFF2-40B4-BE49-F238E27FC236}">
-                <a16:creationId xmlns:a16="http://schemas.microsoft.com/office/drawing/2014/main" id="{9028C468-EF8C-4409-A630-9A06AF0720BE}"/>
-              </a:ext>
-            </a:extLst>
-          </p:cNvPr>
-          <p:cNvSpPr>
-            <a:spLocks xmlns:a="http://schemas.openxmlformats.org/drawingml/2006/main" noGrp="1"/>
-          </p:cNvSpPr>
-          <p:nvPr/>
-        </p:nvSpPr>
-        <p:spPr>
-          <a:xfrm xmlns:a="http://schemas.openxmlformats.org/drawingml/2006/main">
-            <a:off x="685800" y="1819275"/>
-            <a:ext cx="10820400" cy="2057400"/>
+                <a16:creationId xmlns:a16="http://schemas.microsoft.com/office/drawing/2014/main" id="{0E25563F-EA2E-4CB2-B394-D3C73CF795DF}"/>
+              </a:ext>
+            </a:extLst>
+          </p:cNvPr>
+          <p:cNvSpPr>
+            <a:spLocks xmlns:a="http://schemas.openxmlformats.org/drawingml/2006/main" noGrp="1"/>
+          </p:cNvSpPr>
+          <p:nvPr/>
+        </p:nvSpPr>
+        <p:spPr>
+          <a:xfrm xmlns:a="http://schemas.openxmlformats.org/drawingml/2006/main">
+            <a:off x="685800" y="1695450"/>
+            <a:ext cx="10820400" cy="1000125"/>
           </a:xfrm>
           <a:prstGeom xmlns:a="http://schemas.openxmlformats.org/drawingml/2006/main" prst="rect">
             <a:avLst/>
           </a:prstGeom>
           <a:solidFill xmlns:a="http://schemas.openxmlformats.org/drawingml/2006/main">
-            <a:srgbClr val="FFF0E6"/>
+            <a:srgbClr val="101728"/>
           </a:solidFill>
           <a:ln xmlns:a="http://schemas.openxmlformats.org/drawingml/2006/main" w="0">
             <a:solidFill>
-              <a:srgbClr val="FFF0E6"/>
+              <a:srgbClr val="101728"/>
             </a:solidFill>
           </a:ln>
         </p:spPr>
       </p:sp>
       <p:sp>
         <p:nvSpPr>
-          <p:cNvPr id="6" name="sample-update">
-            <a:extLst xmlns:a="http://schemas.openxmlformats.org/drawingml/2006/main">
-              <a:ext uri="{FF2B5EF4-FFF2-40B4-BE49-F238E27FC236}">
-                <a16:creationId xmlns:a16="http://schemas.microsoft.com/office/drawing/2014/main" id="{D0EC1275-453F-49DA-9397-73FC45D91B16}"/>
-              </a:ext>
-            </a:extLst>
-          </p:cNvPr>
-          <p:cNvSpPr>
-            <a:spLocks xmlns:a="http://schemas.openxmlformats.org/drawingml/2006/main" noGrp="1"/>
-          </p:cNvSpPr>
-          <p:nvPr/>
-        </p:nvSpPr>
-        <p:spPr>
-          <a:xfrm xmlns:a="http://schemas.openxmlformats.org/drawingml/2006/main">
-            <a:off x="876300" y="1990725"/>
-            <a:ext cx="10439400" cy="1714500"/>
+          <p:cNvPr id="6" name="flags">
+            <a:extLst xmlns:a="http://schemas.openxmlformats.org/drawingml/2006/main">
+              <a:ext uri="{FF2B5EF4-FFF2-40B4-BE49-F238E27FC236}">
+                <a16:creationId xmlns:a16="http://schemas.microsoft.com/office/drawing/2014/main" id="{3B04AA3A-F15F-42B3-98B3-F1509AAF5FEF}"/>
+              </a:ext>
+            </a:extLst>
+          </p:cNvPr>
+          <p:cNvSpPr>
+            <a:spLocks xmlns:a="http://schemas.openxmlformats.org/drawingml/2006/main" noGrp="1"/>
+          </p:cNvSpPr>
+          <p:nvPr/>
+        </p:nvSpPr>
+        <p:spPr>
+          <a:xfrm xmlns:a="http://schemas.openxmlformats.org/drawingml/2006/main">
+            <a:off x="876300" y="1866900"/>
+            <a:ext cx="10439400" cy="657225"/>
           </a:xfrm>
           <a:prstGeom xmlns:a="http://schemas.openxmlformats.org/drawingml/2006/main" prst="rect">
             <a:avLst/>
@@ -12874,47 +13394,70 @@
           <a:lstStyle xmlns:a="http://schemas.openxmlformats.org/drawingml/2006/main"/>
           <a:p xmlns:a="http://schemas.openxmlformats.org/drawingml/2006/main">
             <a:pPr>
-              <a:defRPr sz="2325" b="0">
-                <a:solidFill>
-                  <a:srgbClr val="111827"/>
-                </a:solidFill>
-                <a:latin typeface="Helvetica Neue"/>
-                <a:ea typeface="Helvetica Neue"/>
-                <a:cs typeface="Helvetica Neue"/>
-              </a:defRPr>
-            </a:pPr>
-            <a:r>
-              <a:rPr sz="2325" b="0">
-                <a:solidFill>
-                  <a:srgbClr val="111827"/>
-                </a:solidFill>
-                <a:latin typeface="Helvetica Neue"/>
-                <a:ea typeface="Helvetica Neue"/>
-                <a:cs typeface="Helvetica Neue"/>
-              </a:rPr>
-              <a:t>The status update waited for A's uncommitted change to the same ticket. The captured result showed B's PID blocked by A's PID. Rolling back A let B finish: priority stayed medium and status became in_progress.</a:t>
-            </a:r>
-          </a:p>
-        </p:txBody>
-      </p:sp>
-      <p:sp>
-        <p:nvSpPr>
-          <p:cNvPr id="7" name="interpret">
-            <a:extLst xmlns:a="http://schemas.openxmlformats.org/drawingml/2006/main">
-              <a:ext uri="{FF2B5EF4-FFF2-40B4-BE49-F238E27FC236}">
-                <a16:creationId xmlns:a16="http://schemas.microsoft.com/office/drawing/2014/main" id="{EFA5FBA4-90D1-4845-91F7-3A398C5D2FD1}"/>
-              </a:ext>
-            </a:extLst>
-          </p:cNvPr>
-          <p:cNvSpPr>
-            <a:spLocks xmlns:a="http://schemas.openxmlformats.org/drawingml/2006/main" noGrp="1"/>
-          </p:cNvSpPr>
-          <p:nvPr/>
-        </p:nvSpPr>
-        <p:spPr>
-          <a:xfrm xmlns:a="http://schemas.openxmlformats.org/drawingml/2006/main">
-            <a:off x="723900" y="4429125"/>
-            <a:ext cx="10668000" cy="1133475"/>
+              <a:defRPr sz="1875" b="0">
+                <a:solidFill>
+                  <a:srgbClr val="E2E8F0"/>
+                </a:solidFill>
+                <a:latin typeface="Menlo"/>
+                <a:ea typeface="Menlo"/>
+                <a:cs typeface="Menlo"/>
+              </a:defRPr>
+            </a:pPr>
+            <a:r>
+              <a:rPr sz="1875" b="0">
+                <a:solidFill>
+                  <a:srgbClr val="E2E8F0"/>
+                </a:solidFill>
+                <a:latin typeface="Menlo"/>
+                <a:ea typeface="Menlo"/>
+                <a:cs typeface="Menlo"/>
+              </a:rPr>
+              <a:t>USE_CLOUD = True</a:t>
+            </a:r>
+          </a:p>
+          <a:p xmlns:a="http://schemas.openxmlformats.org/drawingml/2006/main">
+            <a:pPr>
+              <a:defRPr sz="1875" b="0">
+                <a:solidFill>
+                  <a:srgbClr val="E2E8F0"/>
+                </a:solidFill>
+                <a:latin typeface="Menlo"/>
+                <a:ea typeface="Menlo"/>
+                <a:cs typeface="Menlo"/>
+              </a:defRPr>
+            </a:pPr>
+            <a:r>
+              <a:rPr sz="1875" b="0">
+                <a:solidFill>
+                  <a:srgbClr val="E2E8F0"/>
+                </a:solidFill>
+                <a:latin typeface="Menlo"/>
+                <a:ea typeface="Menlo"/>
+                <a:cs typeface="Menlo"/>
+              </a:rPr>
+              <a:t>KEEP_A_CHANGE = False  # first run: rollback A</a:t>
+            </a:r>
+          </a:p>
+        </p:txBody>
+      </p:sp>
+      <p:sp>
+        <p:nvSpPr>
+          <p:cNvPr id="7" name="run-order">
+            <a:extLst xmlns:a="http://schemas.openxmlformats.org/drawingml/2006/main">
+              <a:ext uri="{FF2B5EF4-FFF2-40B4-BE49-F238E27FC236}">
+                <a16:creationId xmlns:a16="http://schemas.microsoft.com/office/drawing/2014/main" id="{CA56697D-3B91-4145-8A9C-FE9FDA2E8A56}"/>
+              </a:ext>
+            </a:extLst>
+          </p:cNvPr>
+          <p:cNvSpPr>
+            <a:spLocks xmlns:a="http://schemas.openxmlformats.org/drawingml/2006/main" noGrp="1"/>
+          </p:cNvSpPr>
+          <p:nvPr/>
+        </p:nvSpPr>
+        <p:spPr>
+          <a:xfrm xmlns:a="http://schemas.openxmlformats.org/drawingml/2006/main">
+            <a:off x="723900" y="3000375"/>
+            <a:ext cx="10668000" cy="819150"/>
           </a:xfrm>
           <a:prstGeom xmlns:a="http://schemas.openxmlformats.org/drawingml/2006/main" prst="rect">
             <a:avLst/>
@@ -12931,47 +13474,102 @@
           <a:lstStyle xmlns:a="http://schemas.openxmlformats.org/drawingml/2006/main"/>
           <a:p xmlns:a="http://schemas.openxmlformats.org/drawingml/2006/main">
             <a:pPr>
-              <a:defRPr sz="2250" b="0">
-                <a:solidFill>
-                  <a:srgbClr val="111827"/>
-                </a:solidFill>
-                <a:latin typeface="Helvetica Neue"/>
-                <a:ea typeface="Helvetica Neue"/>
-                <a:cs typeface="Helvetica Neue"/>
-              </a:defRPr>
-            </a:pPr>
-            <a:r>
-              <a:rPr sz="2250" b="0">
-                <a:solidFill>
-                  <a:srgbClr val="111827"/>
-                </a:solidFill>
-                <a:latin typeface="Helvetica Neue"/>
-                <a:ea typeface="Helvetica Neue"/>
-                <a:cs typeface="Helvetica Neue"/>
-              </a:rPr>
-              <a:t>In your comparison, explain how committing A changes that result. State why you could not choose blindly in a real application.</a:t>
-            </a:r>
-          </a:p>
-        </p:txBody>
-      </p:sp>
-      <p:sp>
-        <p:nvSpPr>
-          <p:cNvPr id="8" name="source-kind">
-            <a:extLst xmlns:a="http://schemas.openxmlformats.org/drawingml/2006/main">
-              <a:ext uri="{FF2B5EF4-FFF2-40B4-BE49-F238E27FC236}">
-                <a16:creationId xmlns:a16="http://schemas.microsoft.com/office/drawing/2014/main" id="{FBADCC9D-03D5-4FFE-BF3C-CCD91297EF77}"/>
-              </a:ext>
-            </a:extLst>
-          </p:cNvPr>
-          <p:cNvSpPr>
-            <a:spLocks xmlns:a="http://schemas.openxmlformats.org/drawingml/2006/main" noGrp="1"/>
-          </p:cNvSpPr>
-          <p:nvPr/>
-        </p:nvSpPr>
-        <p:spPr>
-          <a:xfrm xmlns:a="http://schemas.openxmlformats.org/drawingml/2006/main">
-            <a:off x="723900" y="6038850"/>
-            <a:ext cx="10668000" cy="409575"/>
+              <a:defRPr sz="2100" b="0">
+                <a:solidFill>
+                  <a:srgbClr val="111827"/>
+                </a:solidFill>
+                <a:latin typeface="Helvetica Neue"/>
+                <a:ea typeface="Helvetica Neue"/>
+                <a:cs typeface="Helvetica Neue"/>
+              </a:defRPr>
+            </a:pPr>
+            <a:r>
+              <a:rPr sz="2100" b="0">
+                <a:solidFill>
+                  <a:srgbClr val="111827"/>
+                </a:solidFill>
+                <a:latin typeface="Helvetica Neue"/>
+                <a:ea typeface="Helvetica Neue"/>
+                <a:cs typeface="Helvetica Neue"/>
+              </a:rPr>
+              <a:t>Run code cells from the top, one at a time.</a:t>
+            </a:r>
+          </a:p>
+          <a:p xmlns:a="http://schemas.openxmlformats.org/drawingml/2006/main">
+            <a:pPr>
+              <a:defRPr sz="2100" b="0">
+                <a:solidFill>
+                  <a:srgbClr val="111827"/>
+                </a:solidFill>
+                <a:latin typeface="Helvetica Neue"/>
+                <a:ea typeface="Helvetica Neue"/>
+                <a:cs typeface="Helvetica Neue"/>
+              </a:defRPr>
+            </a:pPr>
+            <a:r>
+              <a:rPr sz="2100" b="0">
+                <a:solidFill>
+                  <a:srgbClr val="111827"/>
+                </a:solidFill>
+                <a:latin typeface="Helvetica Neue"/>
+                <a:ea typeface="Helvetica Neue"/>
+                <a:cs typeface="Helvetica Neue"/>
+              </a:rPr>
+              <a:t>In Section 1, paste the URL at the hidden prompt and press Enter.</a:t>
+            </a:r>
+          </a:p>
+        </p:txBody>
+      </p:sp>
+      <p:sp>
+        <p:nvSpPr>
+          <p:cNvPr id="8" name="">
+            <a:extLst xmlns:a="http://schemas.openxmlformats.org/drawingml/2006/main">
+              <a:ext uri="{FF2B5EF4-FFF2-40B4-BE49-F238E27FC236}">
+                <a16:creationId xmlns:a16="http://schemas.microsoft.com/office/drawing/2014/main" id="{A9303387-92DC-46B3-A2B2-38BFB03DF1DF}"/>
+              </a:ext>
+            </a:extLst>
+          </p:cNvPr>
+          <p:cNvSpPr>
+            <a:spLocks xmlns:a="http://schemas.openxmlformats.org/drawingml/2006/main" noGrp="1"/>
+          </p:cNvSpPr>
+          <p:nvPr/>
+        </p:nvSpPr>
+        <p:spPr>
+          <a:xfrm xmlns:a="http://schemas.openxmlformats.org/drawingml/2006/main">
+            <a:off x="685800" y="4010025"/>
+            <a:ext cx="10820400" cy="1028700"/>
+          </a:xfrm>
+          <a:prstGeom xmlns:a="http://schemas.openxmlformats.org/drawingml/2006/main" prst="rect">
+            <a:avLst/>
+          </a:prstGeom>
+          <a:solidFill xmlns:a="http://schemas.openxmlformats.org/drawingml/2006/main">
+            <a:srgbClr val="101728"/>
+          </a:solidFill>
+          <a:ln xmlns:a="http://schemas.openxmlformats.org/drawingml/2006/main" w="0">
+            <a:solidFill>
+              <a:srgbClr val="101728"/>
+            </a:solidFill>
+          </a:ln>
+        </p:spPr>
+      </p:sp>
+      <p:sp>
+        <p:nvSpPr>
+          <p:cNvPr id="9" name="connection-success">
+            <a:extLst xmlns:a="http://schemas.openxmlformats.org/drawingml/2006/main">
+              <a:ext uri="{FF2B5EF4-FFF2-40B4-BE49-F238E27FC236}">
+                <a16:creationId xmlns:a16="http://schemas.microsoft.com/office/drawing/2014/main" id="{8A67A71E-2113-4A39-B89B-6769094E962C}"/>
+              </a:ext>
+            </a:extLst>
+          </p:cNvPr>
+          <p:cNvSpPr>
+            <a:spLocks xmlns:a="http://schemas.openxmlformats.org/drawingml/2006/main" noGrp="1"/>
+          </p:cNvSpPr>
+          <p:nvPr/>
+        </p:nvSpPr>
+        <p:spPr>
+          <a:xfrm xmlns:a="http://schemas.openxmlformats.org/drawingml/2006/main">
+            <a:off x="876300" y="4181475"/>
+            <a:ext cx="10439400" cy="685800"/>
           </a:xfrm>
           <a:prstGeom xmlns:a="http://schemas.openxmlformats.org/drawingml/2006/main" prst="rect">
             <a:avLst/>
@@ -12990,23 +13588,183 @@
             <a:pPr>
               <a:defRPr sz="1725" b="0">
                 <a:solidFill>
-                  <a:srgbClr val="111827"/>
-                </a:solidFill>
-                <a:latin typeface="Helvetica Neue"/>
-                <a:ea typeface="Helvetica Neue"/>
-                <a:cs typeface="Helvetica Neue"/>
+                  <a:srgbClr val="E2E8F0"/>
+                </a:solidFill>
+                <a:latin typeface="Menlo"/>
+                <a:ea typeface="Menlo"/>
+                <a:cs typeface="Menlo"/>
               </a:defRPr>
             </a:pPr>
             <a:r>
               <a:rPr sz="1725" b="0">
                 <a:solidFill>
-                  <a:srgbClr val="111827"/>
-                </a:solidFill>
-                <a:latin typeface="Helvetica Neue"/>
-                <a:ea typeface="Helvetica Neue"/>
-                <a:cs typeface="Helvetica Neue"/>
-              </a:rPr>
-              <a:t>Use your run's observations, or identify the supplied trace and your unexecuted prediction.</a:t>
+                  <a:srgbClr val="E2E8F0"/>
+                </a:solidFill>
+                <a:latin typeface="Menlo"/>
+                <a:ea typeface="Menlo"/>
+                <a:cs typeface="Menlo"/>
+              </a:rPr>
+              <a:t>Opened Session A, Session B, and the diagnostic session.</a:t>
+            </a:r>
+          </a:p>
+          <a:p xmlns:a="http://schemas.openxmlformats.org/drawingml/2006/main">
+            <a:pPr>
+              <a:defRPr sz="1725" b="0">
+                <a:solidFill>
+                  <a:srgbClr val="E2E8F0"/>
+                </a:solidFill>
+                <a:latin typeface="Menlo"/>
+                <a:ea typeface="Menlo"/>
+                <a:cs typeface="Menlo"/>
+              </a:defRPr>
+            </a:pPr>
+            <a:r>
+              <a:rPr sz="1725" b="0">
+                <a:solidFill>
+                  <a:srgbClr val="E2E8F0"/>
+                </a:solidFill>
+                <a:latin typeface="Menlo"/>
+                <a:ea typeface="Menlo"/>
+                <a:cs typeface="Menlo"/>
+              </a:rPr>
+              <a:t>Starting row: (1004, 'medium', 'open')</a:t>
+            </a:r>
+          </a:p>
+        </p:txBody>
+      </p:sp>
+      <p:sp>
+        <p:nvSpPr>
+          <p:cNvPr id="10" name="connection-check">
+            <a:extLst xmlns:a="http://schemas.openxmlformats.org/drawingml/2006/main">
+              <a:ext uri="{FF2B5EF4-FFF2-40B4-BE49-F238E27FC236}">
+                <a16:creationId xmlns:a16="http://schemas.microsoft.com/office/drawing/2014/main" id="{B480A9F4-2E6A-4B2E-A7D0-5DC405342A28}"/>
+              </a:ext>
+            </a:extLst>
+          </p:cNvPr>
+          <p:cNvSpPr>
+            <a:spLocks xmlns:a="http://schemas.openxmlformats.org/drawingml/2006/main" noGrp="1"/>
+          </p:cNvSpPr>
+          <p:nvPr/>
+        </p:nvSpPr>
+        <p:spPr>
+          <a:xfrm xmlns:a="http://schemas.openxmlformats.org/drawingml/2006/main">
+            <a:off x="723900" y="5238750"/>
+            <a:ext cx="10668000" cy="685800"/>
+          </a:xfrm>
+          <a:prstGeom xmlns:a="http://schemas.openxmlformats.org/drawingml/2006/main" prst="rect">
+            <a:avLst/>
+          </a:prstGeom>
+          <a:noFill xmlns:a="http://schemas.openxmlformats.org/drawingml/2006/main"/>
+          <a:ln xmlns:a="http://schemas.openxmlformats.org/drawingml/2006/main" w="0">
+            <a:noFill/>
+          </a:ln>
+        </p:spPr>
+        <p:txBody>
+          <a:bodyPr xmlns:a="http://schemas.openxmlformats.org/drawingml/2006/main" wrap="square" lIns="0" tIns="0" rIns="0" bIns="0" anchor="t">
+            <a:noAutofit/>
+          </a:bodyPr>
+          <a:lstStyle xmlns:a="http://schemas.openxmlformats.org/drawingml/2006/main"/>
+          <a:p xmlns:a="http://schemas.openxmlformats.org/drawingml/2006/main">
+            <a:pPr>
+              <a:defRPr sz="1800" b="0">
+                <a:solidFill>
+                  <a:srgbClr val="111827"/>
+                </a:solidFill>
+                <a:latin typeface="Helvetica Neue"/>
+                <a:ea typeface="Helvetica Neue"/>
+                <a:cs typeface="Helvetica Neue"/>
+              </a:defRPr>
+            </a:pPr>
+            <a:r>
+              <a:rPr sz="1800" b="0">
+                <a:solidFill>
+                  <a:srgbClr val="111827"/>
+                </a:solidFill>
+                <a:latin typeface="Helvetica Neue"/>
+                <a:ea typeface="Helvetica Neue"/>
+                <a:cs typeface="Helvetica Neue"/>
+              </a:rPr>
+              <a:t>Continue after Section 1 opens the sessions and Section 2 prints the starting row.</a:t>
+            </a:r>
+          </a:p>
+          <a:p xmlns:a="http://schemas.openxmlformats.org/drawingml/2006/main">
+            <a:pPr>
+              <a:defRPr sz="1800" b="0">
+                <a:solidFill>
+                  <a:srgbClr val="111827"/>
+                </a:solidFill>
+                <a:latin typeface="Helvetica Neue"/>
+                <a:ea typeface="Helvetica Neue"/>
+                <a:cs typeface="Helvetica Neue"/>
+              </a:defRPr>
+            </a:pPr>
+            <a:r>
+              <a:rPr sz="1800" b="0">
+                <a:solidFill>
+                  <a:srgbClr val="111827"/>
+                </a:solidFill>
+                <a:latin typeface="Helvetica Neue"/>
+                <a:ea typeface="Helvetica Neue"/>
+                <a:cs typeface="Helvetica Neue"/>
+              </a:rPr>
+              <a:t>A connection error means stop here and check the URL, password, and SSL.</a:t>
+            </a:r>
+          </a:p>
+        </p:txBody>
+      </p:sp>
+      <p:sp>
+        <p:nvSpPr>
+          <p:cNvPr id="11" name="result-locations">
+            <a:extLst xmlns:a="http://schemas.openxmlformats.org/drawingml/2006/main">
+              <a:ext uri="{FF2B5EF4-FFF2-40B4-BE49-F238E27FC236}">
+                <a16:creationId xmlns:a16="http://schemas.microsoft.com/office/drawing/2014/main" id="{78B45782-04AF-4419-ADE6-68EB9762EBF4}"/>
+              </a:ext>
+            </a:extLst>
+          </p:cNvPr>
+          <p:cNvSpPr>
+            <a:spLocks xmlns:a="http://schemas.openxmlformats.org/drawingml/2006/main" noGrp="1"/>
+          </p:cNvSpPr>
+          <p:nvPr/>
+        </p:nvSpPr>
+        <p:spPr>
+          <a:xfrm xmlns:a="http://schemas.openxmlformats.org/drawingml/2006/main">
+            <a:off x="723900" y="6124575"/>
+            <a:ext cx="10668000" cy="333375"/>
+          </a:xfrm>
+          <a:prstGeom xmlns:a="http://schemas.openxmlformats.org/drawingml/2006/main" prst="rect">
+            <a:avLst/>
+          </a:prstGeom>
+          <a:noFill xmlns:a="http://schemas.openxmlformats.org/drawingml/2006/main"/>
+          <a:ln xmlns:a="http://schemas.openxmlformats.org/drawingml/2006/main" w="0">
+            <a:noFill/>
+          </a:ln>
+        </p:spPr>
+        <p:txBody>
+          <a:bodyPr xmlns:a="http://schemas.openxmlformats.org/drawingml/2006/main" wrap="square" lIns="0" tIns="0" rIns="0" bIns="0" anchor="t">
+            <a:noAutofit/>
+          </a:bodyPr>
+          <a:lstStyle xmlns:a="http://schemas.openxmlformats.org/drawingml/2006/main"/>
+          <a:p xmlns:a="http://schemas.openxmlformats.org/drawingml/2006/main">
+            <a:pPr>
+              <a:defRPr sz="1650" b="0">
+                <a:solidFill>
+                  <a:srgbClr val="111827"/>
+                </a:solidFill>
+                <a:latin typeface="Helvetica Neue"/>
+                <a:ea typeface="Helvetica Neue"/>
+                <a:cs typeface="Helvetica Neue"/>
+              </a:defRPr>
+            </a:pPr>
+            <a:r>
+              <a:rPr sz="1650" b="0">
+                <a:solidFill>
+                  <a:srgbClr val="111827"/>
+                </a:solidFill>
+                <a:latin typeface="Helvetica Neue"/>
+                <a:ea typeface="Helvetica Neue"/>
+                <a:cs typeface="Helvetica Neue"/>
+              </a:rPr>
+              <a:t>Section 4 runs the experiment. Section 5 shows blockers. Section 6 shows the final row.</a:t>
             </a:r>
           </a:p>
         </p:txBody>
@@ -13042,10 +13800,10 @@
       </p:grpSpPr>
       <p:sp>
         <p:nvSpPr>
-          <p:cNvPr id="8" name="eyebrow">
-            <a:extLst xmlns:a="http://schemas.openxmlformats.org/drawingml/2006/main">
-              <a:ext uri="{FF2B5EF4-FFF2-40B4-BE49-F238E27FC236}">
-                <a16:creationId xmlns:a16="http://schemas.microsoft.com/office/drawing/2014/main" id="{9DEA49AC-BADE-4E93-A69E-31619EA29B56}"/>
+          <p:cNvPr id="9" name="eyebrow">
+            <a:extLst xmlns:a="http://schemas.openxmlformats.org/drawingml/2006/main">
+              <a:ext uri="{FF2B5EF4-FFF2-40B4-BE49-F238E27FC236}">
+                <a16:creationId xmlns:a16="http://schemas.microsoft.com/office/drawing/2014/main" id="{81D188C2-BE9A-4D63-834D-C664E49EB001}"/>
               </a:ext>
             </a:extLst>
           </p:cNvPr>
@@ -13102,7 +13860,7 @@
           <p:cNvPr id="2" name="slide-title">
             <a:extLst xmlns:a="http://schemas.openxmlformats.org/drawingml/2006/main">
               <a:ext uri="{FF2B5EF4-FFF2-40B4-BE49-F238E27FC236}">
-                <a16:creationId xmlns:a16="http://schemas.microsoft.com/office/drawing/2014/main" id="{19511CC4-E3E8-4F62-86C9-517E9AEF36B2}"/>
+                <a16:creationId xmlns:a16="http://schemas.microsoft.com/office/drawing/2014/main" id="{22A33371-8E58-4779-9134-EDD9BADB72A6}"/>
               </a:ext>
             </a:extLst>
           </p:cNvPr>
@@ -13149,7 +13907,7 @@
                 <a:ea typeface="Helvetica Neue"/>
                 <a:cs typeface="Helvetica Neue"/>
               </a:rPr>
-              <a:t>Transaction decisions leave observable results</a:t>
+              <a:t>Lab 2: Compare two resolutions of the same wait</a:t>
             </a:r>
           </a:p>
         </p:txBody>
@@ -13159,7 +13917,7 @@
           <p:cNvPr id="3" name="">
             <a:extLst xmlns:a="http://schemas.openxmlformats.org/drawingml/2006/main">
               <a:ext uri="{FF2B5EF4-FFF2-40B4-BE49-F238E27FC236}">
-                <a16:creationId xmlns:a16="http://schemas.microsoft.com/office/drawing/2014/main" id="{676CBED8-1A5F-4DEF-867A-60A24D1B3494}"/>
+                <a16:creationId xmlns:a16="http://schemas.microsoft.com/office/drawing/2014/main" id="{A87BD1B9-C371-42F5-B7B6-C0672C9E6CA4}"/>
               </a:ext>
             </a:extLst>
           </p:cNvPr>
@@ -13191,7 +13949,7 @@
           <p:cNvPr id="4" name="slide-number">
             <a:extLst xmlns:a="http://schemas.openxmlformats.org/drawingml/2006/main">
               <a:ext uri="{FF2B5EF4-FFF2-40B4-BE49-F238E27FC236}">
-                <a16:creationId xmlns:a16="http://schemas.microsoft.com/office/drawing/2014/main" id="{13B035D3-FBFE-423F-A0CB-587E912A2F6B}"/>
+                <a16:creationId xmlns:a16="http://schemas.microsoft.com/office/drawing/2014/main" id="{96BDE59D-25C0-473E-89F4-2918611F9C9E}"/>
               </a:ext>
             </a:extLst>
           </p:cNvPr>
@@ -13245,22 +14003,22 @@
       </p:sp>
       <p:sp>
         <p:nvSpPr>
-          <p:cNvPr id="5" name="summary">
-            <a:extLst xmlns:a="http://schemas.openxmlformats.org/drawingml/2006/main">
-              <a:ext uri="{FF2B5EF4-FFF2-40B4-BE49-F238E27FC236}">
-                <a16:creationId xmlns:a16="http://schemas.microsoft.com/office/drawing/2014/main" id="{32268515-DCA8-46E8-88DC-904942007FD7}"/>
-              </a:ext>
-            </a:extLst>
-          </p:cNvPr>
-          <p:cNvSpPr>
-            <a:spLocks xmlns:a="http://schemas.openxmlformats.org/drawingml/2006/main" noGrp="1"/>
-          </p:cNvSpPr>
-          <p:nvPr/>
-        </p:nvSpPr>
-        <p:spPr>
-          <a:xfrm xmlns:a="http://schemas.openxmlformats.org/drawingml/2006/main">
-            <a:off x="723900" y="2028825"/>
-            <a:ext cx="10668000" cy="1876425"/>
+          <p:cNvPr id="5" name="lab2">
+            <a:extLst xmlns:a="http://schemas.openxmlformats.org/drawingml/2006/main">
+              <a:ext uri="{FF2B5EF4-FFF2-40B4-BE49-F238E27FC236}">
+                <a16:creationId xmlns:a16="http://schemas.microsoft.com/office/drawing/2014/main" id="{C516772B-758B-4B0A-965E-5D3598237D2E}"/>
+              </a:ext>
+            </a:extLst>
+          </p:cNvPr>
+          <p:cNvSpPr>
+            <a:spLocks xmlns:a="http://schemas.openxmlformats.org/drawingml/2006/main" noGrp="1"/>
+          </p:cNvSpPr>
+          <p:nvPr/>
+        </p:nvSpPr>
+        <p:spPr>
+          <a:xfrm xmlns:a="http://schemas.openxmlformats.org/drawingml/2006/main">
+            <a:off x="723900" y="1743075"/>
+            <a:ext cx="10668000" cy="590550"/>
           </a:xfrm>
           <a:prstGeom xmlns:a="http://schemas.openxmlformats.org/drawingml/2006/main" prst="rect">
             <a:avLst/>
@@ -13277,6 +14035,924 @@
           <a:lstStyle xmlns:a="http://schemas.openxmlformats.org/drawingml/2006/main"/>
           <a:p xmlns:a="http://schemas.openxmlformats.org/drawingml/2006/main">
             <a:pPr>
+              <a:defRPr sz="2400" b="1">
+                <a:solidFill>
+                  <a:srgbClr val="BF3E05"/>
+                </a:solidFill>
+                <a:latin typeface="Helvetica Neue"/>
+                <a:ea typeface="Helvetica Neue"/>
+                <a:cs typeface="Helvetica Neue"/>
+              </a:defRPr>
+            </a:pPr>
+            <a:r>
+              <a:rPr sz="2400" b="1">
+                <a:solidFill>
+                  <a:srgbClr val="BF3E05"/>
+                </a:solidFill>
+                <a:latin typeface="Helvetica Neue"/>
+                <a:ea typeface="Helvetica Neue"/>
+                <a:cs typeface="Helvetica Neue"/>
+              </a:rPr>
+              <a:t>Individual work in Notebook 02</a:t>
+            </a:r>
+          </a:p>
+        </p:txBody>
+      </p:sp>
+      <p:sp>
+        <p:nvSpPr>
+          <p:cNvPr id="6" name="lab2-action">
+            <a:extLst xmlns:a="http://schemas.openxmlformats.org/drawingml/2006/main">
+              <a:ext uri="{FF2B5EF4-FFF2-40B4-BE49-F238E27FC236}">
+                <a16:creationId xmlns:a16="http://schemas.microsoft.com/office/drawing/2014/main" id="{1CFD6200-7B47-4521-9109-D076342AF913}"/>
+              </a:ext>
+            </a:extLst>
+          </p:cNvPr>
+          <p:cNvSpPr>
+            <a:spLocks xmlns:a="http://schemas.openxmlformats.org/drawingml/2006/main" noGrp="1"/>
+          </p:cNvSpPr>
+          <p:nvPr/>
+        </p:nvSpPr>
+        <p:spPr>
+          <a:xfrm xmlns:a="http://schemas.openxmlformats.org/drawingml/2006/main">
+            <a:off x="723900" y="2752725"/>
+            <a:ext cx="10668000" cy="1285875"/>
+          </a:xfrm>
+          <a:prstGeom xmlns:a="http://schemas.openxmlformats.org/drawingml/2006/main" prst="rect">
+            <a:avLst/>
+          </a:prstGeom>
+          <a:noFill xmlns:a="http://schemas.openxmlformats.org/drawingml/2006/main"/>
+          <a:ln xmlns:a="http://schemas.openxmlformats.org/drawingml/2006/main" w="0">
+            <a:noFill/>
+          </a:ln>
+        </p:spPr>
+        <p:txBody>
+          <a:bodyPr xmlns:a="http://schemas.openxmlformats.org/drawingml/2006/main" wrap="square" lIns="0" tIns="0" rIns="0" bIns="0" anchor="t">
+            <a:noAutofit/>
+          </a:bodyPr>
+          <a:lstStyle xmlns:a="http://schemas.openxmlformats.org/drawingml/2006/main"/>
+          <a:p xmlns:a="http://schemas.openxmlformats.org/drawingml/2006/main">
+            <a:pPr>
+              <a:defRPr sz="2325" b="0">
+                <a:solidFill>
+                  <a:srgbClr val="111827"/>
+                </a:solidFill>
+                <a:latin typeface="Helvetica Neue"/>
+                <a:ea typeface="Helvetica Neue"/>
+                <a:cs typeface="Helvetica Neue"/>
+              </a:defRPr>
+            </a:pPr>
+            <a:r>
+              <a:rPr sz="2325" b="0">
+                <a:solidFill>
+                  <a:srgbClr val="111827"/>
+                </a:solidFill>
+                <a:latin typeface="Helvetica Neue"/>
+                <a:ea typeface="Helvetica Neue"/>
+                <a:cs typeface="Helvetica Neue"/>
+              </a:rPr>
+              <a:t>Run the rollback case and keep its final row.</a:t>
+            </a:r>
+          </a:p>
+          <a:p xmlns:a="http://schemas.openxmlformats.org/drawingml/2006/main">
+            <a:pPr>
+              <a:defRPr sz="2325" b="0">
+                <a:solidFill>
+                  <a:srgbClr val="111827"/>
+                </a:solidFill>
+                <a:latin typeface="Helvetica Neue"/>
+                <a:ea typeface="Helvetica Neue"/>
+                <a:cs typeface="Helvetica Neue"/>
+              </a:defRPr>
+            </a:pPr>
+            <a:r>
+              <a:rPr sz="2325" b="0">
+                <a:solidFill>
+                  <a:srgbClr val="111827"/>
+                </a:solidFill>
+                <a:latin typeface="Helvetica Neue"/>
+                <a:ea typeface="Helvetica Neue"/>
+                <a:cs typeface="Helvetica Neue"/>
+              </a:rPr>
+              <a:t>Predict the commit case, then change the setting and rerun.</a:t>
+            </a:r>
+          </a:p>
+        </p:txBody>
+      </p:sp>
+      <p:sp>
+        <p:nvSpPr>
+          <p:cNvPr id="7" name="lab2-explain">
+            <a:extLst xmlns:a="http://schemas.openxmlformats.org/drawingml/2006/main">
+              <a:ext uri="{FF2B5EF4-FFF2-40B4-BE49-F238E27FC236}">
+                <a16:creationId xmlns:a16="http://schemas.microsoft.com/office/drawing/2014/main" id="{B6481686-53AD-4ECC-A4DF-5727C967F51D}"/>
+              </a:ext>
+            </a:extLst>
+          </p:cNvPr>
+          <p:cNvSpPr>
+            <a:spLocks xmlns:a="http://schemas.openxmlformats.org/drawingml/2006/main" noGrp="1"/>
+          </p:cNvSpPr>
+          <p:nvPr/>
+        </p:nvSpPr>
+        <p:spPr>
+          <a:xfrm xmlns:a="http://schemas.openxmlformats.org/drawingml/2006/main">
+            <a:off x="723900" y="4629150"/>
+            <a:ext cx="10668000" cy="942975"/>
+          </a:xfrm>
+          <a:prstGeom xmlns:a="http://schemas.openxmlformats.org/drawingml/2006/main" prst="rect">
+            <a:avLst/>
+          </a:prstGeom>
+          <a:noFill xmlns:a="http://schemas.openxmlformats.org/drawingml/2006/main"/>
+          <a:ln xmlns:a="http://schemas.openxmlformats.org/drawingml/2006/main" w="0">
+            <a:noFill/>
+          </a:ln>
+        </p:spPr>
+        <p:txBody>
+          <a:bodyPr xmlns:a="http://schemas.openxmlformats.org/drawingml/2006/main" wrap="square" lIns="0" tIns="0" rIns="0" bIns="0" anchor="t">
+            <a:noAutofit/>
+          </a:bodyPr>
+          <a:lstStyle xmlns:a="http://schemas.openxmlformats.org/drawingml/2006/main"/>
+          <a:p xmlns:a="http://schemas.openxmlformats.org/drawingml/2006/main">
+            <a:pPr>
+              <a:defRPr sz="2250" b="0">
+                <a:solidFill>
+                  <a:srgbClr val="111827"/>
+                </a:solidFill>
+                <a:latin typeface="Helvetica Neue"/>
+                <a:ea typeface="Helvetica Neue"/>
+                <a:cs typeface="Helvetica Neue"/>
+              </a:defRPr>
+            </a:pPr>
+            <a:r>
+              <a:rPr sz="2250" b="0">
+                <a:solidFill>
+                  <a:srgbClr val="111827"/>
+                </a:solidFill>
+                <a:latin typeface="Helvetica Neue"/>
+                <a:ea typeface="Helvetica Neue"/>
+                <a:cs typeface="Helvetica Neue"/>
+              </a:rPr>
+              <a:t>In the final Markdown cell: complete the comparison and explain the wait to the developer.</a:t>
+            </a:r>
+          </a:p>
+        </p:txBody>
+      </p:sp>
+      <p:sp>
+        <p:nvSpPr>
+          <p:cNvPr id="8" name="lab2-submit">
+            <a:extLst xmlns:a="http://schemas.openxmlformats.org/drawingml/2006/main">
+              <a:ext uri="{FF2B5EF4-FFF2-40B4-BE49-F238E27FC236}">
+                <a16:creationId xmlns:a16="http://schemas.microsoft.com/office/drawing/2014/main" id="{AB156C0E-BD3F-4C40-8773-EEE862CDF991}"/>
+              </a:ext>
+            </a:extLst>
+          </p:cNvPr>
+          <p:cNvSpPr>
+            <a:spLocks xmlns:a="http://schemas.openxmlformats.org/drawingml/2006/main" noGrp="1"/>
+          </p:cNvSpPr>
+          <p:nvPr/>
+        </p:nvSpPr>
+        <p:spPr>
+          <a:xfrm xmlns:a="http://schemas.openxmlformats.org/drawingml/2006/main">
+            <a:off x="723900" y="6029325"/>
+            <a:ext cx="10668000" cy="409575"/>
+          </a:xfrm>
+          <a:prstGeom xmlns:a="http://schemas.openxmlformats.org/drawingml/2006/main" prst="rect">
+            <a:avLst/>
+          </a:prstGeom>
+          <a:noFill xmlns:a="http://schemas.openxmlformats.org/drawingml/2006/main"/>
+          <a:ln xmlns:a="http://schemas.openxmlformats.org/drawingml/2006/main" w="0">
+            <a:noFill/>
+          </a:ln>
+        </p:spPr>
+        <p:txBody>
+          <a:bodyPr xmlns:a="http://schemas.openxmlformats.org/drawingml/2006/main" wrap="square" lIns="0" tIns="0" rIns="0" bIns="0" anchor="t">
+            <a:noAutofit/>
+          </a:bodyPr>
+          <a:lstStyle xmlns:a="http://schemas.openxmlformats.org/drawingml/2006/main"/>
+          <a:p xmlns:a="http://schemas.openxmlformats.org/drawingml/2006/main">
+            <a:pPr>
+              <a:defRPr sz="1725" b="0">
+                <a:solidFill>
+                  <a:srgbClr val="111827"/>
+                </a:solidFill>
+                <a:latin typeface="Helvetica Neue"/>
+                <a:ea typeface="Helvetica Neue"/>
+                <a:cs typeface="Helvetica Neue"/>
+              </a:defRPr>
+            </a:pPr>
+            <a:r>
+              <a:rPr sz="1725" b="0">
+                <a:solidFill>
+                  <a:srgbClr val="111827"/>
+                </a:solidFill>
+                <a:latin typeface="Helvetica Neue"/>
+                <a:ea typeface="Helvetica Neue"/>
+                <a:cs typeface="Helvetica Neue"/>
+              </a:rPr>
+              <a:t>Brightspace: the completed notebook. Run cleanup after each experiment.</a:t>
+            </a:r>
+          </a:p>
+        </p:txBody>
+      </p:sp>
+    </p:spTree>
+    <p:extLst>
+      <p:ext uri="{BB962C8B-B14F-4D97-AF65-F5344CB8AC3E}">
+        <p14:creationId xmlns:p14="http://schemas.microsoft.com/office/powerpoint/2010/main" val="23974070"/>
+      </p:ext>
+    </p:extLst>
+  </p:cSld>
+</p:sld>
+</file>
+
+<file path=ppt/slides/slide24.xml><?xml version="1.0" encoding="utf-8"?>
+<p:sld xmlns:p="http://schemas.openxmlformats.org/presentationml/2006/main">
+  <p:cSld>
+    <p:bg>
+      <p:bgPr>
+        <a:solidFill xmlns:a="http://schemas.openxmlformats.org/drawingml/2006/main">
+          <a:srgbClr val="FCFCFA"/>
+        </a:solidFill>
+      </p:bgPr>
+    </p:bg>
+    <p:spTree>
+      <p:nvGrpSpPr>
+        <p:cNvPr id="1" name=""/>
+        <p:cNvGrpSpPr/>
+        <p:nvPr/>
+      </p:nvGrpSpPr>
+      <p:grpSpPr>
+        <a:xfrm xmlns:a="http://schemas.openxmlformats.org/drawingml/2006/main"/>
+      </p:grpSpPr>
+      <p:sp>
+        <p:nvSpPr>
+          <p:cNvPr id="9" name="eyebrow">
+            <a:extLst xmlns:a="http://schemas.openxmlformats.org/drawingml/2006/main">
+              <a:ext uri="{FF2B5EF4-FFF2-40B4-BE49-F238E27FC236}">
+                <a16:creationId xmlns:a16="http://schemas.microsoft.com/office/drawing/2014/main" id="{9223D04E-0319-42A6-A7E7-3FA30F086052}"/>
+              </a:ext>
+            </a:extLst>
+          </p:cNvPr>
+          <p:cNvSpPr>
+            <a:spLocks xmlns:a="http://schemas.openxmlformats.org/drawingml/2006/main" noGrp="1"/>
+          </p:cNvSpPr>
+          <p:nvPr/>
+        </p:nvSpPr>
+        <p:spPr>
+          <a:xfrm xmlns:a="http://schemas.openxmlformats.org/drawingml/2006/main">
+            <a:off x="609600" y="295275"/>
+            <a:ext cx="5715000" cy="228600"/>
+          </a:xfrm>
+          <a:prstGeom xmlns:a="http://schemas.openxmlformats.org/drawingml/2006/main" prst="rect">
+            <a:avLst/>
+          </a:prstGeom>
+          <a:noFill xmlns:a="http://schemas.openxmlformats.org/drawingml/2006/main"/>
+          <a:ln xmlns:a="http://schemas.openxmlformats.org/drawingml/2006/main" w="0">
+            <a:noFill/>
+          </a:ln>
+        </p:spPr>
+        <p:txBody>
+          <a:bodyPr xmlns:a="http://schemas.openxmlformats.org/drawingml/2006/main" wrap="square" lIns="0" tIns="0" rIns="0" bIns="0" anchor="t">
+            <a:noAutofit/>
+          </a:bodyPr>
+          <a:lstStyle xmlns:a="http://schemas.openxmlformats.org/drawingml/2006/main"/>
+          <a:p xmlns:a="http://schemas.openxmlformats.org/drawingml/2006/main">
+            <a:pPr>
+              <a:defRPr sz="1050" b="1">
+                <a:solidFill>
+                  <a:srgbClr val="BF3E05"/>
+                </a:solidFill>
+                <a:latin typeface="Helvetica Neue"/>
+                <a:ea typeface="Helvetica Neue"/>
+                <a:cs typeface="Helvetica Neue"/>
+              </a:defRPr>
+            </a:pPr>
+            <a:r>
+              <a:rPr sz="1050" b="1">
+                <a:solidFill>
+                  <a:srgbClr val="BF3E05"/>
+                </a:solidFill>
+                <a:latin typeface="Helvetica Neue"/>
+                <a:ea typeface="Helvetica Neue"/>
+                <a:cs typeface="Helvetica Neue"/>
+              </a:rPr>
+              <a:t>WEEK 05  /  CST4714</a:t>
+            </a:r>
+          </a:p>
+        </p:txBody>
+      </p:sp>
+      <p:sp>
+        <p:nvSpPr>
+          <p:cNvPr id="2" name="slide-title">
+            <a:extLst xmlns:a="http://schemas.openxmlformats.org/drawingml/2006/main">
+              <a:ext uri="{FF2B5EF4-FFF2-40B4-BE49-F238E27FC236}">
+                <a16:creationId xmlns:a16="http://schemas.microsoft.com/office/drawing/2014/main" id="{EBDF1AA2-0D64-42D5-84AD-D9769997CA4D}"/>
+              </a:ext>
+            </a:extLst>
+          </p:cNvPr>
+          <p:cNvSpPr>
+            <a:spLocks xmlns:a="http://schemas.openxmlformats.org/drawingml/2006/main" noGrp="1"/>
+          </p:cNvSpPr>
+          <p:nvPr/>
+        </p:nvSpPr>
+        <p:spPr>
+          <a:xfrm xmlns:a="http://schemas.openxmlformats.org/drawingml/2006/main">
+            <a:off x="609600" y="619125"/>
+            <a:ext cx="10972800" cy="628650"/>
+          </a:xfrm>
+          <a:prstGeom xmlns:a="http://schemas.openxmlformats.org/drawingml/2006/main" prst="rect">
+            <a:avLst/>
+          </a:prstGeom>
+          <a:noFill xmlns:a="http://schemas.openxmlformats.org/drawingml/2006/main"/>
+          <a:ln xmlns:a="http://schemas.openxmlformats.org/drawingml/2006/main" w="0">
+            <a:noFill/>
+          </a:ln>
+        </p:spPr>
+        <p:txBody>
+          <a:bodyPr xmlns:a="http://schemas.openxmlformats.org/drawingml/2006/main" wrap="square" lIns="0" tIns="0" rIns="0" bIns="0" anchor="t">
+            <a:noAutofit/>
+          </a:bodyPr>
+          <a:lstStyle xmlns:a="http://schemas.openxmlformats.org/drawingml/2006/main"/>
+          <a:p xmlns:a="http://schemas.openxmlformats.org/drawingml/2006/main">
+            <a:pPr>
+              <a:defRPr sz="2775" b="1">
+                <a:solidFill>
+                  <a:srgbClr val="111827"/>
+                </a:solidFill>
+                <a:latin typeface="Helvetica Neue"/>
+                <a:ea typeface="Helvetica Neue"/>
+                <a:cs typeface="Helvetica Neue"/>
+              </a:defRPr>
+            </a:pPr>
+            <a:r>
+              <a:rPr sz="2775" b="1">
+                <a:solidFill>
+                  <a:srgbClr val="111827"/>
+                </a:solidFill>
+                <a:latin typeface="Helvetica Neue"/>
+                <a:ea typeface="Helvetica Neue"/>
+                <a:cs typeface="Helvetica Neue"/>
+              </a:rPr>
+              <a:t>A useful incident update explains the data too</a:t>
+            </a:r>
+          </a:p>
+        </p:txBody>
+      </p:sp>
+      <p:sp>
+        <p:nvSpPr>
+          <p:cNvPr id="3" name="">
+            <a:extLst xmlns:a="http://schemas.openxmlformats.org/drawingml/2006/main">
+              <a:ext uri="{FF2B5EF4-FFF2-40B4-BE49-F238E27FC236}">
+                <a16:creationId xmlns:a16="http://schemas.microsoft.com/office/drawing/2014/main" id="{BDBF2852-F829-4042-B8D2-207D69F760A1}"/>
+              </a:ext>
+            </a:extLst>
+          </p:cNvPr>
+          <p:cNvSpPr>
+            <a:spLocks xmlns:a="http://schemas.openxmlformats.org/drawingml/2006/main" noGrp="1"/>
+          </p:cNvSpPr>
+          <p:nvPr/>
+        </p:nvSpPr>
+        <p:spPr>
+          <a:xfrm xmlns:a="http://schemas.openxmlformats.org/drawingml/2006/main">
+            <a:off x="609600" y="1295400"/>
+            <a:ext cx="10972800" cy="9525"/>
+          </a:xfrm>
+          <a:prstGeom xmlns:a="http://schemas.openxmlformats.org/drawingml/2006/main" prst="rect">
+            <a:avLst/>
+          </a:prstGeom>
+          <a:solidFill xmlns:a="http://schemas.openxmlformats.org/drawingml/2006/main">
+            <a:srgbClr val="CBD5E1"/>
+          </a:solidFill>
+          <a:ln xmlns:a="http://schemas.openxmlformats.org/drawingml/2006/main" w="0">
+            <a:solidFill>
+              <a:srgbClr val="CBD5E1"/>
+            </a:solidFill>
+          </a:ln>
+        </p:spPr>
+      </p:sp>
+      <p:sp>
+        <p:nvSpPr>
+          <p:cNvPr id="4" name="slide-number">
+            <a:extLst xmlns:a="http://schemas.openxmlformats.org/drawingml/2006/main">
+              <a:ext uri="{FF2B5EF4-FFF2-40B4-BE49-F238E27FC236}">
+                <a16:creationId xmlns:a16="http://schemas.microsoft.com/office/drawing/2014/main" id="{3EA093F5-2F9F-48A2-B09F-8FAC068B4503}"/>
+              </a:ext>
+            </a:extLst>
+          </p:cNvPr>
+          <p:cNvSpPr>
+            <a:spLocks xmlns:a="http://schemas.openxmlformats.org/drawingml/2006/main" noGrp="1"/>
+          </p:cNvSpPr>
+          <p:nvPr/>
+        </p:nvSpPr>
+        <p:spPr>
+          <a:xfrm xmlns:a="http://schemas.openxmlformats.org/drawingml/2006/main">
+            <a:off x="11125200" y="6467475"/>
+            <a:ext cx="457200" cy="190500"/>
+          </a:xfrm>
+          <a:prstGeom xmlns:a="http://schemas.openxmlformats.org/drawingml/2006/main" prst="rect">
+            <a:avLst/>
+          </a:prstGeom>
+          <a:noFill xmlns:a="http://schemas.openxmlformats.org/drawingml/2006/main"/>
+          <a:ln xmlns:a="http://schemas.openxmlformats.org/drawingml/2006/main" w="0">
+            <a:noFill/>
+          </a:ln>
+        </p:spPr>
+        <p:txBody>
+          <a:bodyPr xmlns:a="http://schemas.openxmlformats.org/drawingml/2006/main" wrap="square" lIns="0" tIns="0" rIns="0" bIns="0" anchor="t">
+            <a:noAutofit/>
+          </a:bodyPr>
+          <a:lstStyle xmlns:a="http://schemas.openxmlformats.org/drawingml/2006/main"/>
+          <a:p xmlns:a="http://schemas.openxmlformats.org/drawingml/2006/main">
+            <a:pPr>
+              <a:defRPr sz="900" b="0">
+                <a:solidFill>
+                  <a:srgbClr val="64748B"/>
+                </a:solidFill>
+                <a:latin typeface="Helvetica Neue"/>
+                <a:ea typeface="Helvetica Neue"/>
+                <a:cs typeface="Helvetica Neue"/>
+              </a:defRPr>
+            </a:pPr>
+            <a:r>
+              <a:rPr sz="900" b="0">
+                <a:solidFill>
+                  <a:srgbClr val="64748B"/>
+                </a:solidFill>
+                <a:latin typeface="Helvetica Neue"/>
+                <a:ea typeface="Helvetica Neue"/>
+                <a:cs typeface="Helvetica Neue"/>
+              </a:rPr>
+              <a:t>24</a:t>
+            </a:r>
+          </a:p>
+        </p:txBody>
+      </p:sp>
+      <p:sp>
+        <p:nvSpPr>
+          <p:cNvPr id="5" name="">
+            <a:extLst xmlns:a="http://schemas.openxmlformats.org/drawingml/2006/main">
+              <a:ext uri="{FF2B5EF4-FFF2-40B4-BE49-F238E27FC236}">
+                <a16:creationId xmlns:a16="http://schemas.microsoft.com/office/drawing/2014/main" id="{3CDEBC6B-D2CE-46BF-973B-AADCD9632801}"/>
+              </a:ext>
+            </a:extLst>
+          </p:cNvPr>
+          <p:cNvSpPr>
+            <a:spLocks xmlns:a="http://schemas.openxmlformats.org/drawingml/2006/main" noGrp="1"/>
+          </p:cNvSpPr>
+          <p:nvPr/>
+        </p:nvSpPr>
+        <p:spPr>
+          <a:xfrm xmlns:a="http://schemas.openxmlformats.org/drawingml/2006/main">
+            <a:off x="685800" y="1819275"/>
+            <a:ext cx="10820400" cy="2057400"/>
+          </a:xfrm>
+          <a:prstGeom xmlns:a="http://schemas.openxmlformats.org/drawingml/2006/main" prst="rect">
+            <a:avLst/>
+          </a:prstGeom>
+          <a:solidFill xmlns:a="http://schemas.openxmlformats.org/drawingml/2006/main">
+            <a:srgbClr val="FFF0E6"/>
+          </a:solidFill>
+          <a:ln xmlns:a="http://schemas.openxmlformats.org/drawingml/2006/main" w="0">
+            <a:solidFill>
+              <a:srgbClr val="FFF0E6"/>
+            </a:solidFill>
+          </a:ln>
+        </p:spPr>
+      </p:sp>
+      <p:sp>
+        <p:nvSpPr>
+          <p:cNvPr id="6" name="sample-update">
+            <a:extLst xmlns:a="http://schemas.openxmlformats.org/drawingml/2006/main">
+              <a:ext uri="{FF2B5EF4-FFF2-40B4-BE49-F238E27FC236}">
+                <a16:creationId xmlns:a16="http://schemas.microsoft.com/office/drawing/2014/main" id="{11DBE8B6-B709-4B12-A9A7-FBC201BE208E}"/>
+              </a:ext>
+            </a:extLst>
+          </p:cNvPr>
+          <p:cNvSpPr>
+            <a:spLocks xmlns:a="http://schemas.openxmlformats.org/drawingml/2006/main" noGrp="1"/>
+          </p:cNvSpPr>
+          <p:nvPr/>
+        </p:nvSpPr>
+        <p:spPr>
+          <a:xfrm xmlns:a="http://schemas.openxmlformats.org/drawingml/2006/main">
+            <a:off x="876300" y="1990725"/>
+            <a:ext cx="10439400" cy="1714500"/>
+          </a:xfrm>
+          <a:prstGeom xmlns:a="http://schemas.openxmlformats.org/drawingml/2006/main" prst="rect">
+            <a:avLst/>
+          </a:prstGeom>
+          <a:noFill xmlns:a="http://schemas.openxmlformats.org/drawingml/2006/main"/>
+          <a:ln xmlns:a="http://schemas.openxmlformats.org/drawingml/2006/main" w="0">
+            <a:noFill/>
+          </a:ln>
+        </p:spPr>
+        <p:txBody>
+          <a:bodyPr xmlns:a="http://schemas.openxmlformats.org/drawingml/2006/main" wrap="square" lIns="0" tIns="0" rIns="0" bIns="0" anchor="t">
+            <a:noAutofit/>
+          </a:bodyPr>
+          <a:lstStyle xmlns:a="http://schemas.openxmlformats.org/drawingml/2006/main"/>
+          <a:p xmlns:a="http://schemas.openxmlformats.org/drawingml/2006/main">
+            <a:pPr>
+              <a:defRPr sz="2325" b="0">
+                <a:solidFill>
+                  <a:srgbClr val="111827"/>
+                </a:solidFill>
+                <a:latin typeface="Helvetica Neue"/>
+                <a:ea typeface="Helvetica Neue"/>
+                <a:cs typeface="Helvetica Neue"/>
+              </a:defRPr>
+            </a:pPr>
+            <a:r>
+              <a:rPr sz="2325" b="0">
+                <a:solidFill>
+                  <a:srgbClr val="111827"/>
+                </a:solidFill>
+                <a:latin typeface="Helvetica Neue"/>
+                <a:ea typeface="Helvetica Neue"/>
+                <a:cs typeface="Helvetica Neue"/>
+              </a:rPr>
+              <a:t>The status update waited for A's uncommitted change to the same ticket. The captured result showed B's PID blocked by A's PID. Rolling back A let B finish: priority stayed medium and status became in_progress.</a:t>
+            </a:r>
+          </a:p>
+        </p:txBody>
+      </p:sp>
+      <p:sp>
+        <p:nvSpPr>
+          <p:cNvPr id="7" name="interpret">
+            <a:extLst xmlns:a="http://schemas.openxmlformats.org/drawingml/2006/main">
+              <a:ext uri="{FF2B5EF4-FFF2-40B4-BE49-F238E27FC236}">
+                <a16:creationId xmlns:a16="http://schemas.microsoft.com/office/drawing/2014/main" id="{5688E129-C058-4A48-BEC1-6C778B859F95}"/>
+              </a:ext>
+            </a:extLst>
+          </p:cNvPr>
+          <p:cNvSpPr>
+            <a:spLocks xmlns:a="http://schemas.openxmlformats.org/drawingml/2006/main" noGrp="1"/>
+          </p:cNvSpPr>
+          <p:nvPr/>
+        </p:nvSpPr>
+        <p:spPr>
+          <a:xfrm xmlns:a="http://schemas.openxmlformats.org/drawingml/2006/main">
+            <a:off x="723900" y="4429125"/>
+            <a:ext cx="10668000" cy="1133475"/>
+          </a:xfrm>
+          <a:prstGeom xmlns:a="http://schemas.openxmlformats.org/drawingml/2006/main" prst="rect">
+            <a:avLst/>
+          </a:prstGeom>
+          <a:noFill xmlns:a="http://schemas.openxmlformats.org/drawingml/2006/main"/>
+          <a:ln xmlns:a="http://schemas.openxmlformats.org/drawingml/2006/main" w="0">
+            <a:noFill/>
+          </a:ln>
+        </p:spPr>
+        <p:txBody>
+          <a:bodyPr xmlns:a="http://schemas.openxmlformats.org/drawingml/2006/main" wrap="square" lIns="0" tIns="0" rIns="0" bIns="0" anchor="t">
+            <a:noAutofit/>
+          </a:bodyPr>
+          <a:lstStyle xmlns:a="http://schemas.openxmlformats.org/drawingml/2006/main"/>
+          <a:p xmlns:a="http://schemas.openxmlformats.org/drawingml/2006/main">
+            <a:pPr>
+              <a:defRPr sz="2250" b="0">
+                <a:solidFill>
+                  <a:srgbClr val="111827"/>
+                </a:solidFill>
+                <a:latin typeface="Helvetica Neue"/>
+                <a:ea typeface="Helvetica Neue"/>
+                <a:cs typeface="Helvetica Neue"/>
+              </a:defRPr>
+            </a:pPr>
+            <a:r>
+              <a:rPr sz="2250" b="0">
+                <a:solidFill>
+                  <a:srgbClr val="111827"/>
+                </a:solidFill>
+                <a:latin typeface="Helvetica Neue"/>
+                <a:ea typeface="Helvetica Neue"/>
+                <a:cs typeface="Helvetica Neue"/>
+              </a:rPr>
+              <a:t>In your comparison, explain how committing A changes that result. State why you could not choose blindly in a real application.</a:t>
+            </a:r>
+          </a:p>
+        </p:txBody>
+      </p:sp>
+      <p:sp>
+        <p:nvSpPr>
+          <p:cNvPr id="8" name="source-kind">
+            <a:extLst xmlns:a="http://schemas.openxmlformats.org/drawingml/2006/main">
+              <a:ext uri="{FF2B5EF4-FFF2-40B4-BE49-F238E27FC236}">
+                <a16:creationId xmlns:a16="http://schemas.microsoft.com/office/drawing/2014/main" id="{2B21D496-E9CF-4794-9B22-9D1EBAE37AC4}"/>
+              </a:ext>
+            </a:extLst>
+          </p:cNvPr>
+          <p:cNvSpPr>
+            <a:spLocks xmlns:a="http://schemas.openxmlformats.org/drawingml/2006/main" noGrp="1"/>
+          </p:cNvSpPr>
+          <p:nvPr/>
+        </p:nvSpPr>
+        <p:spPr>
+          <a:xfrm xmlns:a="http://schemas.openxmlformats.org/drawingml/2006/main">
+            <a:off x="723900" y="6038850"/>
+            <a:ext cx="10668000" cy="409575"/>
+          </a:xfrm>
+          <a:prstGeom xmlns:a="http://schemas.openxmlformats.org/drawingml/2006/main" prst="rect">
+            <a:avLst/>
+          </a:prstGeom>
+          <a:noFill xmlns:a="http://schemas.openxmlformats.org/drawingml/2006/main"/>
+          <a:ln xmlns:a="http://schemas.openxmlformats.org/drawingml/2006/main" w="0">
+            <a:noFill/>
+          </a:ln>
+        </p:spPr>
+        <p:txBody>
+          <a:bodyPr xmlns:a="http://schemas.openxmlformats.org/drawingml/2006/main" wrap="square" lIns="0" tIns="0" rIns="0" bIns="0" anchor="t">
+            <a:noAutofit/>
+          </a:bodyPr>
+          <a:lstStyle xmlns:a="http://schemas.openxmlformats.org/drawingml/2006/main"/>
+          <a:p xmlns:a="http://schemas.openxmlformats.org/drawingml/2006/main">
+            <a:pPr>
+              <a:defRPr sz="1725" b="0">
+                <a:solidFill>
+                  <a:srgbClr val="111827"/>
+                </a:solidFill>
+                <a:latin typeface="Helvetica Neue"/>
+                <a:ea typeface="Helvetica Neue"/>
+                <a:cs typeface="Helvetica Neue"/>
+              </a:defRPr>
+            </a:pPr>
+            <a:r>
+              <a:rPr sz="1725" b="0">
+                <a:solidFill>
+                  <a:srgbClr val="111827"/>
+                </a:solidFill>
+                <a:latin typeface="Helvetica Neue"/>
+                <a:ea typeface="Helvetica Neue"/>
+                <a:cs typeface="Helvetica Neue"/>
+              </a:rPr>
+              <a:t>Use your run's observations, or identify the supplied trace and your unexecuted prediction.</a:t>
+            </a:r>
+          </a:p>
+        </p:txBody>
+      </p:sp>
+    </p:spTree>
+    <p:extLst>
+      <p:ext uri="{BB962C8B-B14F-4D97-AF65-F5344CB8AC3E}">
+        <p14:creationId xmlns:p14="http://schemas.microsoft.com/office/powerpoint/2010/main" val="23974070"/>
+      </p:ext>
+    </p:extLst>
+  </p:cSld>
+</p:sld>
+</file>
+
+<file path=ppt/slides/slide25.xml><?xml version="1.0" encoding="utf-8"?>
+<p:sld xmlns:p="http://schemas.openxmlformats.org/presentationml/2006/main">
+  <p:cSld>
+    <p:bg>
+      <p:bgPr>
+        <a:solidFill xmlns:a="http://schemas.openxmlformats.org/drawingml/2006/main">
+          <a:srgbClr val="FCFCFA"/>
+        </a:solidFill>
+      </p:bgPr>
+    </p:bg>
+    <p:spTree>
+      <p:nvGrpSpPr>
+        <p:cNvPr id="1" name=""/>
+        <p:cNvGrpSpPr/>
+        <p:nvPr/>
+      </p:nvGrpSpPr>
+      <p:grpSpPr>
+        <a:xfrm xmlns:a="http://schemas.openxmlformats.org/drawingml/2006/main"/>
+      </p:grpSpPr>
+      <p:sp>
+        <p:nvSpPr>
+          <p:cNvPr id="8" name="eyebrow">
+            <a:extLst xmlns:a="http://schemas.openxmlformats.org/drawingml/2006/main">
+              <a:ext uri="{FF2B5EF4-FFF2-40B4-BE49-F238E27FC236}">
+                <a16:creationId xmlns:a16="http://schemas.microsoft.com/office/drawing/2014/main" id="{D5112A70-1D1D-4510-9105-F55F91E3EBFA}"/>
+              </a:ext>
+            </a:extLst>
+          </p:cNvPr>
+          <p:cNvSpPr>
+            <a:spLocks xmlns:a="http://schemas.openxmlformats.org/drawingml/2006/main" noGrp="1"/>
+          </p:cNvSpPr>
+          <p:nvPr/>
+        </p:nvSpPr>
+        <p:spPr>
+          <a:xfrm xmlns:a="http://schemas.openxmlformats.org/drawingml/2006/main">
+            <a:off x="609600" y="295275"/>
+            <a:ext cx="5715000" cy="228600"/>
+          </a:xfrm>
+          <a:prstGeom xmlns:a="http://schemas.openxmlformats.org/drawingml/2006/main" prst="rect">
+            <a:avLst/>
+          </a:prstGeom>
+          <a:noFill xmlns:a="http://schemas.openxmlformats.org/drawingml/2006/main"/>
+          <a:ln xmlns:a="http://schemas.openxmlformats.org/drawingml/2006/main" w="0">
+            <a:noFill/>
+          </a:ln>
+        </p:spPr>
+        <p:txBody>
+          <a:bodyPr xmlns:a="http://schemas.openxmlformats.org/drawingml/2006/main" wrap="square" lIns="0" tIns="0" rIns="0" bIns="0" anchor="t">
+            <a:noAutofit/>
+          </a:bodyPr>
+          <a:lstStyle xmlns:a="http://schemas.openxmlformats.org/drawingml/2006/main"/>
+          <a:p xmlns:a="http://schemas.openxmlformats.org/drawingml/2006/main">
+            <a:pPr>
+              <a:defRPr sz="1050" b="1">
+                <a:solidFill>
+                  <a:srgbClr val="BF3E05"/>
+                </a:solidFill>
+                <a:latin typeface="Helvetica Neue"/>
+                <a:ea typeface="Helvetica Neue"/>
+                <a:cs typeface="Helvetica Neue"/>
+              </a:defRPr>
+            </a:pPr>
+            <a:r>
+              <a:rPr sz="1050" b="1">
+                <a:solidFill>
+                  <a:srgbClr val="BF3E05"/>
+                </a:solidFill>
+                <a:latin typeface="Helvetica Neue"/>
+                <a:ea typeface="Helvetica Neue"/>
+                <a:cs typeface="Helvetica Neue"/>
+              </a:rPr>
+              <a:t>WEEK 05  /  CST4714</a:t>
+            </a:r>
+          </a:p>
+        </p:txBody>
+      </p:sp>
+      <p:sp>
+        <p:nvSpPr>
+          <p:cNvPr id="2" name="slide-title">
+            <a:extLst xmlns:a="http://schemas.openxmlformats.org/drawingml/2006/main">
+              <a:ext uri="{FF2B5EF4-FFF2-40B4-BE49-F238E27FC236}">
+                <a16:creationId xmlns:a16="http://schemas.microsoft.com/office/drawing/2014/main" id="{70EABDFB-467F-4982-A611-E25A20E353B1}"/>
+              </a:ext>
+            </a:extLst>
+          </p:cNvPr>
+          <p:cNvSpPr>
+            <a:spLocks xmlns:a="http://schemas.openxmlformats.org/drawingml/2006/main" noGrp="1"/>
+          </p:cNvSpPr>
+          <p:nvPr/>
+        </p:nvSpPr>
+        <p:spPr>
+          <a:xfrm xmlns:a="http://schemas.openxmlformats.org/drawingml/2006/main">
+            <a:off x="609600" y="619125"/>
+            <a:ext cx="10972800" cy="628650"/>
+          </a:xfrm>
+          <a:prstGeom xmlns:a="http://schemas.openxmlformats.org/drawingml/2006/main" prst="rect">
+            <a:avLst/>
+          </a:prstGeom>
+          <a:noFill xmlns:a="http://schemas.openxmlformats.org/drawingml/2006/main"/>
+          <a:ln xmlns:a="http://schemas.openxmlformats.org/drawingml/2006/main" w="0">
+            <a:noFill/>
+          </a:ln>
+        </p:spPr>
+        <p:txBody>
+          <a:bodyPr xmlns:a="http://schemas.openxmlformats.org/drawingml/2006/main" wrap="square" lIns="0" tIns="0" rIns="0" bIns="0" anchor="t">
+            <a:noAutofit/>
+          </a:bodyPr>
+          <a:lstStyle xmlns:a="http://schemas.openxmlformats.org/drawingml/2006/main"/>
+          <a:p xmlns:a="http://schemas.openxmlformats.org/drawingml/2006/main">
+            <a:pPr>
+              <a:defRPr sz="2775" b="1">
+                <a:solidFill>
+                  <a:srgbClr val="111827"/>
+                </a:solidFill>
+                <a:latin typeface="Helvetica Neue"/>
+                <a:ea typeface="Helvetica Neue"/>
+                <a:cs typeface="Helvetica Neue"/>
+              </a:defRPr>
+            </a:pPr>
+            <a:r>
+              <a:rPr sz="2775" b="1">
+                <a:solidFill>
+                  <a:srgbClr val="111827"/>
+                </a:solidFill>
+                <a:latin typeface="Helvetica Neue"/>
+                <a:ea typeface="Helvetica Neue"/>
+                <a:cs typeface="Helvetica Neue"/>
+              </a:rPr>
+              <a:t>Transaction decisions leave observable results</a:t>
+            </a:r>
+          </a:p>
+        </p:txBody>
+      </p:sp>
+      <p:sp>
+        <p:nvSpPr>
+          <p:cNvPr id="3" name="">
+            <a:extLst xmlns:a="http://schemas.openxmlformats.org/drawingml/2006/main">
+              <a:ext uri="{FF2B5EF4-FFF2-40B4-BE49-F238E27FC236}">
+                <a16:creationId xmlns:a16="http://schemas.microsoft.com/office/drawing/2014/main" id="{EEF0DEB8-0155-4AA7-8AC7-B6FBB7FE44D7}"/>
+              </a:ext>
+            </a:extLst>
+          </p:cNvPr>
+          <p:cNvSpPr>
+            <a:spLocks xmlns:a="http://schemas.openxmlformats.org/drawingml/2006/main" noGrp="1"/>
+          </p:cNvSpPr>
+          <p:nvPr/>
+        </p:nvSpPr>
+        <p:spPr>
+          <a:xfrm xmlns:a="http://schemas.openxmlformats.org/drawingml/2006/main">
+            <a:off x="609600" y="1295400"/>
+            <a:ext cx="10972800" cy="9525"/>
+          </a:xfrm>
+          <a:prstGeom xmlns:a="http://schemas.openxmlformats.org/drawingml/2006/main" prst="rect">
+            <a:avLst/>
+          </a:prstGeom>
+          <a:solidFill xmlns:a="http://schemas.openxmlformats.org/drawingml/2006/main">
+            <a:srgbClr val="CBD5E1"/>
+          </a:solidFill>
+          <a:ln xmlns:a="http://schemas.openxmlformats.org/drawingml/2006/main" w="0">
+            <a:solidFill>
+              <a:srgbClr val="CBD5E1"/>
+            </a:solidFill>
+          </a:ln>
+        </p:spPr>
+      </p:sp>
+      <p:sp>
+        <p:nvSpPr>
+          <p:cNvPr id="4" name="slide-number">
+            <a:extLst xmlns:a="http://schemas.openxmlformats.org/drawingml/2006/main">
+              <a:ext uri="{FF2B5EF4-FFF2-40B4-BE49-F238E27FC236}">
+                <a16:creationId xmlns:a16="http://schemas.microsoft.com/office/drawing/2014/main" id="{B59B3127-64CF-42EF-AB0C-DD9FA5FBD1DB}"/>
+              </a:ext>
+            </a:extLst>
+          </p:cNvPr>
+          <p:cNvSpPr>
+            <a:spLocks xmlns:a="http://schemas.openxmlformats.org/drawingml/2006/main" noGrp="1"/>
+          </p:cNvSpPr>
+          <p:nvPr/>
+        </p:nvSpPr>
+        <p:spPr>
+          <a:xfrm xmlns:a="http://schemas.openxmlformats.org/drawingml/2006/main">
+            <a:off x="11125200" y="6467475"/>
+            <a:ext cx="457200" cy="190500"/>
+          </a:xfrm>
+          <a:prstGeom xmlns:a="http://schemas.openxmlformats.org/drawingml/2006/main" prst="rect">
+            <a:avLst/>
+          </a:prstGeom>
+          <a:noFill xmlns:a="http://schemas.openxmlformats.org/drawingml/2006/main"/>
+          <a:ln xmlns:a="http://schemas.openxmlformats.org/drawingml/2006/main" w="0">
+            <a:noFill/>
+          </a:ln>
+        </p:spPr>
+        <p:txBody>
+          <a:bodyPr xmlns:a="http://schemas.openxmlformats.org/drawingml/2006/main" wrap="square" lIns="0" tIns="0" rIns="0" bIns="0" anchor="t">
+            <a:noAutofit/>
+          </a:bodyPr>
+          <a:lstStyle xmlns:a="http://schemas.openxmlformats.org/drawingml/2006/main"/>
+          <a:p xmlns:a="http://schemas.openxmlformats.org/drawingml/2006/main">
+            <a:pPr>
+              <a:defRPr sz="900" b="0">
+                <a:solidFill>
+                  <a:srgbClr val="64748B"/>
+                </a:solidFill>
+                <a:latin typeface="Helvetica Neue"/>
+                <a:ea typeface="Helvetica Neue"/>
+                <a:cs typeface="Helvetica Neue"/>
+              </a:defRPr>
+            </a:pPr>
+            <a:r>
+              <a:rPr sz="900" b="0">
+                <a:solidFill>
+                  <a:srgbClr val="64748B"/>
+                </a:solidFill>
+                <a:latin typeface="Helvetica Neue"/>
+                <a:ea typeface="Helvetica Neue"/>
+                <a:cs typeface="Helvetica Neue"/>
+              </a:rPr>
+              <a:t>25</a:t>
+            </a:r>
+          </a:p>
+        </p:txBody>
+      </p:sp>
+      <p:sp>
+        <p:nvSpPr>
+          <p:cNvPr id="5" name="summary">
+            <a:extLst xmlns:a="http://schemas.openxmlformats.org/drawingml/2006/main">
+              <a:ext uri="{FF2B5EF4-FFF2-40B4-BE49-F238E27FC236}">
+                <a16:creationId xmlns:a16="http://schemas.microsoft.com/office/drawing/2014/main" id="{03DC8891-4595-4079-B34E-35844E553141}"/>
+              </a:ext>
+            </a:extLst>
+          </p:cNvPr>
+          <p:cNvSpPr>
+            <a:spLocks xmlns:a="http://schemas.openxmlformats.org/drawingml/2006/main" noGrp="1"/>
+          </p:cNvSpPr>
+          <p:nvPr/>
+        </p:nvSpPr>
+        <p:spPr>
+          <a:xfrm xmlns:a="http://schemas.openxmlformats.org/drawingml/2006/main">
+            <a:off x="723900" y="2028825"/>
+            <a:ext cx="10668000" cy="1876425"/>
+          </a:xfrm>
+          <a:prstGeom xmlns:a="http://schemas.openxmlformats.org/drawingml/2006/main" prst="rect">
+            <a:avLst/>
+          </a:prstGeom>
+          <a:noFill xmlns:a="http://schemas.openxmlformats.org/drawingml/2006/main"/>
+          <a:ln xmlns:a="http://schemas.openxmlformats.org/drawingml/2006/main" w="0">
+            <a:noFill/>
+          </a:ln>
+        </p:spPr>
+        <p:txBody>
+          <a:bodyPr xmlns:a="http://schemas.openxmlformats.org/drawingml/2006/main" wrap="square" lIns="0" tIns="0" rIns="0" bIns="0" anchor="t">
+            <a:noAutofit/>
+          </a:bodyPr>
+          <a:lstStyle xmlns:a="http://schemas.openxmlformats.org/drawingml/2006/main"/>
+          <a:p xmlns:a="http://schemas.openxmlformats.org/drawingml/2006/main">
+            <a:pPr>
               <a:defRPr sz="2925" b="0">
                 <a:solidFill>
                   <a:srgbClr val="111827"/>
@@ -13351,7 +15027,7 @@
           <p:cNvPr id="6" name="synthesis">
             <a:extLst xmlns:a="http://schemas.openxmlformats.org/drawingml/2006/main">
               <a:ext uri="{FF2B5EF4-FFF2-40B4-BE49-F238E27FC236}">
-                <a16:creationId xmlns:a16="http://schemas.microsoft.com/office/drawing/2014/main" id="{B604F771-994E-4C2B-8957-F08FD9D20E87}"/>
+                <a16:creationId xmlns:a16="http://schemas.microsoft.com/office/drawing/2014/main" id="{10809E31-FF40-4C95-9CCD-BAC57C5CB9F2}"/>
               </a:ext>
             </a:extLst>
           </p:cNvPr>
@@ -13408,7 +15084,7 @@
           <p:cNvPr id="7" name="next">
             <a:extLst xmlns:a="http://schemas.openxmlformats.org/drawingml/2006/main">
               <a:ext uri="{FF2B5EF4-FFF2-40B4-BE49-F238E27FC236}">
-                <a16:creationId xmlns:a16="http://schemas.microsoft.com/office/drawing/2014/main" id="{DB58AFA3-93D5-487E-A420-C135D4BBA5C4}"/>
+                <a16:creationId xmlns:a16="http://schemas.microsoft.com/office/drawing/2014/main" id="{0D3BF291-F9C7-4184-85A0-A53435A80F73}"/>
               </a:ext>
             </a:extLst>
           </p:cNvPr>
@@ -13494,7 +15170,7 @@
           <p:cNvPr id="17" name="eyebrow">
             <a:extLst xmlns:a="http://schemas.openxmlformats.org/drawingml/2006/main">
               <a:ext uri="{FF2B5EF4-FFF2-40B4-BE49-F238E27FC236}">
-                <a16:creationId xmlns:a16="http://schemas.microsoft.com/office/drawing/2014/main" id="{EDE0ABD4-33BE-4ABA-BFE4-22CF7190DC1C}"/>
+                <a16:creationId xmlns:a16="http://schemas.microsoft.com/office/drawing/2014/main" id="{688082A1-D97C-47FE-840D-072836920AC6}"/>
               </a:ext>
             </a:extLst>
           </p:cNvPr>
@@ -13551,7 +15227,7 @@
           <p:cNvPr id="2" name="slide-title">
             <a:extLst xmlns:a="http://schemas.openxmlformats.org/drawingml/2006/main">
               <a:ext uri="{FF2B5EF4-FFF2-40B4-BE49-F238E27FC236}">
-                <a16:creationId xmlns:a16="http://schemas.microsoft.com/office/drawing/2014/main" id="{826F38BB-555E-4675-B3D9-CD62B925B3FD}"/>
+                <a16:creationId xmlns:a16="http://schemas.microsoft.com/office/drawing/2014/main" id="{39C290FD-E052-432C-9161-CB6ECAD7F778}"/>
               </a:ext>
             </a:extLst>
           </p:cNvPr>
@@ -13608,7 +15284,7 @@
           <p:cNvPr id="3" name="">
             <a:extLst xmlns:a="http://schemas.openxmlformats.org/drawingml/2006/main">
               <a:ext uri="{FF2B5EF4-FFF2-40B4-BE49-F238E27FC236}">
-                <a16:creationId xmlns:a16="http://schemas.microsoft.com/office/drawing/2014/main" id="{BC813853-F604-4450-97E0-8AFB695B0BCB}"/>
+                <a16:creationId xmlns:a16="http://schemas.microsoft.com/office/drawing/2014/main" id="{C8E7EBA1-502A-4228-A35D-DACEB762E3F7}"/>
               </a:ext>
             </a:extLst>
           </p:cNvPr>
@@ -13640,7 +15316,7 @@
           <p:cNvPr id="4" name="slide-number">
             <a:extLst xmlns:a="http://schemas.openxmlformats.org/drawingml/2006/main">
               <a:ext uri="{FF2B5EF4-FFF2-40B4-BE49-F238E27FC236}">
-                <a16:creationId xmlns:a16="http://schemas.microsoft.com/office/drawing/2014/main" id="{B221BDB5-DBAC-4675-A5DB-9A2A72359F5F}"/>
+                <a16:creationId xmlns:a16="http://schemas.microsoft.com/office/drawing/2014/main" id="{269BCB21-B648-4E20-8E29-715929E5C892}"/>
               </a:ext>
             </a:extLst>
           </p:cNvPr>
@@ -13697,7 +15373,7 @@
           <p:cNvPr id="5" name="">
             <a:extLst xmlns:a="http://schemas.openxmlformats.org/drawingml/2006/main">
               <a:ext uri="{FF2B5EF4-FFF2-40B4-BE49-F238E27FC236}">
-                <a16:creationId xmlns:a16="http://schemas.microsoft.com/office/drawing/2014/main" id="{A774F2CD-1500-4FDB-AD0D-A1101B2248BC}"/>
+                <a16:creationId xmlns:a16="http://schemas.microsoft.com/office/drawing/2014/main" id="{88229531-B019-4434-868A-2541FBC4B3B6}"/>
               </a:ext>
             </a:extLst>
           </p:cNvPr>
@@ -13729,7 +15405,7 @@
           <p:cNvPr id="6" name="begin">
             <a:extLst xmlns:a="http://schemas.openxmlformats.org/drawingml/2006/main">
               <a:ext uri="{FF2B5EF4-FFF2-40B4-BE49-F238E27FC236}">
-                <a16:creationId xmlns:a16="http://schemas.microsoft.com/office/drawing/2014/main" id="{F292FD1D-A734-4DEF-983E-770D4BA534EB}"/>
+                <a16:creationId xmlns:a16="http://schemas.microsoft.com/office/drawing/2014/main" id="{27CCAC05-3473-48E3-8A9E-BFB5DFAAF389}"/>
               </a:ext>
             </a:extLst>
           </p:cNvPr>
@@ -13809,7 +15485,7 @@
           <p:cNvPr id="7" name="">
             <a:extLst xmlns:a="http://schemas.openxmlformats.org/drawingml/2006/main">
               <a:ext uri="{FF2B5EF4-FFF2-40B4-BE49-F238E27FC236}">
-                <a16:creationId xmlns:a16="http://schemas.microsoft.com/office/drawing/2014/main" id="{E4412517-F5C6-4576-80C7-F05C0795C1EA}"/>
+                <a16:creationId xmlns:a16="http://schemas.microsoft.com/office/drawing/2014/main" id="{FBBE86D6-BA80-4B94-88BA-1838AB79DA4E}"/>
               </a:ext>
             </a:extLst>
           </p:cNvPr>
@@ -13841,7 +15517,7 @@
           <p:cNvPr id="8" name="">
             <a:extLst xmlns:a="http://schemas.openxmlformats.org/drawingml/2006/main">
               <a:ext uri="{FF2B5EF4-FFF2-40B4-BE49-F238E27FC236}">
-                <a16:creationId xmlns:a16="http://schemas.microsoft.com/office/drawing/2014/main" id="{C848783E-B1A3-496A-A83C-9B6CF35BBC18}"/>
+                <a16:creationId xmlns:a16="http://schemas.microsoft.com/office/drawing/2014/main" id="{889C597E-CA81-448E-93E6-05AFE8899ACF}"/>
               </a:ext>
             </a:extLst>
           </p:cNvPr>
@@ -13873,7 +15549,7 @@
           <p:cNvPr id="9" name="work">
             <a:extLst xmlns:a="http://schemas.openxmlformats.org/drawingml/2006/main">
               <a:ext uri="{FF2B5EF4-FFF2-40B4-BE49-F238E27FC236}">
-                <a16:creationId xmlns:a16="http://schemas.microsoft.com/office/drawing/2014/main" id="{6720F450-36E2-4F52-B016-F483BCF333E2}"/>
+                <a16:creationId xmlns:a16="http://schemas.microsoft.com/office/drawing/2014/main" id="{F261694E-01C3-4E4C-9BEC-909EEFD559F9}"/>
               </a:ext>
             </a:extLst>
           </p:cNvPr>
@@ -13953,7 +15629,7 @@
           <p:cNvPr id="10" name="">
             <a:extLst xmlns:a="http://schemas.openxmlformats.org/drawingml/2006/main">
               <a:ext uri="{FF2B5EF4-FFF2-40B4-BE49-F238E27FC236}">
-                <a16:creationId xmlns:a16="http://schemas.microsoft.com/office/drawing/2014/main" id="{D9003930-2912-4A25-8CD9-6503FF03281A}"/>
+                <a16:creationId xmlns:a16="http://schemas.microsoft.com/office/drawing/2014/main" id="{CCC7D78A-54A5-471E-A758-7F142B1070AE}"/>
               </a:ext>
             </a:extLst>
           </p:cNvPr>
@@ -13985,7 +15661,7 @@
           <p:cNvPr id="11" name="">
             <a:extLst xmlns:a="http://schemas.openxmlformats.org/drawingml/2006/main">
               <a:ext uri="{FF2B5EF4-FFF2-40B4-BE49-F238E27FC236}">
-                <a16:creationId xmlns:a16="http://schemas.microsoft.com/office/drawing/2014/main" id="{B47FC5F0-C09C-455E-9F2D-E565EF7E5841}"/>
+                <a16:creationId xmlns:a16="http://schemas.microsoft.com/office/drawing/2014/main" id="{12110D1B-CFF7-4592-AED1-0F9E391808D2}"/>
               </a:ext>
             </a:extLst>
           </p:cNvPr>
@@ -14017,7 +15693,7 @@
           <p:cNvPr id="12" name="">
             <a:extLst xmlns:a="http://schemas.openxmlformats.org/drawingml/2006/main">
               <a:ext uri="{FF2B5EF4-FFF2-40B4-BE49-F238E27FC236}">
-                <a16:creationId xmlns:a16="http://schemas.microsoft.com/office/drawing/2014/main" id="{E2030B7B-9902-4601-835C-326335D8B7E0}"/>
+                <a16:creationId xmlns:a16="http://schemas.microsoft.com/office/drawing/2014/main" id="{F10A48F5-53A9-46DA-838B-4DD08321C869}"/>
               </a:ext>
             </a:extLst>
           </p:cNvPr>
@@ -14049,7 +15725,7 @@
           <p:cNvPr id="13" name="commit">
             <a:extLst xmlns:a="http://schemas.openxmlformats.org/drawingml/2006/main">
               <a:ext uri="{FF2B5EF4-FFF2-40B4-BE49-F238E27FC236}">
-                <a16:creationId xmlns:a16="http://schemas.microsoft.com/office/drawing/2014/main" id="{7875C11B-5D3A-4F06-8D9E-F99B6671A9D6}"/>
+                <a16:creationId xmlns:a16="http://schemas.microsoft.com/office/drawing/2014/main" id="{DEB949F8-5D45-4C5D-B0F8-BABB9A19B93D}"/>
               </a:ext>
             </a:extLst>
           </p:cNvPr>
@@ -14129,7 +15805,7 @@
           <p:cNvPr id="14" name="">
             <a:extLst xmlns:a="http://schemas.openxmlformats.org/drawingml/2006/main">
               <a:ext uri="{FF2B5EF4-FFF2-40B4-BE49-F238E27FC236}">
-                <a16:creationId xmlns:a16="http://schemas.microsoft.com/office/drawing/2014/main" id="{60051C8D-FCC5-4011-BE3F-B779F9EF28AC}"/>
+                <a16:creationId xmlns:a16="http://schemas.microsoft.com/office/drawing/2014/main" id="{0D23FBC5-64A4-4C86-99B1-19A9C705A8B6}"/>
               </a:ext>
             </a:extLst>
           </p:cNvPr>
@@ -14161,7 +15837,7 @@
           <p:cNvPr id="15" name="rollback">
             <a:extLst xmlns:a="http://schemas.openxmlformats.org/drawingml/2006/main">
               <a:ext uri="{FF2B5EF4-FFF2-40B4-BE49-F238E27FC236}">
-                <a16:creationId xmlns:a16="http://schemas.microsoft.com/office/drawing/2014/main" id="{EF4CC15A-BF5A-4A75-8814-AF987064EE3B}"/>
+                <a16:creationId xmlns:a16="http://schemas.microsoft.com/office/drawing/2014/main" id="{F009B4E4-D81B-4562-9FAA-E36EF628004C}"/>
               </a:ext>
             </a:extLst>
           </p:cNvPr>
@@ -14241,7 +15917,7 @@
           <p:cNvPr id="16" name="boundary">
             <a:extLst xmlns:a="http://schemas.openxmlformats.org/drawingml/2006/main">
               <a:ext uri="{FF2B5EF4-FFF2-40B4-BE49-F238E27FC236}">
-                <a16:creationId xmlns:a16="http://schemas.microsoft.com/office/drawing/2014/main" id="{E3D7A150-E1EB-466C-903A-2B7F72D0DF3A}"/>
+                <a16:creationId xmlns:a16="http://schemas.microsoft.com/office/drawing/2014/main" id="{122C1D17-FF08-4A99-A37C-D7ACDF73BBE9}"/>
               </a:ext>
             </a:extLst>
           </p:cNvPr>
@@ -14327,7 +16003,7 @@
           <p:cNvPr id="8" name="eyebrow">
             <a:extLst xmlns:a="http://schemas.openxmlformats.org/drawingml/2006/main">
               <a:ext uri="{FF2B5EF4-FFF2-40B4-BE49-F238E27FC236}">
-                <a16:creationId xmlns:a16="http://schemas.microsoft.com/office/drawing/2014/main" id="{06DA6D27-0E2C-421B-8467-EAEC4ABA0886}"/>
+                <a16:creationId xmlns:a16="http://schemas.microsoft.com/office/drawing/2014/main" id="{8051D8FE-5DD2-4177-B071-C4C98C53E2BB}"/>
               </a:ext>
             </a:extLst>
           </p:cNvPr>
@@ -14384,7 +16060,7 @@
           <p:cNvPr id="2" name="slide-title">
             <a:extLst xmlns:a="http://schemas.openxmlformats.org/drawingml/2006/main">
               <a:ext uri="{FF2B5EF4-FFF2-40B4-BE49-F238E27FC236}">
-                <a16:creationId xmlns:a16="http://schemas.microsoft.com/office/drawing/2014/main" id="{A1D8C996-F885-4C60-9186-F76999DA9A26}"/>
+                <a16:creationId xmlns:a16="http://schemas.microsoft.com/office/drawing/2014/main" id="{90B760E4-824C-4867-86EC-E5DFA7BD400E}"/>
               </a:ext>
             </a:extLst>
           </p:cNvPr>
@@ -14441,7 +16117,7 @@
           <p:cNvPr id="3" name="">
             <a:extLst xmlns:a="http://schemas.openxmlformats.org/drawingml/2006/main">
               <a:ext uri="{FF2B5EF4-FFF2-40B4-BE49-F238E27FC236}">
-                <a16:creationId xmlns:a16="http://schemas.microsoft.com/office/drawing/2014/main" id="{FE021676-EE78-4438-AA7E-B9AE577B63E5}"/>
+                <a16:creationId xmlns:a16="http://schemas.microsoft.com/office/drawing/2014/main" id="{E25E67EE-34F5-4968-BFCB-902734634FAE}"/>
               </a:ext>
             </a:extLst>
           </p:cNvPr>
@@ -14473,7 +16149,7 @@
           <p:cNvPr id="4" name="slide-number">
             <a:extLst xmlns:a="http://schemas.openxmlformats.org/drawingml/2006/main">
               <a:ext uri="{FF2B5EF4-FFF2-40B4-BE49-F238E27FC236}">
-                <a16:creationId xmlns:a16="http://schemas.microsoft.com/office/drawing/2014/main" id="{FBFB5B3E-B5EB-4A70-BD1E-3554161F4DCA}"/>
+                <a16:creationId xmlns:a16="http://schemas.microsoft.com/office/drawing/2014/main" id="{BDEEFCF6-3B52-4FE5-8AFF-225D884C666F}"/>
               </a:ext>
             </a:extLst>
           </p:cNvPr>
@@ -14530,7 +16206,7 @@
           <p:cNvPr id="5" name="">
             <a:extLst xmlns:a="http://schemas.openxmlformats.org/drawingml/2006/main">
               <a:ext uri="{FF2B5EF4-FFF2-40B4-BE49-F238E27FC236}">
-                <a16:creationId xmlns:a16="http://schemas.microsoft.com/office/drawing/2014/main" id="{B3912175-4F6A-4C04-9C3F-91B880622377}"/>
+                <a16:creationId xmlns:a16="http://schemas.microsoft.com/office/drawing/2014/main" id="{182F6318-41AE-4530-91C2-99B973E0F2DF}"/>
               </a:ext>
             </a:extLst>
           </p:cNvPr>
@@ -14562,7 +16238,7 @@
           <p:cNvPr id="6" name="pair-sql">
             <a:extLst xmlns:a="http://schemas.openxmlformats.org/drawingml/2006/main">
               <a:ext uri="{FF2B5EF4-FFF2-40B4-BE49-F238E27FC236}">
-                <a16:creationId xmlns:a16="http://schemas.microsoft.com/office/drawing/2014/main" id="{E727CEC1-A70C-4584-9910-C0EC21706EBF}"/>
+                <a16:creationId xmlns:a16="http://schemas.microsoft.com/office/drawing/2014/main" id="{63F5B4DF-B407-4921-A2BB-12C10C19AB67}"/>
               </a:ext>
             </a:extLst>
           </p:cNvPr>
@@ -14821,7 +16497,7 @@
                 <a:ea typeface="Menlo"/>
                 <a:cs typeface="Menlo"/>
               </a:rPr>
-              <a:t>        'in_progress', 'Assigned to Noah', now());</a:t>
+              <a:t>        'in_progress', 'Assigned to Agent 202', now());</a:t>
             </a:r>
           </a:p>
           <a:p xmlns:a="http://schemas.openxmlformats.org/drawingml/2006/main">
@@ -14859,7 +16535,7 @@
           <p:cNvPr id="7" name="whole-block">
             <a:extLst xmlns:a="http://schemas.openxmlformats.org/drawingml/2006/main">
               <a:ext uri="{FF2B5EF4-FFF2-40B4-BE49-F238E27FC236}">
-                <a16:creationId xmlns:a16="http://schemas.microsoft.com/office/drawing/2014/main" id="{5BFE7905-7489-46B5-985A-3E3DBABF3F25}"/>
+                <a16:creationId xmlns:a16="http://schemas.microsoft.com/office/drawing/2014/main" id="{624D7362-C1EF-42E8-8490-AED380B67119}"/>
               </a:ext>
             </a:extLst>
           </p:cNvPr>
@@ -14945,7 +16621,7 @@
           <p:cNvPr id="8" name="eyebrow">
             <a:extLst xmlns:a="http://schemas.openxmlformats.org/drawingml/2006/main">
               <a:ext uri="{FF2B5EF4-FFF2-40B4-BE49-F238E27FC236}">
-                <a16:creationId xmlns:a16="http://schemas.microsoft.com/office/drawing/2014/main" id="{F5103186-F296-4C98-BCB7-9127FA2D529D}"/>
+                <a16:creationId xmlns:a16="http://schemas.microsoft.com/office/drawing/2014/main" id="{43DCE163-434F-420E-8A1F-AE4D8220DCD4}"/>
               </a:ext>
             </a:extLst>
           </p:cNvPr>
@@ -15002,7 +16678,7 @@
           <p:cNvPr id="2" name="slide-title">
             <a:extLst xmlns:a="http://schemas.openxmlformats.org/drawingml/2006/main">
               <a:ext uri="{FF2B5EF4-FFF2-40B4-BE49-F238E27FC236}">
-                <a16:creationId xmlns:a16="http://schemas.microsoft.com/office/drawing/2014/main" id="{A2068DE1-858C-4ABB-A009-1418F5A9C73C}"/>
+                <a16:creationId xmlns:a16="http://schemas.microsoft.com/office/drawing/2014/main" id="{2DD5314F-28DC-4251-BB48-814A03FCABE6}"/>
               </a:ext>
             </a:extLst>
           </p:cNvPr>
@@ -15059,7 +16735,7 @@
           <p:cNvPr id="3" name="">
             <a:extLst xmlns:a="http://schemas.openxmlformats.org/drawingml/2006/main">
               <a:ext uri="{FF2B5EF4-FFF2-40B4-BE49-F238E27FC236}">
-                <a16:creationId xmlns:a16="http://schemas.microsoft.com/office/drawing/2014/main" id="{B4A7F4E2-3370-45B1-8731-EA51030D03AE}"/>
+                <a16:creationId xmlns:a16="http://schemas.microsoft.com/office/drawing/2014/main" id="{E33CF2F8-70A6-4278-ADC8-8A5040ECE98D}"/>
               </a:ext>
             </a:extLst>
           </p:cNvPr>
@@ -15091,7 +16767,7 @@
           <p:cNvPr id="4" name="slide-number">
             <a:extLst xmlns:a="http://schemas.openxmlformats.org/drawingml/2006/main">
               <a:ext uri="{FF2B5EF4-FFF2-40B4-BE49-F238E27FC236}">
-                <a16:creationId xmlns:a16="http://schemas.microsoft.com/office/drawing/2014/main" id="{6394A3D0-32B0-4FD9-AB5C-93D4E284D6D9}"/>
+                <a16:creationId xmlns:a16="http://schemas.microsoft.com/office/drawing/2014/main" id="{20D1D607-E3B8-41C2-83DE-0D42F2B2A679}"/>
               </a:ext>
             </a:extLst>
           </p:cNvPr>
@@ -15467,7 +17143,7 @@
           <p:cNvPr id="6" name="">
             <a:extLst xmlns:a="http://schemas.openxmlformats.org/drawingml/2006/main">
               <a:ext uri="{FF2B5EF4-FFF2-40B4-BE49-F238E27FC236}">
-                <a16:creationId xmlns:a16="http://schemas.microsoft.com/office/drawing/2014/main" id="{ABBFCE14-E8D2-4AD1-8D6A-45F132AEA114}"/>
+                <a16:creationId xmlns:a16="http://schemas.microsoft.com/office/drawing/2014/main" id="{BA04138D-300D-4525-9E4A-0E8489498EBD}"/>
               </a:ext>
             </a:extLst>
           </p:cNvPr>
@@ -15499,7 +17175,7 @@
           <p:cNvPr id="7" name="postcheck">
             <a:extLst xmlns:a="http://schemas.openxmlformats.org/drawingml/2006/main">
               <a:ext uri="{FF2B5EF4-FFF2-40B4-BE49-F238E27FC236}">
-                <a16:creationId xmlns:a16="http://schemas.microsoft.com/office/drawing/2014/main" id="{3D13179B-055F-436C-A5C0-9C1DA6F52407}"/>
+                <a16:creationId xmlns:a16="http://schemas.microsoft.com/office/drawing/2014/main" id="{7DDAD491-446C-497D-874F-FE720B562FAA}"/>
               </a:ext>
             </a:extLst>
           </p:cNvPr>
@@ -15631,7 +17307,7 @@
           <p:cNvPr id="11" name="eyebrow">
             <a:extLst xmlns:a="http://schemas.openxmlformats.org/drawingml/2006/main">
               <a:ext uri="{FF2B5EF4-FFF2-40B4-BE49-F238E27FC236}">
-                <a16:creationId xmlns:a16="http://schemas.microsoft.com/office/drawing/2014/main" id="{5FB0CB77-A11B-4C3F-93F5-E79B25F68EB8}"/>
+                <a16:creationId xmlns:a16="http://schemas.microsoft.com/office/drawing/2014/main" id="{F4C8F190-89C1-4CF2-B404-922D80AD799A}"/>
               </a:ext>
             </a:extLst>
           </p:cNvPr>
@@ -15688,7 +17364,7 @@
           <p:cNvPr id="2" name="slide-title">
             <a:extLst xmlns:a="http://schemas.openxmlformats.org/drawingml/2006/main">
               <a:ext uri="{FF2B5EF4-FFF2-40B4-BE49-F238E27FC236}">
-                <a16:creationId xmlns:a16="http://schemas.microsoft.com/office/drawing/2014/main" id="{A416EB9A-855B-48A0-831B-7FE43682C286}"/>
+                <a16:creationId xmlns:a16="http://schemas.microsoft.com/office/drawing/2014/main" id="{12A84190-FED1-496C-ACD6-7A3F50078840}"/>
               </a:ext>
             </a:extLst>
           </p:cNvPr>
@@ -15745,7 +17421,7 @@
           <p:cNvPr id="3" name="">
             <a:extLst xmlns:a="http://schemas.openxmlformats.org/drawingml/2006/main">
               <a:ext uri="{FF2B5EF4-FFF2-40B4-BE49-F238E27FC236}">
-                <a16:creationId xmlns:a16="http://schemas.microsoft.com/office/drawing/2014/main" id="{B9BEC49D-E5E2-4662-8037-DBDA54308C7F}"/>
+                <a16:creationId xmlns:a16="http://schemas.microsoft.com/office/drawing/2014/main" id="{55304660-AC97-4E64-8D29-A430C0AE65C7}"/>
               </a:ext>
             </a:extLst>
           </p:cNvPr>
@@ -15777,7 +17453,7 @@
           <p:cNvPr id="4" name="slide-number">
             <a:extLst xmlns:a="http://schemas.openxmlformats.org/drawingml/2006/main">
               <a:ext uri="{FF2B5EF4-FFF2-40B4-BE49-F238E27FC236}">
-                <a16:creationId xmlns:a16="http://schemas.microsoft.com/office/drawing/2014/main" id="{58935236-4B61-4553-8BE6-4689558F79B2}"/>
+                <a16:creationId xmlns:a16="http://schemas.microsoft.com/office/drawing/2014/main" id="{B124780C-4BEE-4ED3-9476-E29984A3967B}"/>
               </a:ext>
             </a:extLst>
           </p:cNvPr>
@@ -15834,7 +17510,7 @@
           <p:cNvPr id="5" name="">
             <a:extLst xmlns:a="http://schemas.openxmlformats.org/drawingml/2006/main">
               <a:ext uri="{FF2B5EF4-FFF2-40B4-BE49-F238E27FC236}">
-                <a16:creationId xmlns:a16="http://schemas.microsoft.com/office/drawing/2014/main" id="{F343CB03-C42A-4B12-A7FE-FB3D13506DF6}"/>
+                <a16:creationId xmlns:a16="http://schemas.microsoft.com/office/drawing/2014/main" id="{68320229-CFB0-40B4-80E8-E8CF7D40E111}"/>
               </a:ext>
             </a:extLst>
           </p:cNvPr>
@@ -15866,7 +17542,7 @@
           <p:cNvPr id="6" name="failure-sql">
             <a:extLst xmlns:a="http://schemas.openxmlformats.org/drawingml/2006/main">
               <a:ext uri="{FF2B5EF4-FFF2-40B4-BE49-F238E27FC236}">
-                <a16:creationId xmlns:a16="http://schemas.microsoft.com/office/drawing/2014/main" id="{16BA1DEC-3455-42E5-9417-F616FC04B5BA}"/>
+                <a16:creationId xmlns:a16="http://schemas.microsoft.com/office/drawing/2014/main" id="{8778C9A6-516B-4B17-B2A6-714BE8FBE9EF}"/>
               </a:ext>
             </a:extLst>
           </p:cNvPr>
@@ -16015,7 +17691,7 @@
           <p:cNvPr id="7" name="failure-result">
             <a:extLst xmlns:a="http://schemas.openxmlformats.org/drawingml/2006/main">
               <a:ext uri="{FF2B5EF4-FFF2-40B4-BE49-F238E27FC236}">
-                <a16:creationId xmlns:a16="http://schemas.microsoft.com/office/drawing/2014/main" id="{2177C360-5F79-49E1-90B8-EBF65EEAA136}"/>
+                <a16:creationId xmlns:a16="http://schemas.microsoft.com/office/drawing/2014/main" id="{0C1B60DF-2898-4FA4-A3A2-748AE802AE1B}"/>
               </a:ext>
             </a:extLst>
           </p:cNvPr>
@@ -16095,7 +17771,7 @@
           <p:cNvPr id="8" name="">
             <a:extLst xmlns:a="http://schemas.openxmlformats.org/drawingml/2006/main">
               <a:ext uri="{FF2B5EF4-FFF2-40B4-BE49-F238E27FC236}">
-                <a16:creationId xmlns:a16="http://schemas.microsoft.com/office/drawing/2014/main" id="{560996C1-CC85-4970-8A2D-6C7C6D17B347}"/>
+                <a16:creationId xmlns:a16="http://schemas.microsoft.com/office/drawing/2014/main" id="{4E40C680-12F0-4B81-85D3-651B25B98F7E}"/>
               </a:ext>
             </a:extLst>
           </p:cNvPr>
@@ -16127,7 +17803,7 @@
           <p:cNvPr id="9" name="failure-cleanup">
             <a:extLst xmlns:a="http://schemas.openxmlformats.org/drawingml/2006/main">
               <a:ext uri="{FF2B5EF4-FFF2-40B4-BE49-F238E27FC236}">
-                <a16:creationId xmlns:a16="http://schemas.microsoft.com/office/drawing/2014/main" id="{2F20C1D2-81A5-4432-B9FF-32E9CA9E0EEE}"/>
+                <a16:creationId xmlns:a16="http://schemas.microsoft.com/office/drawing/2014/main" id="{885E8C99-78A3-4EC9-BA08-90C5094D8FF1}"/>
               </a:ext>
             </a:extLst>
           </p:cNvPr>
@@ -16207,7 +17883,7 @@
           <p:cNvPr id="10" name="failure-run">
             <a:extLst xmlns:a="http://schemas.openxmlformats.org/drawingml/2006/main">
               <a:ext uri="{FF2B5EF4-FFF2-40B4-BE49-F238E27FC236}">
-                <a16:creationId xmlns:a16="http://schemas.microsoft.com/office/drawing/2014/main" id="{2AB73AAD-28AC-4306-9072-EA6FA26F794C}"/>
+                <a16:creationId xmlns:a16="http://schemas.microsoft.com/office/drawing/2014/main" id="{E07B30BE-C334-47A2-B127-014D3D34BF82}"/>
               </a:ext>
             </a:extLst>
           </p:cNvPr>
@@ -16293,7 +17969,7 @@
           <p:cNvPr id="9" name="eyebrow">
             <a:extLst xmlns:a="http://schemas.openxmlformats.org/drawingml/2006/main">
               <a:ext uri="{FF2B5EF4-FFF2-40B4-BE49-F238E27FC236}">
-                <a16:creationId xmlns:a16="http://schemas.microsoft.com/office/drawing/2014/main" id="{FD15A125-832E-4E9B-97AC-7BAA6EF11FC8}"/>
+                <a16:creationId xmlns:a16="http://schemas.microsoft.com/office/drawing/2014/main" id="{54DAB090-2B50-4B8E-9B6C-803E9D14FCB0}"/>
               </a:ext>
             </a:extLst>
           </p:cNvPr>
@@ -16350,7 +18026,7 @@
           <p:cNvPr id="2" name="slide-title">
             <a:extLst xmlns:a="http://schemas.openxmlformats.org/drawingml/2006/main">
               <a:ext uri="{FF2B5EF4-FFF2-40B4-BE49-F238E27FC236}">
-                <a16:creationId xmlns:a16="http://schemas.microsoft.com/office/drawing/2014/main" id="{E35C31FA-D981-4F02-ADED-5FA54229E0B9}"/>
+                <a16:creationId xmlns:a16="http://schemas.microsoft.com/office/drawing/2014/main" id="{F2E114FE-EEFC-42A7-8BFE-0429E6F69800}"/>
               </a:ext>
             </a:extLst>
           </p:cNvPr>
@@ -16407,7 +18083,7 @@
           <p:cNvPr id="3" name="">
             <a:extLst xmlns:a="http://schemas.openxmlformats.org/drawingml/2006/main">
               <a:ext uri="{FF2B5EF4-FFF2-40B4-BE49-F238E27FC236}">
-                <a16:creationId xmlns:a16="http://schemas.microsoft.com/office/drawing/2014/main" id="{86935EFE-8338-490F-9BB1-5B17257219D9}"/>
+                <a16:creationId xmlns:a16="http://schemas.microsoft.com/office/drawing/2014/main" id="{3A6A7EED-1978-41E9-BCDB-739CCEEDF722}"/>
               </a:ext>
             </a:extLst>
           </p:cNvPr>
@@ -16439,7 +18115,7 @@
           <p:cNvPr id="4" name="slide-number">
             <a:extLst xmlns:a="http://schemas.openxmlformats.org/drawingml/2006/main">
               <a:ext uri="{FF2B5EF4-FFF2-40B4-BE49-F238E27FC236}">
-                <a16:creationId xmlns:a16="http://schemas.microsoft.com/office/drawing/2014/main" id="{2B00323B-4012-4200-B18C-0BF71ADDC5D7}"/>
+                <a16:creationId xmlns:a16="http://schemas.microsoft.com/office/drawing/2014/main" id="{B1E92335-010F-46FB-A344-E123A0A6EE29}"/>
               </a:ext>
             </a:extLst>
           </p:cNvPr>
@@ -16496,7 +18172,7 @@
           <p:cNvPr id="5" name="">
             <a:extLst xmlns:a="http://schemas.openxmlformats.org/drawingml/2006/main">
               <a:ext uri="{FF2B5EF4-FFF2-40B4-BE49-F238E27FC236}">
-                <a16:creationId xmlns:a16="http://schemas.microsoft.com/office/drawing/2014/main" id="{0A9F8DE3-5E58-47F8-9F57-C78786155363}"/>
+                <a16:creationId xmlns:a16="http://schemas.microsoft.com/office/drawing/2014/main" id="{411259DF-2ACF-41C7-B222-0DAF4E7F1412}"/>
               </a:ext>
             </a:extLst>
           </p:cNvPr>
@@ -16528,7 +18204,7 @@
           <p:cNvPr id="6" name="zero-sql">
             <a:extLst xmlns:a="http://schemas.openxmlformats.org/drawingml/2006/main">
               <a:ext uri="{FF2B5EF4-FFF2-40B4-BE49-F238E27FC236}">
-                <a16:creationId xmlns:a16="http://schemas.microsoft.com/office/drawing/2014/main" id="{DF4FD002-9971-45CE-B91B-54019E39FC33}"/>
+                <a16:creationId xmlns:a16="http://schemas.microsoft.com/office/drawing/2014/main" id="{2D44EF27-E551-46CC-AB16-8E5C0B4E1B8A}"/>
               </a:ext>
             </a:extLst>
           </p:cNvPr>
@@ -16677,7 +18353,7 @@
           <p:cNvPr id="7" name="zero-outcome">
             <a:extLst xmlns:a="http://schemas.openxmlformats.org/drawingml/2006/main">
               <a:ext uri="{FF2B5EF4-FFF2-40B4-BE49-F238E27FC236}">
-                <a16:creationId xmlns:a16="http://schemas.microsoft.com/office/drawing/2014/main" id="{54139A78-306E-46DF-BA00-E88ED9B4DF18}"/>
+                <a16:creationId xmlns:a16="http://schemas.microsoft.com/office/drawing/2014/main" id="{175F0A42-57E9-4B86-92A7-E4EB88DC6588}"/>
               </a:ext>
             </a:extLst>
           </p:cNvPr>
@@ -16734,7 +18410,7 @@
           <p:cNvPr id="8" name="zero-action">
             <a:extLst xmlns:a="http://schemas.openxmlformats.org/drawingml/2006/main">
               <a:ext uri="{FF2B5EF4-FFF2-40B4-BE49-F238E27FC236}">
-                <a16:creationId xmlns:a16="http://schemas.microsoft.com/office/drawing/2014/main" id="{BA877CBD-532A-42CF-8478-ECE6601E1BD2}"/>
+                <a16:creationId xmlns:a16="http://schemas.microsoft.com/office/drawing/2014/main" id="{B84C6E03-1A98-4B4D-805F-184C8770437F}"/>
               </a:ext>
             </a:extLst>
           </p:cNvPr>
@@ -16820,7 +18496,7 @@
           <p:cNvPr id="7" name="eyebrow">
             <a:extLst xmlns:a="http://schemas.openxmlformats.org/drawingml/2006/main">
               <a:ext uri="{FF2B5EF4-FFF2-40B4-BE49-F238E27FC236}">
-                <a16:creationId xmlns:a16="http://schemas.microsoft.com/office/drawing/2014/main" id="{99A11F11-3218-4766-A4CE-CA316E2EA45F}"/>
+                <a16:creationId xmlns:a16="http://schemas.microsoft.com/office/drawing/2014/main" id="{AD48B9E7-B625-411C-83B9-B42CB3B3DD95}"/>
               </a:ext>
             </a:extLst>
           </p:cNvPr>
@@ -16877,7 +18553,7 @@
           <p:cNvPr id="2" name="slide-title">
             <a:extLst xmlns:a="http://schemas.openxmlformats.org/drawingml/2006/main">
               <a:ext uri="{FF2B5EF4-FFF2-40B4-BE49-F238E27FC236}">
-                <a16:creationId xmlns:a16="http://schemas.microsoft.com/office/drawing/2014/main" id="{C3140584-4701-4462-921B-1B780D0DF556}"/>
+                <a16:creationId xmlns:a16="http://schemas.microsoft.com/office/drawing/2014/main" id="{18D2ACF0-D112-4278-AD10-C60FBD0D2CAC}"/>
               </a:ext>
             </a:extLst>
           </p:cNvPr>
@@ -16934,7 +18610,7 @@
           <p:cNvPr id="3" name="">
             <a:extLst xmlns:a="http://schemas.openxmlformats.org/drawingml/2006/main">
               <a:ext uri="{FF2B5EF4-FFF2-40B4-BE49-F238E27FC236}">
-                <a16:creationId xmlns:a16="http://schemas.microsoft.com/office/drawing/2014/main" id="{C07F8ADB-C7F8-4A97-882A-9E3FEC470B17}"/>
+                <a16:creationId xmlns:a16="http://schemas.microsoft.com/office/drawing/2014/main" id="{4E592F35-DB02-4004-B681-7B3C24D81153}"/>
               </a:ext>
             </a:extLst>
           </p:cNvPr>
@@ -16966,7 +18642,7 @@
           <p:cNvPr id="4" name="slide-number">
             <a:extLst xmlns:a="http://schemas.openxmlformats.org/drawingml/2006/main">
               <a:ext uri="{FF2B5EF4-FFF2-40B4-BE49-F238E27FC236}">
-                <a16:creationId xmlns:a16="http://schemas.microsoft.com/office/drawing/2014/main" id="{52743D68-0E56-423E-B08C-EE625269B78A}"/>
+                <a16:creationId xmlns:a16="http://schemas.microsoft.com/office/drawing/2014/main" id="{8369EF31-57AB-446C-A319-99510138E2C8}"/>
               </a:ext>
             </a:extLst>
           </p:cNvPr>
@@ -17295,7 +18971,7 @@
           <p:cNvPr id="6" name="acid-limits">
             <a:extLst xmlns:a="http://schemas.openxmlformats.org/drawingml/2006/main">
               <a:ext uri="{FF2B5EF4-FFF2-40B4-BE49-F238E27FC236}">
-                <a16:creationId xmlns:a16="http://schemas.microsoft.com/office/drawing/2014/main" id="{D4C30E08-3AB9-4DD8-9377-8629134CE8AE}"/>
+                <a16:creationId xmlns:a16="http://schemas.microsoft.com/office/drawing/2014/main" id="{F5C11A5E-C64D-4AE0-B227-66EA7E68D135}"/>
               </a:ext>
             </a:extLst>
           </p:cNvPr>
@@ -17381,7 +19057,7 @@
           <p:cNvPr id="9" name="eyebrow">
             <a:extLst xmlns:a="http://schemas.openxmlformats.org/drawingml/2006/main">
               <a:ext uri="{FF2B5EF4-FFF2-40B4-BE49-F238E27FC236}">
-                <a16:creationId xmlns:a16="http://schemas.microsoft.com/office/drawing/2014/main" id="{38A5FB20-C46B-486D-A3FA-D4837C4D510F}"/>
+                <a16:creationId xmlns:a16="http://schemas.microsoft.com/office/drawing/2014/main" id="{877FAA9E-32A9-4F77-82C9-72CB962E6C8A}"/>
               </a:ext>
             </a:extLst>
           </p:cNvPr>
@@ -17438,7 +19114,7 @@
           <p:cNvPr id="2" name="slide-title">
             <a:extLst xmlns:a="http://schemas.openxmlformats.org/drawingml/2006/main">
               <a:ext uri="{FF2B5EF4-FFF2-40B4-BE49-F238E27FC236}">
-                <a16:creationId xmlns:a16="http://schemas.microsoft.com/office/drawing/2014/main" id="{14E505A2-0B40-4C04-B027-4722E8FC18C2}"/>
+                <a16:creationId xmlns:a16="http://schemas.microsoft.com/office/drawing/2014/main" id="{62C5D7D8-4BD6-4F3E-BDAC-94D89A49EF8A}"/>
               </a:ext>
             </a:extLst>
           </p:cNvPr>
@@ -17495,7 +19171,7 @@
           <p:cNvPr id="3" name="">
             <a:extLst xmlns:a="http://schemas.openxmlformats.org/drawingml/2006/main">
               <a:ext uri="{FF2B5EF4-FFF2-40B4-BE49-F238E27FC236}">
-                <a16:creationId xmlns:a16="http://schemas.microsoft.com/office/drawing/2014/main" id="{9A5253C8-538B-4E37-89F7-573DB4105B54}"/>
+                <a16:creationId xmlns:a16="http://schemas.microsoft.com/office/drawing/2014/main" id="{496CCBAF-F079-4AC1-9A7E-C9669591D755}"/>
               </a:ext>
             </a:extLst>
           </p:cNvPr>
@@ -17527,7 +19203,7 @@
           <p:cNvPr id="4" name="slide-number">
             <a:extLst xmlns:a="http://schemas.openxmlformats.org/drawingml/2006/main">
               <a:ext uri="{FF2B5EF4-FFF2-40B4-BE49-F238E27FC236}">
-                <a16:creationId xmlns:a16="http://schemas.microsoft.com/office/drawing/2014/main" id="{21E8F151-B18E-4E39-8DC0-4305B574C61D}"/>
+                <a16:creationId xmlns:a16="http://schemas.microsoft.com/office/drawing/2014/main" id="{78439AD0-32D5-4835-A3C4-3AED5E1E5742}"/>
               </a:ext>
             </a:extLst>
           </p:cNvPr>
@@ -17584,7 +19260,7 @@
           <p:cNvPr id="5" name="lab1">
             <a:extLst xmlns:a="http://schemas.openxmlformats.org/drawingml/2006/main">
               <a:ext uri="{FF2B5EF4-FFF2-40B4-BE49-F238E27FC236}">
-                <a16:creationId xmlns:a16="http://schemas.microsoft.com/office/drawing/2014/main" id="{DCC5646F-FDCE-444A-8F59-9601D80FC493}"/>
+                <a16:creationId xmlns:a16="http://schemas.microsoft.com/office/drawing/2014/main" id="{912559B3-89AD-4222-8D88-71FA46A63C84}"/>
               </a:ext>
             </a:extLst>
           </p:cNvPr>
@@ -17641,7 +19317,7 @@
           <p:cNvPr id="6" name="lab1-actions">
             <a:extLst xmlns:a="http://schemas.openxmlformats.org/drawingml/2006/main">
               <a:ext uri="{FF2B5EF4-FFF2-40B4-BE49-F238E27FC236}">
-                <a16:creationId xmlns:a16="http://schemas.microsoft.com/office/drawing/2014/main" id="{6B34128E-D0B2-49EC-BC11-2CCE06610FC8}"/>
+                <a16:creationId xmlns:a16="http://schemas.microsoft.com/office/drawing/2014/main" id="{C09DE4DC-5C31-49F7-B11C-96F77DCDA3FF}"/>
               </a:ext>
             </a:extLst>
           </p:cNvPr>
@@ -17688,7 +19364,7 @@
                 <a:ea typeface="Helvetica Neue"/>
                 <a:cs typeface="Helvetica Neue"/>
               </a:rPr>
-              <a:t>Rehearse and commit Priya's assignment.</a:t>
+              <a:t>Rehearse and commit Agent 201's assignment.</a:t>
             </a:r>
           </a:p>
           <a:p xmlns:a="http://schemas.openxmlformats.org/drawingml/2006/main">
@@ -17721,7 +19397,7 @@
           <p:cNvPr id="7" name="lab1-write">
             <a:extLst xmlns:a="http://schemas.openxmlformats.org/drawingml/2006/main">
               <a:ext uri="{FF2B5EF4-FFF2-40B4-BE49-F238E27FC236}">
-                <a16:creationId xmlns:a16="http://schemas.microsoft.com/office/drawing/2014/main" id="{03D57A15-3D8C-4170-94F9-0D7092531BDA}"/>
+                <a16:creationId xmlns:a16="http://schemas.microsoft.com/office/drawing/2014/main" id="{9DE10F97-C92D-4894-ABAD-384389E2E3FE}"/>
               </a:ext>
             </a:extLst>
           </p:cNvPr>
@@ -17778,7 +19454,7 @@
           <p:cNvPr id="8" name="lab1-submit">
             <a:extLst xmlns:a="http://schemas.openxmlformats.org/drawingml/2006/main">
               <a:ext uri="{FF2B5EF4-FFF2-40B4-BE49-F238E27FC236}">
-                <a16:creationId xmlns:a16="http://schemas.microsoft.com/office/drawing/2014/main" id="{5C6DFDEA-880E-4E21-9929-EFD07425A420}"/>
+                <a16:creationId xmlns:a16="http://schemas.microsoft.com/office/drawing/2014/main" id="{C66F2766-DED2-48C0-82FB-0F8CD6700E45}"/>
               </a:ext>
             </a:extLst>
           </p:cNvPr>

</xml_diff>